<commit_message>
Docs: redraw the pipeline flowchart around the algorithm (age-ordered recursion central, n MBIR iterations per outer iteration, implementation details removed)
Co-Authored-By: Claude Fable 5.1 <noreply@anthropic.com>
</commit_message>
<xml_diff>
--- a/docs/figures/citrus_pipeline.pptx
+++ b/docs/figures/citrus_pipeline.pptx
@@ -3096,8 +3096,8 @@
         </p:nvSpPr>
         <p:spPr>
           <a:xfrm>
-            <a:off x="320040" y="868680"/>
-            <a:ext cx="2057400" cy="868680"/>
+            <a:off x="365760" y="1463040"/>
+            <a:ext cx="2011680" cy="868680"/>
           </a:xfrm>
           <a:prstGeom prst="roundRect">
             <a:avLst>
@@ -3134,37 +3134,25 @@
           <a:p>
             <a:pPr algn="ctr"/>
             <a:r>
-              <a:rPr sz="1100" b="1">
+              <a:rPr sz="1200" b="1">
                 <a:solidFill>
                   <a:srgbClr val="1F3864"/>
                 </a:solidFill>
                 <a:latin typeface="Calibri"/>
               </a:rPr>
-              <a:t>Measured projections</a:t>
+              <a:t>Measured projections Y</a:t>
             </a:r>
           </a:p>
           <a:p>
             <a:pPr algn="ctr"/>
             <a:r>
-              <a:rPr sz="1100" b="0">
+              <a:rPr sz="1200" b="0">
                 <a:solidFill>
                   <a:srgbClr val="1F3864"/>
                 </a:solidFill>
                 <a:latin typeface="Calibri"/>
               </a:rPr>
-              <a:t>counts Y = primary + scatter,</a:t>
-            </a:r>
-          </a:p>
-          <a:p>
-            <a:pPr algn="ctr"/>
-            <a:r>
-              <a:rPr sz="1100" b="0">
-                <a:solidFill>
-                  <a:srgbClr val="1F3864"/>
-                </a:solidFill>
-                <a:latin typeface="Calibri"/>
-              </a:rPr>
-              <a:t>flat field I0, view angles</a:t>
+              <a:t>primary + scatter, all views</a:t>
             </a:r>
           </a:p>
         </p:txBody>
@@ -3177,8 +3165,8 @@
         </p:nvSpPr>
         <p:spPr>
           <a:xfrm>
-            <a:off x="320040" y="2240280"/>
-            <a:ext cx="2057400" cy="868680"/>
+            <a:off x="365760" y="3017520"/>
+            <a:ext cx="2011680" cy="868680"/>
           </a:xfrm>
           <a:prstGeom prst="roundRect">
             <a:avLst>
@@ -3215,51 +3203,739 @@
           <a:p>
             <a:pPr algn="ctr"/>
             <a:r>
-              <a:rPr sz="1100" b="1">
+              <a:rPr sz="1200" b="1">
                 <a:solidFill>
                   <a:srgbClr val="1F3864"/>
                 </a:solidFill>
                 <a:latin typeface="Calibri"/>
               </a:rPr>
-              <a:t>FDK initialization</a:t>
+              <a:t>Initial reconstruction X₀</a:t>
             </a:r>
           </a:p>
           <a:p>
             <a:pPr algn="ctr"/>
             <a:r>
-              <a:rPr sz="1100" b="0">
+              <a:rPr sz="1200" b="0">
                 <a:solidFill>
                   <a:srgbClr val="1F3864"/>
                 </a:solidFill>
                 <a:latin typeface="Calibri"/>
               </a:rPr>
-              <a:t>Parker weights for a short scan</a:t>
-            </a:r>
-          </a:p>
+              <a:t>(FDK)</a:t>
+            </a:r>
+          </a:p>
+        </p:txBody>
+      </p:sp>
+      <p:cxnSp>
+        <p:nvCxnSpPr>
+          <p:cNvPr id="4" name="Connector 3"/>
+          <p:cNvCxnSpPr/>
+          <p:nvPr/>
+        </p:nvCxnSpPr>
+        <p:spPr>
+          <a:xfrm>
+            <a:off x="1371600" y="2331720"/>
+            <a:ext cx="0" cy="685800"/>
+          </a:xfrm>
+          <a:prstGeom prst="line">
+            <a:avLst/>
+          </a:prstGeom>
+          <a:ln w="19050">
+            <a:solidFill>
+              <a:srgbClr val="595959"/>
+            </a:solidFill>
+            <a:tailEnd type="triangle" w="med" len="med"/>
+          </a:ln>
+        </p:spPr>
+        <p:style>
+          <a:lnRef idx="2">
+            <a:schemeClr val="accent1"/>
+          </a:lnRef>
+          <a:fillRef idx="0">
+            <a:schemeClr val="accent1"/>
+          </a:fillRef>
+          <a:effectRef idx="1">
+            <a:schemeClr val="accent1"/>
+          </a:effectRef>
+          <a:fontRef idx="minor">
+            <a:schemeClr val="tx1"/>
+          </a:fontRef>
+        </p:style>
+      </p:cxnSp>
+      <p:sp>
+        <p:nvSpPr>
+          <p:cNvPr id="5" name="Rounded Rectangle 4"/>
+          <p:cNvSpPr/>
+          <p:nvPr/>
+        </p:nvSpPr>
+        <p:spPr>
+          <a:xfrm>
+            <a:off x="2743200" y="365760"/>
+            <a:ext cx="9144000" cy="5806440"/>
+          </a:xfrm>
+          <a:prstGeom prst="roundRect">
+            <a:avLst>
+              <a:gd name="adj" fmla="val 4000"/>
+            </a:avLst>
+          </a:prstGeom>
+          <a:noFill/>
+          <a:ln w="15875">
+            <a:solidFill>
+              <a:srgbClr val="595959"/>
+            </a:solidFill>
+            <a:prstDash val="dash"/>
+          </a:ln>
+          <a:effectLst/>
+        </p:spPr>
+        <p:style>
+          <a:lnRef idx="1">
+            <a:schemeClr val="accent1"/>
+          </a:lnRef>
+          <a:fillRef idx="3">
+            <a:schemeClr val="accent1"/>
+          </a:fillRef>
+          <a:effectRef idx="2">
+            <a:schemeClr val="accent1"/>
+          </a:effectRef>
+          <a:fontRef idx="minor">
+            <a:schemeClr val="lt1"/>
+          </a:fontRef>
+        </p:style>
+        <p:txBody>
+          <a:bodyPr rtlCol="0" anchor="ctr" wrap="square" lIns="54864" rIns="54864" tIns="27432" bIns="27432"/>
+          <a:lstStyle/>
           <a:p>
             <a:pPr algn="ctr"/>
             <a:r>
-              <a:rPr sz="1100" b="0">
-                <a:solidFill>
-                  <a:srgbClr val="1F3864"/>
+              <a:rPr sz="1100" b="1">
+                <a:solidFill>
+                  <a:srgbClr val="404040"/>
                 </a:solidFill>
                 <a:latin typeface="Calibri"/>
               </a:rPr>
-              <a:t>(MBIRTORCH)</a:t>
-            </a:r>
-          </a:p>
-        </p:txBody>
-      </p:sp>
-      <p:sp>
-        <p:nvSpPr>
-          <p:cNvPr id="4" name="Rounded Rectangle 3"/>
+              <a:t/>
+            </a:r>
+          </a:p>
+        </p:txBody>
+      </p:sp>
+      <p:sp>
+        <p:nvSpPr>
+          <p:cNvPr id="6" name="TextBox 5"/>
+          <p:cNvSpPr txBox="1"/>
+          <p:nvPr/>
+        </p:nvSpPr>
+        <p:spPr>
+          <a:xfrm>
+            <a:off x="2971800" y="411480"/>
+            <a:ext cx="8229600" cy="274320"/>
+          </a:xfrm>
+          <a:prstGeom prst="rect">
+            <a:avLst/>
+          </a:prstGeom>
+          <a:noFill/>
+        </p:spPr>
+        <p:txBody>
+          <a:bodyPr wrap="square" lIns="18288" rIns="18288" tIns="0" bIns="0">
+            <a:spAutoFit/>
+          </a:bodyPr>
+          <a:lstStyle/>
+          <a:p>
+            <a:pPr algn="l"/>
+            <a:r>
+              <a:rPr sz="1300" b="1" i="0">
+                <a:solidFill>
+                  <a:srgbClr val="404040"/>
+                </a:solidFill>
+                <a:latin typeface="Calibri"/>
+              </a:rPr>
+              <a:t>Outer iteration k</a:t>
+            </a:r>
+          </a:p>
+        </p:txBody>
+      </p:sp>
+      <p:sp>
+        <p:nvSpPr>
+          <p:cNvPr id="7" name="Rounded Rectangle 6"/>
           <p:cNvSpPr/>
           <p:nvPr/>
         </p:nvSpPr>
         <p:spPr>
           <a:xfrm>
-            <a:off x="320040" y="3611880"/>
-            <a:ext cx="2057400" cy="640080"/>
+            <a:off x="3063240" y="914400"/>
+            <a:ext cx="2240280" cy="960120"/>
+          </a:xfrm>
+          <a:prstGeom prst="roundRect">
+            <a:avLst>
+              <a:gd name="adj" fmla="val 12000"/>
+            </a:avLst>
+          </a:prstGeom>
+          <a:solidFill>
+            <a:srgbClr val="E2F0D9"/>
+          </a:solidFill>
+          <a:ln w="15875">
+            <a:solidFill>
+              <a:srgbClr val="548235"/>
+            </a:solidFill>
+          </a:ln>
+          <a:effectLst/>
+        </p:spPr>
+        <p:style>
+          <a:lnRef idx="1">
+            <a:schemeClr val="accent1"/>
+          </a:lnRef>
+          <a:fillRef idx="3">
+            <a:schemeClr val="accent1"/>
+          </a:fillRef>
+          <a:effectRef idx="2">
+            <a:schemeClr val="accent1"/>
+          </a:effectRef>
+          <a:fontRef idx="minor">
+            <a:schemeClr val="lt1"/>
+          </a:fontRef>
+        </p:style>
+        <p:txBody>
+          <a:bodyPr rtlCol="0" anchor="ctr" wrap="square" lIns="54864" rIns="54864" tIns="27432" bIns="27432"/>
+          <a:lstStyle/>
+          <a:p>
+            <a:pPr algn="ctr"/>
+            <a:r>
+              <a:rPr sz="1100" b="1">
+                <a:solidFill>
+                  <a:srgbClr val="385723"/>
+                </a:solidFill>
+                <a:latin typeface="Calibri"/>
+              </a:rPr>
+              <a:t>Material densities</a:t>
+            </a:r>
+          </a:p>
+          <a:p>
+            <a:pPr algn="ctr"/>
+            <a:r>
+              <a:rPr sz="1100" b="0">
+                <a:solidFill>
+                  <a:srgbClr val="385723"/>
+                </a:solidFill>
+                <a:latin typeface="Calibri"/>
+              </a:rPr>
+              <a:t>ρ(Xₖ): each voxel a mixture of</a:t>
+            </a:r>
+          </a:p>
+          <a:p>
+            <a:pPr algn="ctr"/>
+            <a:r>
+              <a:rPr sz="1100" b="0">
+                <a:solidFill>
+                  <a:srgbClr val="385723"/>
+                </a:solidFill>
+                <a:latin typeface="Calibri"/>
+              </a:rPr>
+              <a:t>two anchor materials</a:t>
+            </a:r>
+          </a:p>
+        </p:txBody>
+      </p:sp>
+      <p:sp>
+        <p:nvSpPr>
+          <p:cNvPr id="8" name="Rounded Rectangle 7"/>
+          <p:cNvSpPr/>
+          <p:nvPr/>
+        </p:nvSpPr>
+        <p:spPr>
+          <a:xfrm>
+            <a:off x="5669280" y="868680"/>
+            <a:ext cx="5943600" cy="2011680"/>
+          </a:xfrm>
+          <a:prstGeom prst="roundRect">
+            <a:avLst>
+              <a:gd name="adj" fmla="val 12000"/>
+            </a:avLst>
+          </a:prstGeom>
+          <a:solidFill>
+            <a:srgbClr val="FBE5D6"/>
+          </a:solidFill>
+          <a:ln w="15875">
+            <a:solidFill>
+              <a:srgbClr val="C55A11"/>
+            </a:solidFill>
+          </a:ln>
+          <a:effectLst/>
+        </p:spPr>
+        <p:style>
+          <a:lnRef idx="1">
+            <a:schemeClr val="accent1"/>
+          </a:lnRef>
+          <a:fillRef idx="3">
+            <a:schemeClr val="accent1"/>
+          </a:fillRef>
+          <a:effectRef idx="2">
+            <a:schemeClr val="accent1"/>
+          </a:effectRef>
+          <a:fontRef idx="minor">
+            <a:schemeClr val="lt1"/>
+          </a:fontRef>
+        </p:style>
+        <p:txBody>
+          <a:bodyPr rtlCol="0" anchor="t" wrap="square" lIns="54864" rIns="54864" tIns="73152" bIns="27432"/>
+          <a:lstStyle/>
+          <a:p>
+            <a:pPr algn="ctr"/>
+            <a:r>
+              <a:rPr sz="1200" b="1">
+                <a:solidFill>
+                  <a:srgbClr val="843C0C"/>
+                </a:solidFill>
+                <a:latin typeface="Calibri"/>
+              </a:rPr>
+              <a:t/>
+            </a:r>
+            <a:r>
+              <a:rPr sz="1300" b="1">
+                <a:solidFill>
+                  <a:srgbClr val="843C0C"/>
+                </a:solidFill>
+                <a:latin typeface="Calibri"/>
+              </a:rPr>
+              <a:t>Age-ordered scatter recursion:  one transport sweep Gₖ per view</a:t>
+            </a:r>
+          </a:p>
+          <a:p>
+            <a:pPr algn="ctr"/>
+            <a:r>
+              <a:rPr sz="400" b="0">
+                <a:solidFill>
+                  <a:srgbClr val="843C0C"/>
+                </a:solidFill>
+                <a:latin typeface="Calibri"/>
+              </a:rPr>
+              <a:t/>
+            </a:r>
+          </a:p>
+          <a:p>
+            <a:pPr algn="ctr"/>
+            <a:r>
+              <a:rPr sz="1800" b="1">
+                <a:solidFill>
+                  <a:srgbClr val="843C0C"/>
+                </a:solidFill>
+                <a:latin typeface="Calibri"/>
+              </a:rPr>
+              <a:t>Φᵥ⁽ᵏ⁾  =  Gₖ φ₁(Xₖ)  +  Gₖ Φᵥ⁽ᵏ⁻¹⁾</a:t>
+            </a:r>
+          </a:p>
+          <a:p>
+            <a:pPr algn="ctr"/>
+            <a:r>
+              <a:rPr sz="900" b="0">
+                <a:solidFill>
+                  <a:srgbClr val="C55A11"/>
+                </a:solidFill>
+                <a:latin typeface="Calibri"/>
+              </a:rPr>
+              <a:t>newest first-collision source        previous accumulator</a:t>
+            </a:r>
+          </a:p>
+          <a:p>
+            <a:pPr algn="ctr"/>
+            <a:r>
+              <a:rPr sz="400" b="0">
+                <a:solidFill>
+                  <a:srgbClr val="843C0C"/>
+                </a:solidFill>
+                <a:latin typeface="Calibri"/>
+              </a:rPr>
+              <a:t/>
+            </a:r>
+          </a:p>
+          <a:p>
+            <a:pPr algn="ctr"/>
+            <a:r>
+              <a:rPr sz="1300" b="0">
+                <a:solidFill>
+                  <a:srgbClr val="843C0C"/>
+                </a:solidFill>
+                <a:latin typeface="Calibri"/>
+              </a:rPr>
+              <a:t>=  Gₖ φ₁⁽ᵏ⁾  +  GₖGₖ₋₁ φ₁⁽ᵏ⁻¹⁾  +  GₖGₖ₋₁Gₖ₋₂ φ₁⁽ᵏ⁻²⁾  +  …</a:t>
+            </a:r>
+          </a:p>
+          <a:p>
+            <a:pPr algn="ctr"/>
+            <a:r>
+              <a:rPr sz="1000" b="0">
+                <a:solidFill>
+                  <a:srgbClr val="843C0C"/>
+                </a:solidFill>
+                <a:latin typeface="Calibri"/>
+              </a:rPr>
+              <a:t>2nd-order scatter from Xₖ,  3rd order from Xₖ₋₁,  4th order from Xₖ₋₂, …</a:t>
+            </a:r>
+          </a:p>
+          <a:p>
+            <a:pPr algn="ctr"/>
+            <a:r>
+              <a:rPr sz="1000" b="0">
+                <a:solidFill>
+                  <a:srgbClr val="843C0C"/>
+                </a:solidFill>
+                <a:latin typeface="Calibri"/>
+              </a:rPr>
+              <a:t>the dominant low orders are refreshed from the newest reconstruction;</a:t>
+            </a:r>
+          </a:p>
+          <a:p>
+            <a:pPr algn="ctr"/>
+            <a:r>
+              <a:rPr sz="1000" b="0">
+                <a:solidFill>
+                  <a:srgbClr val="843C0C"/>
+                </a:solidFill>
+                <a:latin typeface="Calibri"/>
+              </a:rPr>
+              <a:t>stale information is pushed into the weak, smooth high orders</a:t>
+            </a:r>
+          </a:p>
+        </p:txBody>
+      </p:sp>
+      <p:cxnSp>
+        <p:nvCxnSpPr>
+          <p:cNvPr id="9" name="Connector 8"/>
+          <p:cNvCxnSpPr/>
+          <p:nvPr/>
+        </p:nvCxnSpPr>
+        <p:spPr>
+          <a:xfrm>
+            <a:off x="5303520" y="1394460"/>
+            <a:ext cx="365760" cy="0"/>
+          </a:xfrm>
+          <a:prstGeom prst="line">
+            <a:avLst/>
+          </a:prstGeom>
+          <a:ln w="19050">
+            <a:solidFill>
+              <a:srgbClr val="595959"/>
+            </a:solidFill>
+            <a:tailEnd type="triangle" w="med" len="med"/>
+          </a:ln>
+        </p:spPr>
+        <p:style>
+          <a:lnRef idx="2">
+            <a:schemeClr val="accent1"/>
+          </a:lnRef>
+          <a:fillRef idx="0">
+            <a:schemeClr val="accent1"/>
+          </a:fillRef>
+          <a:effectRef idx="1">
+            <a:schemeClr val="accent1"/>
+          </a:effectRef>
+          <a:fontRef idx="minor">
+            <a:schemeClr val="tx1"/>
+          </a:fontRef>
+        </p:style>
+      </p:cxnSp>
+      <p:cxnSp>
+        <p:nvCxnSpPr>
+          <p:cNvPr id="10" name="Connector 9"/>
+          <p:cNvCxnSpPr/>
+          <p:nvPr/>
+        </p:nvCxnSpPr>
+        <p:spPr>
+          <a:xfrm>
+            <a:off x="10515600" y="2880360"/>
+            <a:ext cx="0" cy="274319"/>
+          </a:xfrm>
+          <a:prstGeom prst="line">
+            <a:avLst/>
+          </a:prstGeom>
+          <a:ln w="25400">
+            <a:solidFill>
+              <a:srgbClr val="C55A11"/>
+            </a:solidFill>
+            <a:prstDash val="dash"/>
+          </a:ln>
+        </p:spPr>
+        <p:style>
+          <a:lnRef idx="2">
+            <a:schemeClr val="accent1"/>
+          </a:lnRef>
+          <a:fillRef idx="0">
+            <a:schemeClr val="accent1"/>
+          </a:fillRef>
+          <a:effectRef idx="1">
+            <a:schemeClr val="accent1"/>
+          </a:effectRef>
+          <a:fontRef idx="minor">
+            <a:schemeClr val="tx1"/>
+          </a:fontRef>
+        </p:style>
+      </p:cxnSp>
+      <p:cxnSp>
+        <p:nvCxnSpPr>
+          <p:cNvPr id="11" name="Connector 10"/>
+          <p:cNvCxnSpPr/>
+          <p:nvPr/>
+        </p:nvCxnSpPr>
+        <p:spPr>
+          <a:xfrm flipH="1">
+            <a:off x="6766560" y="3154679"/>
+            <a:ext cx="3749040" cy="0"/>
+          </a:xfrm>
+          <a:prstGeom prst="line">
+            <a:avLst/>
+          </a:prstGeom>
+          <a:ln w="25400">
+            <a:solidFill>
+              <a:srgbClr val="C55A11"/>
+            </a:solidFill>
+            <a:prstDash val="dash"/>
+          </a:ln>
+        </p:spPr>
+        <p:style>
+          <a:lnRef idx="2">
+            <a:schemeClr val="accent1"/>
+          </a:lnRef>
+          <a:fillRef idx="0">
+            <a:schemeClr val="accent1"/>
+          </a:fillRef>
+          <a:effectRef idx="1">
+            <a:schemeClr val="accent1"/>
+          </a:effectRef>
+          <a:fontRef idx="minor">
+            <a:schemeClr val="tx1"/>
+          </a:fontRef>
+        </p:style>
+      </p:cxnSp>
+      <p:cxnSp>
+        <p:nvCxnSpPr>
+          <p:cNvPr id="12" name="Connector 11"/>
+          <p:cNvCxnSpPr/>
+          <p:nvPr/>
+        </p:nvCxnSpPr>
+        <p:spPr>
+          <a:xfrm flipV="1">
+            <a:off x="6766560" y="2889503"/>
+            <a:ext cx="0" cy="265176"/>
+          </a:xfrm>
+          <a:prstGeom prst="line">
+            <a:avLst/>
+          </a:prstGeom>
+          <a:ln w="25400">
+            <a:solidFill>
+              <a:srgbClr val="C55A11"/>
+            </a:solidFill>
+            <a:prstDash val="dash"/>
+            <a:tailEnd type="triangle" w="med" len="med"/>
+          </a:ln>
+        </p:spPr>
+        <p:style>
+          <a:lnRef idx="2">
+            <a:schemeClr val="accent1"/>
+          </a:lnRef>
+          <a:fillRef idx="0">
+            <a:schemeClr val="accent1"/>
+          </a:fillRef>
+          <a:effectRef idx="1">
+            <a:schemeClr val="accent1"/>
+          </a:effectRef>
+          <a:fontRef idx="minor">
+            <a:schemeClr val="tx1"/>
+          </a:fontRef>
+        </p:style>
+      </p:cxnSp>
+      <p:sp>
+        <p:nvSpPr>
+          <p:cNvPr id="13" name="TextBox 12"/>
+          <p:cNvSpPr txBox="1"/>
+          <p:nvPr/>
+        </p:nvSpPr>
+        <p:spPr>
+          <a:xfrm>
+            <a:off x="6858000" y="2935224"/>
+            <a:ext cx="3566160" cy="182880"/>
+          </a:xfrm>
+          <a:prstGeom prst="rect">
+            <a:avLst/>
+          </a:prstGeom>
+          <a:noFill/>
+        </p:spPr>
+        <p:txBody>
+          <a:bodyPr wrap="square" lIns="18288" rIns="18288" tIns="0" bIns="0">
+            <a:spAutoFit/>
+          </a:bodyPr>
+          <a:lstStyle/>
+          <a:p>
+            <a:pPr algn="l"/>
+            <a:r>
+              <a:rPr sz="900" b="0" i="1">
+                <a:solidFill>
+                  <a:srgbClr val="843C0C"/>
+                </a:solidFill>
+                <a:latin typeface="Calibri"/>
+              </a:rPr>
+              <a:t>Φᵥ⁽ᵏ⁾ kept per view → enters the next outer iteration as Φᵥ⁽ᵏ⁾</a:t>
+            </a:r>
+          </a:p>
+        </p:txBody>
+      </p:sp>
+      <p:sp>
+        <p:nvSpPr>
+          <p:cNvPr id="14" name="Rounded Rectangle 13"/>
+          <p:cNvSpPr/>
+          <p:nvPr/>
+        </p:nvSpPr>
+        <p:spPr>
+          <a:xfrm>
+            <a:off x="3063240" y="3977639"/>
+            <a:ext cx="3611880" cy="1005840"/>
+          </a:xfrm>
+          <a:prstGeom prst="roundRect">
+            <a:avLst>
+              <a:gd name="adj" fmla="val 12000"/>
+            </a:avLst>
+          </a:prstGeom>
+          <a:solidFill>
+            <a:srgbClr val="FFF2CC"/>
+          </a:solidFill>
+          <a:ln w="15875">
+            <a:solidFill>
+              <a:srgbClr val="BF9000"/>
+            </a:solidFill>
+          </a:ln>
+          <a:effectLst/>
+        </p:spPr>
+        <p:style>
+          <a:lnRef idx="1">
+            <a:schemeClr val="accent1"/>
+          </a:lnRef>
+          <a:fillRef idx="3">
+            <a:schemeClr val="accent1"/>
+          </a:fillRef>
+          <a:effectRef idx="2">
+            <a:schemeClr val="accent1"/>
+          </a:effectRef>
+          <a:fontRef idx="minor">
+            <a:schemeClr val="lt1"/>
+          </a:fontRef>
+        </p:style>
+        <p:txBody>
+          <a:bodyPr rtlCol="0" anchor="ctr" wrap="square" lIns="54864" rIns="54864" tIns="27432" bIns="27432"/>
+          <a:lstStyle/>
+          <a:p>
+            <a:pPr algn="ctr"/>
+            <a:r>
+              <a:rPr sz="1100" b="1">
+                <a:solidFill>
+                  <a:srgbClr val="7F6000"/>
+                </a:solidFill>
+                <a:latin typeface="Calibri"/>
+              </a:rPr>
+              <a:t>Scatter-to-primary ratio of every view</a:t>
+            </a:r>
+          </a:p>
+          <a:p>
+            <a:pPr algn="ctr"/>
+            <a:r>
+              <a:rPr sz="1100" b="0">
+                <a:solidFill>
+                  <a:srgbClr val="7F6000"/>
+                </a:solidFill>
+                <a:latin typeface="Calibri"/>
+              </a:rPr>
+              <a:t>SPRᵥ = sᵥ / pᵥ</a:t>
+            </a:r>
+          </a:p>
+          <a:p>
+            <a:pPr algn="ctr"/>
+            <a:r>
+              <a:rPr sz="1100" b="0">
+                <a:solidFill>
+                  <a:srgbClr val="7F6000"/>
+                </a:solidFill>
+                <a:latin typeface="Calibri"/>
+              </a:rPr>
+              <a:t>sᵥ: projected scatter of Φᵥ⁽ᵏ⁾;  pᵥ: primary of Xₖ</a:t>
+            </a:r>
+          </a:p>
+        </p:txBody>
+      </p:sp>
+      <p:sp>
+        <p:nvSpPr>
+          <p:cNvPr id="15" name="Rounded Rectangle 14"/>
+          <p:cNvSpPr/>
+          <p:nvPr/>
+        </p:nvSpPr>
+        <p:spPr>
+          <a:xfrm>
+            <a:off x="6995160" y="3977639"/>
+            <a:ext cx="2194560" cy="1005840"/>
+          </a:xfrm>
+          <a:prstGeom prst="roundRect">
+            <a:avLst>
+              <a:gd name="adj" fmla="val 12000"/>
+            </a:avLst>
+          </a:prstGeom>
+          <a:solidFill>
+            <a:srgbClr val="FFF2CC"/>
+          </a:solidFill>
+          <a:ln w="15875">
+            <a:solidFill>
+              <a:srgbClr val="BF9000"/>
+            </a:solidFill>
+          </a:ln>
+          <a:effectLst/>
+        </p:spPr>
+        <p:style>
+          <a:lnRef idx="1">
+            <a:schemeClr val="accent1"/>
+          </a:lnRef>
+          <a:fillRef idx="3">
+            <a:schemeClr val="accent1"/>
+          </a:fillRef>
+          <a:effectRef idx="2">
+            <a:schemeClr val="accent1"/>
+          </a:effectRef>
+          <a:fontRef idx="minor">
+            <a:schemeClr val="lt1"/>
+          </a:fontRef>
+        </p:style>
+        <p:txBody>
+          <a:bodyPr rtlCol="0" anchor="ctr" wrap="square" lIns="54864" rIns="54864" tIns="27432" bIns="27432"/>
+          <a:lstStyle/>
+          <a:p>
+            <a:pPr algn="ctr"/>
+            <a:r>
+              <a:rPr sz="1100" b="1">
+                <a:solidFill>
+                  <a:srgbClr val="7F6000"/>
+                </a:solidFill>
+                <a:latin typeface="Calibri"/>
+              </a:rPr>
+              <a:t>Corrected projections</a:t>
+            </a:r>
+          </a:p>
+          <a:p>
+            <a:pPr algn="ctr"/>
+            <a:r>
+              <a:rPr sz="1100" b="0">
+                <a:solidFill>
+                  <a:srgbClr val="7F6000"/>
+                </a:solidFill>
+                <a:latin typeface="Calibri"/>
+              </a:rPr>
+              <a:t>Yᵥ / (1 + SPRᵥ)</a:t>
+            </a:r>
+          </a:p>
+        </p:txBody>
+      </p:sp>
+      <p:sp>
+        <p:nvSpPr>
+          <p:cNvPr id="16" name="Rounded Rectangle 15"/>
+          <p:cNvSpPr/>
+          <p:nvPr/>
+        </p:nvSpPr>
+        <p:spPr>
+          <a:xfrm>
+            <a:off x="9509760" y="3977639"/>
+            <a:ext cx="2103120" cy="1005840"/>
           </a:xfrm>
           <a:prstGeom prst="roundRect">
             <a:avLst>
@@ -3302,21 +3978,33 @@
                 </a:solidFill>
                 <a:latin typeface="Calibri"/>
               </a:rPr>
-              <a:t>Initial volume X₀</a:t>
+              <a:t>n MBIR iterations</a:t>
+            </a:r>
+          </a:p>
+          <a:p>
+            <a:pPr algn="ctr"/>
+            <a:r>
+              <a:rPr sz="1100" b="0">
+                <a:solidFill>
+                  <a:srgbClr val="1F3864"/>
+                </a:solidFill>
+                <a:latin typeface="Calibri"/>
+              </a:rPr>
+              <a:t>warm-started at Xₖ  →  Xₖ₊₁</a:t>
             </a:r>
           </a:p>
         </p:txBody>
       </p:sp>
       <p:cxnSp>
         <p:nvCxnSpPr>
-          <p:cNvPr id="5" name="Connector 4"/>
+          <p:cNvPr id="17" name="Connector 16"/>
           <p:cNvCxnSpPr/>
           <p:nvPr/>
         </p:nvCxnSpPr>
         <p:spPr>
           <a:xfrm>
-            <a:off x="1348740" y="1737360"/>
-            <a:ext cx="0" cy="502920"/>
+            <a:off x="6812279" y="3154679"/>
+            <a:ext cx="0" cy="594360"/>
           </a:xfrm>
           <a:prstGeom prst="line">
             <a:avLst/>
@@ -3325,725 +4013,6 @@
             <a:solidFill>
               <a:srgbClr val="595959"/>
             </a:solidFill>
-            <a:tailEnd type="triangle" w="med" len="med"/>
-          </a:ln>
-        </p:spPr>
-        <p:style>
-          <a:lnRef idx="2">
-            <a:schemeClr val="accent1"/>
-          </a:lnRef>
-          <a:fillRef idx="0">
-            <a:schemeClr val="accent1"/>
-          </a:fillRef>
-          <a:effectRef idx="1">
-            <a:schemeClr val="accent1"/>
-          </a:effectRef>
-          <a:fontRef idx="minor">
-            <a:schemeClr val="tx1"/>
-          </a:fontRef>
-        </p:style>
-      </p:cxnSp>
-      <p:cxnSp>
-        <p:nvCxnSpPr>
-          <p:cNvPr id="6" name="Connector 5"/>
-          <p:cNvCxnSpPr/>
-          <p:nvPr/>
-        </p:nvCxnSpPr>
-        <p:spPr>
-          <a:xfrm>
-            <a:off x="1348740" y="3108960"/>
-            <a:ext cx="0" cy="502920"/>
-          </a:xfrm>
-          <a:prstGeom prst="line">
-            <a:avLst/>
-          </a:prstGeom>
-          <a:ln w="19050">
-            <a:solidFill>
-              <a:srgbClr val="595959"/>
-            </a:solidFill>
-            <a:tailEnd type="triangle" w="med" len="med"/>
-          </a:ln>
-        </p:spPr>
-        <p:style>
-          <a:lnRef idx="2">
-            <a:schemeClr val="accent1"/>
-          </a:lnRef>
-          <a:fillRef idx="0">
-            <a:schemeClr val="accent1"/>
-          </a:fillRef>
-          <a:effectRef idx="1">
-            <a:schemeClr val="accent1"/>
-          </a:effectRef>
-          <a:fontRef idx="minor">
-            <a:schemeClr val="tx1"/>
-          </a:fontRef>
-        </p:style>
-      </p:cxnSp>
-      <p:sp>
-        <p:nvSpPr>
-          <p:cNvPr id="7" name="Rounded Rectangle 6"/>
-          <p:cNvSpPr/>
-          <p:nvPr/>
-        </p:nvSpPr>
-        <p:spPr>
-          <a:xfrm>
-            <a:off x="2788920" y="411480"/>
-            <a:ext cx="9098280" cy="5440680"/>
-          </a:xfrm>
-          <a:prstGeom prst="roundRect">
-            <a:avLst>
-              <a:gd name="adj" fmla="val 4000"/>
-            </a:avLst>
-          </a:prstGeom>
-          <a:noFill/>
-          <a:ln w="15875">
-            <a:solidFill>
-              <a:srgbClr val="595959"/>
-            </a:solidFill>
-            <a:prstDash val="dash"/>
-          </a:ln>
-          <a:effectLst/>
-        </p:spPr>
-        <p:style>
-          <a:lnRef idx="1">
-            <a:schemeClr val="accent1"/>
-          </a:lnRef>
-          <a:fillRef idx="3">
-            <a:schemeClr val="accent1"/>
-          </a:fillRef>
-          <a:effectRef idx="2">
-            <a:schemeClr val="accent1"/>
-          </a:effectRef>
-          <a:fontRef idx="minor">
-            <a:schemeClr val="lt1"/>
-          </a:fontRef>
-        </p:style>
-        <p:txBody>
-          <a:bodyPr rtlCol="0" anchor="ctr" wrap="square" lIns="54864" rIns="54864" tIns="27432" bIns="27432"/>
-          <a:lstStyle/>
-          <a:p>
-            <a:pPr algn="ctr"/>
-            <a:r>
-              <a:rPr sz="1100" b="1">
-                <a:solidFill>
-                  <a:srgbClr val="404040"/>
-                </a:solidFill>
-                <a:latin typeface="Calibri"/>
-              </a:rPr>
-              <a:t/>
-            </a:r>
-          </a:p>
-        </p:txBody>
-      </p:sp>
-      <p:sp>
-        <p:nvSpPr>
-          <p:cNvPr id="8" name="TextBox 7"/>
-          <p:cNvSpPr txBox="1"/>
-          <p:nvPr/>
-        </p:nvSpPr>
-        <p:spPr>
-          <a:xfrm>
-            <a:off x="3017520" y="457200"/>
-            <a:ext cx="8686800" cy="274320"/>
-          </a:xfrm>
-          <a:prstGeom prst="rect">
-            <a:avLst/>
-          </a:prstGeom>
-          <a:noFill/>
-        </p:spPr>
-        <p:txBody>
-          <a:bodyPr wrap="square" lIns="18288" rIns="18288" tIns="0" bIns="0">
-            <a:spAutoFit/>
-          </a:bodyPr>
-          <a:lstStyle/>
-          <a:p>
-            <a:pPr algn="l"/>
-            <a:r>
-              <a:rPr sz="1100" b="1" i="0">
-                <a:solidFill>
-                  <a:srgbClr val="404040"/>
-                </a:solidFill>
-                <a:latin typeface="Calibri"/>
-              </a:rPr>
-              <a:t>Outer iteration k:  one scatter step per view  +  one MBIR iteration   (repeated N times)</a:t>
-            </a:r>
-          </a:p>
-        </p:txBody>
-      </p:sp>
-      <p:sp>
-        <p:nvSpPr>
-          <p:cNvPr id="9" name="Rounded Rectangle 8"/>
-          <p:cNvSpPr/>
-          <p:nvPr/>
-        </p:nvSpPr>
-        <p:spPr>
-          <a:xfrm>
-            <a:off x="3200400" y="914400"/>
-            <a:ext cx="3566160" cy="960120"/>
-          </a:xfrm>
-          <a:prstGeom prst="roundRect">
-            <a:avLst>
-              <a:gd name="adj" fmla="val 12000"/>
-            </a:avLst>
-          </a:prstGeom>
-          <a:solidFill>
-            <a:srgbClr val="E2F0D9"/>
-          </a:solidFill>
-          <a:ln w="15875">
-            <a:solidFill>
-              <a:srgbClr val="548235"/>
-            </a:solidFill>
-          </a:ln>
-          <a:effectLst/>
-        </p:spPr>
-        <p:style>
-          <a:lnRef idx="1">
-            <a:schemeClr val="accent1"/>
-          </a:lnRef>
-          <a:fillRef idx="3">
-            <a:schemeClr val="accent1"/>
-          </a:fillRef>
-          <a:effectRef idx="2">
-            <a:schemeClr val="accent1"/>
-          </a:effectRef>
-          <a:fontRef idx="minor">
-            <a:schemeClr val="lt1"/>
-          </a:fontRef>
-        </p:style>
-        <p:txBody>
-          <a:bodyPr rtlCol="0" anchor="ctr" wrap="square" lIns="54864" rIns="54864" tIns="27432" bIns="27432"/>
-          <a:lstStyle/>
-          <a:p>
-            <a:pPr algn="ctr"/>
-            <a:r>
-              <a:rPr sz="1100" b="1">
-                <a:solidFill>
-                  <a:srgbClr val="385723"/>
-                </a:solidFill>
-                <a:latin typeface="Calibri"/>
-              </a:rPr>
-              <a:t>Density model</a:t>
-            </a:r>
-          </a:p>
-          <a:p>
-            <a:pPr algn="ctr"/>
-            <a:r>
-              <a:rPr sz="1100" b="0">
-                <a:solidFill>
-                  <a:srgbClr val="385723"/>
-                </a:solidFill>
-                <a:latin typeface="Calibri"/>
-              </a:rPr>
-              <a:t>Xₖ → densities of the anchor materials</a:t>
-            </a:r>
-          </a:p>
-          <a:p>
-            <a:pPr algn="ctr"/>
-            <a:r>
-              <a:rPr sz="1100" b="0">
-                <a:solidFill>
-                  <a:srgbClr val="385723"/>
-                </a:solidFill>
-                <a:latin typeface="Calibri"/>
-              </a:rPr>
-              <a:t>(two materials per voxel, one map at a time)</a:t>
-            </a:r>
-          </a:p>
-        </p:txBody>
-      </p:sp>
-      <p:sp>
-        <p:nvSpPr>
-          <p:cNvPr id="10" name="Rounded Rectangle 9"/>
-          <p:cNvSpPr/>
-          <p:nvPr/>
-        </p:nvSpPr>
-        <p:spPr>
-          <a:xfrm>
-            <a:off x="7132320" y="914400"/>
-            <a:ext cx="4572000" cy="960120"/>
-          </a:xfrm>
-          <a:prstGeom prst="roundRect">
-            <a:avLst>
-              <a:gd name="adj" fmla="val 12000"/>
-            </a:avLst>
-          </a:prstGeom>
-          <a:solidFill>
-            <a:srgbClr val="E2F0D9"/>
-          </a:solidFill>
-          <a:ln w="15875">
-            <a:solidFill>
-              <a:srgbClr val="548235"/>
-            </a:solidFill>
-          </a:ln>
-          <a:effectLst/>
-        </p:spPr>
-        <p:style>
-          <a:lnRef idx="1">
-            <a:schemeClr val="accent1"/>
-          </a:lnRef>
-          <a:fillRef idx="3">
-            <a:schemeClr val="accent1"/>
-          </a:fillRef>
-          <a:effectRef idx="2">
-            <a:schemeClr val="accent1"/>
-          </a:effectRef>
-          <a:fontRef idx="minor">
-            <a:schemeClr val="lt1"/>
-          </a:fontRef>
-        </p:style>
-        <p:txBody>
-          <a:bodyPr rtlCol="0" anchor="ctr" wrap="square" lIns="54864" rIns="54864" tIns="27432" bIns="27432"/>
-          <a:lstStyle/>
-          <a:p>
-            <a:pPr algn="ctr"/>
-            <a:r>
-              <a:rPr sz="1100" b="1">
-                <a:solidFill>
-                  <a:srgbClr val="385723"/>
-                </a:solidFill>
-                <a:latin typeface="Calibri"/>
-              </a:rPr>
-              <a:t>Transport and quadrature grids</a:t>
-            </a:r>
-          </a:p>
-          <a:p>
-            <a:pPr algn="ctr"/>
-            <a:r>
-              <a:rPr sz="1100" b="0">
-                <a:solidFill>
-                  <a:srgbClr val="385723"/>
-                </a:solidFill>
-                <a:latin typeface="Calibri"/>
-              </a:rPr>
-              <a:t>conservative resampling onto cubic transport cells (1 cm)</a:t>
-            </a:r>
-          </a:p>
-          <a:p>
-            <a:pPr algn="ctr"/>
-            <a:r>
-              <a:rPr sz="1100" b="0">
-                <a:solidFill>
-                  <a:srgbClr val="385723"/>
-                </a:solidFill>
-                <a:latin typeface="Calibri"/>
-              </a:rPr>
-              <a:t>and q³ quadrature points per cell, any voxel size</a:t>
-            </a:r>
-          </a:p>
-        </p:txBody>
-      </p:sp>
-      <p:cxnSp>
-        <p:nvCxnSpPr>
-          <p:cNvPr id="11" name="Connector 10"/>
-          <p:cNvCxnSpPr/>
-          <p:nvPr/>
-        </p:nvCxnSpPr>
-        <p:spPr>
-          <a:xfrm>
-            <a:off x="6766560" y="1394460"/>
-            <a:ext cx="365760" cy="0"/>
-          </a:xfrm>
-          <a:prstGeom prst="line">
-            <a:avLst/>
-          </a:prstGeom>
-          <a:ln w="19050">
-            <a:solidFill>
-              <a:srgbClr val="595959"/>
-            </a:solidFill>
-            <a:tailEnd type="triangle" w="med" len="med"/>
-          </a:ln>
-        </p:spPr>
-        <p:style>
-          <a:lnRef idx="2">
-            <a:schemeClr val="accent1"/>
-          </a:lnRef>
-          <a:fillRef idx="0">
-            <a:schemeClr val="accent1"/>
-          </a:fillRef>
-          <a:effectRef idx="1">
-            <a:schemeClr val="accent1"/>
-          </a:effectRef>
-          <a:fontRef idx="minor">
-            <a:schemeClr val="tx1"/>
-          </a:fontRef>
-        </p:style>
-      </p:cxnSp>
-      <p:sp>
-        <p:nvSpPr>
-          <p:cNvPr id="12" name="Rectangle 11"/>
-          <p:cNvSpPr/>
-          <p:nvPr/>
-        </p:nvSpPr>
-        <p:spPr>
-          <a:xfrm>
-            <a:off x="3611880" y="2148840"/>
-            <a:ext cx="8138159" cy="1783080"/>
-          </a:xfrm>
-          <a:prstGeom prst="rect">
-            <a:avLst/>
-          </a:prstGeom>
-          <a:solidFill>
-            <a:srgbClr val="FDF3EC"/>
-          </a:solidFill>
-          <a:ln w="9525">
-            <a:solidFill>
-              <a:srgbClr val="C55A11"/>
-            </a:solidFill>
-          </a:ln>
-          <a:effectLst/>
-        </p:spPr>
-        <p:style>
-          <a:lnRef idx="1">
-            <a:schemeClr val="accent1"/>
-          </a:lnRef>
-          <a:fillRef idx="3">
-            <a:schemeClr val="accent1"/>
-          </a:fillRef>
-          <a:effectRef idx="2">
-            <a:schemeClr val="accent1"/>
-          </a:effectRef>
-          <a:fontRef idx="minor">
-            <a:schemeClr val="lt1"/>
-          </a:fontRef>
-        </p:style>
-        <p:txBody>
-          <a:bodyPr rtlCol="0" anchor="ctr" wrap="square" lIns="54864" rIns="54864" tIns="27432" bIns="27432"/>
-          <a:lstStyle/>
-          <a:p>
-            <a:pPr algn="ctr"/>
-            <a:r>
-              <a:rPr sz="1100" b="1">
-                <a:solidFill>
-                  <a:srgbClr val="843C0C"/>
-                </a:solidFill>
-                <a:latin typeface="Calibri"/>
-              </a:rPr>
-              <a:t/>
-            </a:r>
-          </a:p>
-        </p:txBody>
-      </p:sp>
-      <p:sp>
-        <p:nvSpPr>
-          <p:cNvPr id="13" name="TextBox 12"/>
-          <p:cNvSpPr txBox="1"/>
-          <p:nvPr/>
-        </p:nvSpPr>
-        <p:spPr>
-          <a:xfrm>
-            <a:off x="3703320" y="2176272"/>
-            <a:ext cx="7772400" cy="256032"/>
-          </a:xfrm>
-          <a:prstGeom prst="rect">
-            <a:avLst/>
-          </a:prstGeom>
-          <a:noFill/>
-        </p:spPr>
-        <p:txBody>
-          <a:bodyPr wrap="square" lIns="18288" rIns="18288" tIns="0" bIns="0">
-            <a:spAutoFit/>
-          </a:bodyPr>
-          <a:lstStyle/>
-          <a:p>
-            <a:pPr algn="l"/>
-            <a:r>
-              <a:rPr sz="1000" b="1" i="0">
-                <a:solidFill>
-                  <a:srgbClr val="843C0C"/>
-                </a:solidFill>
-                <a:latin typeface="Calibri"/>
-              </a:rPr>
-              <a:t>LBTE scatter solver, one step per view v (deterministic, multigroup, discrete ordinates)</a:t>
-            </a:r>
-          </a:p>
-        </p:txBody>
-      </p:sp>
-      <p:sp>
-        <p:nvSpPr>
-          <p:cNvPr id="14" name="Rounded Rectangle 13"/>
-          <p:cNvSpPr/>
-          <p:nvPr/>
-        </p:nvSpPr>
-        <p:spPr>
-          <a:xfrm>
-            <a:off x="3749039" y="2514600"/>
-            <a:ext cx="2514600" cy="1143000"/>
-          </a:xfrm>
-          <a:prstGeom prst="roundRect">
-            <a:avLst>
-              <a:gd name="adj" fmla="val 12000"/>
-            </a:avLst>
-          </a:prstGeom>
-          <a:solidFill>
-            <a:srgbClr val="FBE5D6"/>
-          </a:solidFill>
-          <a:ln w="15875">
-            <a:solidFill>
-              <a:srgbClr val="C55A11"/>
-            </a:solidFill>
-          </a:ln>
-          <a:effectLst/>
-        </p:spPr>
-        <p:style>
-          <a:lnRef idx="1">
-            <a:schemeClr val="accent1"/>
-          </a:lnRef>
-          <a:fillRef idx="3">
-            <a:schemeClr val="accent1"/>
-          </a:fillRef>
-          <a:effectRef idx="2">
-            <a:schemeClr val="accent1"/>
-          </a:effectRef>
-          <a:fontRef idx="minor">
-            <a:schemeClr val="lt1"/>
-          </a:fontRef>
-        </p:style>
-        <p:txBody>
-          <a:bodyPr rtlCol="0" anchor="ctr" wrap="square" lIns="54864" rIns="54864" tIns="27432" bIns="27432"/>
-          <a:lstStyle/>
-          <a:p>
-            <a:pPr algn="ctr"/>
-            <a:r>
-              <a:rPr sz="1100" b="1">
-                <a:solidFill>
-                  <a:srgbClr val="843C0C"/>
-                </a:solidFill>
-                <a:latin typeface="Calibri"/>
-              </a:rPr>
-              <a:t>Uncollided fluence</a:t>
-            </a:r>
-          </a:p>
-          <a:p>
-            <a:pPr algn="ctr"/>
-            <a:r>
-              <a:rPr sz="1100" b="0">
-                <a:solidFill>
-                  <a:srgbClr val="843C0C"/>
-                </a:solidFill>
-                <a:latin typeface="Calibri"/>
-              </a:rPr>
-              <a:t>ray traced through the quadrature grid,</a:t>
-            </a:r>
-          </a:p>
-          <a:p>
-            <a:pPr algn="ctr"/>
-            <a:r>
-              <a:rPr sz="1100" b="0">
-                <a:solidFill>
-                  <a:srgbClr val="843C0C"/>
-                </a:solidFill>
-                <a:latin typeface="Calibri"/>
-              </a:rPr>
-              <a:t>first-collision source on its points</a:t>
-            </a:r>
-          </a:p>
-        </p:txBody>
-      </p:sp>
-      <p:sp>
-        <p:nvSpPr>
-          <p:cNvPr id="15" name="Rounded Rectangle 14"/>
-          <p:cNvSpPr/>
-          <p:nvPr/>
-        </p:nvSpPr>
-        <p:spPr>
-          <a:xfrm>
-            <a:off x="6537960" y="2514600"/>
-            <a:ext cx="2697480" cy="1143000"/>
-          </a:xfrm>
-          <a:prstGeom prst="roundRect">
-            <a:avLst>
-              <a:gd name="adj" fmla="val 12000"/>
-            </a:avLst>
-          </a:prstGeom>
-          <a:solidFill>
-            <a:srgbClr val="FBE5D6"/>
-          </a:solidFill>
-          <a:ln w="15875">
-            <a:solidFill>
-              <a:srgbClr val="C55A11"/>
-            </a:solidFill>
-          </a:ln>
-          <a:effectLst/>
-        </p:spPr>
-        <p:style>
-          <a:lnRef idx="1">
-            <a:schemeClr val="accent1"/>
-          </a:lnRef>
-          <a:fillRef idx="3">
-            <a:schemeClr val="accent1"/>
-          </a:fillRef>
-          <a:effectRef idx="2">
-            <a:schemeClr val="accent1"/>
-          </a:effectRef>
-          <a:fontRef idx="minor">
-            <a:schemeClr val="lt1"/>
-          </a:fontRef>
-        </p:style>
-        <p:txBody>
-          <a:bodyPr rtlCol="0" anchor="ctr" wrap="square" lIns="54864" rIns="54864" tIns="27432" bIns="27432"/>
-          <a:lstStyle/>
-          <a:p>
-            <a:pPr algn="ctr"/>
-            <a:r>
-              <a:rPr sz="1000" b="1">
-                <a:solidFill>
-                  <a:srgbClr val="843C0C"/>
-                </a:solidFill>
-                <a:latin typeface="Calibri"/>
-              </a:rPr>
-              <a:t>One transport sweep</a:t>
-            </a:r>
-          </a:p>
-          <a:p>
-            <a:pPr algn="ctr"/>
-            <a:r>
-              <a:rPr sz="1000" b="0">
-                <a:solidFill>
-                  <a:srgbClr val="843C0C"/>
-                </a:solidFill>
-                <a:latin typeface="Calibri"/>
-              </a:rPr>
-              <a:t>linear-discontinuous cells of C, fed by</a:t>
-            </a:r>
-          </a:p>
-          <a:p>
-            <a:pPr algn="ctr"/>
-            <a:r>
-              <a:rPr sz="1000" b="0">
-                <a:solidFill>
-                  <a:srgbClr val="843C0C"/>
-                </a:solidFill>
-                <a:latin typeface="Calibri"/>
-              </a:rPr>
-              <a:t>the first-collision source + the</a:t>
-            </a:r>
-          </a:p>
-          <a:p>
-            <a:pPr algn="ctr"/>
-            <a:r>
-              <a:rPr sz="1000" b="0">
-                <a:solidFill>
-                  <a:srgbClr val="843C0C"/>
-                </a:solidFill>
-                <a:latin typeface="Calibri"/>
-              </a:rPr>
-              <a:t>aged accumulator Φᵥ⁽ᵏ⁻¹⁾ → Φᵥ⁽ᵏ⁾</a:t>
-            </a:r>
-          </a:p>
-        </p:txBody>
-      </p:sp>
-      <p:sp>
-        <p:nvSpPr>
-          <p:cNvPr id="16" name="Rounded Rectangle 15"/>
-          <p:cNvSpPr/>
-          <p:nvPr/>
-        </p:nvSpPr>
-        <p:spPr>
-          <a:xfrm>
-            <a:off x="9509760" y="2514600"/>
-            <a:ext cx="2148840" cy="1143000"/>
-          </a:xfrm>
-          <a:prstGeom prst="roundRect">
-            <a:avLst>
-              <a:gd name="adj" fmla="val 12000"/>
-            </a:avLst>
-          </a:prstGeom>
-          <a:solidFill>
-            <a:srgbClr val="FBE5D6"/>
-          </a:solidFill>
-          <a:ln w="15875">
-            <a:solidFill>
-              <a:srgbClr val="C55A11"/>
-            </a:solidFill>
-          </a:ln>
-          <a:effectLst/>
-        </p:spPr>
-        <p:style>
-          <a:lnRef idx="1">
-            <a:schemeClr val="accent1"/>
-          </a:lnRef>
-          <a:fillRef idx="3">
-            <a:schemeClr val="accent1"/>
-          </a:fillRef>
-          <a:effectRef idx="2">
-            <a:schemeClr val="accent1"/>
-          </a:effectRef>
-          <a:fontRef idx="minor">
-            <a:schemeClr val="lt1"/>
-          </a:fontRef>
-        </p:style>
-        <p:txBody>
-          <a:bodyPr rtlCol="0" anchor="ctr" wrap="square" lIns="54864" rIns="54864" tIns="27432" bIns="27432"/>
-          <a:lstStyle/>
-          <a:p>
-            <a:pPr algn="ctr"/>
-            <a:r>
-              <a:rPr sz="1000" b="1">
-                <a:solidFill>
-                  <a:srgbClr val="843C0C"/>
-                </a:solidFill>
-                <a:latin typeface="Calibri"/>
-              </a:rPr>
-              <a:t>Collapsed-cone projection</a:t>
-            </a:r>
-          </a:p>
-          <a:p>
-            <a:pPr algn="ctr"/>
-            <a:r>
-              <a:rPr sz="1000" b="0">
-                <a:solidFill>
-                  <a:srgbClr val="843C0C"/>
-                </a:solidFill>
-                <a:latin typeface="Calibri"/>
-              </a:rPr>
-              <a:t>first-order + multiple-collision</a:t>
-            </a:r>
-          </a:p>
-          <a:p>
-            <a:pPr algn="ctr"/>
-            <a:r>
-              <a:rPr sz="1000" b="0">
-                <a:solidFill>
-                  <a:srgbClr val="843C0C"/>
-                </a:solidFill>
-                <a:latin typeface="Calibri"/>
-              </a:rPr>
-              <a:t>emission to the panel</a:t>
-            </a:r>
-          </a:p>
-          <a:p>
-            <a:pPr algn="ctr"/>
-            <a:r>
-              <a:rPr sz="1000" b="0">
-                <a:solidFill>
-                  <a:srgbClr val="843C0C"/>
-                </a:solidFill>
-                <a:latin typeface="Calibri"/>
-              </a:rPr>
-              <a:t>→ scatter sᵥ</a:t>
-            </a:r>
-          </a:p>
-        </p:txBody>
-      </p:sp>
-      <p:cxnSp>
-        <p:nvCxnSpPr>
-          <p:cNvPr id="17" name="Connector 16"/>
-          <p:cNvCxnSpPr/>
-          <p:nvPr/>
-        </p:nvCxnSpPr>
-        <p:spPr>
-          <a:xfrm>
-            <a:off x="6263639" y="3086100"/>
-            <a:ext cx="274321" cy="0"/>
-          </a:xfrm>
-          <a:prstGeom prst="line">
-            <a:avLst/>
-          </a:prstGeom>
-          <a:ln w="19050">
-            <a:solidFill>
-              <a:srgbClr val="595959"/>
-            </a:solidFill>
-            <a:tailEnd type="triangle" w="med" len="med"/>
           </a:ln>
         </p:spPr>
         <p:style>
@@ -4068,9 +4037,9 @@
           <p:nvPr/>
         </p:nvCxnSpPr>
         <p:spPr>
-          <a:xfrm>
-            <a:off x="9235440" y="3086100"/>
-            <a:ext cx="274320" cy="0"/>
+          <a:xfrm flipH="1">
+            <a:off x="5417820" y="3749039"/>
+            <a:ext cx="1394459" cy="0"/>
           </a:xfrm>
           <a:prstGeom prst="line">
             <a:avLst/>
@@ -4079,7 +4048,6 @@
             <a:solidFill>
               <a:srgbClr val="595959"/>
             </a:solidFill>
-            <a:tailEnd type="triangle" w="med" len="med"/>
           </a:ln>
         </p:spPr>
         <p:style>
@@ -4105,17 +4073,159 @@
         </p:nvCxnSpPr>
         <p:spPr>
           <a:xfrm>
-            <a:off x="8709660" y="3657600"/>
-            <a:ext cx="0" cy="155448"/>
+            <a:off x="5417820" y="3749039"/>
+            <a:ext cx="0" cy="228600"/>
           </a:xfrm>
           <a:prstGeom prst="line">
             <a:avLst/>
           </a:prstGeom>
-          <a:ln w="15875">
+          <a:ln w="19050">
             <a:solidFill>
-              <a:srgbClr val="C55A11"/>
+              <a:srgbClr val="595959"/>
             </a:solidFill>
-            <a:prstDash val="dash"/>
+            <a:tailEnd type="triangle" w="med" len="med"/>
+          </a:ln>
+        </p:spPr>
+        <p:style>
+          <a:lnRef idx="2">
+            <a:schemeClr val="accent1"/>
+          </a:lnRef>
+          <a:fillRef idx="0">
+            <a:schemeClr val="accent1"/>
+          </a:fillRef>
+          <a:effectRef idx="1">
+            <a:schemeClr val="accent1"/>
+          </a:effectRef>
+          <a:fontRef idx="minor">
+            <a:schemeClr val="tx1"/>
+          </a:fontRef>
+        </p:style>
+      </p:cxnSp>
+      <p:sp>
+        <p:nvSpPr>
+          <p:cNvPr id="20" name="TextBox 19"/>
+          <p:cNvSpPr txBox="1"/>
+          <p:nvPr/>
+        </p:nvSpPr>
+        <p:spPr>
+          <a:xfrm>
+            <a:off x="5490972" y="3749039"/>
+            <a:ext cx="457200" cy="182880"/>
+          </a:xfrm>
+          <a:prstGeom prst="rect">
+            <a:avLst/>
+          </a:prstGeom>
+          <a:noFill/>
+        </p:spPr>
+        <p:txBody>
+          <a:bodyPr wrap="square" lIns="18288" rIns="18288" tIns="0" bIns="0">
+            <a:spAutoFit/>
+          </a:bodyPr>
+          <a:lstStyle/>
+          <a:p>
+            <a:pPr algn="l"/>
+            <a:r>
+              <a:rPr sz="1000" b="0" i="1">
+                <a:solidFill>
+                  <a:srgbClr val="843C0C"/>
+                </a:solidFill>
+                <a:latin typeface="Calibri"/>
+              </a:rPr>
+              <a:t>sᵥ</a:t>
+            </a:r>
+          </a:p>
+        </p:txBody>
+      </p:sp>
+      <p:cxnSp>
+        <p:nvCxnSpPr>
+          <p:cNvPr id="21" name="Connector 20"/>
+          <p:cNvCxnSpPr/>
+          <p:nvPr/>
+        </p:nvCxnSpPr>
+        <p:spPr>
+          <a:xfrm>
+            <a:off x="3634740" y="1874519"/>
+            <a:ext cx="0" cy="2103120"/>
+          </a:xfrm>
+          <a:prstGeom prst="line">
+            <a:avLst/>
+          </a:prstGeom>
+          <a:ln w="19050">
+            <a:solidFill>
+              <a:srgbClr val="7030A0"/>
+            </a:solidFill>
+            <a:tailEnd type="triangle" w="med" len="med"/>
+          </a:ln>
+        </p:spPr>
+        <p:style>
+          <a:lnRef idx="2">
+            <a:schemeClr val="accent1"/>
+          </a:lnRef>
+          <a:fillRef idx="0">
+            <a:schemeClr val="accent1"/>
+          </a:fillRef>
+          <a:effectRef idx="1">
+            <a:schemeClr val="accent1"/>
+          </a:effectRef>
+          <a:fontRef idx="minor">
+            <a:schemeClr val="tx1"/>
+          </a:fontRef>
+        </p:style>
+      </p:cxnSp>
+      <p:sp>
+        <p:nvSpPr>
+          <p:cNvPr id="22" name="TextBox 21"/>
+          <p:cNvSpPr txBox="1"/>
+          <p:nvPr/>
+        </p:nvSpPr>
+        <p:spPr>
+          <a:xfrm>
+            <a:off x="3680460" y="3291840"/>
+            <a:ext cx="822960" cy="182880"/>
+          </a:xfrm>
+          <a:prstGeom prst="rect">
+            <a:avLst/>
+          </a:prstGeom>
+          <a:noFill/>
+        </p:spPr>
+        <p:txBody>
+          <a:bodyPr wrap="square" lIns="18288" rIns="18288" tIns="0" bIns="0">
+            <a:spAutoFit/>
+          </a:bodyPr>
+          <a:lstStyle/>
+          <a:p>
+            <a:pPr algn="l"/>
+            <a:r>
+              <a:rPr sz="1000" b="0" i="1">
+                <a:solidFill>
+                  <a:srgbClr val="7030A0"/>
+                </a:solidFill>
+                <a:latin typeface="Calibri"/>
+              </a:rPr>
+              <a:t>pᵥ(Xₖ)</a:t>
+            </a:r>
+          </a:p>
+        </p:txBody>
+      </p:sp>
+      <p:cxnSp>
+        <p:nvCxnSpPr>
+          <p:cNvPr id="23" name="Connector 22"/>
+          <p:cNvCxnSpPr/>
+          <p:nvPr/>
+        </p:nvCxnSpPr>
+        <p:spPr>
+          <a:xfrm>
+            <a:off x="6675120" y="4480559"/>
+            <a:ext cx="320040" cy="0"/>
+          </a:xfrm>
+          <a:prstGeom prst="line">
+            <a:avLst/>
+          </a:prstGeom>
+          <a:ln w="19050">
+            <a:solidFill>
+              <a:srgbClr val="595959"/>
+            </a:solidFill>
+            <a:tailEnd type="triangle" w="med" len="med"/>
           </a:ln>
         </p:spPr>
         <p:style>
@@ -4135,23 +4245,23 @@
       </p:cxnSp>
       <p:cxnSp>
         <p:nvCxnSpPr>
-          <p:cNvPr id="20" name="Connector 19"/>
+          <p:cNvPr id="24" name="Connector 23"/>
           <p:cNvCxnSpPr/>
           <p:nvPr/>
         </p:nvCxnSpPr>
         <p:spPr>
-          <a:xfrm flipH="1">
-            <a:off x="7063740" y="3813048"/>
-            <a:ext cx="1645920" cy="0"/>
+          <a:xfrm>
+            <a:off x="9189720" y="4480559"/>
+            <a:ext cx="320040" cy="0"/>
           </a:xfrm>
           <a:prstGeom prst="line">
             <a:avLst/>
           </a:prstGeom>
-          <a:ln w="15875">
+          <a:ln w="19050">
             <a:solidFill>
-              <a:srgbClr val="C55A11"/>
+              <a:srgbClr val="595959"/>
             </a:solidFill>
-            <a:prstDash val="dash"/>
+            <a:tailEnd type="triangle" w="med" len="med"/>
           </a:ln>
         </p:spPr>
         <p:style>
@@ -4171,24 +4281,22 @@
       </p:cxnSp>
       <p:cxnSp>
         <p:nvCxnSpPr>
-          <p:cNvPr id="21" name="Connector 20"/>
+          <p:cNvPr id="25" name="Connector 24"/>
           <p:cNvCxnSpPr/>
           <p:nvPr/>
         </p:nvCxnSpPr>
         <p:spPr>
-          <a:xfrm flipV="1">
-            <a:off x="7063740" y="3666744"/>
-            <a:ext cx="0" cy="146304"/>
+          <a:xfrm>
+            <a:off x="2377440" y="3451860"/>
+            <a:ext cx="182880" cy="0"/>
           </a:xfrm>
           <a:prstGeom prst="line">
             <a:avLst/>
           </a:prstGeom>
-          <a:ln w="15875">
+          <a:ln w="19050">
             <a:solidFill>
-              <a:srgbClr val="C55A11"/>
+              <a:srgbClr val="595959"/>
             </a:solidFill>
-            <a:prstDash val="dash"/>
-            <a:tailEnd type="triangle" w="med" len="med"/>
           </a:ln>
         </p:spPr>
         <p:style>
@@ -4206,16 +4314,228 @@
           </a:fontRef>
         </p:style>
       </p:cxnSp>
-      <p:sp>
-        <p:nvSpPr>
-          <p:cNvPr id="22" name="TextBox 21"/>
+      <p:cxnSp>
+        <p:nvCxnSpPr>
+          <p:cNvPr id="26" name="Connector 25"/>
+          <p:cNvCxnSpPr/>
+          <p:nvPr/>
+        </p:nvCxnSpPr>
+        <p:spPr>
+          <a:xfrm flipV="1">
+            <a:off x="2560320" y="1394460"/>
+            <a:ext cx="0" cy="2057400"/>
+          </a:xfrm>
+          <a:prstGeom prst="line">
+            <a:avLst/>
+          </a:prstGeom>
+          <a:ln w="19050">
+            <a:solidFill>
+              <a:srgbClr val="595959"/>
+            </a:solidFill>
+          </a:ln>
+        </p:spPr>
+        <p:style>
+          <a:lnRef idx="2">
+            <a:schemeClr val="accent1"/>
+          </a:lnRef>
+          <a:fillRef idx="0">
+            <a:schemeClr val="accent1"/>
+          </a:fillRef>
+          <a:effectRef idx="1">
+            <a:schemeClr val="accent1"/>
+          </a:effectRef>
+          <a:fontRef idx="minor">
+            <a:schemeClr val="tx1"/>
+          </a:fontRef>
+        </p:style>
+      </p:cxnSp>
+      <p:cxnSp>
+        <p:nvCxnSpPr>
+          <p:cNvPr id="27" name="Connector 26"/>
+          <p:cNvCxnSpPr/>
+          <p:nvPr/>
+        </p:nvCxnSpPr>
+        <p:spPr>
+          <a:xfrm>
+            <a:off x="2560320" y="1394460"/>
+            <a:ext cx="502920" cy="0"/>
+          </a:xfrm>
+          <a:prstGeom prst="line">
+            <a:avLst/>
+          </a:prstGeom>
+          <a:ln w="19050">
+            <a:solidFill>
+              <a:srgbClr val="595959"/>
+            </a:solidFill>
+            <a:tailEnd type="triangle" w="med" len="med"/>
+          </a:ln>
+        </p:spPr>
+        <p:style>
+          <a:lnRef idx="2">
+            <a:schemeClr val="accent1"/>
+          </a:lnRef>
+          <a:fillRef idx="0">
+            <a:schemeClr val="accent1"/>
+          </a:fillRef>
+          <a:effectRef idx="1">
+            <a:schemeClr val="accent1"/>
+          </a:effectRef>
+          <a:fontRef idx="minor">
+            <a:schemeClr val="tx1"/>
+          </a:fontRef>
+        </p:style>
+      </p:cxnSp>
+      <p:cxnSp>
+        <p:nvCxnSpPr>
+          <p:cNvPr id="28" name="Connector 27"/>
+          <p:cNvCxnSpPr/>
+          <p:nvPr/>
+        </p:nvCxnSpPr>
+        <p:spPr>
+          <a:xfrm>
+            <a:off x="10561320" y="4983479"/>
+            <a:ext cx="0" cy="594361"/>
+          </a:xfrm>
+          <a:prstGeom prst="line">
+            <a:avLst/>
+          </a:prstGeom>
+          <a:ln w="19050">
+            <a:solidFill>
+              <a:srgbClr val="2F5597"/>
+            </a:solidFill>
+          </a:ln>
+        </p:spPr>
+        <p:style>
+          <a:lnRef idx="2">
+            <a:schemeClr val="accent1"/>
+          </a:lnRef>
+          <a:fillRef idx="0">
+            <a:schemeClr val="accent1"/>
+          </a:fillRef>
+          <a:effectRef idx="1">
+            <a:schemeClr val="accent1"/>
+          </a:effectRef>
+          <a:fontRef idx="minor">
+            <a:schemeClr val="tx1"/>
+          </a:fontRef>
+        </p:style>
+      </p:cxnSp>
+      <p:cxnSp>
+        <p:nvCxnSpPr>
+          <p:cNvPr id="29" name="Connector 28"/>
+          <p:cNvCxnSpPr/>
+          <p:nvPr/>
+        </p:nvCxnSpPr>
+        <p:spPr>
+          <a:xfrm flipH="1">
+            <a:off x="2926080" y="5577840"/>
+            <a:ext cx="7635240" cy="0"/>
+          </a:xfrm>
+          <a:prstGeom prst="line">
+            <a:avLst/>
+          </a:prstGeom>
+          <a:ln w="19050">
+            <a:solidFill>
+              <a:srgbClr val="2F5597"/>
+            </a:solidFill>
+          </a:ln>
+        </p:spPr>
+        <p:style>
+          <a:lnRef idx="2">
+            <a:schemeClr val="accent1"/>
+          </a:lnRef>
+          <a:fillRef idx="0">
+            <a:schemeClr val="accent1"/>
+          </a:fillRef>
+          <a:effectRef idx="1">
+            <a:schemeClr val="accent1"/>
+          </a:effectRef>
+          <a:fontRef idx="minor">
+            <a:schemeClr val="tx1"/>
+          </a:fontRef>
+        </p:style>
+      </p:cxnSp>
+      <p:cxnSp>
+        <p:nvCxnSpPr>
+          <p:cNvPr id="30" name="Connector 29"/>
+          <p:cNvCxnSpPr/>
+          <p:nvPr/>
+        </p:nvCxnSpPr>
+        <p:spPr>
+          <a:xfrm flipV="1">
+            <a:off x="2926080" y="1668780"/>
+            <a:ext cx="0" cy="3909060"/>
+          </a:xfrm>
+          <a:prstGeom prst="line">
+            <a:avLst/>
+          </a:prstGeom>
+          <a:ln w="19050">
+            <a:solidFill>
+              <a:srgbClr val="2F5597"/>
+            </a:solidFill>
+          </a:ln>
+        </p:spPr>
+        <p:style>
+          <a:lnRef idx="2">
+            <a:schemeClr val="accent1"/>
+          </a:lnRef>
+          <a:fillRef idx="0">
+            <a:schemeClr val="accent1"/>
+          </a:fillRef>
+          <a:effectRef idx="1">
+            <a:schemeClr val="accent1"/>
+          </a:effectRef>
+          <a:fontRef idx="minor">
+            <a:schemeClr val="tx1"/>
+          </a:fontRef>
+        </p:style>
+      </p:cxnSp>
+      <p:cxnSp>
+        <p:nvCxnSpPr>
+          <p:cNvPr id="31" name="Connector 30"/>
+          <p:cNvCxnSpPr/>
+          <p:nvPr/>
+        </p:nvCxnSpPr>
+        <p:spPr>
+          <a:xfrm>
+            <a:off x="2926080" y="1668780"/>
+            <a:ext cx="137160" cy="0"/>
+          </a:xfrm>
+          <a:prstGeom prst="line">
+            <a:avLst/>
+          </a:prstGeom>
+          <a:ln w="19050">
+            <a:solidFill>
+              <a:srgbClr val="2F5597"/>
+            </a:solidFill>
+            <a:tailEnd type="triangle" w="med" len="med"/>
+          </a:ln>
+        </p:spPr>
+        <p:style>
+          <a:lnRef idx="2">
+            <a:schemeClr val="accent1"/>
+          </a:lnRef>
+          <a:fillRef idx="0">
+            <a:schemeClr val="accent1"/>
+          </a:fillRef>
+          <a:effectRef idx="1">
+            <a:schemeClr val="accent1"/>
+          </a:effectRef>
+          <a:fontRef idx="minor">
+            <a:schemeClr val="tx1"/>
+          </a:fontRef>
+        </p:style>
+      </p:cxnSp>
+      <p:sp>
+        <p:nvSpPr>
+          <p:cNvPr id="32" name="TextBox 31"/>
           <p:cNvSpPr txBox="1"/>
           <p:nvPr/>
         </p:nvSpPr>
         <p:spPr>
           <a:xfrm>
-            <a:off x="6606540" y="3675887"/>
-            <a:ext cx="2560320" cy="182880"/>
+            <a:off x="5029200" y="5376672"/>
+            <a:ext cx="4114800" cy="182880"/>
           </a:xfrm>
           <a:prstGeom prst="rect">
             <a:avLst/>
@@ -4230,294 +4550,74 @@
           <a:p>
             <a:pPr algn="ctr"/>
             <a:r>
-              <a:rPr sz="800" b="0" i="1">
-                <a:solidFill>
-                  <a:srgbClr val="843C0C"/>
+              <a:rPr sz="1000" b="0" i="1">
+                <a:solidFill>
+                  <a:srgbClr val="1F3864"/>
                 </a:solidFill>
                 <a:latin typeface="Calibri"/>
               </a:rPr>
-              <a:t>Φᵥ kept per view across outer iterations (age-ordered source iteration)</a:t>
-            </a:r>
-          </a:p>
-        </p:txBody>
-      </p:sp>
-      <p:sp>
-        <p:nvSpPr>
-          <p:cNvPr id="23" name="Rounded Rectangle 22"/>
+              <a:t>Xₖ₊₁ → next outer iteration (k ← k + 1)</a:t>
+            </a:r>
+          </a:p>
+        </p:txBody>
+      </p:sp>
+      <p:sp>
+        <p:nvSpPr>
+          <p:cNvPr id="33" name="TextBox 32"/>
+          <p:cNvSpPr txBox="1"/>
+          <p:nvPr/>
+        </p:nvSpPr>
+        <p:spPr>
+          <a:xfrm>
+            <a:off x="9646920" y="5074920"/>
+            <a:ext cx="2103120" cy="274320"/>
+          </a:xfrm>
+          <a:prstGeom prst="rect">
+            <a:avLst/>
+          </a:prstGeom>
+          <a:noFill/>
+        </p:spPr>
+        <p:txBody>
+          <a:bodyPr wrap="square" lIns="18288" rIns="18288" tIns="0" bIns="0">
+            <a:spAutoFit/>
+          </a:bodyPr>
+          <a:lstStyle/>
+          <a:p>
+            <a:pPr algn="ctr"/>
+            <a:r>
+              <a:rPr sz="900" b="0" i="1">
+                <a:solidFill>
+                  <a:srgbClr val="1F3864"/>
+                </a:solidFill>
+                <a:latin typeface="Calibri"/>
+              </a:rPr>
+              <a:t>n ≥ 1: several MBIR iterations</a:t>
+            </a:r>
+          </a:p>
+          <a:p>
+            <a:pPr algn="ctr"/>
+            <a:r>
+              <a:rPr sz="900" b="0" i="1">
+                <a:solidFill>
+                  <a:srgbClr val="1F3864"/>
+                </a:solidFill>
+                <a:latin typeface="Calibri"/>
+              </a:rPr>
+              <a:t>per scatter update</a:t>
+            </a:r>
+          </a:p>
+        </p:txBody>
+      </p:sp>
+      <p:sp>
+        <p:nvSpPr>
+          <p:cNvPr id="34" name="Rounded Rectangle 33"/>
           <p:cNvSpPr/>
           <p:nvPr/>
         </p:nvSpPr>
         <p:spPr>
           <a:xfrm>
-            <a:off x="3200400" y="4343400"/>
-            <a:ext cx="2103120" cy="960120"/>
-          </a:xfrm>
-          <a:prstGeom prst="roundRect">
-            <a:avLst>
-              <a:gd name="adj" fmla="val 12000"/>
-            </a:avLst>
-          </a:prstGeom>
-          <a:solidFill>
-            <a:srgbClr val="E4DFEC"/>
-          </a:solidFill>
-          <a:ln w="15875">
-            <a:solidFill>
-              <a:srgbClr val="7030A0"/>
-            </a:solidFill>
-          </a:ln>
-          <a:effectLst/>
-        </p:spPr>
-        <p:style>
-          <a:lnRef idx="1">
-            <a:schemeClr val="accent1"/>
-          </a:lnRef>
-          <a:fillRef idx="3">
-            <a:schemeClr val="accent1"/>
-          </a:fillRef>
-          <a:effectRef idx="2">
-            <a:schemeClr val="accent1"/>
-          </a:effectRef>
-          <a:fontRef idx="minor">
-            <a:schemeClr val="lt1"/>
-          </a:fontRef>
-        </p:style>
-        <p:txBody>
-          <a:bodyPr rtlCol="0" anchor="ctr" wrap="square" lIns="54864" rIns="54864" tIns="27432" bIns="27432"/>
-          <a:lstStyle/>
-          <a:p>
-            <a:pPr algn="ctr"/>
-            <a:r>
-              <a:rPr sz="1000" b="1">
-                <a:solidFill>
-                  <a:srgbClr val="3F1F5E"/>
-                </a:solidFill>
-                <a:latin typeface="Calibri"/>
-              </a:rPr>
-              <a:t>Primary pᵥ of every view</a:t>
-            </a:r>
-          </a:p>
-          <a:p>
-            <a:pPr algn="ctr"/>
-            <a:r>
-              <a:rPr sz="1000" b="0">
-                <a:solidFill>
-                  <a:srgbClr val="3F1F5E"/>
-                </a:solidFill>
-                <a:latin typeface="Calibri"/>
-              </a:rPr>
-              <a:t>MBIRTORCH per-material projections,</a:t>
-            </a:r>
-          </a:p>
-          <a:p>
-            <a:pPr algn="ctr"/>
-            <a:r>
-              <a:rPr sz="1000" b="0">
-                <a:solidFill>
-                  <a:srgbClr val="3F1F5E"/>
-                </a:solidFill>
-                <a:latin typeface="Calibri"/>
-              </a:rPr>
-              <a:t>spectrum + detector response</a:t>
-            </a:r>
-          </a:p>
-        </p:txBody>
-      </p:sp>
-      <p:sp>
-        <p:nvSpPr>
-          <p:cNvPr id="24" name="Rounded Rectangle 23"/>
-          <p:cNvSpPr/>
-          <p:nvPr/>
-        </p:nvSpPr>
-        <p:spPr>
-          <a:xfrm>
-            <a:off x="5532120" y="4343400"/>
-            <a:ext cx="2011680" cy="960120"/>
-          </a:xfrm>
-          <a:prstGeom prst="roundRect">
-            <a:avLst>
-              <a:gd name="adj" fmla="val 12000"/>
-            </a:avLst>
-          </a:prstGeom>
-          <a:solidFill>
-            <a:srgbClr val="FFF2CC"/>
-          </a:solidFill>
-          <a:ln w="15875">
-            <a:solidFill>
-              <a:srgbClr val="BF9000"/>
-            </a:solidFill>
-          </a:ln>
-          <a:effectLst/>
-        </p:spPr>
-        <p:style>
-          <a:lnRef idx="1">
-            <a:schemeClr val="accent1"/>
-          </a:lnRef>
-          <a:fillRef idx="3">
-            <a:schemeClr val="accent1"/>
-          </a:fillRef>
-          <a:effectRef idx="2">
-            <a:schemeClr val="accent1"/>
-          </a:effectRef>
-          <a:fontRef idx="minor">
-            <a:schemeClr val="lt1"/>
-          </a:fontRef>
-        </p:style>
-        <p:txBody>
-          <a:bodyPr rtlCol="0" anchor="ctr" wrap="square" lIns="54864" rIns="54864" tIns="27432" bIns="27432"/>
-          <a:lstStyle/>
-          <a:p>
-            <a:pPr algn="ctr"/>
-            <a:r>
-              <a:rPr sz="1000" b="1">
-                <a:solidFill>
-                  <a:srgbClr val="7F6000"/>
-                </a:solidFill>
-                <a:latin typeface="Calibri"/>
-              </a:rPr>
-              <a:t>Scatter-to-primary ratio</a:t>
-            </a:r>
-          </a:p>
-          <a:p>
-            <a:pPr algn="ctr"/>
-            <a:r>
-              <a:rPr sz="1000" b="0">
-                <a:solidFill>
-                  <a:srgbClr val="7F6000"/>
-                </a:solidFill>
-                <a:latin typeface="Calibri"/>
-              </a:rPr>
-              <a:t>SPRᵥ = sᵥ / pᵥ</a:t>
-            </a:r>
-          </a:p>
-          <a:p>
-            <a:pPr algn="ctr"/>
-            <a:r>
-              <a:rPr sz="1000" b="0">
-                <a:solidFill>
-                  <a:srgbClr val="7F6000"/>
-                </a:solidFill>
-                <a:latin typeface="Calibri"/>
-              </a:rPr>
-              <a:t>(interpolated in angle for</a:t>
-            </a:r>
-          </a:p>
-          <a:p>
-            <a:pPr algn="ctr"/>
-            <a:r>
-              <a:rPr sz="1000" b="0">
-                <a:solidFill>
-                  <a:srgbClr val="7F6000"/>
-                </a:solidFill>
-                <a:latin typeface="Calibri"/>
-              </a:rPr>
-              <a:t>skipped views)</a:t>
-            </a:r>
-          </a:p>
-        </p:txBody>
-      </p:sp>
-      <p:sp>
-        <p:nvSpPr>
-          <p:cNvPr id="25" name="Rounded Rectangle 24"/>
-          <p:cNvSpPr/>
-          <p:nvPr/>
-        </p:nvSpPr>
-        <p:spPr>
-          <a:xfrm>
-            <a:off x="7772400" y="4343400"/>
-            <a:ext cx="1828800" cy="960120"/>
-          </a:xfrm>
-          <a:prstGeom prst="roundRect">
-            <a:avLst>
-              <a:gd name="adj" fmla="val 12000"/>
-            </a:avLst>
-          </a:prstGeom>
-          <a:solidFill>
-            <a:srgbClr val="FFF2CC"/>
-          </a:solidFill>
-          <a:ln w="15875">
-            <a:solidFill>
-              <a:srgbClr val="BF9000"/>
-            </a:solidFill>
-          </a:ln>
-          <a:effectLst/>
-        </p:spPr>
-        <p:style>
-          <a:lnRef idx="1">
-            <a:schemeClr val="accent1"/>
-          </a:lnRef>
-          <a:fillRef idx="3">
-            <a:schemeClr val="accent1"/>
-          </a:fillRef>
-          <a:effectRef idx="2">
-            <a:schemeClr val="accent1"/>
-          </a:effectRef>
-          <a:fontRef idx="minor">
-            <a:schemeClr val="lt1"/>
-          </a:fontRef>
-        </p:style>
-        <p:txBody>
-          <a:bodyPr rtlCol="0" anchor="ctr" wrap="square" lIns="54864" rIns="54864" tIns="27432" bIns="27432"/>
-          <a:lstStyle/>
-          <a:p>
-            <a:pPr algn="ctr"/>
-            <a:r>
-              <a:rPr sz="1000" b="1">
-                <a:solidFill>
-                  <a:srgbClr val="7F6000"/>
-                </a:solidFill>
-                <a:latin typeface="Calibri"/>
-              </a:rPr>
-              <a:t>Corrected counts</a:t>
-            </a:r>
-          </a:p>
-          <a:p>
-            <a:pPr algn="ctr"/>
-            <a:r>
-              <a:rPr sz="1000" b="0">
-                <a:solidFill>
-                  <a:srgbClr val="7F6000"/>
-                </a:solidFill>
-                <a:latin typeface="Calibri"/>
-              </a:rPr>
-              <a:t>Yᵥ / (1 + SPRᵥ)</a:t>
-            </a:r>
-          </a:p>
-          <a:p>
-            <a:pPr algn="ctr"/>
-            <a:r>
-              <a:rPr sz="1000" b="0">
-                <a:solidFill>
-                  <a:srgbClr val="7F6000"/>
-                </a:solidFill>
-                <a:latin typeface="Calibri"/>
-              </a:rPr>
-              <a:t>line integrals</a:t>
-            </a:r>
-          </a:p>
-          <a:p>
-            <a:pPr algn="ctr"/>
-            <a:r>
-              <a:rPr sz="1000" b="0">
-                <a:solidFill>
-                  <a:srgbClr val="7F6000"/>
-                </a:solidFill>
-                <a:latin typeface="Calibri"/>
-              </a:rPr>
-              <a:t>−log(Yᵥ / I0)</a:t>
-            </a:r>
-          </a:p>
-        </p:txBody>
-      </p:sp>
-      <p:sp>
-        <p:nvSpPr>
-          <p:cNvPr id="26" name="Rounded Rectangle 25"/>
-          <p:cNvSpPr/>
-          <p:nvPr/>
-        </p:nvSpPr>
-        <p:spPr>
-          <a:xfrm>
-            <a:off x="9829800" y="4343400"/>
-            <a:ext cx="1828800" cy="960120"/>
+            <a:off x="9509760" y="6309360"/>
+            <a:ext cx="2103120" cy="457200"/>
           </a:xfrm>
           <a:prstGeom prst="roundRect">
             <a:avLst>
@@ -4554,339 +4654,17 @@
           <a:p>
             <a:pPr algn="ctr"/>
             <a:r>
-              <a:rPr sz="1000" b="1">
+              <a:rPr sz="1100" b="1">
                 <a:solidFill>
                   <a:srgbClr val="1F3864"/>
                 </a:solidFill>
                 <a:latin typeface="Calibri"/>
               </a:rPr>
-              <a:t>One warm-started</a:t>
-            </a:r>
-          </a:p>
-          <a:p>
-            <a:pPr algn="ctr"/>
-            <a:r>
-              <a:rPr sz="1000" b="0">
-                <a:solidFill>
-                  <a:srgbClr val="1F3864"/>
-                </a:solidFill>
-                <a:latin typeface="Calibri"/>
-              </a:rPr>
-              <a:t>MBIR iteration</a:t>
-            </a:r>
-          </a:p>
-          <a:p>
-            <a:pPr algn="ctr"/>
-            <a:r>
-              <a:rPr sz="1000" b="0">
-                <a:solidFill>
-                  <a:srgbClr val="1F3864"/>
-                </a:solidFill>
-                <a:latin typeface="Calibri"/>
-              </a:rPr>
-              <a:t>MBIRTORCH coordinate descent,</a:t>
-            </a:r>
-          </a:p>
-          <a:p>
-            <a:pPr algn="ctr"/>
-            <a:r>
-              <a:rPr sz="1000" b="0">
-                <a:solidFill>
-                  <a:srgbClr val="1F3864"/>
-                </a:solidFill>
-                <a:latin typeface="Calibri"/>
-              </a:rPr>
-              <a:t>resumed error sinogram → Xₖ₊₁</a:t>
-            </a:r>
-          </a:p>
-        </p:txBody>
-      </p:sp>
-      <p:cxnSp>
-        <p:nvCxnSpPr>
-          <p:cNvPr id="27" name="Connector 26"/>
-          <p:cNvCxnSpPr/>
-          <p:nvPr/>
-        </p:nvCxnSpPr>
-        <p:spPr>
-          <a:xfrm>
-            <a:off x="5303520" y="4823460"/>
-            <a:ext cx="228600" cy="0"/>
-          </a:xfrm>
-          <a:prstGeom prst="line">
-            <a:avLst/>
-          </a:prstGeom>
-          <a:ln w="19050">
-            <a:solidFill>
-              <a:srgbClr val="595959"/>
-            </a:solidFill>
-            <a:tailEnd type="triangle" w="med" len="med"/>
-          </a:ln>
-        </p:spPr>
-        <p:style>
-          <a:lnRef idx="2">
-            <a:schemeClr val="accent1"/>
-          </a:lnRef>
-          <a:fillRef idx="0">
-            <a:schemeClr val="accent1"/>
-          </a:fillRef>
-          <a:effectRef idx="1">
-            <a:schemeClr val="accent1"/>
-          </a:effectRef>
-          <a:fontRef idx="minor">
-            <a:schemeClr val="tx1"/>
-          </a:fontRef>
-        </p:style>
-      </p:cxnSp>
-      <p:cxnSp>
-        <p:nvCxnSpPr>
-          <p:cNvPr id="28" name="Connector 27"/>
-          <p:cNvCxnSpPr/>
-          <p:nvPr/>
-        </p:nvCxnSpPr>
-        <p:spPr>
-          <a:xfrm>
-            <a:off x="7543800" y="4823460"/>
-            <a:ext cx="228600" cy="0"/>
-          </a:xfrm>
-          <a:prstGeom prst="line">
-            <a:avLst/>
-          </a:prstGeom>
-          <a:ln w="19050">
-            <a:solidFill>
-              <a:srgbClr val="595959"/>
-            </a:solidFill>
-            <a:tailEnd type="triangle" w="med" len="med"/>
-          </a:ln>
-        </p:spPr>
-        <p:style>
-          <a:lnRef idx="2">
-            <a:schemeClr val="accent1"/>
-          </a:lnRef>
-          <a:fillRef idx="0">
-            <a:schemeClr val="accent1"/>
-          </a:fillRef>
-          <a:effectRef idx="1">
-            <a:schemeClr val="accent1"/>
-          </a:effectRef>
-          <a:fontRef idx="minor">
-            <a:schemeClr val="tx1"/>
-          </a:fontRef>
-        </p:style>
-      </p:cxnSp>
-      <p:cxnSp>
-        <p:nvCxnSpPr>
-          <p:cNvPr id="29" name="Connector 28"/>
-          <p:cNvCxnSpPr/>
-          <p:nvPr/>
-        </p:nvCxnSpPr>
-        <p:spPr>
-          <a:xfrm>
-            <a:off x="9601200" y="4823460"/>
-            <a:ext cx="228600" cy="0"/>
-          </a:xfrm>
-          <a:prstGeom prst="line">
-            <a:avLst/>
-          </a:prstGeom>
-          <a:ln w="19050">
-            <a:solidFill>
-              <a:srgbClr val="595959"/>
-            </a:solidFill>
-            <a:tailEnd type="triangle" w="med" len="med"/>
-          </a:ln>
-        </p:spPr>
-        <p:style>
-          <a:lnRef idx="2">
-            <a:schemeClr val="accent1"/>
-          </a:lnRef>
-          <a:fillRef idx="0">
-            <a:schemeClr val="accent1"/>
-          </a:fillRef>
-          <a:effectRef idx="1">
-            <a:schemeClr val="accent1"/>
-          </a:effectRef>
-          <a:fontRef idx="minor">
-            <a:schemeClr val="tx1"/>
-          </a:fontRef>
-        </p:style>
-      </p:cxnSp>
-      <p:cxnSp>
-        <p:nvCxnSpPr>
-          <p:cNvPr id="30" name="Connector 29"/>
-          <p:cNvCxnSpPr/>
-          <p:nvPr/>
-        </p:nvCxnSpPr>
-        <p:spPr>
-          <a:xfrm>
-            <a:off x="5006339" y="1874519"/>
-            <a:ext cx="0" cy="640081"/>
-          </a:xfrm>
-          <a:prstGeom prst="line">
-            <a:avLst/>
-          </a:prstGeom>
-          <a:ln w="19050">
-            <a:solidFill>
-              <a:srgbClr val="595959"/>
-            </a:solidFill>
-            <a:tailEnd type="triangle" w="med" len="med"/>
-          </a:ln>
-        </p:spPr>
-        <p:style>
-          <a:lnRef idx="2">
-            <a:schemeClr val="accent1"/>
-          </a:lnRef>
-          <a:fillRef idx="0">
-            <a:schemeClr val="accent1"/>
-          </a:fillRef>
-          <a:effectRef idx="1">
-            <a:schemeClr val="accent1"/>
-          </a:effectRef>
-          <a:fontRef idx="minor">
-            <a:schemeClr val="tx1"/>
-          </a:fontRef>
-        </p:style>
-      </p:cxnSp>
-      <p:cxnSp>
-        <p:nvCxnSpPr>
-          <p:cNvPr id="31" name="Connector 30"/>
-          <p:cNvCxnSpPr/>
-          <p:nvPr/>
-        </p:nvCxnSpPr>
-        <p:spPr>
-          <a:xfrm>
-            <a:off x="7886700" y="1874519"/>
-            <a:ext cx="0" cy="274321"/>
-          </a:xfrm>
-          <a:prstGeom prst="line">
-            <a:avLst/>
-          </a:prstGeom>
-          <a:ln w="19050">
-            <a:solidFill>
-              <a:srgbClr val="595959"/>
-            </a:solidFill>
-            <a:tailEnd type="triangle" w="med" len="med"/>
-          </a:ln>
-        </p:spPr>
-        <p:style>
-          <a:lnRef idx="2">
-            <a:schemeClr val="accent1"/>
-          </a:lnRef>
-          <a:fillRef idx="0">
-            <a:schemeClr val="accent1"/>
-          </a:fillRef>
-          <a:effectRef idx="1">
-            <a:schemeClr val="accent1"/>
-          </a:effectRef>
-          <a:fontRef idx="minor">
-            <a:schemeClr val="tx1"/>
-          </a:fontRef>
-        </p:style>
-      </p:cxnSp>
-      <p:cxnSp>
-        <p:nvCxnSpPr>
-          <p:cNvPr id="32" name="Connector 31"/>
-          <p:cNvCxnSpPr/>
-          <p:nvPr/>
-        </p:nvCxnSpPr>
-        <p:spPr>
-          <a:xfrm>
-            <a:off x="3383280" y="1874519"/>
-            <a:ext cx="0" cy="2468881"/>
-          </a:xfrm>
-          <a:prstGeom prst="line">
-            <a:avLst/>
-          </a:prstGeom>
-          <a:ln w="15875">
-            <a:solidFill>
-              <a:srgbClr val="548235"/>
-            </a:solidFill>
-            <a:tailEnd type="triangle" w="med" len="med"/>
-          </a:ln>
-        </p:spPr>
-        <p:style>
-          <a:lnRef idx="2">
-            <a:schemeClr val="accent1"/>
-          </a:lnRef>
-          <a:fillRef idx="0">
-            <a:schemeClr val="accent1"/>
-          </a:fillRef>
-          <a:effectRef idx="1">
-            <a:schemeClr val="accent1"/>
-          </a:effectRef>
-          <a:fontRef idx="minor">
-            <a:schemeClr val="tx1"/>
-          </a:fontRef>
-        </p:style>
-      </p:cxnSp>
-      <p:sp>
-        <p:nvSpPr>
-          <p:cNvPr id="33" name="TextBox 32"/>
-          <p:cNvSpPr txBox="1"/>
-          <p:nvPr/>
-        </p:nvSpPr>
-        <p:spPr>
-          <a:xfrm>
-            <a:off x="2999232" y="2926080"/>
-            <a:ext cx="457200" cy="182880"/>
-          </a:xfrm>
-          <a:prstGeom prst="rect">
-            <a:avLst/>
-          </a:prstGeom>
-          <a:noFill/>
-        </p:spPr>
-        <p:txBody>
-          <a:bodyPr wrap="square" lIns="18288" rIns="18288" tIns="0" bIns="0">
-            <a:spAutoFit/>
-          </a:bodyPr>
-          <a:lstStyle/>
-          <a:p>
-            <a:pPr algn="l"/>
-            <a:r>
-              <a:rPr sz="900" b="0" i="1">
-                <a:solidFill>
-                  <a:srgbClr val="385723"/>
-                </a:solidFill>
-                <a:latin typeface="Calibri"/>
-              </a:rPr>
-              <a:t>ρₘ</a:t>
-            </a:r>
-          </a:p>
-        </p:txBody>
-      </p:sp>
-      <p:cxnSp>
-        <p:nvCxnSpPr>
-          <p:cNvPr id="34" name="Connector 33"/>
-          <p:cNvCxnSpPr/>
-          <p:nvPr/>
-        </p:nvCxnSpPr>
-        <p:spPr>
-          <a:xfrm>
-            <a:off x="10584180" y="3657600"/>
-            <a:ext cx="0" cy="475487"/>
-          </a:xfrm>
-          <a:prstGeom prst="line">
-            <a:avLst/>
-          </a:prstGeom>
-          <a:ln w="19050">
-            <a:solidFill>
-              <a:srgbClr val="595959"/>
-            </a:solidFill>
-          </a:ln>
-        </p:spPr>
-        <p:style>
-          <a:lnRef idx="2">
-            <a:schemeClr val="accent1"/>
-          </a:lnRef>
-          <a:fillRef idx="0">
-            <a:schemeClr val="accent1"/>
-          </a:fillRef>
-          <a:effectRef idx="1">
-            <a:schemeClr val="accent1"/>
-          </a:effectRef>
-          <a:fontRef idx="minor">
-            <a:schemeClr val="tx1"/>
-          </a:fontRef>
-        </p:style>
-      </p:cxnSp>
+              <a:t>Scatter-corrected reconstruction</a:t>
+            </a:r>
+          </a:p>
+        </p:txBody>
+      </p:sp>
       <p:cxnSp>
         <p:nvCxnSpPr>
           <p:cNvPr id="35" name="Connector 34"/>
@@ -4894,16 +4672,16 @@
           <p:nvPr/>
         </p:nvCxnSpPr>
         <p:spPr>
-          <a:xfrm flipH="1">
-            <a:off x="6812280" y="4133087"/>
-            <a:ext cx="3771900" cy="0"/>
+          <a:xfrm>
+            <a:off x="11612880" y="4480559"/>
+            <a:ext cx="137160" cy="0"/>
           </a:xfrm>
           <a:prstGeom prst="line">
             <a:avLst/>
           </a:prstGeom>
           <a:ln w="19050">
             <a:solidFill>
-              <a:srgbClr val="595959"/>
+              <a:srgbClr val="2F5597"/>
             </a:solidFill>
           </a:ln>
         </p:spPr>
@@ -4930,86 +4708,15 @@
         </p:nvCxnSpPr>
         <p:spPr>
           <a:xfrm>
-            <a:off x="6812280" y="4133087"/>
-            <a:ext cx="0" cy="210313"/>
+            <a:off x="11750040" y="4480559"/>
+            <a:ext cx="0" cy="2057401"/>
           </a:xfrm>
           <a:prstGeom prst="line">
             <a:avLst/>
           </a:prstGeom>
           <a:ln w="19050">
             <a:solidFill>
-              <a:srgbClr val="595959"/>
-            </a:solidFill>
-            <a:tailEnd type="triangle" w="med" len="med"/>
-          </a:ln>
-        </p:spPr>
-        <p:style>
-          <a:lnRef idx="2">
-            <a:schemeClr val="accent1"/>
-          </a:lnRef>
-          <a:fillRef idx="0">
-            <a:schemeClr val="accent1"/>
-          </a:fillRef>
-          <a:effectRef idx="1">
-            <a:schemeClr val="accent1"/>
-          </a:effectRef>
-          <a:fontRef idx="minor">
-            <a:schemeClr val="tx1"/>
-          </a:fontRef>
-        </p:style>
-      </p:cxnSp>
-      <p:sp>
-        <p:nvSpPr>
-          <p:cNvPr id="37" name="TextBox 36"/>
-          <p:cNvSpPr txBox="1"/>
-          <p:nvPr/>
-        </p:nvSpPr>
-        <p:spPr>
-          <a:xfrm>
-            <a:off x="6885432" y="4114800"/>
-            <a:ext cx="548640" cy="182880"/>
-          </a:xfrm>
-          <a:prstGeom prst="rect">
-            <a:avLst/>
-          </a:prstGeom>
-          <a:noFill/>
-        </p:spPr>
-        <p:txBody>
-          <a:bodyPr wrap="square" lIns="18288" rIns="18288" tIns="0" bIns="0">
-            <a:spAutoFit/>
-          </a:bodyPr>
-          <a:lstStyle/>
-          <a:p>
-            <a:pPr algn="l"/>
-            <a:r>
-              <a:rPr sz="900" b="0" i="1">
-                <a:solidFill>
-                  <a:srgbClr val="843C0C"/>
-                </a:solidFill>
-                <a:latin typeface="Calibri"/>
-              </a:rPr>
-              <a:t>sᵥ</a:t>
-            </a:r>
-          </a:p>
-        </p:txBody>
-      </p:sp>
-      <p:cxnSp>
-        <p:nvCxnSpPr>
-          <p:cNvPr id="38" name="Connector 37"/>
-          <p:cNvCxnSpPr/>
-          <p:nvPr/>
-        </p:nvCxnSpPr>
-        <p:spPr>
-          <a:xfrm>
-            <a:off x="2377440" y="3931920"/>
-            <a:ext cx="228600" cy="0"/>
-          </a:xfrm>
-          <a:prstGeom prst="line">
-            <a:avLst/>
-          </a:prstGeom>
-          <a:ln w="19050">
-            <a:solidFill>
-              <a:srgbClr val="595959"/>
+              <a:srgbClr val="2F5597"/>
             </a:solidFill>
           </a:ln>
         </p:spPr>
@@ -5030,225 +4737,14 @@
       </p:cxnSp>
       <p:cxnSp>
         <p:nvCxnSpPr>
-          <p:cNvPr id="39" name="Connector 38"/>
+          <p:cNvPr id="37" name="Connector 36"/>
           <p:cNvCxnSpPr/>
           <p:nvPr/>
         </p:nvCxnSpPr>
         <p:spPr>
-          <a:xfrm flipV="1">
-            <a:off x="2606040" y="1211580"/>
-            <a:ext cx="0" cy="2720340"/>
-          </a:xfrm>
-          <a:prstGeom prst="line">
-            <a:avLst/>
-          </a:prstGeom>
-          <a:ln w="19050">
-            <a:solidFill>
-              <a:srgbClr val="595959"/>
-            </a:solidFill>
-          </a:ln>
-        </p:spPr>
-        <p:style>
-          <a:lnRef idx="2">
-            <a:schemeClr val="accent1"/>
-          </a:lnRef>
-          <a:fillRef idx="0">
-            <a:schemeClr val="accent1"/>
-          </a:fillRef>
-          <a:effectRef idx="1">
-            <a:schemeClr val="accent1"/>
-          </a:effectRef>
-          <a:fontRef idx="minor">
-            <a:schemeClr val="tx1"/>
-          </a:fontRef>
-        </p:style>
-      </p:cxnSp>
-      <p:cxnSp>
-        <p:nvCxnSpPr>
-          <p:cNvPr id="40" name="Connector 39"/>
-          <p:cNvCxnSpPr/>
-          <p:nvPr/>
-        </p:nvCxnSpPr>
-        <p:spPr>
-          <a:xfrm>
-            <a:off x="2606040" y="1211580"/>
-            <a:ext cx="594360" cy="0"/>
-          </a:xfrm>
-          <a:prstGeom prst="line">
-            <a:avLst/>
-          </a:prstGeom>
-          <a:ln w="19050">
-            <a:solidFill>
-              <a:srgbClr val="595959"/>
-            </a:solidFill>
-            <a:tailEnd type="triangle" w="med" len="med"/>
-          </a:ln>
-        </p:spPr>
-        <p:style>
-          <a:lnRef idx="2">
-            <a:schemeClr val="accent1"/>
-          </a:lnRef>
-          <a:fillRef idx="0">
-            <a:schemeClr val="accent1"/>
-          </a:fillRef>
-          <a:effectRef idx="1">
-            <a:schemeClr val="accent1"/>
-          </a:effectRef>
-          <a:fontRef idx="minor">
-            <a:schemeClr val="tx1"/>
-          </a:fontRef>
-        </p:style>
-      </p:cxnSp>
-      <p:cxnSp>
-        <p:nvCxnSpPr>
-          <p:cNvPr id="41" name="Connector 40"/>
-          <p:cNvCxnSpPr/>
-          <p:nvPr/>
-        </p:nvCxnSpPr>
-        <p:spPr>
-          <a:xfrm>
-            <a:off x="11658600" y="4823460"/>
+          <a:xfrm flipH="1">
+            <a:off x="11612880" y="6537960"/>
             <a:ext cx="137160" cy="0"/>
-          </a:xfrm>
-          <a:prstGeom prst="line">
-            <a:avLst/>
-          </a:prstGeom>
-          <a:ln w="19050">
-            <a:solidFill>
-              <a:srgbClr val="2F5597"/>
-            </a:solidFill>
-          </a:ln>
-        </p:spPr>
-        <p:style>
-          <a:lnRef idx="2">
-            <a:schemeClr val="accent1"/>
-          </a:lnRef>
-          <a:fillRef idx="0">
-            <a:schemeClr val="accent1"/>
-          </a:fillRef>
-          <a:effectRef idx="1">
-            <a:schemeClr val="accent1"/>
-          </a:effectRef>
-          <a:fontRef idx="minor">
-            <a:schemeClr val="tx1"/>
-          </a:fontRef>
-        </p:style>
-      </p:cxnSp>
-      <p:cxnSp>
-        <p:nvCxnSpPr>
-          <p:cNvPr id="42" name="Connector 41"/>
-          <p:cNvCxnSpPr/>
-          <p:nvPr/>
-        </p:nvCxnSpPr>
-        <p:spPr>
-          <a:xfrm>
-            <a:off x="11795760" y="4823460"/>
-            <a:ext cx="0" cy="800100"/>
-          </a:xfrm>
-          <a:prstGeom prst="line">
-            <a:avLst/>
-          </a:prstGeom>
-          <a:ln w="19050">
-            <a:solidFill>
-              <a:srgbClr val="2F5597"/>
-            </a:solidFill>
-          </a:ln>
-        </p:spPr>
-        <p:style>
-          <a:lnRef idx="2">
-            <a:schemeClr val="accent1"/>
-          </a:lnRef>
-          <a:fillRef idx="0">
-            <a:schemeClr val="accent1"/>
-          </a:fillRef>
-          <a:effectRef idx="1">
-            <a:schemeClr val="accent1"/>
-          </a:effectRef>
-          <a:fontRef idx="minor">
-            <a:schemeClr val="tx1"/>
-          </a:fontRef>
-        </p:style>
-      </p:cxnSp>
-      <p:cxnSp>
-        <p:nvCxnSpPr>
-          <p:cNvPr id="43" name="Connector 42"/>
-          <p:cNvCxnSpPr/>
-          <p:nvPr/>
-        </p:nvCxnSpPr>
-        <p:spPr>
-          <a:xfrm flipH="1">
-            <a:off x="2971800" y="5623560"/>
-            <a:ext cx="8823960" cy="0"/>
-          </a:xfrm>
-          <a:prstGeom prst="line">
-            <a:avLst/>
-          </a:prstGeom>
-          <a:ln w="19050">
-            <a:solidFill>
-              <a:srgbClr val="2F5597"/>
-            </a:solidFill>
-          </a:ln>
-        </p:spPr>
-        <p:style>
-          <a:lnRef idx="2">
-            <a:schemeClr val="accent1"/>
-          </a:lnRef>
-          <a:fillRef idx="0">
-            <a:schemeClr val="accent1"/>
-          </a:fillRef>
-          <a:effectRef idx="1">
-            <a:schemeClr val="accent1"/>
-          </a:effectRef>
-          <a:fontRef idx="minor">
-            <a:schemeClr val="tx1"/>
-          </a:fontRef>
-        </p:style>
-      </p:cxnSp>
-      <p:cxnSp>
-        <p:nvCxnSpPr>
-          <p:cNvPr id="44" name="Connector 43"/>
-          <p:cNvCxnSpPr/>
-          <p:nvPr/>
-        </p:nvCxnSpPr>
-        <p:spPr>
-          <a:xfrm flipV="1">
-            <a:off x="2971800" y="1577339"/>
-            <a:ext cx="0" cy="4046221"/>
-          </a:xfrm>
-          <a:prstGeom prst="line">
-            <a:avLst/>
-          </a:prstGeom>
-          <a:ln w="19050">
-            <a:solidFill>
-              <a:srgbClr val="2F5597"/>
-            </a:solidFill>
-          </a:ln>
-        </p:spPr>
-        <p:style>
-          <a:lnRef idx="2">
-            <a:schemeClr val="accent1"/>
-          </a:lnRef>
-          <a:fillRef idx="0">
-            <a:schemeClr val="accent1"/>
-          </a:fillRef>
-          <a:effectRef idx="1">
-            <a:schemeClr val="accent1"/>
-          </a:effectRef>
-          <a:fontRef idx="minor">
-            <a:schemeClr val="tx1"/>
-          </a:fontRef>
-        </p:style>
-      </p:cxnSp>
-      <p:cxnSp>
-        <p:nvCxnSpPr>
-          <p:cNvPr id="45" name="Connector 44"/>
-          <p:cNvCxnSpPr/>
-          <p:nvPr/>
-        </p:nvCxnSpPr>
-        <p:spPr>
-          <a:xfrm>
-            <a:off x="2971800" y="1577339"/>
-            <a:ext cx="228600" cy="0"/>
           </a:xfrm>
           <a:prstGeom prst="line">
             <a:avLst/>
@@ -5277,14 +4773,14 @@
       </p:cxnSp>
       <p:sp>
         <p:nvSpPr>
-          <p:cNvPr id="46" name="TextBox 45"/>
+          <p:cNvPr id="38" name="TextBox 37"/>
           <p:cNvSpPr txBox="1"/>
           <p:nvPr/>
         </p:nvSpPr>
         <p:spPr>
           <a:xfrm>
-            <a:off x="5943600" y="5440680"/>
-            <a:ext cx="3200400" cy="182880"/>
+            <a:off x="365760" y="6309360"/>
+            <a:ext cx="8778240" cy="457200"/>
           </a:xfrm>
           <a:prstGeom prst="rect">
             <a:avLst/>
@@ -5297,272 +4793,27 @@
           </a:bodyPr>
           <a:lstStyle/>
           <a:p>
-            <a:pPr algn="ctr"/>
+            <a:pPr algn="l"/>
             <a:r>
               <a:rPr sz="900" b="0" i="1">
                 <a:solidFill>
-                  <a:srgbClr val="1F3864"/>
+                  <a:srgbClr val="404040"/>
                 </a:solidFill>
                 <a:latin typeface="Calibri"/>
               </a:rPr>
-              <a:t>Xₖ₊₁ → next outer iteration</a:t>
-            </a:r>
-          </a:p>
-        </p:txBody>
-      </p:sp>
-      <p:sp>
-        <p:nvSpPr>
-          <p:cNvPr id="47" name="Rounded Rectangle 46"/>
-          <p:cNvSpPr/>
-          <p:nvPr/>
-        </p:nvSpPr>
-        <p:spPr>
-          <a:xfrm>
-            <a:off x="9829800" y="6080760"/>
-            <a:ext cx="1828800" cy="594360"/>
-          </a:xfrm>
-          <a:prstGeom prst="roundRect">
-            <a:avLst>
-              <a:gd name="adj" fmla="val 12000"/>
-            </a:avLst>
-          </a:prstGeom>
-          <a:solidFill>
-            <a:srgbClr val="DEEAF6"/>
-          </a:solidFill>
-          <a:ln w="15875">
-            <a:solidFill>
-              <a:srgbClr val="2F5597"/>
-            </a:solidFill>
-          </a:ln>
-          <a:effectLst/>
-        </p:spPr>
-        <p:style>
-          <a:lnRef idx="1">
-            <a:schemeClr val="accent1"/>
-          </a:lnRef>
-          <a:fillRef idx="3">
-            <a:schemeClr val="accent1"/>
-          </a:fillRef>
-          <a:effectRef idx="2">
-            <a:schemeClr val="accent1"/>
-          </a:effectRef>
-          <a:fontRef idx="minor">
-            <a:schemeClr val="lt1"/>
-          </a:fontRef>
-        </p:style>
-        <p:txBody>
-          <a:bodyPr rtlCol="0" anchor="ctr" wrap="square" lIns="54864" rIns="54864" tIns="27432" bIns="27432"/>
-          <a:lstStyle/>
-          <a:p>
-            <a:pPr algn="ctr"/>
-            <a:r>
-              <a:rPr sz="1000" b="1">
-                <a:solidFill>
-                  <a:srgbClr val="1F3864"/>
+              <a:t>With X held fixed, N outer iterations reproduce N source iterations of the transport solver: the scatter estimate converges together with the reconstruction,</a:t>
+            </a:r>
+          </a:p>
+          <a:p>
+            <a:pPr algn="l"/>
+            <a:r>
+              <a:rPr sz="900" b="0" i="1">
+                <a:solidFill>
+                  <a:srgbClr val="404040"/>
                 </a:solidFill>
                 <a:latin typeface="Calibri"/>
               </a:rPr>
-              <a:t>Scatter-corrected</a:t>
-            </a:r>
-          </a:p>
-          <a:p>
-            <a:pPr algn="ctr"/>
-            <a:r>
-              <a:rPr sz="1000" b="0">
-                <a:solidFill>
-                  <a:srgbClr val="1F3864"/>
-                </a:solidFill>
-                <a:latin typeface="Calibri"/>
-              </a:rPr>
-              <a:t>reconstruction X</a:t>
-            </a:r>
-          </a:p>
-        </p:txBody>
-      </p:sp>
-      <p:cxnSp>
-        <p:nvCxnSpPr>
-          <p:cNvPr id="48" name="Connector 47"/>
-          <p:cNvCxnSpPr/>
-          <p:nvPr/>
-        </p:nvCxnSpPr>
-        <p:spPr>
-          <a:xfrm>
-            <a:off x="10744200" y="5303520"/>
-            <a:ext cx="0" cy="777240"/>
-          </a:xfrm>
-          <a:prstGeom prst="line">
-            <a:avLst/>
-          </a:prstGeom>
-          <a:ln w="19050">
-            <a:solidFill>
-              <a:srgbClr val="595959"/>
-            </a:solidFill>
-            <a:tailEnd type="triangle" w="med" len="med"/>
-          </a:ln>
-        </p:spPr>
-        <p:style>
-          <a:lnRef idx="2">
-            <a:schemeClr val="accent1"/>
-          </a:lnRef>
-          <a:fillRef idx="0">
-            <a:schemeClr val="accent1"/>
-          </a:fillRef>
-          <a:effectRef idx="1">
-            <a:schemeClr val="accent1"/>
-          </a:effectRef>
-          <a:fontRef idx="minor">
-            <a:schemeClr val="tx1"/>
-          </a:fontRef>
-        </p:style>
-      </p:cxnSp>
-      <p:sp>
-        <p:nvSpPr>
-          <p:cNvPr id="49" name="Rounded Rectangle 48"/>
-          <p:cNvSpPr/>
-          <p:nvPr/>
-        </p:nvSpPr>
-        <p:spPr>
-          <a:xfrm>
-            <a:off x="320040" y="4572000"/>
-            <a:ext cx="2057400" cy="1234440"/>
-          </a:xfrm>
-          <a:prstGeom prst="roundRect">
-            <a:avLst>
-              <a:gd name="adj" fmla="val 12000"/>
-            </a:avLst>
-          </a:prstGeom>
-          <a:solidFill>
-            <a:srgbClr val="F2F2F2"/>
-          </a:solidFill>
-          <a:ln w="15875">
-            <a:solidFill>
-              <a:srgbClr val="7F7F7F"/>
-            </a:solidFill>
-          </a:ln>
-          <a:effectLst/>
-        </p:spPr>
-        <p:style>
-          <a:lnRef idx="1">
-            <a:schemeClr val="accent1"/>
-          </a:lnRef>
-          <a:fillRef idx="3">
-            <a:schemeClr val="accent1"/>
-          </a:fillRef>
-          <a:effectRef idx="2">
-            <a:schemeClr val="accent1"/>
-          </a:effectRef>
-          <a:fontRef idx="minor">
-            <a:schemeClr val="lt1"/>
-          </a:fontRef>
-        </p:style>
-        <p:txBody>
-          <a:bodyPr rtlCol="0" anchor="ctr" wrap="square" lIns="54864" rIns="54864" tIns="27432" bIns="27432"/>
-          <a:lstStyle/>
-          <a:p>
-            <a:pPr algn="ctr"/>
-            <a:r>
-              <a:rPr sz="900" b="1">
-                <a:solidFill>
-                  <a:srgbClr val="404040"/>
-                </a:solidFill>
-                <a:latin typeface="Calibri"/>
-              </a:rPr>
-              <a:t>Options</a:t>
-            </a:r>
-          </a:p>
-          <a:p>
-            <a:pPr algn="ctr"/>
-            <a:r>
-              <a:rPr sz="900" b="0">
-                <a:solidFill>
-                  <a:srgbClr val="404040"/>
-                </a:solidFill>
-                <a:latin typeface="Calibri"/>
-              </a:rPr>
-              <a:t>scatter stage every n outer iterations;</a:t>
-            </a:r>
-          </a:p>
-          <a:p>
-            <a:pPr algn="ctr"/>
-            <a:r>
-              <a:rPr sz="900" b="0">
-                <a:solidFill>
-                  <a:srgbClr val="404040"/>
-                </a:solidFill>
-                <a:latin typeface="Calibri"/>
-              </a:rPr>
-              <a:t>scatter step on every n-th view, the</a:t>
-            </a:r>
-          </a:p>
-          <a:p>
-            <a:pPr algn="ctr"/>
-            <a:r>
-              <a:rPr sz="900" b="0">
-                <a:solidFill>
-                  <a:srgbClr val="404040"/>
-                </a:solidFill>
-                <a:latin typeface="Calibri"/>
-              </a:rPr>
-              <a:t>others interpolated in angle; anchor</a:t>
-            </a:r>
-          </a:p>
-          <a:p>
-            <a:pPr algn="ctr"/>
-            <a:r>
-              <a:rPr sz="900" b="0">
-                <a:solidFill>
-                  <a:srgbClr val="404040"/>
-                </a:solidFill>
-                <a:latin typeface="Calibri"/>
-              </a:rPr>
-              <a:t>materials chosen from the catalogue</a:t>
-            </a:r>
-          </a:p>
-        </p:txBody>
-      </p:sp>
-      <p:sp>
-        <p:nvSpPr>
-          <p:cNvPr id="50" name="TextBox 49"/>
-          <p:cNvSpPr txBox="1"/>
-          <p:nvPr/>
-        </p:nvSpPr>
-        <p:spPr>
-          <a:xfrm>
-            <a:off x="320040" y="6172200"/>
-            <a:ext cx="7772400" cy="411480"/>
-          </a:xfrm>
-          <a:prstGeom prst="rect">
-            <a:avLst/>
-          </a:prstGeom>
-          <a:noFill/>
-        </p:spPr>
-        <p:txBody>
-          <a:bodyPr wrap="square" lIns="18288" rIns="18288" tIns="0" bIns="0">
-            <a:spAutoFit/>
-          </a:bodyPr>
-          <a:lstStyle/>
-          <a:p>
-            <a:pPr algn="l"/>
-            <a:r>
-              <a:rPr sz="900" b="0" i="1">
-                <a:solidFill>
-                  <a:srgbClr val="404040"/>
-                </a:solidFill>
-                <a:latin typeface="Calibri"/>
-              </a:rPr>
-              <a:t>CITRUS: Coupled Iterative Tomographic reconstruction and Recursively-Updated Scatter.</a:t>
-            </a:r>
-          </a:p>
-          <a:p>
-            <a:pPr algn="l"/>
-            <a:r>
-              <a:rPr sz="900" b="0" i="1">
-                <a:solidFill>
-                  <a:srgbClr val="404040"/>
-                </a:solidFill>
-                <a:latin typeface="Calibri"/>
-              </a:rPr>
-              <a:t>With the densities held fixed, N steps reproduce N source iterations; the scatter converges with the reconstruction.</a:t>
+              <a:t>for the cost of one sweep per view per outer iteration instead of a converged scatter solve for every new volume.</a:t>
             </a:r>
           </a:p>
         </p:txBody>

</xml_diff>

<commit_message>
Docs: flowchart back to the solver-band layout with a prominent age-ordered recursion loop and equation; n MBIR iterations per outer iteration; grid box and Parker-weight detail removed
Co-Authored-By: Claude Fable 5.1 <noreply@anthropic.com>
</commit_message>
<xml_diff>
--- a/docs/figures/citrus_pipeline.pptx
+++ b/docs/figures/citrus_pipeline.pptx
@@ -3096,8 +3096,8 @@
         </p:nvSpPr>
         <p:spPr>
           <a:xfrm>
-            <a:off x="365760" y="1463040"/>
-            <a:ext cx="2011680" cy="868680"/>
+            <a:off x="320040" y="1280160"/>
+            <a:ext cx="2057400" cy="868680"/>
           </a:xfrm>
           <a:prstGeom prst="roundRect">
             <a:avLst>
@@ -3134,7 +3134,7 @@
           <a:p>
             <a:pPr algn="ctr"/>
             <a:r>
-              <a:rPr sz="1200" b="1">
+              <a:rPr sz="1100" b="1">
                 <a:solidFill>
                   <a:srgbClr val="1F3864"/>
                 </a:solidFill>
@@ -3146,7 +3146,7 @@
           <a:p>
             <a:pPr algn="ctr"/>
             <a:r>
-              <a:rPr sz="1200" b="0">
+              <a:rPr sz="1100" b="0">
                 <a:solidFill>
                   <a:srgbClr val="1F3864"/>
                 </a:solidFill>
@@ -3165,8 +3165,8 @@
         </p:nvSpPr>
         <p:spPr>
           <a:xfrm>
-            <a:off x="365760" y="3017520"/>
-            <a:ext cx="2011680" cy="868680"/>
+            <a:off x="320040" y="3017520"/>
+            <a:ext cx="2057400" cy="868680"/>
           </a:xfrm>
           <a:prstGeom prst="roundRect">
             <a:avLst>
@@ -3203,7 +3203,7 @@
           <a:p>
             <a:pPr algn="ctr"/>
             <a:r>
-              <a:rPr sz="1200" b="1">
+              <a:rPr sz="1100" b="1">
                 <a:solidFill>
                   <a:srgbClr val="1F3864"/>
                 </a:solidFill>
@@ -3215,7 +3215,7 @@
           <a:p>
             <a:pPr algn="ctr"/>
             <a:r>
-              <a:rPr sz="1200" b="0">
+              <a:rPr sz="1100" b="0">
                 <a:solidFill>
                   <a:srgbClr val="1F3864"/>
                 </a:solidFill>
@@ -3234,8 +3234,8 @@
         </p:nvCxnSpPr>
         <p:spPr>
           <a:xfrm>
-            <a:off x="1371600" y="2331720"/>
-            <a:ext cx="0" cy="685800"/>
+            <a:off x="1348740" y="2148840"/>
+            <a:ext cx="0" cy="868680"/>
           </a:xfrm>
           <a:prstGeom prst="line">
             <a:avLst/>
@@ -3270,8 +3270,8 @@
         </p:nvSpPr>
         <p:spPr>
           <a:xfrm>
-            <a:off x="2743200" y="365760"/>
-            <a:ext cx="9144000" cy="5806440"/>
+            <a:off x="2788920" y="411480"/>
+            <a:ext cx="9098280" cy="5577840"/>
           </a:xfrm>
           <a:prstGeom prst="roundRect">
             <a:avLst>
@@ -3326,7 +3326,7 @@
         </p:nvSpPr>
         <p:spPr>
           <a:xfrm>
-            <a:off x="2971800" y="411480"/>
+            <a:off x="3017520" y="457200"/>
             <a:ext cx="8229600" cy="274320"/>
           </a:xfrm>
           <a:prstGeom prst="rect">
@@ -3342,7 +3342,7 @@
           <a:p>
             <a:pPr algn="l"/>
             <a:r>
-              <a:rPr sz="1300" b="1" i="0">
+              <a:rPr sz="1200" b="1" i="0">
                 <a:solidFill>
                   <a:srgbClr val="404040"/>
                 </a:solidFill>
@@ -3361,8 +3361,8 @@
         </p:nvSpPr>
         <p:spPr>
           <a:xfrm>
-            <a:off x="3063240" y="914400"/>
-            <a:ext cx="2240280" cy="960120"/>
+            <a:off x="3200400" y="914400"/>
+            <a:ext cx="4754880" cy="960120"/>
           </a:xfrm>
           <a:prstGeom prst="roundRect">
             <a:avLst>
@@ -3405,7 +3405,7 @@
                 </a:solidFill>
                 <a:latin typeface="Calibri"/>
               </a:rPr>
-              <a:t>Material densities</a:t>
+              <a:t>Material densities ρ(Xₖ)</a:t>
             </a:r>
           </a:p>
           <a:p>
@@ -3417,7 +3417,7 @@
                 </a:solidFill>
                 <a:latin typeface="Calibri"/>
               </a:rPr>
-              <a:t>ρ(Xₖ): each voxel a mixture of</a:t>
+              <a:t>each voxel a mixture of the two anchor materials</a:t>
             </a:r>
           </a:p>
           <a:p>
@@ -3429,7 +3429,7 @@
                 </a:solidFill>
                 <a:latin typeface="Calibri"/>
               </a:rPr>
-              <a:t>two anchor materials</a:t>
+              <a:t>whose attenuations bracket its value</a:t>
             </a:r>
           </a:p>
         </p:txBody>
@@ -3442,8 +3442,191 @@
         </p:nvSpPr>
         <p:spPr>
           <a:xfrm>
-            <a:off x="5669280" y="868680"/>
-            <a:ext cx="5943600" cy="2011680"/>
+            <a:off x="8229600" y="914400"/>
+            <a:ext cx="3429000" cy="960120"/>
+          </a:xfrm>
+          <a:prstGeom prst="roundRect">
+            <a:avLst>
+              <a:gd name="adj" fmla="val 12000"/>
+            </a:avLst>
+          </a:prstGeom>
+          <a:solidFill>
+            <a:srgbClr val="F2F2F2"/>
+          </a:solidFill>
+          <a:ln w="15875">
+            <a:solidFill>
+              <a:srgbClr val="7F7F7F"/>
+            </a:solidFill>
+          </a:ln>
+          <a:effectLst/>
+        </p:spPr>
+        <p:style>
+          <a:lnRef idx="1">
+            <a:schemeClr val="accent1"/>
+          </a:lnRef>
+          <a:fillRef idx="3">
+            <a:schemeClr val="accent1"/>
+          </a:fillRef>
+          <a:effectRef idx="2">
+            <a:schemeClr val="accent1"/>
+          </a:effectRef>
+          <a:fontRef idx="minor">
+            <a:schemeClr val="lt1"/>
+          </a:fontRef>
+        </p:style>
+        <p:txBody>
+          <a:bodyPr rtlCol="0" anchor="ctr" wrap="square" lIns="54864" rIns="54864" tIns="27432" bIns="27432"/>
+          <a:lstStyle/>
+          <a:p>
+            <a:pPr algn="ctr"/>
+            <a:r>
+              <a:rPr sz="900" b="1">
+                <a:solidFill>
+                  <a:srgbClr val="404040"/>
+                </a:solidFill>
+                <a:latin typeface="Calibri"/>
+              </a:rPr>
+              <a:t>Schedule</a:t>
+            </a:r>
+          </a:p>
+          <a:p>
+            <a:pPr algn="ctr"/>
+            <a:r>
+              <a:rPr sz="900" b="0">
+                <a:solidFill>
+                  <a:srgbClr val="404040"/>
+                </a:solidFill>
+                <a:latin typeface="Calibri"/>
+              </a:rPr>
+              <a:t>scatter step at every n-th outer iteration;</a:t>
+            </a:r>
+          </a:p>
+          <a:p>
+            <a:pPr algn="ctr"/>
+            <a:r>
+              <a:rPr sz="900" b="0">
+                <a:solidFill>
+                  <a:srgbClr val="404040"/>
+                </a:solidFill>
+                <a:latin typeface="Calibri"/>
+              </a:rPr>
+              <a:t>scatter on every m-th view, the others</a:t>
+            </a:r>
+          </a:p>
+          <a:p>
+            <a:pPr algn="ctr"/>
+            <a:r>
+              <a:rPr sz="900" b="0">
+                <a:solidFill>
+                  <a:srgbClr val="404040"/>
+                </a:solidFill>
+                <a:latin typeface="Calibri"/>
+              </a:rPr>
+              <a:t>interpolated in angle</a:t>
+            </a:r>
+          </a:p>
+        </p:txBody>
+      </p:sp>
+      <p:sp>
+        <p:nvSpPr>
+          <p:cNvPr id="9" name="Rectangle 8"/>
+          <p:cNvSpPr/>
+          <p:nvPr/>
+        </p:nvSpPr>
+        <p:spPr>
+          <a:xfrm>
+            <a:off x="3611880" y="2148840"/>
+            <a:ext cx="8138159" cy="2103120"/>
+          </a:xfrm>
+          <a:prstGeom prst="rect">
+            <a:avLst/>
+          </a:prstGeom>
+          <a:solidFill>
+            <a:srgbClr val="FDF3EC"/>
+          </a:solidFill>
+          <a:ln w="9525">
+            <a:solidFill>
+              <a:srgbClr val="C55A11"/>
+            </a:solidFill>
+          </a:ln>
+          <a:effectLst/>
+        </p:spPr>
+        <p:style>
+          <a:lnRef idx="1">
+            <a:schemeClr val="accent1"/>
+          </a:lnRef>
+          <a:fillRef idx="3">
+            <a:schemeClr val="accent1"/>
+          </a:fillRef>
+          <a:effectRef idx="2">
+            <a:schemeClr val="accent1"/>
+          </a:effectRef>
+          <a:fontRef idx="minor">
+            <a:schemeClr val="lt1"/>
+          </a:fontRef>
+        </p:style>
+        <p:txBody>
+          <a:bodyPr rtlCol="0" anchor="ctr" wrap="square" lIns="54864" rIns="54864" tIns="27432" bIns="27432"/>
+          <a:lstStyle/>
+          <a:p>
+            <a:pPr algn="ctr"/>
+            <a:r>
+              <a:rPr sz="1100" b="1">
+                <a:solidFill>
+                  <a:srgbClr val="843C0C"/>
+                </a:solidFill>
+                <a:latin typeface="Calibri"/>
+              </a:rPr>
+              <a:t/>
+            </a:r>
+          </a:p>
+        </p:txBody>
+      </p:sp>
+      <p:sp>
+        <p:nvSpPr>
+          <p:cNvPr id="10" name="TextBox 9"/>
+          <p:cNvSpPr txBox="1"/>
+          <p:nvPr/>
+        </p:nvSpPr>
+        <p:spPr>
+          <a:xfrm>
+            <a:off x="3703320" y="2176272"/>
+            <a:ext cx="7772400" cy="256032"/>
+          </a:xfrm>
+          <a:prstGeom prst="rect">
+            <a:avLst/>
+          </a:prstGeom>
+          <a:noFill/>
+        </p:spPr>
+        <p:txBody>
+          <a:bodyPr wrap="square" lIns="18288" rIns="18288" tIns="0" bIns="0">
+            <a:spAutoFit/>
+          </a:bodyPr>
+          <a:lstStyle/>
+          <a:p>
+            <a:pPr algn="l"/>
+            <a:r>
+              <a:rPr sz="1000" b="1" i="0">
+                <a:solidFill>
+                  <a:srgbClr val="843C0C"/>
+                </a:solidFill>
+                <a:latin typeface="Calibri"/>
+              </a:rPr>
+              <a:t>LBTE scatter solver, one step per view v (deterministic, multigroup, discrete ordinates)</a:t>
+            </a:r>
+          </a:p>
+        </p:txBody>
+      </p:sp>
+      <p:sp>
+        <p:nvSpPr>
+          <p:cNvPr id="11" name="Rounded Rectangle 10"/>
+          <p:cNvSpPr/>
+          <p:nvPr/>
+        </p:nvSpPr>
+        <p:spPr>
+          <a:xfrm>
+            <a:off x="3749039" y="2487168"/>
+            <a:ext cx="2514600" cy="1097280"/>
           </a:xfrm>
           <a:prstGeom prst="roundRect">
             <a:avLst>
@@ -3475,87 +3658,180 @@
           </a:fontRef>
         </p:style>
         <p:txBody>
-          <a:bodyPr rtlCol="0" anchor="t" wrap="square" lIns="54864" rIns="54864" tIns="73152" bIns="27432"/>
+          <a:bodyPr rtlCol="0" anchor="ctr" wrap="square" lIns="54864" rIns="54864" tIns="27432" bIns="27432"/>
           <a:lstStyle/>
           <a:p>
             <a:pPr algn="ctr"/>
             <a:r>
-              <a:rPr sz="1200" b="1">
+              <a:rPr sz="1100" b="1">
                 <a:solidFill>
                   <a:srgbClr val="843C0C"/>
                 </a:solidFill>
                 <a:latin typeface="Calibri"/>
               </a:rPr>
-              <a:t/>
-            </a:r>
-            <a:r>
-              <a:rPr sz="1300" b="1">
+              <a:t>Uncollided fluence</a:t>
+            </a:r>
+          </a:p>
+          <a:p>
+            <a:pPr algn="ctr"/>
+            <a:r>
+              <a:rPr sz="1100" b="0">
                 <a:solidFill>
                   <a:srgbClr val="843C0C"/>
                 </a:solidFill>
                 <a:latin typeface="Calibri"/>
               </a:rPr>
-              <a:t>Age-ordered scatter recursion:  one transport sweep Gₖ per view</a:t>
+              <a:t>and first-collision source</a:t>
             </a:r>
           </a:p>
           <a:p>
             <a:pPr algn="ctr"/>
             <a:r>
-              <a:rPr sz="400" b="0">
+              <a:rPr sz="1100" b="0">
                 <a:solidFill>
                   <a:srgbClr val="843C0C"/>
                 </a:solidFill>
                 <a:latin typeface="Calibri"/>
               </a:rPr>
-              <a:t/>
-            </a:r>
-          </a:p>
+              <a:t>φ₁⁽ᵏ⁾ of the densities ρ(Xₖ)</a:t>
+            </a:r>
+          </a:p>
+        </p:txBody>
+      </p:sp>
+      <p:sp>
+        <p:nvSpPr>
+          <p:cNvPr id="12" name="Rounded Rectangle 11"/>
+          <p:cNvSpPr/>
+          <p:nvPr/>
+        </p:nvSpPr>
+        <p:spPr>
+          <a:xfrm>
+            <a:off x="6537960" y="2487168"/>
+            <a:ext cx="2697480" cy="1097280"/>
+          </a:xfrm>
+          <a:prstGeom prst="roundRect">
+            <a:avLst>
+              <a:gd name="adj" fmla="val 12000"/>
+            </a:avLst>
+          </a:prstGeom>
+          <a:solidFill>
+            <a:srgbClr val="FBE5D6"/>
+          </a:solidFill>
+          <a:ln w="15875">
+            <a:solidFill>
+              <a:srgbClr val="C55A11"/>
+            </a:solidFill>
+          </a:ln>
+          <a:effectLst/>
+        </p:spPr>
+        <p:style>
+          <a:lnRef idx="1">
+            <a:schemeClr val="accent1"/>
+          </a:lnRef>
+          <a:fillRef idx="3">
+            <a:schemeClr val="accent1"/>
+          </a:fillRef>
+          <a:effectRef idx="2">
+            <a:schemeClr val="accent1"/>
+          </a:effectRef>
+          <a:fontRef idx="minor">
+            <a:schemeClr val="lt1"/>
+          </a:fontRef>
+        </p:style>
+        <p:txBody>
+          <a:bodyPr rtlCol="0" anchor="ctr" wrap="square" lIns="54864" rIns="54864" tIns="27432" bIns="27432"/>
+          <a:lstStyle/>
           <a:p>
             <a:pPr algn="ctr"/>
             <a:r>
-              <a:rPr sz="1800" b="1">
+              <a:rPr sz="1000" b="1">
                 <a:solidFill>
                   <a:srgbClr val="843C0C"/>
                 </a:solidFill>
                 <a:latin typeface="Calibri"/>
               </a:rPr>
-              <a:t>Φᵥ⁽ᵏ⁾  =  Gₖ φ₁(Xₖ)  +  Gₖ Φᵥ⁽ᵏ⁻¹⁾</a:t>
+              <a:t>One transport sweep Gₖ</a:t>
             </a:r>
           </a:p>
           <a:p>
             <a:pPr algn="ctr"/>
             <a:r>
-              <a:rPr sz="900" b="0">
-                <a:solidFill>
-                  <a:srgbClr val="C55A11"/>
+              <a:rPr sz="1000" b="0">
+                <a:solidFill>
+                  <a:srgbClr val="843C0C"/>
                 </a:solidFill>
                 <a:latin typeface="Calibri"/>
               </a:rPr>
-              <a:t>newest first-collision source        previous accumulator</a:t>
+              <a:t>over φ₁⁽ᵏ⁾ + the aged accumulator</a:t>
             </a:r>
           </a:p>
           <a:p>
             <a:pPr algn="ctr"/>
             <a:r>
-              <a:rPr sz="400" b="0">
+              <a:rPr sz="1000" b="0">
                 <a:solidFill>
                   <a:srgbClr val="843C0C"/>
                 </a:solidFill>
                 <a:latin typeface="Calibri"/>
               </a:rPr>
-              <a:t/>
-            </a:r>
-          </a:p>
+              <a:t>Φᵥ⁽ᵏ⁻¹⁾  →  Φᵥ⁽ᵏ⁾ (all collision orders)</a:t>
+            </a:r>
+          </a:p>
+        </p:txBody>
+      </p:sp>
+      <p:sp>
+        <p:nvSpPr>
+          <p:cNvPr id="13" name="Rounded Rectangle 12"/>
+          <p:cNvSpPr/>
+          <p:nvPr/>
+        </p:nvSpPr>
+        <p:spPr>
+          <a:xfrm>
+            <a:off x="9509760" y="2487168"/>
+            <a:ext cx="2148840" cy="1097280"/>
+          </a:xfrm>
+          <a:prstGeom prst="roundRect">
+            <a:avLst>
+              <a:gd name="adj" fmla="val 12000"/>
+            </a:avLst>
+          </a:prstGeom>
+          <a:solidFill>
+            <a:srgbClr val="FBE5D6"/>
+          </a:solidFill>
+          <a:ln w="15875">
+            <a:solidFill>
+              <a:srgbClr val="C55A11"/>
+            </a:solidFill>
+          </a:ln>
+          <a:effectLst/>
+        </p:spPr>
+        <p:style>
+          <a:lnRef idx="1">
+            <a:schemeClr val="accent1"/>
+          </a:lnRef>
+          <a:fillRef idx="3">
+            <a:schemeClr val="accent1"/>
+          </a:fillRef>
+          <a:effectRef idx="2">
+            <a:schemeClr val="accent1"/>
+          </a:effectRef>
+          <a:fontRef idx="minor">
+            <a:schemeClr val="lt1"/>
+          </a:fontRef>
+        </p:style>
+        <p:txBody>
+          <a:bodyPr rtlCol="0" anchor="ctr" wrap="square" lIns="54864" rIns="54864" tIns="27432" bIns="27432"/>
+          <a:lstStyle/>
           <a:p>
             <a:pPr algn="ctr"/>
             <a:r>
-              <a:rPr sz="1300" b="0">
+              <a:rPr sz="1000" b="1">
                 <a:solidFill>
                   <a:srgbClr val="843C0C"/>
                 </a:solidFill>
                 <a:latin typeface="Calibri"/>
               </a:rPr>
-              <a:t>=  Gₖ φ₁⁽ᵏ⁾  +  GₖGₖ₋₁ φ₁⁽ᵏ⁻¹⁾  +  GₖGₖ₋₁Gₖ₋₂ φ₁⁽ᵏ⁻²⁾  +  …</a:t>
+              <a:t>Collapsed-cone projection</a:t>
             </a:r>
           </a:p>
           <a:p>
@@ -3567,7 +3843,7 @@
                 </a:solidFill>
                 <a:latin typeface="Calibri"/>
               </a:rPr>
-              <a:t>2nd-order scatter from Xₖ,  3rd order from Xₖ₋₁,  4th order from Xₖ₋₂, …</a:t>
+              <a:t>of the scatter emission</a:t>
             </a:r>
           </a:p>
           <a:p>
@@ -3579,33 +3855,21 @@
                 </a:solidFill>
                 <a:latin typeface="Calibri"/>
               </a:rPr>
-              <a:t>the dominant low orders are refreshed from the newest reconstruction;</a:t>
-            </a:r>
-          </a:p>
-          <a:p>
-            <a:pPr algn="ctr"/>
-            <a:r>
-              <a:rPr sz="1000" b="0">
-                <a:solidFill>
-                  <a:srgbClr val="843C0C"/>
-                </a:solidFill>
-                <a:latin typeface="Calibri"/>
-              </a:rPr>
-              <a:t>stale information is pushed into the weak, smooth high orders</a:t>
+              <a:t>to the panel → sᵥ</a:t>
             </a:r>
           </a:p>
         </p:txBody>
       </p:sp>
       <p:cxnSp>
         <p:nvCxnSpPr>
-          <p:cNvPr id="9" name="Connector 8"/>
+          <p:cNvPr id="14" name="Connector 13"/>
           <p:cNvCxnSpPr/>
           <p:nvPr/>
         </p:nvCxnSpPr>
         <p:spPr>
           <a:xfrm>
-            <a:off x="5303520" y="1394460"/>
-            <a:ext cx="365760" cy="0"/>
+            <a:off x="6263639" y="3035808"/>
+            <a:ext cx="274321" cy="0"/>
           </a:xfrm>
           <a:prstGeom prst="line">
             <a:avLst/>
@@ -3634,23 +3898,23 @@
       </p:cxnSp>
       <p:cxnSp>
         <p:nvCxnSpPr>
-          <p:cNvPr id="10" name="Connector 9"/>
+          <p:cNvPr id="15" name="Connector 14"/>
           <p:cNvCxnSpPr/>
           <p:nvPr/>
         </p:nvCxnSpPr>
         <p:spPr>
           <a:xfrm>
-            <a:off x="10515600" y="2880360"/>
-            <a:ext cx="0" cy="274319"/>
+            <a:off x="9235440" y="3035808"/>
+            <a:ext cx="274320" cy="0"/>
           </a:xfrm>
           <a:prstGeom prst="line">
             <a:avLst/>
           </a:prstGeom>
-          <a:ln w="25400">
+          <a:ln w="19050">
             <a:solidFill>
-              <a:srgbClr val="C55A11"/>
+              <a:srgbClr val="595959"/>
             </a:solidFill>
-            <a:prstDash val="dash"/>
+            <a:tailEnd type="triangle" w="med" len="med"/>
           </a:ln>
         </p:spPr>
         <p:style>
@@ -3670,23 +3934,22 @@
       </p:cxnSp>
       <p:cxnSp>
         <p:nvCxnSpPr>
-          <p:cNvPr id="11" name="Connector 10"/>
+          <p:cNvPr id="16" name="Connector 15"/>
           <p:cNvCxnSpPr/>
           <p:nvPr/>
         </p:nvCxnSpPr>
         <p:spPr>
-          <a:xfrm flipH="1">
-            <a:off x="6766560" y="3154679"/>
-            <a:ext cx="3749040" cy="0"/>
+          <a:xfrm>
+            <a:off x="8983980" y="3584448"/>
+            <a:ext cx="0" cy="292608"/>
           </a:xfrm>
           <a:prstGeom prst="line">
             <a:avLst/>
           </a:prstGeom>
-          <a:ln w="25400">
+          <a:ln w="38100">
             <a:solidFill>
               <a:srgbClr val="C55A11"/>
             </a:solidFill>
-            <a:prstDash val="dash"/>
           </a:ln>
         </p:spPr>
         <p:style>
@@ -3706,24 +3969,22 @@
       </p:cxnSp>
       <p:cxnSp>
         <p:nvCxnSpPr>
-          <p:cNvPr id="12" name="Connector 11"/>
+          <p:cNvPr id="17" name="Connector 16"/>
           <p:cNvCxnSpPr/>
           <p:nvPr/>
         </p:nvCxnSpPr>
         <p:spPr>
-          <a:xfrm flipV="1">
-            <a:off x="6766560" y="2889503"/>
-            <a:ext cx="0" cy="265176"/>
+          <a:xfrm flipH="1">
+            <a:off x="6789420" y="3877056"/>
+            <a:ext cx="2194560" cy="0"/>
           </a:xfrm>
           <a:prstGeom prst="line">
             <a:avLst/>
           </a:prstGeom>
-          <a:ln w="25400">
+          <a:ln w="38100">
             <a:solidFill>
               <a:srgbClr val="C55A11"/>
             </a:solidFill>
-            <a:prstDash val="dash"/>
-            <a:tailEnd type="triangle" w="med" len="med"/>
           </a:ln>
         </p:spPr>
         <p:style>
@@ -3741,16 +4002,52 @@
           </a:fontRef>
         </p:style>
       </p:cxnSp>
-      <p:sp>
-        <p:nvSpPr>
-          <p:cNvPr id="13" name="TextBox 12"/>
+      <p:cxnSp>
+        <p:nvCxnSpPr>
+          <p:cNvPr id="18" name="Connector 17"/>
+          <p:cNvCxnSpPr/>
+          <p:nvPr/>
+        </p:nvCxnSpPr>
+        <p:spPr>
+          <a:xfrm flipV="1">
+            <a:off x="6789420" y="3602736"/>
+            <a:ext cx="0" cy="274320"/>
+          </a:xfrm>
+          <a:prstGeom prst="line">
+            <a:avLst/>
+          </a:prstGeom>
+          <a:ln w="38100">
+            <a:solidFill>
+              <a:srgbClr val="C55A11"/>
+            </a:solidFill>
+            <a:tailEnd type="triangle" w="med" len="med"/>
+          </a:ln>
+        </p:spPr>
+        <p:style>
+          <a:lnRef idx="2">
+            <a:schemeClr val="accent1"/>
+          </a:lnRef>
+          <a:fillRef idx="0">
+            <a:schemeClr val="accent1"/>
+          </a:fillRef>
+          <a:effectRef idx="1">
+            <a:schemeClr val="accent1"/>
+          </a:effectRef>
+          <a:fontRef idx="minor">
+            <a:schemeClr val="tx1"/>
+          </a:fontRef>
+        </p:style>
+      </p:cxnSp>
+      <p:sp>
+        <p:nvSpPr>
+          <p:cNvPr id="19" name="TextBox 18"/>
           <p:cNvSpPr txBox="1"/>
           <p:nvPr/>
         </p:nvSpPr>
         <p:spPr>
           <a:xfrm>
-            <a:off x="6858000" y="2935224"/>
-            <a:ext cx="3566160" cy="182880"/>
+            <a:off x="3703320" y="3913632"/>
+            <a:ext cx="7863840" cy="274320"/>
           </a:xfrm>
           <a:prstGeom prst="rect">
             <a:avLst/>
@@ -3765,27 +4062,213 @@
           <a:p>
             <a:pPr algn="l"/>
             <a:r>
-              <a:rPr sz="900" b="0" i="1">
+              <a:rPr sz="1050" b="1" i="0">
                 <a:solidFill>
                   <a:srgbClr val="843C0C"/>
                 </a:solidFill>
                 <a:latin typeface="Calibri"/>
               </a:rPr>
-              <a:t>Φᵥ⁽ᵏ⁾ kept per view → enters the next outer iteration as Φᵥ⁽ᵏ⁾</a:t>
-            </a:r>
-          </a:p>
-        </p:txBody>
-      </p:sp>
-      <p:sp>
-        <p:nvSpPr>
-          <p:cNvPr id="14" name="Rounded Rectangle 13"/>
+              <a:t>Age-ordered recursion:   Φᵥ⁽ᵏ⁾ = Gₖ φ₁⁽ᵏ⁾ + Gₖ Φᵥ⁽ᵏ⁻¹⁾      (Φᵥ kept per view across outer iterations)</a:t>
+            </a:r>
+          </a:p>
+        </p:txBody>
+      </p:sp>
+      <p:sp>
+        <p:nvSpPr>
+          <p:cNvPr id="20" name="TextBox 19"/>
+          <p:cNvSpPr txBox="1"/>
+          <p:nvPr/>
+        </p:nvSpPr>
+        <p:spPr>
+          <a:xfrm>
+            <a:off x="3703320" y="4133087"/>
+            <a:ext cx="7863840" cy="182880"/>
+          </a:xfrm>
+          <a:prstGeom prst="rect">
+            <a:avLst/>
+          </a:prstGeom>
+          <a:noFill/>
+        </p:spPr>
+        <p:txBody>
+          <a:bodyPr wrap="square" lIns="18288" rIns="18288" tIns="0" bIns="0">
+            <a:spAutoFit/>
+          </a:bodyPr>
+          <a:lstStyle/>
+          <a:p>
+            <a:pPr algn="l"/>
+            <a:r>
+              <a:rPr sz="900" b="0" i="1">
+                <a:solidFill>
+                  <a:srgbClr val="843C0C"/>
+                </a:solidFill>
+                <a:latin typeface="Calibri"/>
+              </a:rPr>
+              <a:t>= Gₖ φ₁⁽ᵏ⁾ + GₖGₖ₋₁ φ₁⁽ᵏ⁻¹⁾ + GₖGₖ₋₁Gₖ₋₂ φ₁⁽ᵏ⁻²⁾ + … :  2nd order from Xₖ, 3rd from Xₖ₋₁, …  (low orders refreshed first)</a:t>
+            </a:r>
+          </a:p>
+        </p:txBody>
+      </p:sp>
+      <p:sp>
+        <p:nvSpPr>
+          <p:cNvPr id="21" name="TextBox 20"/>
+          <p:cNvSpPr txBox="1"/>
+          <p:nvPr/>
+        </p:nvSpPr>
+        <p:spPr>
+          <a:xfrm>
+            <a:off x="9029700" y="3657600"/>
+            <a:ext cx="1463040" cy="182880"/>
+          </a:xfrm>
+          <a:prstGeom prst="rect">
+            <a:avLst/>
+          </a:prstGeom>
+          <a:noFill/>
+        </p:spPr>
+        <p:txBody>
+          <a:bodyPr wrap="square" lIns="18288" rIns="18288" tIns="0" bIns="0">
+            <a:spAutoFit/>
+          </a:bodyPr>
+          <a:lstStyle/>
+          <a:p>
+            <a:pPr algn="l"/>
+            <a:r>
+              <a:rPr sz="900" b="0" i="1">
+                <a:solidFill>
+                  <a:srgbClr val="843C0C"/>
+                </a:solidFill>
+                <a:latin typeface="Calibri"/>
+              </a:rPr>
+              <a:t>Φᵥ⁽ᵏ⁾ out</a:t>
+            </a:r>
+          </a:p>
+        </p:txBody>
+      </p:sp>
+      <p:sp>
+        <p:nvSpPr>
+          <p:cNvPr id="22" name="TextBox 21"/>
+          <p:cNvSpPr txBox="1"/>
+          <p:nvPr/>
+        </p:nvSpPr>
+        <p:spPr>
+          <a:xfrm>
+            <a:off x="6012180" y="3657600"/>
+            <a:ext cx="731520" cy="182880"/>
+          </a:xfrm>
+          <a:prstGeom prst="rect">
+            <a:avLst/>
+          </a:prstGeom>
+          <a:noFill/>
+        </p:spPr>
+        <p:txBody>
+          <a:bodyPr wrap="square" lIns="18288" rIns="18288" tIns="0" bIns="0">
+            <a:spAutoFit/>
+          </a:bodyPr>
+          <a:lstStyle/>
+          <a:p>
+            <a:pPr algn="r"/>
+            <a:r>
+              <a:rPr sz="900" b="0" i="1">
+                <a:solidFill>
+                  <a:srgbClr val="843C0C"/>
+                </a:solidFill>
+                <a:latin typeface="Calibri"/>
+              </a:rPr>
+              <a:t>Φᵥ⁽ᵏ⁻¹⁾ in</a:t>
+            </a:r>
+          </a:p>
+        </p:txBody>
+      </p:sp>
+      <p:sp>
+        <p:nvSpPr>
+          <p:cNvPr id="23" name="Rounded Rectangle 22"/>
           <p:cNvSpPr/>
           <p:nvPr/>
         </p:nvSpPr>
         <p:spPr>
           <a:xfrm>
-            <a:off x="3063240" y="3977639"/>
-            <a:ext cx="3611880" cy="1005840"/>
+            <a:off x="3200400" y="4617720"/>
+            <a:ext cx="2103120" cy="960120"/>
+          </a:xfrm>
+          <a:prstGeom prst="roundRect">
+            <a:avLst>
+              <a:gd name="adj" fmla="val 12000"/>
+            </a:avLst>
+          </a:prstGeom>
+          <a:solidFill>
+            <a:srgbClr val="E4DFEC"/>
+          </a:solidFill>
+          <a:ln w="15875">
+            <a:solidFill>
+              <a:srgbClr val="7030A0"/>
+            </a:solidFill>
+          </a:ln>
+          <a:effectLst/>
+        </p:spPr>
+        <p:style>
+          <a:lnRef idx="1">
+            <a:schemeClr val="accent1"/>
+          </a:lnRef>
+          <a:fillRef idx="3">
+            <a:schemeClr val="accent1"/>
+          </a:fillRef>
+          <a:effectRef idx="2">
+            <a:schemeClr val="accent1"/>
+          </a:effectRef>
+          <a:fontRef idx="minor">
+            <a:schemeClr val="lt1"/>
+          </a:fontRef>
+        </p:style>
+        <p:txBody>
+          <a:bodyPr rtlCol="0" anchor="ctr" wrap="square" lIns="54864" rIns="54864" tIns="27432" bIns="27432"/>
+          <a:lstStyle/>
+          <a:p>
+            <a:pPr algn="ctr"/>
+            <a:r>
+              <a:rPr sz="1000" b="1">
+                <a:solidFill>
+                  <a:srgbClr val="3F1F5E"/>
+                </a:solidFill>
+                <a:latin typeface="Calibri"/>
+              </a:rPr>
+              <a:t>Primary pᵥ of every view</a:t>
+            </a:r>
+          </a:p>
+          <a:p>
+            <a:pPr algn="ctr"/>
+            <a:r>
+              <a:rPr sz="1000" b="0">
+                <a:solidFill>
+                  <a:srgbClr val="3F1F5E"/>
+                </a:solidFill>
+                <a:latin typeface="Calibri"/>
+              </a:rPr>
+              <a:t>projection of the densities ρ(Xₖ)</a:t>
+            </a:r>
+          </a:p>
+          <a:p>
+            <a:pPr algn="ctr"/>
+            <a:r>
+              <a:rPr sz="1000" b="0">
+                <a:solidFill>
+                  <a:srgbClr val="3F1F5E"/>
+                </a:solidFill>
+                <a:latin typeface="Calibri"/>
+              </a:rPr>
+              <a:t>with the spectrum</a:t>
+            </a:r>
+          </a:p>
+        </p:txBody>
+      </p:sp>
+      <p:sp>
+        <p:nvSpPr>
+          <p:cNvPr id="24" name="Rounded Rectangle 23"/>
+          <p:cNvSpPr/>
+          <p:nvPr/>
+        </p:nvSpPr>
+        <p:spPr>
+          <a:xfrm>
+            <a:off x="5532120" y="4617720"/>
+            <a:ext cx="2011680" cy="960120"/>
           </a:xfrm>
           <a:prstGeom prst="roundRect">
             <a:avLst>
@@ -3822,19 +4305,19 @@
           <a:p>
             <a:pPr algn="ctr"/>
             <a:r>
-              <a:rPr sz="1100" b="1">
+              <a:rPr sz="1000" b="1">
                 <a:solidFill>
                   <a:srgbClr val="7F6000"/>
                 </a:solidFill>
                 <a:latin typeface="Calibri"/>
               </a:rPr>
-              <a:t>Scatter-to-primary ratio of every view</a:t>
+              <a:t>Scatter-to-primary ratio</a:t>
             </a:r>
           </a:p>
           <a:p>
             <a:pPr algn="ctr"/>
             <a:r>
-              <a:rPr sz="1100" b="0">
+              <a:rPr sz="1000" b="0">
                 <a:solidFill>
                   <a:srgbClr val="7F6000"/>
                 </a:solidFill>
@@ -3843,30 +4326,18 @@
               <a:t>SPRᵥ = sᵥ / pᵥ</a:t>
             </a:r>
           </a:p>
-          <a:p>
-            <a:pPr algn="ctr"/>
-            <a:r>
-              <a:rPr sz="1100" b="0">
-                <a:solidFill>
-                  <a:srgbClr val="7F6000"/>
-                </a:solidFill>
-                <a:latin typeface="Calibri"/>
-              </a:rPr>
-              <a:t>sᵥ: projected scatter of Φᵥ⁽ᵏ⁾;  pᵥ: primary of Xₖ</a:t>
-            </a:r>
-          </a:p>
-        </p:txBody>
-      </p:sp>
-      <p:sp>
-        <p:nvSpPr>
-          <p:cNvPr id="15" name="Rounded Rectangle 14"/>
+        </p:txBody>
+      </p:sp>
+      <p:sp>
+        <p:nvSpPr>
+          <p:cNvPr id="25" name="Rounded Rectangle 24"/>
           <p:cNvSpPr/>
           <p:nvPr/>
         </p:nvSpPr>
         <p:spPr>
           <a:xfrm>
-            <a:off x="6995160" y="3977639"/>
-            <a:ext cx="2194560" cy="1005840"/>
+            <a:off x="7772400" y="4617720"/>
+            <a:ext cx="1828800" cy="960120"/>
           </a:xfrm>
           <a:prstGeom prst="roundRect">
             <a:avLst>
@@ -3903,7 +4374,7 @@
           <a:p>
             <a:pPr algn="ctr"/>
             <a:r>
-              <a:rPr sz="1100" b="1">
+              <a:rPr sz="1000" b="1">
                 <a:solidFill>
                   <a:srgbClr val="7F6000"/>
                 </a:solidFill>
@@ -3915,7 +4386,7 @@
           <a:p>
             <a:pPr algn="ctr"/>
             <a:r>
-              <a:rPr sz="1100" b="0">
+              <a:rPr sz="1000" b="0">
                 <a:solidFill>
                   <a:srgbClr val="7F6000"/>
                 </a:solidFill>
@@ -3928,14 +4399,14 @@
       </p:sp>
       <p:sp>
         <p:nvSpPr>
-          <p:cNvPr id="16" name="Rounded Rectangle 15"/>
+          <p:cNvPr id="26" name="Rounded Rectangle 25"/>
           <p:cNvSpPr/>
           <p:nvPr/>
         </p:nvSpPr>
         <p:spPr>
           <a:xfrm>
-            <a:off x="9509760" y="3977639"/>
-            <a:ext cx="2103120" cy="1005840"/>
+            <a:off x="9829800" y="4617720"/>
+            <a:ext cx="1828800" cy="960120"/>
           </a:xfrm>
           <a:prstGeom prst="roundRect">
             <a:avLst>
@@ -3972,7 +4443,7 @@
           <a:p>
             <a:pPr algn="ctr"/>
             <a:r>
-              <a:rPr sz="1100" b="1">
+              <a:rPr sz="1000" b="1">
                 <a:solidFill>
                   <a:srgbClr val="1F3864"/>
                 </a:solidFill>
@@ -3984,371 +4455,29 @@
           <a:p>
             <a:pPr algn="ctr"/>
             <a:r>
-              <a:rPr sz="1100" b="0">
+              <a:rPr sz="1000" b="0">
                 <a:solidFill>
                   <a:srgbClr val="1F3864"/>
                 </a:solidFill>
                 <a:latin typeface="Calibri"/>
               </a:rPr>
-              <a:t>warm-started at Xₖ  →  Xₖ₊₁</a:t>
-            </a:r>
-          </a:p>
-        </p:txBody>
-      </p:sp>
-      <p:cxnSp>
-        <p:nvCxnSpPr>
-          <p:cNvPr id="17" name="Connector 16"/>
-          <p:cNvCxnSpPr/>
-          <p:nvPr/>
-        </p:nvCxnSpPr>
-        <p:spPr>
-          <a:xfrm>
-            <a:off x="6812279" y="3154679"/>
-            <a:ext cx="0" cy="594360"/>
-          </a:xfrm>
-          <a:prstGeom prst="line">
-            <a:avLst/>
-          </a:prstGeom>
-          <a:ln w="19050">
-            <a:solidFill>
-              <a:srgbClr val="595959"/>
-            </a:solidFill>
-          </a:ln>
-        </p:spPr>
-        <p:style>
-          <a:lnRef idx="2">
-            <a:schemeClr val="accent1"/>
-          </a:lnRef>
-          <a:fillRef idx="0">
-            <a:schemeClr val="accent1"/>
-          </a:fillRef>
-          <a:effectRef idx="1">
-            <a:schemeClr val="accent1"/>
-          </a:effectRef>
-          <a:fontRef idx="minor">
-            <a:schemeClr val="tx1"/>
-          </a:fontRef>
-        </p:style>
-      </p:cxnSp>
-      <p:cxnSp>
-        <p:nvCxnSpPr>
-          <p:cNvPr id="18" name="Connector 17"/>
-          <p:cNvCxnSpPr/>
-          <p:nvPr/>
-        </p:nvCxnSpPr>
-        <p:spPr>
-          <a:xfrm flipH="1">
-            <a:off x="5417820" y="3749039"/>
-            <a:ext cx="1394459" cy="0"/>
-          </a:xfrm>
-          <a:prstGeom prst="line">
-            <a:avLst/>
-          </a:prstGeom>
-          <a:ln w="19050">
-            <a:solidFill>
-              <a:srgbClr val="595959"/>
-            </a:solidFill>
-          </a:ln>
-        </p:spPr>
-        <p:style>
-          <a:lnRef idx="2">
-            <a:schemeClr val="accent1"/>
-          </a:lnRef>
-          <a:fillRef idx="0">
-            <a:schemeClr val="accent1"/>
-          </a:fillRef>
-          <a:effectRef idx="1">
-            <a:schemeClr val="accent1"/>
-          </a:effectRef>
-          <a:fontRef idx="minor">
-            <a:schemeClr val="tx1"/>
-          </a:fontRef>
-        </p:style>
-      </p:cxnSp>
-      <p:cxnSp>
-        <p:nvCxnSpPr>
-          <p:cNvPr id="19" name="Connector 18"/>
-          <p:cNvCxnSpPr/>
-          <p:nvPr/>
-        </p:nvCxnSpPr>
-        <p:spPr>
-          <a:xfrm>
-            <a:off x="5417820" y="3749039"/>
-            <a:ext cx="0" cy="228600"/>
-          </a:xfrm>
-          <a:prstGeom prst="line">
-            <a:avLst/>
-          </a:prstGeom>
-          <a:ln w="19050">
-            <a:solidFill>
-              <a:srgbClr val="595959"/>
-            </a:solidFill>
-            <a:tailEnd type="triangle" w="med" len="med"/>
-          </a:ln>
-        </p:spPr>
-        <p:style>
-          <a:lnRef idx="2">
-            <a:schemeClr val="accent1"/>
-          </a:lnRef>
-          <a:fillRef idx="0">
-            <a:schemeClr val="accent1"/>
-          </a:fillRef>
-          <a:effectRef idx="1">
-            <a:schemeClr val="accent1"/>
-          </a:effectRef>
-          <a:fontRef idx="minor">
-            <a:schemeClr val="tx1"/>
-          </a:fontRef>
-        </p:style>
-      </p:cxnSp>
-      <p:sp>
-        <p:nvSpPr>
-          <p:cNvPr id="20" name="TextBox 19"/>
-          <p:cNvSpPr txBox="1"/>
-          <p:nvPr/>
-        </p:nvSpPr>
-        <p:spPr>
-          <a:xfrm>
-            <a:off x="5490972" y="3749039"/>
-            <a:ext cx="457200" cy="182880"/>
-          </a:xfrm>
-          <a:prstGeom prst="rect">
-            <a:avLst/>
-          </a:prstGeom>
-          <a:noFill/>
-        </p:spPr>
-        <p:txBody>
-          <a:bodyPr wrap="square" lIns="18288" rIns="18288" tIns="0" bIns="0">
-            <a:spAutoFit/>
-          </a:bodyPr>
-          <a:lstStyle/>
-          <a:p>
-            <a:pPr algn="l"/>
-            <a:r>
-              <a:rPr sz="1000" b="0" i="1">
-                <a:solidFill>
-                  <a:srgbClr val="843C0C"/>
+              <a:t>warm-started at Xₖ</a:t>
+            </a:r>
+          </a:p>
+          <a:p>
+            <a:pPr algn="ctr"/>
+            <a:r>
+              <a:rPr sz="1000" b="0">
+                <a:solidFill>
+                  <a:srgbClr val="1F3864"/>
                 </a:solidFill>
                 <a:latin typeface="Calibri"/>
               </a:rPr>
-              <a:t>sᵥ</a:t>
-            </a:r>
-          </a:p>
-        </p:txBody>
-      </p:sp>
-      <p:cxnSp>
-        <p:nvCxnSpPr>
-          <p:cNvPr id="21" name="Connector 20"/>
-          <p:cNvCxnSpPr/>
-          <p:nvPr/>
-        </p:nvCxnSpPr>
-        <p:spPr>
-          <a:xfrm>
-            <a:off x="3634740" y="1874519"/>
-            <a:ext cx="0" cy="2103120"/>
-          </a:xfrm>
-          <a:prstGeom prst="line">
-            <a:avLst/>
-          </a:prstGeom>
-          <a:ln w="19050">
-            <a:solidFill>
-              <a:srgbClr val="7030A0"/>
-            </a:solidFill>
-            <a:tailEnd type="triangle" w="med" len="med"/>
-          </a:ln>
-        </p:spPr>
-        <p:style>
-          <a:lnRef idx="2">
-            <a:schemeClr val="accent1"/>
-          </a:lnRef>
-          <a:fillRef idx="0">
-            <a:schemeClr val="accent1"/>
-          </a:fillRef>
-          <a:effectRef idx="1">
-            <a:schemeClr val="accent1"/>
-          </a:effectRef>
-          <a:fontRef idx="minor">
-            <a:schemeClr val="tx1"/>
-          </a:fontRef>
-        </p:style>
-      </p:cxnSp>
-      <p:sp>
-        <p:nvSpPr>
-          <p:cNvPr id="22" name="TextBox 21"/>
-          <p:cNvSpPr txBox="1"/>
-          <p:nvPr/>
-        </p:nvSpPr>
-        <p:spPr>
-          <a:xfrm>
-            <a:off x="3680460" y="3291840"/>
-            <a:ext cx="822960" cy="182880"/>
-          </a:xfrm>
-          <a:prstGeom prst="rect">
-            <a:avLst/>
-          </a:prstGeom>
-          <a:noFill/>
-        </p:spPr>
-        <p:txBody>
-          <a:bodyPr wrap="square" lIns="18288" rIns="18288" tIns="0" bIns="0">
-            <a:spAutoFit/>
-          </a:bodyPr>
-          <a:lstStyle/>
-          <a:p>
-            <a:pPr algn="l"/>
-            <a:r>
-              <a:rPr sz="1000" b="0" i="1">
-                <a:solidFill>
-                  <a:srgbClr val="7030A0"/>
-                </a:solidFill>
-                <a:latin typeface="Calibri"/>
-              </a:rPr>
-              <a:t>pᵥ(Xₖ)</a:t>
-            </a:r>
-          </a:p>
-        </p:txBody>
-      </p:sp>
-      <p:cxnSp>
-        <p:nvCxnSpPr>
-          <p:cNvPr id="23" name="Connector 22"/>
-          <p:cNvCxnSpPr/>
-          <p:nvPr/>
-        </p:nvCxnSpPr>
-        <p:spPr>
-          <a:xfrm>
-            <a:off x="6675120" y="4480559"/>
-            <a:ext cx="320040" cy="0"/>
-          </a:xfrm>
-          <a:prstGeom prst="line">
-            <a:avLst/>
-          </a:prstGeom>
-          <a:ln w="19050">
-            <a:solidFill>
-              <a:srgbClr val="595959"/>
-            </a:solidFill>
-            <a:tailEnd type="triangle" w="med" len="med"/>
-          </a:ln>
-        </p:spPr>
-        <p:style>
-          <a:lnRef idx="2">
-            <a:schemeClr val="accent1"/>
-          </a:lnRef>
-          <a:fillRef idx="0">
-            <a:schemeClr val="accent1"/>
-          </a:fillRef>
-          <a:effectRef idx="1">
-            <a:schemeClr val="accent1"/>
-          </a:effectRef>
-          <a:fontRef idx="minor">
-            <a:schemeClr val="tx1"/>
-          </a:fontRef>
-        </p:style>
-      </p:cxnSp>
-      <p:cxnSp>
-        <p:nvCxnSpPr>
-          <p:cNvPr id="24" name="Connector 23"/>
-          <p:cNvCxnSpPr/>
-          <p:nvPr/>
-        </p:nvCxnSpPr>
-        <p:spPr>
-          <a:xfrm>
-            <a:off x="9189720" y="4480559"/>
-            <a:ext cx="320040" cy="0"/>
-          </a:xfrm>
-          <a:prstGeom prst="line">
-            <a:avLst/>
-          </a:prstGeom>
-          <a:ln w="19050">
-            <a:solidFill>
-              <a:srgbClr val="595959"/>
-            </a:solidFill>
-            <a:tailEnd type="triangle" w="med" len="med"/>
-          </a:ln>
-        </p:spPr>
-        <p:style>
-          <a:lnRef idx="2">
-            <a:schemeClr val="accent1"/>
-          </a:lnRef>
-          <a:fillRef idx="0">
-            <a:schemeClr val="accent1"/>
-          </a:fillRef>
-          <a:effectRef idx="1">
-            <a:schemeClr val="accent1"/>
-          </a:effectRef>
-          <a:fontRef idx="minor">
-            <a:schemeClr val="tx1"/>
-          </a:fontRef>
-        </p:style>
-      </p:cxnSp>
-      <p:cxnSp>
-        <p:nvCxnSpPr>
-          <p:cNvPr id="25" name="Connector 24"/>
-          <p:cNvCxnSpPr/>
-          <p:nvPr/>
-        </p:nvCxnSpPr>
-        <p:spPr>
-          <a:xfrm>
-            <a:off x="2377440" y="3451860"/>
-            <a:ext cx="182880" cy="0"/>
-          </a:xfrm>
-          <a:prstGeom prst="line">
-            <a:avLst/>
-          </a:prstGeom>
-          <a:ln w="19050">
-            <a:solidFill>
-              <a:srgbClr val="595959"/>
-            </a:solidFill>
-          </a:ln>
-        </p:spPr>
-        <p:style>
-          <a:lnRef idx="2">
-            <a:schemeClr val="accent1"/>
-          </a:lnRef>
-          <a:fillRef idx="0">
-            <a:schemeClr val="accent1"/>
-          </a:fillRef>
-          <a:effectRef idx="1">
-            <a:schemeClr val="accent1"/>
-          </a:effectRef>
-          <a:fontRef idx="minor">
-            <a:schemeClr val="tx1"/>
-          </a:fontRef>
-        </p:style>
-      </p:cxnSp>
-      <p:cxnSp>
-        <p:nvCxnSpPr>
-          <p:cNvPr id="26" name="Connector 25"/>
-          <p:cNvCxnSpPr/>
-          <p:nvPr/>
-        </p:nvCxnSpPr>
-        <p:spPr>
-          <a:xfrm flipV="1">
-            <a:off x="2560320" y="1394460"/>
-            <a:ext cx="0" cy="2057400"/>
-          </a:xfrm>
-          <a:prstGeom prst="line">
-            <a:avLst/>
-          </a:prstGeom>
-          <a:ln w="19050">
-            <a:solidFill>
-              <a:srgbClr val="595959"/>
-            </a:solidFill>
-          </a:ln>
-        </p:spPr>
-        <p:style>
-          <a:lnRef idx="2">
-            <a:schemeClr val="accent1"/>
-          </a:lnRef>
-          <a:fillRef idx="0">
-            <a:schemeClr val="accent1"/>
-          </a:fillRef>
-          <a:effectRef idx="1">
-            <a:schemeClr val="accent1"/>
-          </a:effectRef>
-          <a:fontRef idx="minor">
-            <a:schemeClr val="tx1"/>
-          </a:fontRef>
-        </p:style>
-      </p:cxnSp>
+              <a:t>→ Xₖ₊₁</a:t>
+            </a:r>
+          </a:p>
+        </p:txBody>
+      </p:sp>
       <p:cxnSp>
         <p:nvCxnSpPr>
           <p:cNvPr id="27" name="Connector 26"/>
@@ -4357,8 +4486,8 @@
         </p:nvCxnSpPr>
         <p:spPr>
           <a:xfrm>
-            <a:off x="2560320" y="1394460"/>
-            <a:ext cx="502920" cy="0"/>
+            <a:off x="5303520" y="5097780"/>
+            <a:ext cx="228600" cy="0"/>
           </a:xfrm>
           <a:prstGeom prst="line">
             <a:avLst/>
@@ -4393,16 +4522,17 @@
         </p:nvCxnSpPr>
         <p:spPr>
           <a:xfrm>
-            <a:off x="10561320" y="4983479"/>
-            <a:ext cx="0" cy="594361"/>
+            <a:off x="7543800" y="5097780"/>
+            <a:ext cx="228600" cy="0"/>
           </a:xfrm>
           <a:prstGeom prst="line">
             <a:avLst/>
           </a:prstGeom>
           <a:ln w="19050">
             <a:solidFill>
-              <a:srgbClr val="2F5597"/>
+              <a:srgbClr val="595959"/>
             </a:solidFill>
+            <a:tailEnd type="triangle" w="med" len="med"/>
           </a:ln>
         </p:spPr>
         <p:style>
@@ -4427,17 +4557,18 @@
           <p:nvPr/>
         </p:nvCxnSpPr>
         <p:spPr>
-          <a:xfrm flipH="1">
-            <a:off x="2926080" y="5577840"/>
-            <a:ext cx="7635240" cy="0"/>
+          <a:xfrm>
+            <a:off x="9601200" y="5097780"/>
+            <a:ext cx="228600" cy="0"/>
           </a:xfrm>
           <a:prstGeom prst="line">
             <a:avLst/>
           </a:prstGeom>
           <a:ln w="19050">
             <a:solidFill>
-              <a:srgbClr val="2F5597"/>
+              <a:srgbClr val="595959"/>
             </a:solidFill>
+            <a:tailEnd type="triangle" w="med" len="med"/>
           </a:ln>
         </p:spPr>
         <p:style>
@@ -4462,17 +4593,18 @@
           <p:nvPr/>
         </p:nvCxnSpPr>
         <p:spPr>
-          <a:xfrm flipV="1">
-            <a:off x="2926080" y="1668780"/>
-            <a:ext cx="0" cy="3909060"/>
+          <a:xfrm>
+            <a:off x="5006339" y="1874519"/>
+            <a:ext cx="0" cy="612649"/>
           </a:xfrm>
           <a:prstGeom prst="line">
             <a:avLst/>
           </a:prstGeom>
           <a:ln w="19050">
             <a:solidFill>
-              <a:srgbClr val="2F5597"/>
+              <a:srgbClr val="595959"/>
             </a:solidFill>
+            <a:tailEnd type="triangle" w="med" len="med"/>
           </a:ln>
         </p:spPr>
         <p:style>
@@ -4498,8 +4630,466 @@
         </p:nvCxnSpPr>
         <p:spPr>
           <a:xfrm>
-            <a:off x="2926080" y="1668780"/>
+            <a:off x="3383280" y="1874519"/>
+            <a:ext cx="0" cy="2743201"/>
+          </a:xfrm>
+          <a:prstGeom prst="line">
+            <a:avLst/>
+          </a:prstGeom>
+          <a:ln w="15875">
+            <a:solidFill>
+              <a:srgbClr val="548235"/>
+            </a:solidFill>
+            <a:tailEnd type="triangle" w="med" len="med"/>
+          </a:ln>
+        </p:spPr>
+        <p:style>
+          <a:lnRef idx="2">
+            <a:schemeClr val="accent1"/>
+          </a:lnRef>
+          <a:fillRef idx="0">
+            <a:schemeClr val="accent1"/>
+          </a:fillRef>
+          <a:effectRef idx="1">
+            <a:schemeClr val="accent1"/>
+          </a:effectRef>
+          <a:fontRef idx="minor">
+            <a:schemeClr val="tx1"/>
+          </a:fontRef>
+        </p:style>
+      </p:cxnSp>
+      <p:sp>
+        <p:nvSpPr>
+          <p:cNvPr id="32" name="TextBox 31"/>
+          <p:cNvSpPr txBox="1"/>
+          <p:nvPr/>
+        </p:nvSpPr>
+        <p:spPr>
+          <a:xfrm>
+            <a:off x="2980944" y="3108960"/>
+            <a:ext cx="457200" cy="182880"/>
+          </a:xfrm>
+          <a:prstGeom prst="rect">
+            <a:avLst/>
+          </a:prstGeom>
+          <a:noFill/>
+        </p:spPr>
+        <p:txBody>
+          <a:bodyPr wrap="square" lIns="18288" rIns="18288" tIns="0" bIns="0">
+            <a:spAutoFit/>
+          </a:bodyPr>
+          <a:lstStyle/>
+          <a:p>
+            <a:pPr algn="l"/>
+            <a:r>
+              <a:rPr sz="800" b="0" i="1">
+                <a:solidFill>
+                  <a:srgbClr val="385723"/>
+                </a:solidFill>
+                <a:latin typeface="Calibri"/>
+              </a:rPr>
+              <a:t>ρ(Xₖ)</a:t>
+            </a:r>
+          </a:p>
+        </p:txBody>
+      </p:sp>
+      <p:cxnSp>
+        <p:nvCxnSpPr>
+          <p:cNvPr id="33" name="Connector 32"/>
+          <p:cNvCxnSpPr/>
+          <p:nvPr/>
+        </p:nvCxnSpPr>
+        <p:spPr>
+          <a:xfrm>
+            <a:off x="10584180" y="3584448"/>
+            <a:ext cx="0" cy="850392"/>
+          </a:xfrm>
+          <a:prstGeom prst="line">
+            <a:avLst/>
+          </a:prstGeom>
+          <a:ln w="19050">
+            <a:solidFill>
+              <a:srgbClr val="595959"/>
+            </a:solidFill>
+          </a:ln>
+        </p:spPr>
+        <p:style>
+          <a:lnRef idx="2">
+            <a:schemeClr val="accent1"/>
+          </a:lnRef>
+          <a:fillRef idx="0">
+            <a:schemeClr val="accent1"/>
+          </a:fillRef>
+          <a:effectRef idx="1">
+            <a:schemeClr val="accent1"/>
+          </a:effectRef>
+          <a:fontRef idx="minor">
+            <a:schemeClr val="tx1"/>
+          </a:fontRef>
+        </p:style>
+      </p:cxnSp>
+      <p:cxnSp>
+        <p:nvCxnSpPr>
+          <p:cNvPr id="34" name="Connector 33"/>
+          <p:cNvCxnSpPr/>
+          <p:nvPr/>
+        </p:nvCxnSpPr>
+        <p:spPr>
+          <a:xfrm flipH="1">
+            <a:off x="6812280" y="4434840"/>
+            <a:ext cx="3771900" cy="0"/>
+          </a:xfrm>
+          <a:prstGeom prst="line">
+            <a:avLst/>
+          </a:prstGeom>
+          <a:ln w="19050">
+            <a:solidFill>
+              <a:srgbClr val="595959"/>
+            </a:solidFill>
+          </a:ln>
+        </p:spPr>
+        <p:style>
+          <a:lnRef idx="2">
+            <a:schemeClr val="accent1"/>
+          </a:lnRef>
+          <a:fillRef idx="0">
+            <a:schemeClr val="accent1"/>
+          </a:fillRef>
+          <a:effectRef idx="1">
+            <a:schemeClr val="accent1"/>
+          </a:effectRef>
+          <a:fontRef idx="minor">
+            <a:schemeClr val="tx1"/>
+          </a:fontRef>
+        </p:style>
+      </p:cxnSp>
+      <p:cxnSp>
+        <p:nvCxnSpPr>
+          <p:cNvPr id="35" name="Connector 34"/>
+          <p:cNvCxnSpPr/>
+          <p:nvPr/>
+        </p:nvCxnSpPr>
+        <p:spPr>
+          <a:xfrm>
+            <a:off x="6812280" y="4434840"/>
+            <a:ext cx="0" cy="182880"/>
+          </a:xfrm>
+          <a:prstGeom prst="line">
+            <a:avLst/>
+          </a:prstGeom>
+          <a:ln w="19050">
+            <a:solidFill>
+              <a:srgbClr val="595959"/>
+            </a:solidFill>
+            <a:tailEnd type="triangle" w="med" len="med"/>
+          </a:ln>
+        </p:spPr>
+        <p:style>
+          <a:lnRef idx="2">
+            <a:schemeClr val="accent1"/>
+          </a:lnRef>
+          <a:fillRef idx="0">
+            <a:schemeClr val="accent1"/>
+          </a:fillRef>
+          <a:effectRef idx="1">
+            <a:schemeClr val="accent1"/>
+          </a:effectRef>
+          <a:fontRef idx="minor">
+            <a:schemeClr val="tx1"/>
+          </a:fontRef>
+        </p:style>
+      </p:cxnSp>
+      <p:sp>
+        <p:nvSpPr>
+          <p:cNvPr id="36" name="TextBox 35"/>
+          <p:cNvSpPr txBox="1"/>
+          <p:nvPr/>
+        </p:nvSpPr>
+        <p:spPr>
+          <a:xfrm>
+            <a:off x="6885432" y="4425696"/>
+            <a:ext cx="548640" cy="182880"/>
+          </a:xfrm>
+          <a:prstGeom prst="rect">
+            <a:avLst/>
+          </a:prstGeom>
+          <a:noFill/>
+        </p:spPr>
+        <p:txBody>
+          <a:bodyPr wrap="square" lIns="18288" rIns="18288" tIns="0" bIns="0">
+            <a:spAutoFit/>
+          </a:bodyPr>
+          <a:lstStyle/>
+          <a:p>
+            <a:pPr algn="l"/>
+            <a:r>
+              <a:rPr sz="900" b="0" i="1">
+                <a:solidFill>
+                  <a:srgbClr val="843C0C"/>
+                </a:solidFill>
+                <a:latin typeface="Calibri"/>
+              </a:rPr>
+              <a:t>sᵥ</a:t>
+            </a:r>
+          </a:p>
+        </p:txBody>
+      </p:sp>
+      <p:cxnSp>
+        <p:nvCxnSpPr>
+          <p:cNvPr id="37" name="Connector 36"/>
+          <p:cNvCxnSpPr/>
+          <p:nvPr/>
+        </p:nvCxnSpPr>
+        <p:spPr>
+          <a:xfrm>
+            <a:off x="2377440" y="3451860"/>
+            <a:ext cx="228600" cy="0"/>
+          </a:xfrm>
+          <a:prstGeom prst="line">
+            <a:avLst/>
+          </a:prstGeom>
+          <a:ln w="19050">
+            <a:solidFill>
+              <a:srgbClr val="595959"/>
+            </a:solidFill>
+          </a:ln>
+        </p:spPr>
+        <p:style>
+          <a:lnRef idx="2">
+            <a:schemeClr val="accent1"/>
+          </a:lnRef>
+          <a:fillRef idx="0">
+            <a:schemeClr val="accent1"/>
+          </a:fillRef>
+          <a:effectRef idx="1">
+            <a:schemeClr val="accent1"/>
+          </a:effectRef>
+          <a:fontRef idx="minor">
+            <a:schemeClr val="tx1"/>
+          </a:fontRef>
+        </p:style>
+      </p:cxnSp>
+      <p:cxnSp>
+        <p:nvCxnSpPr>
+          <p:cNvPr id="38" name="Connector 37"/>
+          <p:cNvCxnSpPr/>
+          <p:nvPr/>
+        </p:nvCxnSpPr>
+        <p:spPr>
+          <a:xfrm flipV="1">
+            <a:off x="2606040" y="1211580"/>
+            <a:ext cx="0" cy="2240280"/>
+          </a:xfrm>
+          <a:prstGeom prst="line">
+            <a:avLst/>
+          </a:prstGeom>
+          <a:ln w="19050">
+            <a:solidFill>
+              <a:srgbClr val="595959"/>
+            </a:solidFill>
+          </a:ln>
+        </p:spPr>
+        <p:style>
+          <a:lnRef idx="2">
+            <a:schemeClr val="accent1"/>
+          </a:lnRef>
+          <a:fillRef idx="0">
+            <a:schemeClr val="accent1"/>
+          </a:fillRef>
+          <a:effectRef idx="1">
+            <a:schemeClr val="accent1"/>
+          </a:effectRef>
+          <a:fontRef idx="minor">
+            <a:schemeClr val="tx1"/>
+          </a:fontRef>
+        </p:style>
+      </p:cxnSp>
+      <p:cxnSp>
+        <p:nvCxnSpPr>
+          <p:cNvPr id="39" name="Connector 38"/>
+          <p:cNvCxnSpPr/>
+          <p:nvPr/>
+        </p:nvCxnSpPr>
+        <p:spPr>
+          <a:xfrm>
+            <a:off x="2606040" y="1211580"/>
+            <a:ext cx="594360" cy="0"/>
+          </a:xfrm>
+          <a:prstGeom prst="line">
+            <a:avLst/>
+          </a:prstGeom>
+          <a:ln w="19050">
+            <a:solidFill>
+              <a:srgbClr val="595959"/>
+            </a:solidFill>
+            <a:tailEnd type="triangle" w="med" len="med"/>
+          </a:ln>
+        </p:spPr>
+        <p:style>
+          <a:lnRef idx="2">
+            <a:schemeClr val="accent1"/>
+          </a:lnRef>
+          <a:fillRef idx="0">
+            <a:schemeClr val="accent1"/>
+          </a:fillRef>
+          <a:effectRef idx="1">
+            <a:schemeClr val="accent1"/>
+          </a:effectRef>
+          <a:fontRef idx="minor">
+            <a:schemeClr val="tx1"/>
+          </a:fontRef>
+        </p:style>
+      </p:cxnSp>
+      <p:cxnSp>
+        <p:nvCxnSpPr>
+          <p:cNvPr id="40" name="Connector 39"/>
+          <p:cNvCxnSpPr/>
+          <p:nvPr/>
+        </p:nvCxnSpPr>
+        <p:spPr>
+          <a:xfrm>
+            <a:off x="11658600" y="5097780"/>
             <a:ext cx="137160" cy="0"/>
+          </a:xfrm>
+          <a:prstGeom prst="line">
+            <a:avLst/>
+          </a:prstGeom>
+          <a:ln w="19050">
+            <a:solidFill>
+              <a:srgbClr val="2F5597"/>
+            </a:solidFill>
+          </a:ln>
+        </p:spPr>
+        <p:style>
+          <a:lnRef idx="2">
+            <a:schemeClr val="accent1"/>
+          </a:lnRef>
+          <a:fillRef idx="0">
+            <a:schemeClr val="accent1"/>
+          </a:fillRef>
+          <a:effectRef idx="1">
+            <a:schemeClr val="accent1"/>
+          </a:effectRef>
+          <a:fontRef idx="minor">
+            <a:schemeClr val="tx1"/>
+          </a:fontRef>
+        </p:style>
+      </p:cxnSp>
+      <p:cxnSp>
+        <p:nvCxnSpPr>
+          <p:cNvPr id="41" name="Connector 40"/>
+          <p:cNvCxnSpPr/>
+          <p:nvPr/>
+        </p:nvCxnSpPr>
+        <p:spPr>
+          <a:xfrm>
+            <a:off x="11795760" y="5097780"/>
+            <a:ext cx="0" cy="681228"/>
+          </a:xfrm>
+          <a:prstGeom prst="line">
+            <a:avLst/>
+          </a:prstGeom>
+          <a:ln w="19050">
+            <a:solidFill>
+              <a:srgbClr val="2F5597"/>
+            </a:solidFill>
+          </a:ln>
+        </p:spPr>
+        <p:style>
+          <a:lnRef idx="2">
+            <a:schemeClr val="accent1"/>
+          </a:lnRef>
+          <a:fillRef idx="0">
+            <a:schemeClr val="accent1"/>
+          </a:fillRef>
+          <a:effectRef idx="1">
+            <a:schemeClr val="accent1"/>
+          </a:effectRef>
+          <a:fontRef idx="minor">
+            <a:schemeClr val="tx1"/>
+          </a:fontRef>
+        </p:style>
+      </p:cxnSp>
+      <p:cxnSp>
+        <p:nvCxnSpPr>
+          <p:cNvPr id="42" name="Connector 41"/>
+          <p:cNvCxnSpPr/>
+          <p:nvPr/>
+        </p:nvCxnSpPr>
+        <p:spPr>
+          <a:xfrm flipH="1">
+            <a:off x="2971800" y="5779008"/>
+            <a:ext cx="8823960" cy="0"/>
+          </a:xfrm>
+          <a:prstGeom prst="line">
+            <a:avLst/>
+          </a:prstGeom>
+          <a:ln w="19050">
+            <a:solidFill>
+              <a:srgbClr val="2F5597"/>
+            </a:solidFill>
+          </a:ln>
+        </p:spPr>
+        <p:style>
+          <a:lnRef idx="2">
+            <a:schemeClr val="accent1"/>
+          </a:lnRef>
+          <a:fillRef idx="0">
+            <a:schemeClr val="accent1"/>
+          </a:fillRef>
+          <a:effectRef idx="1">
+            <a:schemeClr val="accent1"/>
+          </a:effectRef>
+          <a:fontRef idx="minor">
+            <a:schemeClr val="tx1"/>
+          </a:fontRef>
+        </p:style>
+      </p:cxnSp>
+      <p:cxnSp>
+        <p:nvCxnSpPr>
+          <p:cNvPr id="43" name="Connector 42"/>
+          <p:cNvCxnSpPr/>
+          <p:nvPr/>
+        </p:nvCxnSpPr>
+        <p:spPr>
+          <a:xfrm flipV="1">
+            <a:off x="2971800" y="1577339"/>
+            <a:ext cx="0" cy="4201669"/>
+          </a:xfrm>
+          <a:prstGeom prst="line">
+            <a:avLst/>
+          </a:prstGeom>
+          <a:ln w="19050">
+            <a:solidFill>
+              <a:srgbClr val="2F5597"/>
+            </a:solidFill>
+          </a:ln>
+        </p:spPr>
+        <p:style>
+          <a:lnRef idx="2">
+            <a:schemeClr val="accent1"/>
+          </a:lnRef>
+          <a:fillRef idx="0">
+            <a:schemeClr val="accent1"/>
+          </a:fillRef>
+          <a:effectRef idx="1">
+            <a:schemeClr val="accent1"/>
+          </a:effectRef>
+          <a:fontRef idx="minor">
+            <a:schemeClr val="tx1"/>
+          </a:fontRef>
+        </p:style>
+      </p:cxnSp>
+      <p:cxnSp>
+        <p:nvCxnSpPr>
+          <p:cNvPr id="44" name="Connector 43"/>
+          <p:cNvCxnSpPr/>
+          <p:nvPr/>
+        </p:nvCxnSpPr>
+        <p:spPr>
+          <a:xfrm>
+            <a:off x="2971800" y="1577339"/>
+            <a:ext cx="228600" cy="0"/>
           </a:xfrm>
           <a:prstGeom prst="line">
             <a:avLst/>
@@ -4528,14 +5118,14 @@
       </p:cxnSp>
       <p:sp>
         <p:nvSpPr>
-          <p:cNvPr id="32" name="TextBox 31"/>
+          <p:cNvPr id="45" name="TextBox 44"/>
           <p:cNvSpPr txBox="1"/>
           <p:nvPr/>
         </p:nvSpPr>
         <p:spPr>
           <a:xfrm>
-            <a:off x="5029200" y="5376672"/>
-            <a:ext cx="4114800" cy="182880"/>
+            <a:off x="5943600" y="5596128"/>
+            <a:ext cx="3200400" cy="182880"/>
           </a:xfrm>
           <a:prstGeom prst="rect">
             <a:avLst/>
@@ -4550,74 +5140,27 @@
           <a:p>
             <a:pPr algn="ctr"/>
             <a:r>
-              <a:rPr sz="1000" b="0" i="1">
+              <a:rPr sz="900" b="0" i="1">
                 <a:solidFill>
                   <a:srgbClr val="1F3864"/>
                 </a:solidFill>
                 <a:latin typeface="Calibri"/>
               </a:rPr>
-              <a:t>Xₖ₊₁ → next outer iteration (k ← k + 1)</a:t>
-            </a:r>
-          </a:p>
-        </p:txBody>
-      </p:sp>
-      <p:sp>
-        <p:nvSpPr>
-          <p:cNvPr id="33" name="TextBox 32"/>
-          <p:cNvSpPr txBox="1"/>
-          <p:nvPr/>
-        </p:nvSpPr>
-        <p:spPr>
-          <a:xfrm>
-            <a:off x="9646920" y="5074920"/>
-            <a:ext cx="2103120" cy="274320"/>
-          </a:xfrm>
-          <a:prstGeom prst="rect">
-            <a:avLst/>
-          </a:prstGeom>
-          <a:noFill/>
-        </p:spPr>
-        <p:txBody>
-          <a:bodyPr wrap="square" lIns="18288" rIns="18288" tIns="0" bIns="0">
-            <a:spAutoFit/>
-          </a:bodyPr>
-          <a:lstStyle/>
-          <a:p>
-            <a:pPr algn="ctr"/>
-            <a:r>
-              <a:rPr sz="900" b="0" i="1">
-                <a:solidFill>
-                  <a:srgbClr val="1F3864"/>
-                </a:solidFill>
-                <a:latin typeface="Calibri"/>
-              </a:rPr>
-              <a:t>n ≥ 1: several MBIR iterations</a:t>
-            </a:r>
-          </a:p>
-          <a:p>
-            <a:pPr algn="ctr"/>
-            <a:r>
-              <a:rPr sz="900" b="0" i="1">
-                <a:solidFill>
-                  <a:srgbClr val="1F3864"/>
-                </a:solidFill>
-                <a:latin typeface="Calibri"/>
-              </a:rPr>
-              <a:t>per scatter update</a:t>
-            </a:r>
-          </a:p>
-        </p:txBody>
-      </p:sp>
-      <p:sp>
-        <p:nvSpPr>
-          <p:cNvPr id="34" name="Rounded Rectangle 33"/>
+              <a:t>Xₖ₊₁ → next outer iteration</a:t>
+            </a:r>
+          </a:p>
+        </p:txBody>
+      </p:sp>
+      <p:sp>
+        <p:nvSpPr>
+          <p:cNvPr id="46" name="Rounded Rectangle 45"/>
           <p:cNvSpPr/>
           <p:nvPr/>
         </p:nvSpPr>
         <p:spPr>
           <a:xfrm>
-            <a:off x="9509760" y="6309360"/>
-            <a:ext cx="2103120" cy="457200"/>
+            <a:off x="9829800" y="6217920"/>
+            <a:ext cx="1828800" cy="502920"/>
           </a:xfrm>
           <a:prstGeom prst="roundRect">
             <a:avLst>
@@ -4654,35 +5197,48 @@
           <a:p>
             <a:pPr algn="ctr"/>
             <a:r>
-              <a:rPr sz="1100" b="1">
+              <a:rPr sz="1000" b="1">
                 <a:solidFill>
                   <a:srgbClr val="1F3864"/>
                 </a:solidFill>
                 <a:latin typeface="Calibri"/>
               </a:rPr>
-              <a:t>Scatter-corrected reconstruction</a:t>
+              <a:t>Scatter-corrected</a:t>
+            </a:r>
+          </a:p>
+          <a:p>
+            <a:pPr algn="ctr"/>
+            <a:r>
+              <a:rPr sz="1000" b="0">
+                <a:solidFill>
+                  <a:srgbClr val="1F3864"/>
+                </a:solidFill>
+                <a:latin typeface="Calibri"/>
+              </a:rPr>
+              <a:t>reconstruction</a:t>
             </a:r>
           </a:p>
         </p:txBody>
       </p:sp>
       <p:cxnSp>
         <p:nvCxnSpPr>
-          <p:cNvPr id="35" name="Connector 34"/>
+          <p:cNvPr id="47" name="Connector 46"/>
           <p:cNvCxnSpPr/>
           <p:nvPr/>
         </p:nvCxnSpPr>
         <p:spPr>
           <a:xfrm>
-            <a:off x="11612880" y="4480559"/>
-            <a:ext cx="137160" cy="0"/>
+            <a:off x="10744200" y="5577840"/>
+            <a:ext cx="0" cy="640080"/>
           </a:xfrm>
           <a:prstGeom prst="line">
             <a:avLst/>
           </a:prstGeom>
           <a:ln w="19050">
             <a:solidFill>
-              <a:srgbClr val="2F5597"/>
+              <a:srgbClr val="595959"/>
             </a:solidFill>
+            <a:tailEnd type="triangle" w="med" len="med"/>
           </a:ln>
         </p:spPr>
         <p:style>
@@ -4700,87 +5256,16 @@
           </a:fontRef>
         </p:style>
       </p:cxnSp>
-      <p:cxnSp>
-        <p:nvCxnSpPr>
-          <p:cNvPr id="36" name="Connector 35"/>
-          <p:cNvCxnSpPr/>
-          <p:nvPr/>
-        </p:nvCxnSpPr>
-        <p:spPr>
-          <a:xfrm>
-            <a:off x="11750040" y="4480559"/>
-            <a:ext cx="0" cy="2057401"/>
-          </a:xfrm>
-          <a:prstGeom prst="line">
-            <a:avLst/>
-          </a:prstGeom>
-          <a:ln w="19050">
-            <a:solidFill>
-              <a:srgbClr val="2F5597"/>
-            </a:solidFill>
-          </a:ln>
-        </p:spPr>
-        <p:style>
-          <a:lnRef idx="2">
-            <a:schemeClr val="accent1"/>
-          </a:lnRef>
-          <a:fillRef idx="0">
-            <a:schemeClr val="accent1"/>
-          </a:fillRef>
-          <a:effectRef idx="1">
-            <a:schemeClr val="accent1"/>
-          </a:effectRef>
-          <a:fontRef idx="minor">
-            <a:schemeClr val="tx1"/>
-          </a:fontRef>
-        </p:style>
-      </p:cxnSp>
-      <p:cxnSp>
-        <p:nvCxnSpPr>
-          <p:cNvPr id="37" name="Connector 36"/>
-          <p:cNvCxnSpPr/>
-          <p:nvPr/>
-        </p:nvCxnSpPr>
-        <p:spPr>
-          <a:xfrm flipH="1">
-            <a:off x="11612880" y="6537960"/>
-            <a:ext cx="137160" cy="0"/>
-          </a:xfrm>
-          <a:prstGeom prst="line">
-            <a:avLst/>
-          </a:prstGeom>
-          <a:ln w="19050">
-            <a:solidFill>
-              <a:srgbClr val="2F5597"/>
-            </a:solidFill>
-            <a:tailEnd type="triangle" w="med" len="med"/>
-          </a:ln>
-        </p:spPr>
-        <p:style>
-          <a:lnRef idx="2">
-            <a:schemeClr val="accent1"/>
-          </a:lnRef>
-          <a:fillRef idx="0">
-            <a:schemeClr val="accent1"/>
-          </a:fillRef>
-          <a:effectRef idx="1">
-            <a:schemeClr val="accent1"/>
-          </a:effectRef>
-          <a:fontRef idx="minor">
-            <a:schemeClr val="tx1"/>
-          </a:fontRef>
-        </p:style>
-      </p:cxnSp>
-      <p:sp>
-        <p:nvSpPr>
-          <p:cNvPr id="38" name="TextBox 37"/>
+      <p:sp>
+        <p:nvSpPr>
+          <p:cNvPr id="48" name="TextBox 47"/>
           <p:cNvSpPr txBox="1"/>
           <p:nvPr/>
         </p:nvSpPr>
         <p:spPr>
           <a:xfrm>
-            <a:off x="365760" y="6309360"/>
-            <a:ext cx="8778240" cy="457200"/>
+            <a:off x="320040" y="6172200"/>
+            <a:ext cx="8686800" cy="457200"/>
           </a:xfrm>
           <a:prstGeom prst="rect">
             <a:avLst/>
@@ -4801,7 +5286,7 @@
                 </a:solidFill>
                 <a:latin typeface="Calibri"/>
               </a:rPr>
-              <a:t>With X held fixed, N outer iterations reproduce N source iterations of the transport solver: the scatter estimate converges together with the reconstruction,</a:t>
+              <a:t>CITRUS: Coupled Iterative Tomographic reconstruction and Recursively-Updated Scatter.  With X held fixed, N outer iterations reproduce N source</a:t>
             </a:r>
           </a:p>
           <a:p>
@@ -4813,7 +5298,7 @@
                 </a:solidFill>
                 <a:latin typeface="Calibri"/>
               </a:rPr>
-              <a:t>for the cost of one sweep per view per outer iteration instead of a converged scatter solve for every new volume.</a:t>
+              <a:t>iterations of the transport solver, so the scatter estimate converges together with the reconstruction for one sweep per view per outer iteration.</a:t>
             </a:r>
           </a:p>
         </p:txBody>

</xml_diff>

<commit_message>
Docs: flowchart exported from Jordan's hand-edited slide; the script now only re-exports unless --rebuild is given and uses the slide's own aspect ratio; caption matches the figure
Co-Authored-By: Claude Fable 5.1 <noreply@anthropic.com>
</commit_message>
<xml_diff>
--- a/docs/figures/citrus_pipeline.pptx
+++ b/docs/figures/citrus_pipeline.pptx
@@ -5,9 +5,9 @@
     <p:sldMasterId id="2147483648" r:id="rId1"/>
   </p:sldMasterIdLst>
   <p:sldIdLst>
-    <p:sldId id="256" r:id="rId7"/>
+    <p:sldId id="256" r:id="rId2"/>
   </p:sldIdLst>
-  <p:sldSz cx="12191695" cy="6858000" type="screen4x3"/>
+  <p:sldSz cx="15849600" cy="5029200"/>
   <p:notesSz cx="6858000" cy="9144000"/>
   <p:defaultTextStyle>
     <a:defPPr>
@@ -104,6 +104,22 @@
       </a:defRPr>
     </a:lvl9pPr>
   </p:defaultTextStyle>
+  <p:extLst>
+    <p:ext uri="{EFAFB233-063F-42B5-8137-9DF3F51BA10A}">
+      <p15:sldGuideLst xmlns:p15="http://schemas.microsoft.com/office/powerpoint/2012/main">
+        <p15:guide id="1" orient="horz" pos="1584" userDrawn="1">
+          <p15:clr>
+            <a:srgbClr val="A4A3A4"/>
+          </p15:clr>
+        </p15:guide>
+        <p15:guide id="2" pos="3744" userDrawn="1">
+          <p15:clr>
+            <a:srgbClr val="A4A3A4"/>
+          </p15:clr>
+        </p15:guide>
+      </p15:sldGuideLst>
+    </p:ext>
+  </p:extLst>
 </p:presentation>
 </file>
 
@@ -136,8 +152,8 @@
         </p:nvSpPr>
         <p:spPr>
           <a:xfrm>
-            <a:off x="685800" y="2130425"/>
-            <a:ext cx="7772400" cy="1470025"/>
+            <a:off x="891540" y="1562312"/>
+            <a:ext cx="10104120" cy="1078018"/>
           </a:xfrm>
         </p:spPr>
         <p:txBody>
@@ -145,10 +161,9 @@
           <a:lstStyle/>
           <a:p>
             <a:r>
-              <a:rPr lang="en-US" smtClean="0"/>
+              <a:rPr lang="en-US"/>
               <a:t>Click to edit Master title style</a:t>
             </a:r>
-            <a:endParaRPr lang="en-US"/>
           </a:p>
         </p:txBody>
       </p:sp>
@@ -164,8 +179,8 @@
         </p:nvSpPr>
         <p:spPr>
           <a:xfrm>
-            <a:off x="1371600" y="3886200"/>
-            <a:ext cx="6400800" cy="1752600"/>
+            <a:off x="1783080" y="2849880"/>
+            <a:ext cx="8321040" cy="1285240"/>
           </a:xfrm>
         </p:spPr>
         <p:txBody>
@@ -181,7 +196,7 @@
                 </a:solidFill>
               </a:defRPr>
             </a:lvl1pPr>
-            <a:lvl2pPr marL="457200" indent="0" algn="ctr">
+            <a:lvl2pPr marL="335228" indent="0" algn="ctr">
               <a:buNone/>
               <a:defRPr>
                 <a:solidFill>
@@ -191,7 +206,7 @@
                 </a:solidFill>
               </a:defRPr>
             </a:lvl2pPr>
-            <a:lvl3pPr marL="914400" indent="0" algn="ctr">
+            <a:lvl3pPr marL="670454" indent="0" algn="ctr">
               <a:buNone/>
               <a:defRPr>
                 <a:solidFill>
@@ -201,7 +216,7 @@
                 </a:solidFill>
               </a:defRPr>
             </a:lvl3pPr>
-            <a:lvl4pPr marL="1371600" indent="0" algn="ctr">
+            <a:lvl4pPr marL="1005681" indent="0" algn="ctr">
               <a:buNone/>
               <a:defRPr>
                 <a:solidFill>
@@ -211,7 +226,7 @@
                 </a:solidFill>
               </a:defRPr>
             </a:lvl4pPr>
-            <a:lvl5pPr marL="1828800" indent="0" algn="ctr">
+            <a:lvl5pPr marL="1340909" indent="0" algn="ctr">
               <a:buNone/>
               <a:defRPr>
                 <a:solidFill>
@@ -221,7 +236,7 @@
                 </a:solidFill>
               </a:defRPr>
             </a:lvl5pPr>
-            <a:lvl6pPr marL="2286000" indent="0" algn="ctr">
+            <a:lvl6pPr marL="1676136" indent="0" algn="ctr">
               <a:buNone/>
               <a:defRPr>
                 <a:solidFill>
@@ -231,7 +246,7 @@
                 </a:solidFill>
               </a:defRPr>
             </a:lvl6pPr>
-            <a:lvl7pPr marL="2743200" indent="0" algn="ctr">
+            <a:lvl7pPr marL="2011363" indent="0" algn="ctr">
               <a:buNone/>
               <a:defRPr>
                 <a:solidFill>
@@ -241,7 +256,7 @@
                 </a:solidFill>
               </a:defRPr>
             </a:lvl7pPr>
-            <a:lvl8pPr marL="3200400" indent="0" algn="ctr">
+            <a:lvl8pPr marL="2346590" indent="0" algn="ctr">
               <a:buNone/>
               <a:defRPr>
                 <a:solidFill>
@@ -251,7 +266,7 @@
                 </a:solidFill>
               </a:defRPr>
             </a:lvl8pPr>
-            <a:lvl9pPr marL="3657600" indent="0" algn="ctr">
+            <a:lvl9pPr marL="2681817" indent="0" algn="ctr">
               <a:buNone/>
               <a:defRPr>
                 <a:solidFill>
@@ -264,10 +279,9 @@
           </a:lstStyle>
           <a:p>
             <a:r>
-              <a:rPr lang="en-US" smtClean="0"/>
+              <a:rPr lang="en-US"/>
               <a:t>Click to edit Master subtitle style</a:t>
             </a:r>
-            <a:endParaRPr lang="en-US"/>
           </a:p>
         </p:txBody>
       </p:sp>
@@ -288,7 +302,7 @@
           <a:p>
             <a:fld id="{5BCAD085-E8A6-8845-BD4E-CB4CCA059FC4}" type="datetimeFigureOut">
               <a:rPr lang="en-US" smtClean="0"/>
-              <a:t>1/27/13</a:t>
+              <a:t>10/17/2026</a:t>
             </a:fld>
             <a:endParaRPr lang="en-US"/>
           </a:p>
@@ -382,10 +396,9 @@
           <a:lstStyle/>
           <a:p>
             <a:r>
-              <a:rPr lang="en-US" smtClean="0"/>
+              <a:rPr lang="en-US"/>
               <a:t>Click to edit Master title style</a:t>
             </a:r>
-            <a:endParaRPr lang="en-US"/>
           </a:p>
         </p:txBody>
       </p:sp>
@@ -406,38 +419,37 @@
           <a:p>
             <a:pPr lvl="0"/>
             <a:r>
-              <a:rPr lang="en-US" smtClean="0"/>
+              <a:rPr lang="en-US"/>
               <a:t>Click to edit Master text styles</a:t>
             </a:r>
           </a:p>
           <a:p>
             <a:pPr lvl="1"/>
             <a:r>
-              <a:rPr lang="en-US" smtClean="0"/>
+              <a:rPr lang="en-US"/>
               <a:t>Second level</a:t>
             </a:r>
           </a:p>
           <a:p>
             <a:pPr lvl="2"/>
             <a:r>
-              <a:rPr lang="en-US" smtClean="0"/>
+              <a:rPr lang="en-US"/>
               <a:t>Third level</a:t>
             </a:r>
           </a:p>
           <a:p>
             <a:pPr lvl="3"/>
             <a:r>
-              <a:rPr lang="en-US" smtClean="0"/>
+              <a:rPr lang="en-US"/>
               <a:t>Fourth level</a:t>
             </a:r>
           </a:p>
           <a:p>
             <a:pPr lvl="4"/>
             <a:r>
-              <a:rPr lang="en-US" smtClean="0"/>
+              <a:rPr lang="en-US"/>
               <a:t>Fifth level</a:t>
             </a:r>
-            <a:endParaRPr lang="en-US"/>
           </a:p>
         </p:txBody>
       </p:sp>
@@ -458,7 +470,7 @@
           <a:p>
             <a:fld id="{5BCAD085-E8A6-8845-BD4E-CB4CCA059FC4}" type="datetimeFigureOut">
               <a:rPr lang="en-US" smtClean="0"/>
-              <a:t>1/27/13</a:t>
+              <a:t>10/17/2026</a:t>
             </a:fld>
             <a:endParaRPr lang="en-US"/>
           </a:p>
@@ -548,8 +560,8 @@
         </p:nvSpPr>
         <p:spPr>
           <a:xfrm>
-            <a:off x="6629400" y="274638"/>
-            <a:ext cx="2057400" cy="5851525"/>
+            <a:off x="8618220" y="201402"/>
+            <a:ext cx="2674620" cy="4291118"/>
           </a:xfrm>
         </p:spPr>
         <p:txBody>
@@ -557,10 +569,9 @@
           <a:lstStyle/>
           <a:p>
             <a:r>
-              <a:rPr lang="en-US" smtClean="0"/>
+              <a:rPr lang="en-US"/>
               <a:t>Click to edit Master title style</a:t>
             </a:r>
-            <a:endParaRPr lang="en-US"/>
           </a:p>
         </p:txBody>
       </p:sp>
@@ -576,8 +587,8 @@
         </p:nvSpPr>
         <p:spPr>
           <a:xfrm>
-            <a:off x="457200" y="274638"/>
-            <a:ext cx="6019800" cy="5851525"/>
+            <a:off x="594360" y="201402"/>
+            <a:ext cx="7825740" cy="4291118"/>
           </a:xfrm>
         </p:spPr>
         <p:txBody>
@@ -586,38 +597,37 @@
           <a:p>
             <a:pPr lvl="0"/>
             <a:r>
-              <a:rPr lang="en-US" smtClean="0"/>
+              <a:rPr lang="en-US"/>
               <a:t>Click to edit Master text styles</a:t>
             </a:r>
           </a:p>
           <a:p>
             <a:pPr lvl="1"/>
             <a:r>
-              <a:rPr lang="en-US" smtClean="0"/>
+              <a:rPr lang="en-US"/>
               <a:t>Second level</a:t>
             </a:r>
           </a:p>
           <a:p>
             <a:pPr lvl="2"/>
             <a:r>
-              <a:rPr lang="en-US" smtClean="0"/>
+              <a:rPr lang="en-US"/>
               <a:t>Third level</a:t>
             </a:r>
           </a:p>
           <a:p>
             <a:pPr lvl="3"/>
             <a:r>
-              <a:rPr lang="en-US" smtClean="0"/>
+              <a:rPr lang="en-US"/>
               <a:t>Fourth level</a:t>
             </a:r>
           </a:p>
           <a:p>
             <a:pPr lvl="4"/>
             <a:r>
-              <a:rPr lang="en-US" smtClean="0"/>
+              <a:rPr lang="en-US"/>
               <a:t>Fifth level</a:t>
             </a:r>
-            <a:endParaRPr lang="en-US"/>
           </a:p>
         </p:txBody>
       </p:sp>
@@ -638,7 +648,7 @@
           <a:p>
             <a:fld id="{5BCAD085-E8A6-8845-BD4E-CB4CCA059FC4}" type="datetimeFigureOut">
               <a:rPr lang="en-US" smtClean="0"/>
-              <a:t>1/27/13</a:t>
+              <a:t>10/17/2026</a:t>
             </a:fld>
             <a:endParaRPr lang="en-US"/>
           </a:p>
@@ -732,10 +742,9 @@
           <a:lstStyle/>
           <a:p>
             <a:r>
-              <a:rPr lang="en-US" smtClean="0"/>
+              <a:rPr lang="en-US"/>
               <a:t>Click to edit Master title style</a:t>
             </a:r>
-            <a:endParaRPr lang="en-US"/>
           </a:p>
         </p:txBody>
       </p:sp>
@@ -756,38 +765,37 @@
           <a:p>
             <a:pPr lvl="0"/>
             <a:r>
-              <a:rPr lang="en-US" smtClean="0"/>
+              <a:rPr lang="en-US"/>
               <a:t>Click to edit Master text styles</a:t>
             </a:r>
           </a:p>
           <a:p>
             <a:pPr lvl="1"/>
             <a:r>
-              <a:rPr lang="en-US" smtClean="0"/>
+              <a:rPr lang="en-US"/>
               <a:t>Second level</a:t>
             </a:r>
           </a:p>
           <a:p>
             <a:pPr lvl="2"/>
             <a:r>
-              <a:rPr lang="en-US" smtClean="0"/>
+              <a:rPr lang="en-US"/>
               <a:t>Third level</a:t>
             </a:r>
           </a:p>
           <a:p>
             <a:pPr lvl="3"/>
             <a:r>
-              <a:rPr lang="en-US" smtClean="0"/>
+              <a:rPr lang="en-US"/>
               <a:t>Fourth level</a:t>
             </a:r>
           </a:p>
           <a:p>
             <a:pPr lvl="4"/>
             <a:r>
-              <a:rPr lang="en-US" smtClean="0"/>
+              <a:rPr lang="en-US"/>
               <a:t>Fifth level</a:t>
             </a:r>
-            <a:endParaRPr lang="en-US"/>
           </a:p>
         </p:txBody>
       </p:sp>
@@ -808,7 +816,7 @@
           <a:p>
             <a:fld id="{5BCAD085-E8A6-8845-BD4E-CB4CCA059FC4}" type="datetimeFigureOut">
               <a:rPr lang="en-US" smtClean="0"/>
-              <a:t>1/27/13</a:t>
+              <a:t>10/17/2026</a:t>
             </a:fld>
             <a:endParaRPr lang="en-US"/>
           </a:p>
@@ -898,23 +906,22 @@
         </p:nvSpPr>
         <p:spPr>
           <a:xfrm>
-            <a:off x="722313" y="4406900"/>
-            <a:ext cx="7772400" cy="1362075"/>
+            <a:off x="939007" y="3231729"/>
+            <a:ext cx="10104120" cy="998855"/>
           </a:xfrm>
         </p:spPr>
         <p:txBody>
           <a:bodyPr anchor="t"/>
           <a:lstStyle>
             <a:lvl1pPr algn="l">
-              <a:defRPr sz="4000" b="1" cap="all"/>
+              <a:defRPr sz="2932" b="1" cap="all"/>
             </a:lvl1pPr>
           </a:lstStyle>
           <a:p>
             <a:r>
-              <a:rPr lang="en-US" smtClean="0"/>
+              <a:rPr lang="en-US"/>
               <a:t>Click to edit Master title style</a:t>
             </a:r>
-            <a:endParaRPr lang="en-US"/>
           </a:p>
         </p:txBody>
       </p:sp>
@@ -930,8 +937,8 @@
         </p:nvSpPr>
         <p:spPr>
           <a:xfrm>
-            <a:off x="722313" y="2906713"/>
-            <a:ext cx="7772400" cy="1500187"/>
+            <a:off x="939007" y="2131592"/>
+            <a:ext cx="10104120" cy="1100137"/>
           </a:xfrm>
         </p:spPr>
         <p:txBody>
@@ -939,7 +946,7 @@
           <a:lstStyle>
             <a:lvl1pPr marL="0" indent="0">
               <a:buNone/>
-              <a:defRPr sz="2000">
+              <a:defRPr sz="1467">
                 <a:solidFill>
                   <a:schemeClr val="tx1">
                     <a:tint val="75000"/>
@@ -947,9 +954,9 @@
                 </a:solidFill>
               </a:defRPr>
             </a:lvl1pPr>
-            <a:lvl2pPr marL="457200" indent="0">
-              <a:buNone/>
-              <a:defRPr sz="1800">
+            <a:lvl2pPr marL="335228" indent="0">
+              <a:buNone/>
+              <a:defRPr sz="1320">
                 <a:solidFill>
                   <a:schemeClr val="tx1">
                     <a:tint val="75000"/>
@@ -957,9 +964,9 @@
                 </a:solidFill>
               </a:defRPr>
             </a:lvl2pPr>
-            <a:lvl3pPr marL="914400" indent="0">
-              <a:buNone/>
-              <a:defRPr sz="1600">
+            <a:lvl3pPr marL="670454" indent="0">
+              <a:buNone/>
+              <a:defRPr sz="1173">
                 <a:solidFill>
                   <a:schemeClr val="tx1">
                     <a:tint val="75000"/>
@@ -967,9 +974,9 @@
                 </a:solidFill>
               </a:defRPr>
             </a:lvl3pPr>
-            <a:lvl4pPr marL="1371600" indent="0">
-              <a:buNone/>
-              <a:defRPr sz="1400">
+            <a:lvl4pPr marL="1005681" indent="0">
+              <a:buNone/>
+              <a:defRPr sz="1027">
                 <a:solidFill>
                   <a:schemeClr val="tx1">
                     <a:tint val="75000"/>
@@ -977,9 +984,9 @@
                 </a:solidFill>
               </a:defRPr>
             </a:lvl4pPr>
-            <a:lvl5pPr marL="1828800" indent="0">
-              <a:buNone/>
-              <a:defRPr sz="1400">
+            <a:lvl5pPr marL="1340909" indent="0">
+              <a:buNone/>
+              <a:defRPr sz="1027">
                 <a:solidFill>
                   <a:schemeClr val="tx1">
                     <a:tint val="75000"/>
@@ -987,9 +994,9 @@
                 </a:solidFill>
               </a:defRPr>
             </a:lvl5pPr>
-            <a:lvl6pPr marL="2286000" indent="0">
-              <a:buNone/>
-              <a:defRPr sz="1400">
+            <a:lvl6pPr marL="1676136" indent="0">
+              <a:buNone/>
+              <a:defRPr sz="1027">
                 <a:solidFill>
                   <a:schemeClr val="tx1">
                     <a:tint val="75000"/>
@@ -997,9 +1004,9 @@
                 </a:solidFill>
               </a:defRPr>
             </a:lvl6pPr>
-            <a:lvl7pPr marL="2743200" indent="0">
-              <a:buNone/>
-              <a:defRPr sz="1400">
+            <a:lvl7pPr marL="2011363" indent="0">
+              <a:buNone/>
+              <a:defRPr sz="1027">
                 <a:solidFill>
                   <a:schemeClr val="tx1">
                     <a:tint val="75000"/>
@@ -1007,9 +1014,9 @@
                 </a:solidFill>
               </a:defRPr>
             </a:lvl7pPr>
-            <a:lvl8pPr marL="3200400" indent="0">
-              <a:buNone/>
-              <a:defRPr sz="1400">
+            <a:lvl8pPr marL="2346590" indent="0">
+              <a:buNone/>
+              <a:defRPr sz="1027">
                 <a:solidFill>
                   <a:schemeClr val="tx1">
                     <a:tint val="75000"/>
@@ -1017,9 +1024,9 @@
                 </a:solidFill>
               </a:defRPr>
             </a:lvl8pPr>
-            <a:lvl9pPr marL="3657600" indent="0">
-              <a:buNone/>
-              <a:defRPr sz="1400">
+            <a:lvl9pPr marL="2681817" indent="0">
+              <a:buNone/>
+              <a:defRPr sz="1027">
                 <a:solidFill>
                   <a:schemeClr val="tx1">
                     <a:tint val="75000"/>
@@ -1031,7 +1038,7 @@
           <a:p>
             <a:pPr lvl="0"/>
             <a:r>
-              <a:rPr lang="en-US" smtClean="0"/>
+              <a:rPr lang="en-US"/>
               <a:t>Click to edit Master text styles</a:t>
             </a:r>
           </a:p>
@@ -1054,7 +1061,7 @@
           <a:p>
             <a:fld id="{5BCAD085-E8A6-8845-BD4E-CB4CCA059FC4}" type="datetimeFigureOut">
               <a:rPr lang="en-US" smtClean="0"/>
-              <a:t>1/27/13</a:t>
+              <a:t>10/17/2026</a:t>
             </a:fld>
             <a:endParaRPr lang="en-US"/>
           </a:p>
@@ -1148,10 +1155,9 @@
           <a:lstStyle/>
           <a:p>
             <a:r>
-              <a:rPr lang="en-US" smtClean="0"/>
+              <a:rPr lang="en-US"/>
               <a:t>Click to edit Master title style</a:t>
             </a:r>
-            <a:endParaRPr lang="en-US"/>
           </a:p>
         </p:txBody>
       </p:sp>
@@ -1167,76 +1173,75 @@
         </p:nvSpPr>
         <p:spPr>
           <a:xfrm>
-            <a:off x="457200" y="1600200"/>
-            <a:ext cx="4038600" cy="4525963"/>
+            <a:off x="594360" y="1173480"/>
+            <a:ext cx="5250180" cy="3319040"/>
           </a:xfrm>
         </p:spPr>
         <p:txBody>
           <a:bodyPr/>
           <a:lstStyle>
             <a:lvl1pPr>
-              <a:defRPr sz="2800"/>
+              <a:defRPr sz="2053"/>
             </a:lvl1pPr>
             <a:lvl2pPr>
-              <a:defRPr sz="2400"/>
+              <a:defRPr sz="1760"/>
             </a:lvl2pPr>
             <a:lvl3pPr>
-              <a:defRPr sz="2000"/>
+              <a:defRPr sz="1467"/>
             </a:lvl3pPr>
             <a:lvl4pPr>
-              <a:defRPr sz="1800"/>
+              <a:defRPr sz="1320"/>
             </a:lvl4pPr>
             <a:lvl5pPr>
-              <a:defRPr sz="1800"/>
+              <a:defRPr sz="1320"/>
             </a:lvl5pPr>
             <a:lvl6pPr>
-              <a:defRPr sz="1800"/>
+              <a:defRPr sz="1320"/>
             </a:lvl6pPr>
             <a:lvl7pPr>
-              <a:defRPr sz="1800"/>
+              <a:defRPr sz="1320"/>
             </a:lvl7pPr>
             <a:lvl8pPr>
-              <a:defRPr sz="1800"/>
+              <a:defRPr sz="1320"/>
             </a:lvl8pPr>
             <a:lvl9pPr>
-              <a:defRPr sz="1800"/>
+              <a:defRPr sz="1320"/>
             </a:lvl9pPr>
           </a:lstStyle>
           <a:p>
             <a:pPr lvl="0"/>
             <a:r>
-              <a:rPr lang="en-US" smtClean="0"/>
+              <a:rPr lang="en-US"/>
               <a:t>Click to edit Master text styles</a:t>
             </a:r>
           </a:p>
           <a:p>
             <a:pPr lvl="1"/>
             <a:r>
-              <a:rPr lang="en-US" smtClean="0"/>
+              <a:rPr lang="en-US"/>
               <a:t>Second level</a:t>
             </a:r>
           </a:p>
           <a:p>
             <a:pPr lvl="2"/>
             <a:r>
-              <a:rPr lang="en-US" smtClean="0"/>
+              <a:rPr lang="en-US"/>
               <a:t>Third level</a:t>
             </a:r>
           </a:p>
           <a:p>
             <a:pPr lvl="3"/>
             <a:r>
-              <a:rPr lang="en-US" smtClean="0"/>
+              <a:rPr lang="en-US"/>
               <a:t>Fourth level</a:t>
             </a:r>
           </a:p>
           <a:p>
             <a:pPr lvl="4"/>
             <a:r>
-              <a:rPr lang="en-US" smtClean="0"/>
+              <a:rPr lang="en-US"/>
               <a:t>Fifth level</a:t>
             </a:r>
-            <a:endParaRPr lang="en-US"/>
           </a:p>
         </p:txBody>
       </p:sp>
@@ -1252,76 +1257,75 @@
         </p:nvSpPr>
         <p:spPr>
           <a:xfrm>
-            <a:off x="4648200" y="1600200"/>
-            <a:ext cx="4038600" cy="4525963"/>
+            <a:off x="6042660" y="1173480"/>
+            <a:ext cx="5250180" cy="3319040"/>
           </a:xfrm>
         </p:spPr>
         <p:txBody>
           <a:bodyPr/>
           <a:lstStyle>
             <a:lvl1pPr>
-              <a:defRPr sz="2800"/>
+              <a:defRPr sz="2053"/>
             </a:lvl1pPr>
             <a:lvl2pPr>
-              <a:defRPr sz="2400"/>
+              <a:defRPr sz="1760"/>
             </a:lvl2pPr>
             <a:lvl3pPr>
-              <a:defRPr sz="2000"/>
+              <a:defRPr sz="1467"/>
             </a:lvl3pPr>
             <a:lvl4pPr>
-              <a:defRPr sz="1800"/>
+              <a:defRPr sz="1320"/>
             </a:lvl4pPr>
             <a:lvl5pPr>
-              <a:defRPr sz="1800"/>
+              <a:defRPr sz="1320"/>
             </a:lvl5pPr>
             <a:lvl6pPr>
-              <a:defRPr sz="1800"/>
+              <a:defRPr sz="1320"/>
             </a:lvl6pPr>
             <a:lvl7pPr>
-              <a:defRPr sz="1800"/>
+              <a:defRPr sz="1320"/>
             </a:lvl7pPr>
             <a:lvl8pPr>
-              <a:defRPr sz="1800"/>
+              <a:defRPr sz="1320"/>
             </a:lvl8pPr>
             <a:lvl9pPr>
-              <a:defRPr sz="1800"/>
+              <a:defRPr sz="1320"/>
             </a:lvl9pPr>
           </a:lstStyle>
           <a:p>
             <a:pPr lvl="0"/>
             <a:r>
-              <a:rPr lang="en-US" smtClean="0"/>
+              <a:rPr lang="en-US"/>
               <a:t>Click to edit Master text styles</a:t>
             </a:r>
           </a:p>
           <a:p>
             <a:pPr lvl="1"/>
             <a:r>
-              <a:rPr lang="en-US" smtClean="0"/>
+              <a:rPr lang="en-US"/>
               <a:t>Second level</a:t>
             </a:r>
           </a:p>
           <a:p>
             <a:pPr lvl="2"/>
             <a:r>
-              <a:rPr lang="en-US" smtClean="0"/>
+              <a:rPr lang="en-US"/>
               <a:t>Third level</a:t>
             </a:r>
           </a:p>
           <a:p>
             <a:pPr lvl="3"/>
             <a:r>
-              <a:rPr lang="en-US" smtClean="0"/>
+              <a:rPr lang="en-US"/>
               <a:t>Fourth level</a:t>
             </a:r>
           </a:p>
           <a:p>
             <a:pPr lvl="4"/>
             <a:r>
-              <a:rPr lang="en-US" smtClean="0"/>
+              <a:rPr lang="en-US"/>
               <a:t>Fifth level</a:t>
             </a:r>
-            <a:endParaRPr lang="en-US"/>
           </a:p>
         </p:txBody>
       </p:sp>
@@ -1342,7 +1346,7 @@
           <a:p>
             <a:fld id="{5BCAD085-E8A6-8845-BD4E-CB4CCA059FC4}" type="datetimeFigureOut">
               <a:rPr lang="en-US" smtClean="0"/>
-              <a:t>1/27/13</a:t>
+              <a:t>10/17/2026</a:t>
             </a:fld>
             <a:endParaRPr lang="en-US"/>
           </a:p>
@@ -1440,10 +1444,9 @@
           </a:lstStyle>
           <a:p>
             <a:r>
-              <a:rPr lang="en-US" smtClean="0"/>
+              <a:rPr lang="en-US"/>
               <a:t>Click to edit Master title style</a:t>
             </a:r>
-            <a:endParaRPr lang="en-US"/>
           </a:p>
         </p:txBody>
       </p:sp>
@@ -1459,8 +1462,8 @@
         </p:nvSpPr>
         <p:spPr>
           <a:xfrm>
-            <a:off x="457200" y="1535113"/>
-            <a:ext cx="4040188" cy="639762"/>
+            <a:off x="594360" y="1125749"/>
+            <a:ext cx="5252244" cy="469159"/>
           </a:xfrm>
         </p:spPr>
         <p:txBody>
@@ -1468,45 +1471,45 @@
           <a:lstStyle>
             <a:lvl1pPr marL="0" indent="0">
               <a:buNone/>
-              <a:defRPr sz="2400" b="1"/>
+              <a:defRPr sz="1760" b="1"/>
             </a:lvl1pPr>
-            <a:lvl2pPr marL="457200" indent="0">
-              <a:buNone/>
-              <a:defRPr sz="2000" b="1"/>
+            <a:lvl2pPr marL="335228" indent="0">
+              <a:buNone/>
+              <a:defRPr sz="1467" b="1"/>
             </a:lvl2pPr>
-            <a:lvl3pPr marL="914400" indent="0">
-              <a:buNone/>
-              <a:defRPr sz="1800" b="1"/>
+            <a:lvl3pPr marL="670454" indent="0">
+              <a:buNone/>
+              <a:defRPr sz="1320" b="1"/>
             </a:lvl3pPr>
-            <a:lvl4pPr marL="1371600" indent="0">
-              <a:buNone/>
-              <a:defRPr sz="1600" b="1"/>
+            <a:lvl4pPr marL="1005681" indent="0">
+              <a:buNone/>
+              <a:defRPr sz="1173" b="1"/>
             </a:lvl4pPr>
-            <a:lvl5pPr marL="1828800" indent="0">
-              <a:buNone/>
-              <a:defRPr sz="1600" b="1"/>
+            <a:lvl5pPr marL="1340909" indent="0">
+              <a:buNone/>
+              <a:defRPr sz="1173" b="1"/>
             </a:lvl5pPr>
-            <a:lvl6pPr marL="2286000" indent="0">
-              <a:buNone/>
-              <a:defRPr sz="1600" b="1"/>
+            <a:lvl6pPr marL="1676136" indent="0">
+              <a:buNone/>
+              <a:defRPr sz="1173" b="1"/>
             </a:lvl6pPr>
-            <a:lvl7pPr marL="2743200" indent="0">
-              <a:buNone/>
-              <a:defRPr sz="1600" b="1"/>
+            <a:lvl7pPr marL="2011363" indent="0">
+              <a:buNone/>
+              <a:defRPr sz="1173" b="1"/>
             </a:lvl7pPr>
-            <a:lvl8pPr marL="3200400" indent="0">
-              <a:buNone/>
-              <a:defRPr sz="1600" b="1"/>
+            <a:lvl8pPr marL="2346590" indent="0">
+              <a:buNone/>
+              <a:defRPr sz="1173" b="1"/>
             </a:lvl8pPr>
-            <a:lvl9pPr marL="3657600" indent="0">
-              <a:buNone/>
-              <a:defRPr sz="1600" b="1"/>
+            <a:lvl9pPr marL="2681817" indent="0">
+              <a:buNone/>
+              <a:defRPr sz="1173" b="1"/>
             </a:lvl9pPr>
           </a:lstStyle>
           <a:p>
             <a:pPr lvl="0"/>
             <a:r>
-              <a:rPr lang="en-US" smtClean="0"/>
+              <a:rPr lang="en-US"/>
               <a:t>Click to edit Master text styles</a:t>
             </a:r>
           </a:p>
@@ -1524,76 +1527,75 @@
         </p:nvSpPr>
         <p:spPr>
           <a:xfrm>
-            <a:off x="457200" y="2174875"/>
-            <a:ext cx="4040188" cy="3951288"/>
+            <a:off x="594360" y="1594908"/>
+            <a:ext cx="5252244" cy="2897611"/>
           </a:xfrm>
         </p:spPr>
         <p:txBody>
           <a:bodyPr/>
           <a:lstStyle>
             <a:lvl1pPr>
-              <a:defRPr sz="2400"/>
+              <a:defRPr sz="1760"/>
             </a:lvl1pPr>
             <a:lvl2pPr>
-              <a:defRPr sz="2000"/>
+              <a:defRPr sz="1467"/>
             </a:lvl2pPr>
             <a:lvl3pPr>
-              <a:defRPr sz="1800"/>
+              <a:defRPr sz="1320"/>
             </a:lvl3pPr>
             <a:lvl4pPr>
-              <a:defRPr sz="1600"/>
+              <a:defRPr sz="1173"/>
             </a:lvl4pPr>
             <a:lvl5pPr>
-              <a:defRPr sz="1600"/>
+              <a:defRPr sz="1173"/>
             </a:lvl5pPr>
             <a:lvl6pPr>
-              <a:defRPr sz="1600"/>
+              <a:defRPr sz="1173"/>
             </a:lvl6pPr>
             <a:lvl7pPr>
-              <a:defRPr sz="1600"/>
+              <a:defRPr sz="1173"/>
             </a:lvl7pPr>
             <a:lvl8pPr>
-              <a:defRPr sz="1600"/>
+              <a:defRPr sz="1173"/>
             </a:lvl8pPr>
             <a:lvl9pPr>
-              <a:defRPr sz="1600"/>
+              <a:defRPr sz="1173"/>
             </a:lvl9pPr>
           </a:lstStyle>
           <a:p>
             <a:pPr lvl="0"/>
             <a:r>
-              <a:rPr lang="en-US" smtClean="0"/>
+              <a:rPr lang="en-US"/>
               <a:t>Click to edit Master text styles</a:t>
             </a:r>
           </a:p>
           <a:p>
             <a:pPr lvl="1"/>
             <a:r>
-              <a:rPr lang="en-US" smtClean="0"/>
+              <a:rPr lang="en-US"/>
               <a:t>Second level</a:t>
             </a:r>
           </a:p>
           <a:p>
             <a:pPr lvl="2"/>
             <a:r>
-              <a:rPr lang="en-US" smtClean="0"/>
+              <a:rPr lang="en-US"/>
               <a:t>Third level</a:t>
             </a:r>
           </a:p>
           <a:p>
             <a:pPr lvl="3"/>
             <a:r>
-              <a:rPr lang="en-US" smtClean="0"/>
+              <a:rPr lang="en-US"/>
               <a:t>Fourth level</a:t>
             </a:r>
           </a:p>
           <a:p>
             <a:pPr lvl="4"/>
             <a:r>
-              <a:rPr lang="en-US" smtClean="0"/>
+              <a:rPr lang="en-US"/>
               <a:t>Fifth level</a:t>
             </a:r>
-            <a:endParaRPr lang="en-US"/>
           </a:p>
         </p:txBody>
       </p:sp>
@@ -1609,8 +1611,8 @@
         </p:nvSpPr>
         <p:spPr>
           <a:xfrm>
-            <a:off x="4645025" y="1535113"/>
-            <a:ext cx="4041775" cy="639762"/>
+            <a:off x="6038534" y="1125749"/>
+            <a:ext cx="5254308" cy="469159"/>
           </a:xfrm>
         </p:spPr>
         <p:txBody>
@@ -1618,45 +1620,45 @@
           <a:lstStyle>
             <a:lvl1pPr marL="0" indent="0">
               <a:buNone/>
-              <a:defRPr sz="2400" b="1"/>
+              <a:defRPr sz="1760" b="1"/>
             </a:lvl1pPr>
-            <a:lvl2pPr marL="457200" indent="0">
-              <a:buNone/>
-              <a:defRPr sz="2000" b="1"/>
+            <a:lvl2pPr marL="335228" indent="0">
+              <a:buNone/>
+              <a:defRPr sz="1467" b="1"/>
             </a:lvl2pPr>
-            <a:lvl3pPr marL="914400" indent="0">
-              <a:buNone/>
-              <a:defRPr sz="1800" b="1"/>
+            <a:lvl3pPr marL="670454" indent="0">
+              <a:buNone/>
+              <a:defRPr sz="1320" b="1"/>
             </a:lvl3pPr>
-            <a:lvl4pPr marL="1371600" indent="0">
-              <a:buNone/>
-              <a:defRPr sz="1600" b="1"/>
+            <a:lvl4pPr marL="1005681" indent="0">
+              <a:buNone/>
+              <a:defRPr sz="1173" b="1"/>
             </a:lvl4pPr>
-            <a:lvl5pPr marL="1828800" indent="0">
-              <a:buNone/>
-              <a:defRPr sz="1600" b="1"/>
+            <a:lvl5pPr marL="1340909" indent="0">
+              <a:buNone/>
+              <a:defRPr sz="1173" b="1"/>
             </a:lvl5pPr>
-            <a:lvl6pPr marL="2286000" indent="0">
-              <a:buNone/>
-              <a:defRPr sz="1600" b="1"/>
+            <a:lvl6pPr marL="1676136" indent="0">
+              <a:buNone/>
+              <a:defRPr sz="1173" b="1"/>
             </a:lvl6pPr>
-            <a:lvl7pPr marL="2743200" indent="0">
-              <a:buNone/>
-              <a:defRPr sz="1600" b="1"/>
+            <a:lvl7pPr marL="2011363" indent="0">
+              <a:buNone/>
+              <a:defRPr sz="1173" b="1"/>
             </a:lvl7pPr>
-            <a:lvl8pPr marL="3200400" indent="0">
-              <a:buNone/>
-              <a:defRPr sz="1600" b="1"/>
+            <a:lvl8pPr marL="2346590" indent="0">
+              <a:buNone/>
+              <a:defRPr sz="1173" b="1"/>
             </a:lvl8pPr>
-            <a:lvl9pPr marL="3657600" indent="0">
-              <a:buNone/>
-              <a:defRPr sz="1600" b="1"/>
+            <a:lvl9pPr marL="2681817" indent="0">
+              <a:buNone/>
+              <a:defRPr sz="1173" b="1"/>
             </a:lvl9pPr>
           </a:lstStyle>
           <a:p>
             <a:pPr lvl="0"/>
             <a:r>
-              <a:rPr lang="en-US" smtClean="0"/>
+              <a:rPr lang="en-US"/>
               <a:t>Click to edit Master text styles</a:t>
             </a:r>
           </a:p>
@@ -1674,76 +1676,75 @@
         </p:nvSpPr>
         <p:spPr>
           <a:xfrm>
-            <a:off x="4645025" y="2174875"/>
-            <a:ext cx="4041775" cy="3951288"/>
+            <a:off x="6038534" y="1594908"/>
+            <a:ext cx="5254308" cy="2897611"/>
           </a:xfrm>
         </p:spPr>
         <p:txBody>
           <a:bodyPr/>
           <a:lstStyle>
             <a:lvl1pPr>
-              <a:defRPr sz="2400"/>
+              <a:defRPr sz="1760"/>
             </a:lvl1pPr>
             <a:lvl2pPr>
-              <a:defRPr sz="2000"/>
+              <a:defRPr sz="1467"/>
             </a:lvl2pPr>
             <a:lvl3pPr>
-              <a:defRPr sz="1800"/>
+              <a:defRPr sz="1320"/>
             </a:lvl3pPr>
             <a:lvl4pPr>
-              <a:defRPr sz="1600"/>
+              <a:defRPr sz="1173"/>
             </a:lvl4pPr>
             <a:lvl5pPr>
-              <a:defRPr sz="1600"/>
+              <a:defRPr sz="1173"/>
             </a:lvl5pPr>
             <a:lvl6pPr>
-              <a:defRPr sz="1600"/>
+              <a:defRPr sz="1173"/>
             </a:lvl6pPr>
             <a:lvl7pPr>
-              <a:defRPr sz="1600"/>
+              <a:defRPr sz="1173"/>
             </a:lvl7pPr>
             <a:lvl8pPr>
-              <a:defRPr sz="1600"/>
+              <a:defRPr sz="1173"/>
             </a:lvl8pPr>
             <a:lvl9pPr>
-              <a:defRPr sz="1600"/>
+              <a:defRPr sz="1173"/>
             </a:lvl9pPr>
           </a:lstStyle>
           <a:p>
             <a:pPr lvl="0"/>
             <a:r>
-              <a:rPr lang="en-US" smtClean="0"/>
+              <a:rPr lang="en-US"/>
               <a:t>Click to edit Master text styles</a:t>
             </a:r>
           </a:p>
           <a:p>
             <a:pPr lvl="1"/>
             <a:r>
-              <a:rPr lang="en-US" smtClean="0"/>
+              <a:rPr lang="en-US"/>
               <a:t>Second level</a:t>
             </a:r>
           </a:p>
           <a:p>
             <a:pPr lvl="2"/>
             <a:r>
-              <a:rPr lang="en-US" smtClean="0"/>
+              <a:rPr lang="en-US"/>
               <a:t>Third level</a:t>
             </a:r>
           </a:p>
           <a:p>
             <a:pPr lvl="3"/>
             <a:r>
-              <a:rPr lang="en-US" smtClean="0"/>
+              <a:rPr lang="en-US"/>
               <a:t>Fourth level</a:t>
             </a:r>
           </a:p>
           <a:p>
             <a:pPr lvl="4"/>
             <a:r>
-              <a:rPr lang="en-US" smtClean="0"/>
+              <a:rPr lang="en-US"/>
               <a:t>Fifth level</a:t>
             </a:r>
-            <a:endParaRPr lang="en-US"/>
           </a:p>
         </p:txBody>
       </p:sp>
@@ -1764,7 +1765,7 @@
           <a:p>
             <a:fld id="{5BCAD085-E8A6-8845-BD4E-CB4CCA059FC4}" type="datetimeFigureOut">
               <a:rPr lang="en-US" smtClean="0"/>
-              <a:t>1/27/13</a:t>
+              <a:t>10/17/2026</a:t>
             </a:fld>
             <a:endParaRPr lang="en-US"/>
           </a:p>
@@ -1858,10 +1859,9 @@
           <a:lstStyle/>
           <a:p>
             <a:r>
-              <a:rPr lang="en-US" smtClean="0"/>
+              <a:rPr lang="en-US"/>
               <a:t>Click to edit Master title style</a:t>
             </a:r>
-            <a:endParaRPr lang="en-US"/>
           </a:p>
         </p:txBody>
       </p:sp>
@@ -1882,7 +1882,7 @@
           <a:p>
             <a:fld id="{5BCAD085-E8A6-8845-BD4E-CB4CCA059FC4}" type="datetimeFigureOut">
               <a:rPr lang="en-US" smtClean="0"/>
-              <a:t>1/27/13</a:t>
+              <a:t>10/17/2026</a:t>
             </a:fld>
             <a:endParaRPr lang="en-US"/>
           </a:p>
@@ -1977,7 +1977,7 @@
           <a:p>
             <a:fld id="{5BCAD085-E8A6-8845-BD4E-CB4CCA059FC4}" type="datetimeFigureOut">
               <a:rPr lang="en-US" smtClean="0"/>
-              <a:t>1/27/13</a:t>
+              <a:t>10/17/2026</a:t>
             </a:fld>
             <a:endParaRPr lang="en-US"/>
           </a:p>
@@ -2067,23 +2067,22 @@
         </p:nvSpPr>
         <p:spPr>
           <a:xfrm>
-            <a:off x="457200" y="273050"/>
-            <a:ext cx="3008313" cy="1162050"/>
+            <a:off x="594363" y="200237"/>
+            <a:ext cx="3910807" cy="852170"/>
           </a:xfrm>
         </p:spPr>
         <p:txBody>
           <a:bodyPr anchor="b"/>
           <a:lstStyle>
             <a:lvl1pPr algn="l">
-              <a:defRPr sz="2000" b="1"/>
+              <a:defRPr sz="1467" b="1"/>
             </a:lvl1pPr>
           </a:lstStyle>
           <a:p>
             <a:r>
-              <a:rPr lang="en-US" smtClean="0"/>
+              <a:rPr lang="en-US"/>
               <a:t>Click to edit Master title style</a:t>
             </a:r>
-            <a:endParaRPr lang="en-US"/>
           </a:p>
         </p:txBody>
       </p:sp>
@@ -2099,76 +2098,75 @@
         </p:nvSpPr>
         <p:spPr>
           <a:xfrm>
-            <a:off x="3575050" y="273050"/>
-            <a:ext cx="5111750" cy="5853113"/>
+            <a:off x="4647565" y="200239"/>
+            <a:ext cx="6645275" cy="4292283"/>
           </a:xfrm>
         </p:spPr>
         <p:txBody>
           <a:bodyPr/>
           <a:lstStyle>
             <a:lvl1pPr>
-              <a:defRPr sz="3200"/>
+              <a:defRPr sz="2347"/>
             </a:lvl1pPr>
             <a:lvl2pPr>
-              <a:defRPr sz="2800"/>
+              <a:defRPr sz="2053"/>
             </a:lvl2pPr>
             <a:lvl3pPr>
-              <a:defRPr sz="2400"/>
+              <a:defRPr sz="1760"/>
             </a:lvl3pPr>
             <a:lvl4pPr>
-              <a:defRPr sz="2000"/>
+              <a:defRPr sz="1467"/>
             </a:lvl4pPr>
             <a:lvl5pPr>
-              <a:defRPr sz="2000"/>
+              <a:defRPr sz="1467"/>
             </a:lvl5pPr>
             <a:lvl6pPr>
-              <a:defRPr sz="2000"/>
+              <a:defRPr sz="1467"/>
             </a:lvl6pPr>
             <a:lvl7pPr>
-              <a:defRPr sz="2000"/>
+              <a:defRPr sz="1467"/>
             </a:lvl7pPr>
             <a:lvl8pPr>
-              <a:defRPr sz="2000"/>
+              <a:defRPr sz="1467"/>
             </a:lvl8pPr>
             <a:lvl9pPr>
-              <a:defRPr sz="2000"/>
+              <a:defRPr sz="1467"/>
             </a:lvl9pPr>
           </a:lstStyle>
           <a:p>
             <a:pPr lvl="0"/>
             <a:r>
-              <a:rPr lang="en-US" smtClean="0"/>
+              <a:rPr lang="en-US"/>
               <a:t>Click to edit Master text styles</a:t>
             </a:r>
           </a:p>
           <a:p>
             <a:pPr lvl="1"/>
             <a:r>
-              <a:rPr lang="en-US" smtClean="0"/>
+              <a:rPr lang="en-US"/>
               <a:t>Second level</a:t>
             </a:r>
           </a:p>
           <a:p>
             <a:pPr lvl="2"/>
             <a:r>
-              <a:rPr lang="en-US" smtClean="0"/>
+              <a:rPr lang="en-US"/>
               <a:t>Third level</a:t>
             </a:r>
           </a:p>
           <a:p>
             <a:pPr lvl="3"/>
             <a:r>
-              <a:rPr lang="en-US" smtClean="0"/>
+              <a:rPr lang="en-US"/>
               <a:t>Fourth level</a:t>
             </a:r>
           </a:p>
           <a:p>
             <a:pPr lvl="4"/>
             <a:r>
-              <a:rPr lang="en-US" smtClean="0"/>
+              <a:rPr lang="en-US"/>
               <a:t>Fifth level</a:t>
             </a:r>
-            <a:endParaRPr lang="en-US"/>
           </a:p>
         </p:txBody>
       </p:sp>
@@ -2184,8 +2182,8 @@
         </p:nvSpPr>
         <p:spPr>
           <a:xfrm>
-            <a:off x="457200" y="1435100"/>
-            <a:ext cx="3008313" cy="4691063"/>
+            <a:off x="594363" y="1052409"/>
+            <a:ext cx="3910807" cy="3440113"/>
           </a:xfrm>
         </p:spPr>
         <p:txBody>
@@ -2193,45 +2191,45 @@
           <a:lstStyle>
             <a:lvl1pPr marL="0" indent="0">
               <a:buNone/>
-              <a:defRPr sz="1400"/>
+              <a:defRPr sz="1027"/>
             </a:lvl1pPr>
-            <a:lvl2pPr marL="457200" indent="0">
-              <a:buNone/>
-              <a:defRPr sz="1200"/>
+            <a:lvl2pPr marL="335228" indent="0">
+              <a:buNone/>
+              <a:defRPr sz="880"/>
             </a:lvl2pPr>
-            <a:lvl3pPr marL="914400" indent="0">
-              <a:buNone/>
-              <a:defRPr sz="1000"/>
+            <a:lvl3pPr marL="670454" indent="0">
+              <a:buNone/>
+              <a:defRPr sz="733"/>
             </a:lvl3pPr>
-            <a:lvl4pPr marL="1371600" indent="0">
-              <a:buNone/>
-              <a:defRPr sz="900"/>
+            <a:lvl4pPr marL="1005681" indent="0">
+              <a:buNone/>
+              <a:defRPr sz="660"/>
             </a:lvl4pPr>
-            <a:lvl5pPr marL="1828800" indent="0">
-              <a:buNone/>
-              <a:defRPr sz="900"/>
+            <a:lvl5pPr marL="1340909" indent="0">
+              <a:buNone/>
+              <a:defRPr sz="660"/>
             </a:lvl5pPr>
-            <a:lvl6pPr marL="2286000" indent="0">
-              <a:buNone/>
-              <a:defRPr sz="900"/>
+            <a:lvl6pPr marL="1676136" indent="0">
+              <a:buNone/>
+              <a:defRPr sz="660"/>
             </a:lvl6pPr>
-            <a:lvl7pPr marL="2743200" indent="0">
-              <a:buNone/>
-              <a:defRPr sz="900"/>
+            <a:lvl7pPr marL="2011363" indent="0">
+              <a:buNone/>
+              <a:defRPr sz="660"/>
             </a:lvl7pPr>
-            <a:lvl8pPr marL="3200400" indent="0">
-              <a:buNone/>
-              <a:defRPr sz="900"/>
+            <a:lvl8pPr marL="2346590" indent="0">
+              <a:buNone/>
+              <a:defRPr sz="660"/>
             </a:lvl8pPr>
-            <a:lvl9pPr marL="3657600" indent="0">
-              <a:buNone/>
-              <a:defRPr sz="900"/>
+            <a:lvl9pPr marL="2681817" indent="0">
+              <a:buNone/>
+              <a:defRPr sz="660"/>
             </a:lvl9pPr>
           </a:lstStyle>
           <a:p>
             <a:pPr lvl="0"/>
             <a:r>
-              <a:rPr lang="en-US" smtClean="0"/>
+              <a:rPr lang="en-US"/>
               <a:t>Click to edit Master text styles</a:t>
             </a:r>
           </a:p>
@@ -2254,7 +2252,7 @@
           <a:p>
             <a:fld id="{5BCAD085-E8A6-8845-BD4E-CB4CCA059FC4}" type="datetimeFigureOut">
               <a:rPr lang="en-US" smtClean="0"/>
-              <a:t>1/27/13</a:t>
+              <a:t>10/17/2026</a:t>
             </a:fld>
             <a:endParaRPr lang="en-US"/>
           </a:p>
@@ -2344,23 +2342,22 @@
         </p:nvSpPr>
         <p:spPr>
           <a:xfrm>
-            <a:off x="1792288" y="4800600"/>
-            <a:ext cx="5486400" cy="566738"/>
+            <a:off x="2329974" y="3520440"/>
+            <a:ext cx="7132320" cy="415608"/>
           </a:xfrm>
         </p:spPr>
         <p:txBody>
           <a:bodyPr anchor="b"/>
           <a:lstStyle>
             <a:lvl1pPr algn="l">
-              <a:defRPr sz="2000" b="1"/>
+              <a:defRPr sz="1467" b="1"/>
             </a:lvl1pPr>
           </a:lstStyle>
           <a:p>
             <a:r>
-              <a:rPr lang="en-US" smtClean="0"/>
+              <a:rPr lang="en-US"/>
               <a:t>Click to edit Master title style</a:t>
             </a:r>
-            <a:endParaRPr lang="en-US"/>
           </a:p>
         </p:txBody>
       </p:sp>
@@ -2376,8 +2373,8 @@
         </p:nvSpPr>
         <p:spPr>
           <a:xfrm>
-            <a:off x="1792288" y="612775"/>
-            <a:ext cx="5486400" cy="4114800"/>
+            <a:off x="2329974" y="449368"/>
+            <a:ext cx="7132320" cy="3017520"/>
           </a:xfrm>
         </p:spPr>
         <p:txBody>
@@ -2385,39 +2382,39 @@
           <a:lstStyle>
             <a:lvl1pPr marL="0" indent="0">
               <a:buNone/>
-              <a:defRPr sz="3200"/>
+              <a:defRPr sz="2347"/>
             </a:lvl1pPr>
-            <a:lvl2pPr marL="457200" indent="0">
-              <a:buNone/>
-              <a:defRPr sz="2800"/>
+            <a:lvl2pPr marL="335228" indent="0">
+              <a:buNone/>
+              <a:defRPr sz="2053"/>
             </a:lvl2pPr>
-            <a:lvl3pPr marL="914400" indent="0">
-              <a:buNone/>
-              <a:defRPr sz="2400"/>
+            <a:lvl3pPr marL="670454" indent="0">
+              <a:buNone/>
+              <a:defRPr sz="1760"/>
             </a:lvl3pPr>
-            <a:lvl4pPr marL="1371600" indent="0">
-              <a:buNone/>
-              <a:defRPr sz="2000"/>
+            <a:lvl4pPr marL="1005681" indent="0">
+              <a:buNone/>
+              <a:defRPr sz="1467"/>
             </a:lvl4pPr>
-            <a:lvl5pPr marL="1828800" indent="0">
-              <a:buNone/>
-              <a:defRPr sz="2000"/>
+            <a:lvl5pPr marL="1340909" indent="0">
+              <a:buNone/>
+              <a:defRPr sz="1467"/>
             </a:lvl5pPr>
-            <a:lvl6pPr marL="2286000" indent="0">
-              <a:buNone/>
-              <a:defRPr sz="2000"/>
+            <a:lvl6pPr marL="1676136" indent="0">
+              <a:buNone/>
+              <a:defRPr sz="1467"/>
             </a:lvl6pPr>
-            <a:lvl7pPr marL="2743200" indent="0">
-              <a:buNone/>
-              <a:defRPr sz="2000"/>
+            <a:lvl7pPr marL="2011363" indent="0">
+              <a:buNone/>
+              <a:defRPr sz="1467"/>
             </a:lvl7pPr>
-            <a:lvl8pPr marL="3200400" indent="0">
-              <a:buNone/>
-              <a:defRPr sz="2000"/>
+            <a:lvl8pPr marL="2346590" indent="0">
+              <a:buNone/>
+              <a:defRPr sz="1467"/>
             </a:lvl8pPr>
-            <a:lvl9pPr marL="3657600" indent="0">
-              <a:buNone/>
-              <a:defRPr sz="2000"/>
+            <a:lvl9pPr marL="2681817" indent="0">
+              <a:buNone/>
+              <a:defRPr sz="1467"/>
             </a:lvl9pPr>
           </a:lstStyle>
           <a:p>
@@ -2437,8 +2434,8 @@
         </p:nvSpPr>
         <p:spPr>
           <a:xfrm>
-            <a:off x="1792288" y="5367338"/>
-            <a:ext cx="5486400" cy="804862"/>
+            <a:off x="2329974" y="3936048"/>
+            <a:ext cx="7132320" cy="590232"/>
           </a:xfrm>
         </p:spPr>
         <p:txBody>
@@ -2446,45 +2443,45 @@
           <a:lstStyle>
             <a:lvl1pPr marL="0" indent="0">
               <a:buNone/>
-              <a:defRPr sz="1400"/>
+              <a:defRPr sz="1027"/>
             </a:lvl1pPr>
-            <a:lvl2pPr marL="457200" indent="0">
-              <a:buNone/>
-              <a:defRPr sz="1200"/>
+            <a:lvl2pPr marL="335228" indent="0">
+              <a:buNone/>
+              <a:defRPr sz="880"/>
             </a:lvl2pPr>
-            <a:lvl3pPr marL="914400" indent="0">
-              <a:buNone/>
-              <a:defRPr sz="1000"/>
+            <a:lvl3pPr marL="670454" indent="0">
+              <a:buNone/>
+              <a:defRPr sz="733"/>
             </a:lvl3pPr>
-            <a:lvl4pPr marL="1371600" indent="0">
-              <a:buNone/>
-              <a:defRPr sz="900"/>
+            <a:lvl4pPr marL="1005681" indent="0">
+              <a:buNone/>
+              <a:defRPr sz="660"/>
             </a:lvl4pPr>
-            <a:lvl5pPr marL="1828800" indent="0">
-              <a:buNone/>
-              <a:defRPr sz="900"/>
+            <a:lvl5pPr marL="1340909" indent="0">
+              <a:buNone/>
+              <a:defRPr sz="660"/>
             </a:lvl5pPr>
-            <a:lvl6pPr marL="2286000" indent="0">
-              <a:buNone/>
-              <a:defRPr sz="900"/>
+            <a:lvl6pPr marL="1676136" indent="0">
+              <a:buNone/>
+              <a:defRPr sz="660"/>
             </a:lvl6pPr>
-            <a:lvl7pPr marL="2743200" indent="0">
-              <a:buNone/>
-              <a:defRPr sz="900"/>
+            <a:lvl7pPr marL="2011363" indent="0">
+              <a:buNone/>
+              <a:defRPr sz="660"/>
             </a:lvl7pPr>
-            <a:lvl8pPr marL="3200400" indent="0">
-              <a:buNone/>
-              <a:defRPr sz="900"/>
+            <a:lvl8pPr marL="2346590" indent="0">
+              <a:buNone/>
+              <a:defRPr sz="660"/>
             </a:lvl8pPr>
-            <a:lvl9pPr marL="3657600" indent="0">
-              <a:buNone/>
-              <a:defRPr sz="900"/>
+            <a:lvl9pPr marL="2681817" indent="0">
+              <a:buNone/>
+              <a:defRPr sz="660"/>
             </a:lvl9pPr>
           </a:lstStyle>
           <a:p>
             <a:pPr lvl="0"/>
             <a:r>
-              <a:rPr lang="en-US" smtClean="0"/>
+              <a:rPr lang="en-US"/>
               <a:t>Click to edit Master text styles</a:t>
             </a:r>
           </a:p>
@@ -2507,7 +2504,7 @@
           <a:p>
             <a:fld id="{5BCAD085-E8A6-8845-BD4E-CB4CCA059FC4}" type="datetimeFigureOut">
               <a:rPr lang="en-US" smtClean="0"/>
-              <a:t>1/27/13</a:t>
+              <a:t>10/17/2026</a:t>
             </a:fld>
             <a:endParaRPr lang="en-US"/>
           </a:p>
@@ -2602,8 +2599,8 @@
         </p:nvSpPr>
         <p:spPr>
           <a:xfrm>
-            <a:off x="457200" y="274638"/>
-            <a:ext cx="8229600" cy="1143000"/>
+            <a:off x="594360" y="201401"/>
+            <a:ext cx="10698480" cy="838200"/>
           </a:xfrm>
           <a:prstGeom prst="rect">
             <a:avLst/>
@@ -2616,10 +2613,9 @@
           <a:lstStyle/>
           <a:p>
             <a:r>
-              <a:rPr lang="en-US" smtClean="0"/>
+              <a:rPr lang="en-US"/>
               <a:t>Click to edit Master title style</a:t>
             </a:r>
-            <a:endParaRPr lang="en-US"/>
           </a:p>
         </p:txBody>
       </p:sp>
@@ -2635,8 +2631,8 @@
         </p:nvSpPr>
         <p:spPr>
           <a:xfrm>
-            <a:off x="457200" y="1600200"/>
-            <a:ext cx="8229600" cy="4525963"/>
+            <a:off x="594360" y="1173480"/>
+            <a:ext cx="10698480" cy="3319040"/>
           </a:xfrm>
           <a:prstGeom prst="rect">
             <a:avLst/>
@@ -2650,38 +2646,37 @@
           <a:p>
             <a:pPr lvl="0"/>
             <a:r>
-              <a:rPr lang="en-US" smtClean="0"/>
+              <a:rPr lang="en-US"/>
               <a:t>Click to edit Master text styles</a:t>
             </a:r>
           </a:p>
           <a:p>
             <a:pPr lvl="1"/>
             <a:r>
-              <a:rPr lang="en-US" smtClean="0"/>
+              <a:rPr lang="en-US"/>
               <a:t>Second level</a:t>
             </a:r>
           </a:p>
           <a:p>
             <a:pPr lvl="2"/>
             <a:r>
-              <a:rPr lang="en-US" smtClean="0"/>
+              <a:rPr lang="en-US"/>
               <a:t>Third level</a:t>
             </a:r>
           </a:p>
           <a:p>
             <a:pPr lvl="3"/>
             <a:r>
-              <a:rPr lang="en-US" smtClean="0"/>
+              <a:rPr lang="en-US"/>
               <a:t>Fourth level</a:t>
             </a:r>
           </a:p>
           <a:p>
             <a:pPr lvl="4"/>
             <a:r>
-              <a:rPr lang="en-US" smtClean="0"/>
+              <a:rPr lang="en-US"/>
               <a:t>Fifth level</a:t>
             </a:r>
-            <a:endParaRPr lang="en-US"/>
           </a:p>
         </p:txBody>
       </p:sp>
@@ -2697,8 +2692,8 @@
         </p:nvSpPr>
         <p:spPr>
           <a:xfrm>
-            <a:off x="457200" y="6356350"/>
-            <a:ext cx="2133600" cy="365125"/>
+            <a:off x="594360" y="4661325"/>
+            <a:ext cx="2773680" cy="267758"/>
           </a:xfrm>
           <a:prstGeom prst="rect">
             <a:avLst/>
@@ -2708,7 +2703,7 @@
           <a:bodyPr vert="horz" lIns="91440" tIns="45720" rIns="91440" bIns="45720" rtlCol="0" anchor="ctr"/>
           <a:lstStyle>
             <a:lvl1pPr algn="l">
-              <a:defRPr sz="1200">
+              <a:defRPr sz="880">
                 <a:solidFill>
                   <a:schemeClr val="tx1">
                     <a:tint val="75000"/>
@@ -2720,7 +2715,7 @@
           <a:p>
             <a:fld id="{5BCAD085-E8A6-8845-BD4E-CB4CCA059FC4}" type="datetimeFigureOut">
               <a:rPr lang="en-US" smtClean="0"/>
-              <a:t>1/27/13</a:t>
+              <a:t>10/17/2026</a:t>
             </a:fld>
             <a:endParaRPr lang="en-US"/>
           </a:p>
@@ -2738,8 +2733,8 @@
         </p:nvSpPr>
         <p:spPr>
           <a:xfrm>
-            <a:off x="3124200" y="6356350"/>
-            <a:ext cx="2895600" cy="365125"/>
+            <a:off x="4061460" y="4661325"/>
+            <a:ext cx="3764280" cy="267758"/>
           </a:xfrm>
           <a:prstGeom prst="rect">
             <a:avLst/>
@@ -2749,7 +2744,7 @@
           <a:bodyPr vert="horz" lIns="91440" tIns="45720" rIns="91440" bIns="45720" rtlCol="0" anchor="ctr"/>
           <a:lstStyle>
             <a:lvl1pPr algn="ctr">
-              <a:defRPr sz="1200">
+              <a:defRPr sz="880">
                 <a:solidFill>
                   <a:schemeClr val="tx1">
                     <a:tint val="75000"/>
@@ -2775,8 +2770,8 @@
         </p:nvSpPr>
         <p:spPr>
           <a:xfrm>
-            <a:off x="6553200" y="6356350"/>
-            <a:ext cx="2133600" cy="365125"/>
+            <a:off x="8519160" y="4661325"/>
+            <a:ext cx="2773680" cy="267758"/>
           </a:xfrm>
           <a:prstGeom prst="rect">
             <a:avLst/>
@@ -2786,7 +2781,7 @@
           <a:bodyPr vert="horz" lIns="91440" tIns="45720" rIns="91440" bIns="45720" rtlCol="0" anchor="ctr"/>
           <a:lstStyle>
             <a:lvl1pPr algn="r">
-              <a:defRPr sz="1200">
+              <a:defRPr sz="880">
                 <a:solidFill>
                   <a:schemeClr val="tx1">
                     <a:tint val="75000"/>
@@ -2827,12 +2822,12 @@
   </p:sldLayoutIdLst>
   <p:txStyles>
     <p:titleStyle>
-      <a:lvl1pPr algn="ctr" defTabSz="457200" rtl="0" eaLnBrk="1" latinLnBrk="0" hangingPunct="1">
+      <a:lvl1pPr algn="ctr" defTabSz="335228" rtl="0" eaLnBrk="1" latinLnBrk="0" hangingPunct="1">
         <a:spcBef>
           <a:spcPct val="0"/>
         </a:spcBef>
         <a:buNone/>
-        <a:defRPr sz="4400" kern="1200">
+        <a:defRPr sz="3227" kern="1200">
           <a:solidFill>
             <a:schemeClr val="tx1"/>
           </a:solidFill>
@@ -2843,13 +2838,13 @@
       </a:lvl1pPr>
     </p:titleStyle>
     <p:bodyStyle>
-      <a:lvl1pPr marL="342900" indent="-342900" algn="l" defTabSz="457200" rtl="0" eaLnBrk="1" latinLnBrk="0" hangingPunct="1">
+      <a:lvl1pPr marL="251420" indent="-251420" algn="l" defTabSz="335228" rtl="0" eaLnBrk="1" latinLnBrk="0" hangingPunct="1">
         <a:spcBef>
           <a:spcPct val="20000"/>
         </a:spcBef>
         <a:buFont typeface="Arial"/>
         <a:buChar char="•"/>
-        <a:defRPr sz="3200" kern="1200">
+        <a:defRPr sz="2347" kern="1200">
           <a:solidFill>
             <a:schemeClr val="tx1"/>
           </a:solidFill>
@@ -2858,13 +2853,13 @@
           <a:cs typeface="+mn-cs"/>
         </a:defRPr>
       </a:lvl1pPr>
-      <a:lvl2pPr marL="742950" indent="-285750" algn="l" defTabSz="457200" rtl="0" eaLnBrk="1" latinLnBrk="0" hangingPunct="1">
+      <a:lvl2pPr marL="544744" indent="-209517" algn="l" defTabSz="335228" rtl="0" eaLnBrk="1" latinLnBrk="0" hangingPunct="1">
         <a:spcBef>
           <a:spcPct val="20000"/>
         </a:spcBef>
         <a:buFont typeface="Arial"/>
         <a:buChar char="–"/>
-        <a:defRPr sz="2800" kern="1200">
+        <a:defRPr sz="2053" kern="1200">
           <a:solidFill>
             <a:schemeClr val="tx1"/>
           </a:solidFill>
@@ -2873,13 +2868,13 @@
           <a:cs typeface="+mn-cs"/>
         </a:defRPr>
       </a:lvl2pPr>
-      <a:lvl3pPr marL="1143000" indent="-228600" algn="l" defTabSz="457200" rtl="0" eaLnBrk="1" latinLnBrk="0" hangingPunct="1">
+      <a:lvl3pPr marL="838067" indent="-167614" algn="l" defTabSz="335228" rtl="0" eaLnBrk="1" latinLnBrk="0" hangingPunct="1">
         <a:spcBef>
           <a:spcPct val="20000"/>
         </a:spcBef>
         <a:buFont typeface="Arial"/>
         <a:buChar char="•"/>
-        <a:defRPr sz="2400" kern="1200">
+        <a:defRPr sz="1760" kern="1200">
           <a:solidFill>
             <a:schemeClr val="tx1"/>
           </a:solidFill>
@@ -2888,13 +2883,13 @@
           <a:cs typeface="+mn-cs"/>
         </a:defRPr>
       </a:lvl3pPr>
-      <a:lvl4pPr marL="1600200" indent="-228600" algn="l" defTabSz="457200" rtl="0" eaLnBrk="1" latinLnBrk="0" hangingPunct="1">
+      <a:lvl4pPr marL="1173295" indent="-167614" algn="l" defTabSz="335228" rtl="0" eaLnBrk="1" latinLnBrk="0" hangingPunct="1">
         <a:spcBef>
           <a:spcPct val="20000"/>
         </a:spcBef>
         <a:buFont typeface="Arial"/>
         <a:buChar char="–"/>
-        <a:defRPr sz="2000" kern="1200">
+        <a:defRPr sz="1467" kern="1200">
           <a:solidFill>
             <a:schemeClr val="tx1"/>
           </a:solidFill>
@@ -2903,13 +2898,13 @@
           <a:cs typeface="+mn-cs"/>
         </a:defRPr>
       </a:lvl4pPr>
-      <a:lvl5pPr marL="2057400" indent="-228600" algn="l" defTabSz="457200" rtl="0" eaLnBrk="1" latinLnBrk="0" hangingPunct="1">
+      <a:lvl5pPr marL="1508522" indent="-167614" algn="l" defTabSz="335228" rtl="0" eaLnBrk="1" latinLnBrk="0" hangingPunct="1">
         <a:spcBef>
           <a:spcPct val="20000"/>
         </a:spcBef>
         <a:buFont typeface="Arial"/>
         <a:buChar char="»"/>
-        <a:defRPr sz="2000" kern="1200">
+        <a:defRPr sz="1467" kern="1200">
           <a:solidFill>
             <a:schemeClr val="tx1"/>
           </a:solidFill>
@@ -2918,13 +2913,13 @@
           <a:cs typeface="+mn-cs"/>
         </a:defRPr>
       </a:lvl5pPr>
-      <a:lvl6pPr marL="2514600" indent="-228600" algn="l" defTabSz="457200" rtl="0" eaLnBrk="1" latinLnBrk="0" hangingPunct="1">
+      <a:lvl6pPr marL="1843749" indent="-167614" algn="l" defTabSz="335228" rtl="0" eaLnBrk="1" latinLnBrk="0" hangingPunct="1">
         <a:spcBef>
           <a:spcPct val="20000"/>
         </a:spcBef>
         <a:buFont typeface="Arial"/>
         <a:buChar char="•"/>
-        <a:defRPr sz="2000" kern="1200">
+        <a:defRPr sz="1467" kern="1200">
           <a:solidFill>
             <a:schemeClr val="tx1"/>
           </a:solidFill>
@@ -2933,13 +2928,13 @@
           <a:cs typeface="+mn-cs"/>
         </a:defRPr>
       </a:lvl6pPr>
-      <a:lvl7pPr marL="2971800" indent="-228600" algn="l" defTabSz="457200" rtl="0" eaLnBrk="1" latinLnBrk="0" hangingPunct="1">
+      <a:lvl7pPr marL="2178977" indent="-167614" algn="l" defTabSz="335228" rtl="0" eaLnBrk="1" latinLnBrk="0" hangingPunct="1">
         <a:spcBef>
           <a:spcPct val="20000"/>
         </a:spcBef>
         <a:buFont typeface="Arial"/>
         <a:buChar char="•"/>
-        <a:defRPr sz="2000" kern="1200">
+        <a:defRPr sz="1467" kern="1200">
           <a:solidFill>
             <a:schemeClr val="tx1"/>
           </a:solidFill>
@@ -2948,13 +2943,13 @@
           <a:cs typeface="+mn-cs"/>
         </a:defRPr>
       </a:lvl7pPr>
-      <a:lvl8pPr marL="3429000" indent="-228600" algn="l" defTabSz="457200" rtl="0" eaLnBrk="1" latinLnBrk="0" hangingPunct="1">
+      <a:lvl8pPr marL="2514203" indent="-167614" algn="l" defTabSz="335228" rtl="0" eaLnBrk="1" latinLnBrk="0" hangingPunct="1">
         <a:spcBef>
           <a:spcPct val="20000"/>
         </a:spcBef>
         <a:buFont typeface="Arial"/>
         <a:buChar char="•"/>
-        <a:defRPr sz="2000" kern="1200">
+        <a:defRPr sz="1467" kern="1200">
           <a:solidFill>
             <a:schemeClr val="tx1"/>
           </a:solidFill>
@@ -2963,13 +2958,13 @@
           <a:cs typeface="+mn-cs"/>
         </a:defRPr>
       </a:lvl8pPr>
-      <a:lvl9pPr marL="3886200" indent="-228600" algn="l" defTabSz="457200" rtl="0" eaLnBrk="1" latinLnBrk="0" hangingPunct="1">
+      <a:lvl9pPr marL="2849431" indent="-167614" algn="l" defTabSz="335228" rtl="0" eaLnBrk="1" latinLnBrk="0" hangingPunct="1">
         <a:spcBef>
           <a:spcPct val="20000"/>
         </a:spcBef>
         <a:buFont typeface="Arial"/>
         <a:buChar char="•"/>
-        <a:defRPr sz="2000" kern="1200">
+        <a:defRPr sz="1467" kern="1200">
           <a:solidFill>
             <a:schemeClr val="tx1"/>
           </a:solidFill>
@@ -2983,8 +2978,8 @@
       <a:defPPr>
         <a:defRPr lang="en-US"/>
       </a:defPPr>
-      <a:lvl1pPr marL="0" algn="l" defTabSz="457200" rtl="0" eaLnBrk="1" latinLnBrk="0" hangingPunct="1">
-        <a:defRPr sz="1800" kern="1200">
+      <a:lvl1pPr marL="0" algn="l" defTabSz="335228" rtl="0" eaLnBrk="1" latinLnBrk="0" hangingPunct="1">
+        <a:defRPr sz="1320" kern="1200">
           <a:solidFill>
             <a:schemeClr val="tx1"/>
           </a:solidFill>
@@ -2993,8 +2988,8 @@
           <a:cs typeface="+mn-cs"/>
         </a:defRPr>
       </a:lvl1pPr>
-      <a:lvl2pPr marL="457200" algn="l" defTabSz="457200" rtl="0" eaLnBrk="1" latinLnBrk="0" hangingPunct="1">
-        <a:defRPr sz="1800" kern="1200">
+      <a:lvl2pPr marL="335228" algn="l" defTabSz="335228" rtl="0" eaLnBrk="1" latinLnBrk="0" hangingPunct="1">
+        <a:defRPr sz="1320" kern="1200">
           <a:solidFill>
             <a:schemeClr val="tx1"/>
           </a:solidFill>
@@ -3003,8 +2998,8 @@
           <a:cs typeface="+mn-cs"/>
         </a:defRPr>
       </a:lvl2pPr>
-      <a:lvl3pPr marL="914400" algn="l" defTabSz="457200" rtl="0" eaLnBrk="1" latinLnBrk="0" hangingPunct="1">
-        <a:defRPr sz="1800" kern="1200">
+      <a:lvl3pPr marL="670454" algn="l" defTabSz="335228" rtl="0" eaLnBrk="1" latinLnBrk="0" hangingPunct="1">
+        <a:defRPr sz="1320" kern="1200">
           <a:solidFill>
             <a:schemeClr val="tx1"/>
           </a:solidFill>
@@ -3013,8 +3008,8 @@
           <a:cs typeface="+mn-cs"/>
         </a:defRPr>
       </a:lvl3pPr>
-      <a:lvl4pPr marL="1371600" algn="l" defTabSz="457200" rtl="0" eaLnBrk="1" latinLnBrk="0" hangingPunct="1">
-        <a:defRPr sz="1800" kern="1200">
+      <a:lvl4pPr marL="1005681" algn="l" defTabSz="335228" rtl="0" eaLnBrk="1" latinLnBrk="0" hangingPunct="1">
+        <a:defRPr sz="1320" kern="1200">
           <a:solidFill>
             <a:schemeClr val="tx1"/>
           </a:solidFill>
@@ -3023,8 +3018,8 @@
           <a:cs typeface="+mn-cs"/>
         </a:defRPr>
       </a:lvl4pPr>
-      <a:lvl5pPr marL="1828800" algn="l" defTabSz="457200" rtl="0" eaLnBrk="1" latinLnBrk="0" hangingPunct="1">
-        <a:defRPr sz="1800" kern="1200">
+      <a:lvl5pPr marL="1340909" algn="l" defTabSz="335228" rtl="0" eaLnBrk="1" latinLnBrk="0" hangingPunct="1">
+        <a:defRPr sz="1320" kern="1200">
           <a:solidFill>
             <a:schemeClr val="tx1"/>
           </a:solidFill>
@@ -3033,8 +3028,8 @@
           <a:cs typeface="+mn-cs"/>
         </a:defRPr>
       </a:lvl5pPr>
-      <a:lvl6pPr marL="2286000" algn="l" defTabSz="457200" rtl="0" eaLnBrk="1" latinLnBrk="0" hangingPunct="1">
-        <a:defRPr sz="1800" kern="1200">
+      <a:lvl6pPr marL="1676136" algn="l" defTabSz="335228" rtl="0" eaLnBrk="1" latinLnBrk="0" hangingPunct="1">
+        <a:defRPr sz="1320" kern="1200">
           <a:solidFill>
             <a:schemeClr val="tx1"/>
           </a:solidFill>
@@ -3043,8 +3038,8 @@
           <a:cs typeface="+mn-cs"/>
         </a:defRPr>
       </a:lvl6pPr>
-      <a:lvl7pPr marL="2743200" algn="l" defTabSz="457200" rtl="0" eaLnBrk="1" latinLnBrk="0" hangingPunct="1">
-        <a:defRPr sz="1800" kern="1200">
+      <a:lvl7pPr marL="2011363" algn="l" defTabSz="335228" rtl="0" eaLnBrk="1" latinLnBrk="0" hangingPunct="1">
+        <a:defRPr sz="1320" kern="1200">
           <a:solidFill>
             <a:schemeClr val="tx1"/>
           </a:solidFill>
@@ -3053,8 +3048,8 @@
           <a:cs typeface="+mn-cs"/>
         </a:defRPr>
       </a:lvl7pPr>
-      <a:lvl8pPr marL="3200400" algn="l" defTabSz="457200" rtl="0" eaLnBrk="1" latinLnBrk="0" hangingPunct="1">
-        <a:defRPr sz="1800" kern="1200">
+      <a:lvl8pPr marL="2346590" algn="l" defTabSz="335228" rtl="0" eaLnBrk="1" latinLnBrk="0" hangingPunct="1">
+        <a:defRPr sz="1320" kern="1200">
           <a:solidFill>
             <a:schemeClr val="tx1"/>
           </a:solidFill>
@@ -3063,8 +3058,8 @@
           <a:cs typeface="+mn-cs"/>
         </a:defRPr>
       </a:lvl8pPr>
-      <a:lvl9pPr marL="3657600" algn="l" defTabSz="457200" rtl="0" eaLnBrk="1" latinLnBrk="0" hangingPunct="1">
-        <a:defRPr sz="1800" kern="1200">
+      <a:lvl9pPr marL="2681817" algn="l" defTabSz="335228" rtl="0" eaLnBrk="1" latinLnBrk="0" hangingPunct="1">
+        <a:defRPr sz="1320" kern="1200">
           <a:solidFill>
             <a:schemeClr val="tx1"/>
           </a:solidFill>
@@ -3079,7 +3074,7 @@
 </file>
 
 <file path=ppt/slides/slide1.xml><?xml version="1.0" encoding="utf-8"?>
-<p:sld xmlns:a="http://schemas.openxmlformats.org/drawingml/2006/main" xmlns:p="http://schemas.openxmlformats.org/presentationml/2006/main" xmlns:r="http://schemas.openxmlformats.org/officeDocument/2006/relationships">
+<p:sld xmlns:a="http://schemas.openxmlformats.org/drawingml/2006/main" xmlns:r="http://schemas.openxmlformats.org/officeDocument/2006/relationships" xmlns:p="http://schemas.openxmlformats.org/presentationml/2006/main">
   <p:cSld>
     <p:spTree>
       <p:nvGrpSpPr>
@@ -3087,17 +3082,30 @@
         <p:cNvGrpSpPr/>
         <p:nvPr/>
       </p:nvGrpSpPr>
-      <p:grpSpPr/>
-      <p:sp>
-        <p:nvSpPr>
-          <p:cNvPr id="2" name="Rounded Rectangle 1"/>
+      <p:grpSpPr>
+        <a:xfrm>
+          <a:off x="0" y="0"/>
+          <a:ext cx="0" cy="0"/>
+          <a:chOff x="0" y="0"/>
+          <a:chExt cx="0" cy="0"/>
+        </a:xfrm>
+      </p:grpSpPr>
+      <p:sp>
+        <p:nvSpPr>
+          <p:cNvPr id="181" name="Rounded Rectangle 1">
+            <a:extLst>
+              <a:ext uri="{FF2B5EF4-FFF2-40B4-BE49-F238E27FC236}">
+                <a16:creationId xmlns:a16="http://schemas.microsoft.com/office/drawing/2014/main" id="{00CB0606-CB25-9820-417C-2296C47E5578}"/>
+              </a:ext>
+            </a:extLst>
+          </p:cNvPr>
           <p:cNvSpPr/>
           <p:nvPr/>
         </p:nvSpPr>
         <p:spPr>
           <a:xfrm>
-            <a:off x="320040" y="1280160"/>
-            <a:ext cx="2057400" cy="868680"/>
+            <a:off x="-8960" y="347894"/>
+            <a:ext cx="1828800" cy="914400"/>
           </a:xfrm>
           <a:prstGeom prst="roundRect">
             <a:avLst>
@@ -3129,44 +3137,56 @@
           </a:fontRef>
         </p:style>
         <p:txBody>
-          <a:bodyPr rtlCol="0" anchor="ctr" wrap="square" lIns="54864" rIns="54864" tIns="27432" bIns="27432"/>
+          <a:bodyPr wrap="square" lIns="54865" tIns="27432" rIns="54865" bIns="27432" rtlCol="0" anchor="ctr"/>
           <a:lstStyle/>
           <a:p>
             <a:pPr algn="ctr"/>
             <a:r>
-              <a:rPr sz="1100" b="1">
+              <a:rPr sz="1200" b="1" dirty="0">
                 <a:solidFill>
                   <a:srgbClr val="1F3864"/>
                 </a:solidFill>
                 <a:latin typeface="Calibri"/>
               </a:rPr>
-              <a:t>Measured projections Y</a:t>
-            </a:r>
-          </a:p>
-          <a:p>
-            <a:pPr algn="ctr"/>
-            <a:r>
-              <a:rPr sz="1100" b="0">
+              <a:t>Measured </a:t>
+            </a:r>
+            <a:r>
+              <a:rPr lang="en-US" sz="1200" b="1" dirty="0">
                 <a:solidFill>
                   <a:srgbClr val="1F3864"/>
                 </a:solidFill>
                 <a:latin typeface="Calibri"/>
               </a:rPr>
-              <a:t>primary + scatter, all views</a:t>
-            </a:r>
-          </a:p>
-        </p:txBody>
-      </p:sp>
-      <p:sp>
-        <p:nvSpPr>
-          <p:cNvPr id="3" name="Rounded Rectangle 2"/>
+              <a:t>data</a:t>
+            </a:r>
+            <a:r>
+              <a:rPr sz="1200" b="1" dirty="0">
+                <a:solidFill>
+                  <a:srgbClr val="1F3864"/>
+                </a:solidFill>
+                <a:latin typeface="Calibri"/>
+              </a:rPr>
+              <a:t> Y</a:t>
+            </a:r>
+          </a:p>
+        </p:txBody>
+      </p:sp>
+      <p:sp>
+        <p:nvSpPr>
+          <p:cNvPr id="182" name="Rounded Rectangle 2">
+            <a:extLst>
+              <a:ext uri="{FF2B5EF4-FFF2-40B4-BE49-F238E27FC236}">
+                <a16:creationId xmlns:a16="http://schemas.microsoft.com/office/drawing/2014/main" id="{E8F3EBA8-0DE3-6182-FD1E-F40F0F262D61}"/>
+              </a:ext>
+            </a:extLst>
+          </p:cNvPr>
           <p:cNvSpPr/>
           <p:nvPr/>
         </p:nvSpPr>
         <p:spPr>
           <a:xfrm>
-            <a:off x="320040" y="3017520"/>
-            <a:ext cx="2057400" cy="868680"/>
+            <a:off x="2187255" y="350391"/>
+            <a:ext cx="2057400" cy="914400"/>
           </a:xfrm>
           <a:prstGeom prst="roundRect">
             <a:avLst>
@@ -3198,12 +3218,12 @@
           </a:fontRef>
         </p:style>
         <p:txBody>
-          <a:bodyPr rtlCol="0" anchor="ctr" wrap="square" lIns="54864" rIns="54864" tIns="27432" bIns="27432"/>
+          <a:bodyPr wrap="square" lIns="54865" tIns="27432" rIns="54865" bIns="27432" rtlCol="0" anchor="ctr"/>
           <a:lstStyle/>
           <a:p>
             <a:pPr algn="ctr"/>
             <a:r>
-              <a:rPr sz="1100" b="1">
+              <a:rPr sz="1200" b="1" dirty="0">
                 <a:solidFill>
                   <a:srgbClr val="1F3864"/>
                 </a:solidFill>
@@ -3215,34 +3235,44 @@
           <a:p>
             <a:pPr algn="ctr"/>
             <a:r>
-              <a:rPr sz="1100" b="0">
+              <a:rPr sz="1100" dirty="0">
                 <a:solidFill>
                   <a:srgbClr val="1F3864"/>
                 </a:solidFill>
                 <a:latin typeface="Calibri"/>
               </a:rPr>
-              <a:t>(FDK)</a:t>
+              <a:t>FDK</a:t>
             </a:r>
           </a:p>
         </p:txBody>
       </p:sp>
       <p:cxnSp>
         <p:nvCxnSpPr>
-          <p:cNvPr id="4" name="Connector 3"/>
-          <p:cNvCxnSpPr/>
+          <p:cNvPr id="183" name="Connector 3">
+            <a:extLst>
+              <a:ext uri="{FF2B5EF4-FFF2-40B4-BE49-F238E27FC236}">
+                <a16:creationId xmlns:a16="http://schemas.microsoft.com/office/drawing/2014/main" id="{018F8213-E94E-0E31-54C1-CAE9C314B719}"/>
+              </a:ext>
+            </a:extLst>
+          </p:cNvPr>
+          <p:cNvCxnSpPr>
+            <a:cxnSpLocks/>
+            <a:stCxn id="181" idx="3"/>
+            <a:endCxn id="182" idx="1"/>
+          </p:cNvCxnSpPr>
           <p:nvPr/>
         </p:nvCxnSpPr>
         <p:spPr>
           <a:xfrm>
-            <a:off x="1348740" y="2148840"/>
-            <a:ext cx="0" cy="868680"/>
+            <a:off x="1819840" y="805095"/>
+            <a:ext cx="367415" cy="2497"/>
           </a:xfrm>
           <a:prstGeom prst="line">
             <a:avLst/>
           </a:prstGeom>
           <a:ln w="19050">
             <a:solidFill>
-              <a:srgbClr val="595959"/>
+              <a:srgbClr val="2F5597"/>
             </a:solidFill>
             <a:tailEnd type="triangle" w="med" len="med"/>
           </a:ln>
@@ -3264,14 +3294,20 @@
       </p:cxnSp>
       <p:sp>
         <p:nvSpPr>
-          <p:cNvPr id="5" name="Rounded Rectangle 4"/>
+          <p:cNvPr id="184" name="Rounded Rectangle 4">
+            <a:extLst>
+              <a:ext uri="{FF2B5EF4-FFF2-40B4-BE49-F238E27FC236}">
+                <a16:creationId xmlns:a16="http://schemas.microsoft.com/office/drawing/2014/main" id="{8C705704-A0AC-DD60-E07D-F379A2BAD4B6}"/>
+              </a:ext>
+            </a:extLst>
+          </p:cNvPr>
           <p:cNvSpPr/>
           <p:nvPr/>
         </p:nvSpPr>
         <p:spPr>
           <a:xfrm>
-            <a:off x="2788920" y="411480"/>
-            <a:ext cx="9098280" cy="5577840"/>
+            <a:off x="4581296" y="34283"/>
+            <a:ext cx="9156421" cy="4957966"/>
           </a:xfrm>
           <a:prstGeom prst="roundRect">
             <a:avLst>
@@ -3302,32 +3338,30 @@
           </a:fontRef>
         </p:style>
         <p:txBody>
-          <a:bodyPr rtlCol="0" anchor="ctr" wrap="square" lIns="54864" rIns="54864" tIns="27432" bIns="27432"/>
+          <a:bodyPr wrap="square" lIns="54865" tIns="27432" rIns="54865" bIns="27432" rtlCol="0" anchor="ctr"/>
           <a:lstStyle/>
           <a:p>
             <a:pPr algn="ctr"/>
-            <a:r>
-              <a:rPr sz="1100" b="1">
-                <a:solidFill>
-                  <a:srgbClr val="404040"/>
-                </a:solidFill>
-                <a:latin typeface="Calibri"/>
-              </a:rPr>
-              <a:t/>
-            </a:r>
-          </a:p>
-        </p:txBody>
-      </p:sp>
-      <p:sp>
-        <p:nvSpPr>
-          <p:cNvPr id="6" name="TextBox 5"/>
+            <a:endParaRPr/>
+          </a:p>
+        </p:txBody>
+      </p:sp>
+      <p:sp>
+        <p:nvSpPr>
+          <p:cNvPr id="185" name="TextBox 184">
+            <a:extLst>
+              <a:ext uri="{FF2B5EF4-FFF2-40B4-BE49-F238E27FC236}">
+                <a16:creationId xmlns:a16="http://schemas.microsoft.com/office/drawing/2014/main" id="{57458EDD-3903-675B-FA2C-0661ACA86968}"/>
+              </a:ext>
+            </a:extLst>
+          </p:cNvPr>
           <p:cNvSpPr txBox="1"/>
           <p:nvPr/>
         </p:nvSpPr>
         <p:spPr>
           <a:xfrm>
-            <a:off x="3017520" y="457200"/>
-            <a:ext cx="8229600" cy="274320"/>
+            <a:off x="5044706" y="68153"/>
+            <a:ext cx="8229600" cy="215444"/>
           </a:xfrm>
           <a:prstGeom prst="rect">
             <a:avLst/>
@@ -3335,34 +3369,49 @@
           <a:noFill/>
         </p:spPr>
         <p:txBody>
-          <a:bodyPr wrap="square" lIns="18288" rIns="18288" tIns="0" bIns="0">
+          <a:bodyPr wrap="square" lIns="18288" tIns="0" rIns="18288" bIns="0">
             <a:spAutoFit/>
           </a:bodyPr>
           <a:lstStyle/>
           <a:p>
-            <a:pPr algn="l"/>
-            <a:r>
-              <a:rPr sz="1200" b="1" i="0">
+            <a:pPr algn="ctr"/>
+            <a:r>
+              <a:rPr lang="en-US" sz="1400" b="1" dirty="0">
                 <a:solidFill>
                   <a:srgbClr val="404040"/>
                 </a:solidFill>
                 <a:latin typeface="Calibri"/>
               </a:rPr>
-              <a:t>Outer iteration k</a:t>
-            </a:r>
-          </a:p>
-        </p:txBody>
-      </p:sp>
-      <p:sp>
-        <p:nvSpPr>
-          <p:cNvPr id="7" name="Rounded Rectangle 6"/>
+              <a:t>CITRUS</a:t>
+            </a:r>
+            <a:r>
+              <a:rPr sz="1400" b="1" dirty="0">
+                <a:solidFill>
+                  <a:srgbClr val="404040"/>
+                </a:solidFill>
+                <a:latin typeface="Calibri"/>
+              </a:rPr>
+              <a:t> iteration k</a:t>
+            </a:r>
+          </a:p>
+        </p:txBody>
+      </p:sp>
+      <p:sp>
+        <p:nvSpPr>
+          <p:cNvPr id="186" name="Rounded Rectangle 6">
+            <a:extLst>
+              <a:ext uri="{FF2B5EF4-FFF2-40B4-BE49-F238E27FC236}">
+                <a16:creationId xmlns:a16="http://schemas.microsoft.com/office/drawing/2014/main" id="{92D72720-168C-8B3D-27DF-E89861548A38}"/>
+              </a:ext>
+            </a:extLst>
+          </p:cNvPr>
           <p:cNvSpPr/>
           <p:nvPr/>
         </p:nvSpPr>
         <p:spPr>
           <a:xfrm>
-            <a:off x="3200400" y="914400"/>
-            <a:ext cx="4754880" cy="960120"/>
+            <a:off x="4981346" y="350392"/>
+            <a:ext cx="3200400" cy="914400"/>
           </a:xfrm>
           <a:prstGeom prst="roundRect">
             <a:avLst>
@@ -3394,41 +3443,83 @@
           </a:fontRef>
         </p:style>
         <p:txBody>
-          <a:bodyPr rtlCol="0" anchor="ctr" wrap="square" lIns="54864" rIns="54864" tIns="27432" bIns="27432"/>
+          <a:bodyPr wrap="square" lIns="54865" tIns="27432" rIns="54865" bIns="27432" rtlCol="0" anchor="ctr"/>
           <a:lstStyle/>
           <a:p>
             <a:pPr algn="ctr"/>
             <a:r>
-              <a:rPr sz="1100" b="1">
+              <a:rPr sz="1200" b="1" dirty="0">
                 <a:solidFill>
                   <a:srgbClr val="385723"/>
                 </a:solidFill>
                 <a:latin typeface="Calibri"/>
               </a:rPr>
-              <a:t>Material densities ρ(Xₖ)</a:t>
+              <a:t>Material densities ρ(X</a:t>
+            </a:r>
+            <a:r>
+              <a:rPr lang="en-US" sz="1200" b="1" baseline="-25000" dirty="0">
+                <a:solidFill>
+                  <a:srgbClr val="385723"/>
+                </a:solidFill>
+                <a:latin typeface="Calibri"/>
+              </a:rPr>
+              <a:t>k</a:t>
+            </a:r>
+            <a:r>
+              <a:rPr sz="1200" b="1" dirty="0">
+                <a:solidFill>
+                  <a:srgbClr val="385723"/>
+                </a:solidFill>
+                <a:latin typeface="Calibri"/>
+              </a:rPr>
+              <a:t>)</a:t>
             </a:r>
           </a:p>
           <a:p>
             <a:pPr algn="ctr"/>
             <a:r>
-              <a:rPr sz="1100" b="0">
+              <a:rPr sz="1100" dirty="0">
                 <a:solidFill>
                   <a:srgbClr val="385723"/>
                 </a:solidFill>
                 <a:latin typeface="Calibri"/>
               </a:rPr>
-              <a:t>each voxel a mixture of the two anchor materials</a:t>
-            </a:r>
-          </a:p>
-          <a:p>
-            <a:pPr algn="ctr"/>
-            <a:r>
-              <a:rPr sz="1100" b="0">
+              <a:t>each voxel a mixture of the two </a:t>
+            </a:r>
+            <a:r>
+              <a:rPr lang="en-US" sz="1100" dirty="0">
                 <a:solidFill>
                   <a:srgbClr val="385723"/>
                 </a:solidFill>
                 <a:latin typeface="Calibri"/>
               </a:rPr>
+              <a:t>reference</a:t>
+            </a:r>
+            <a:r>
+              <a:rPr sz="1100" dirty="0">
+                <a:solidFill>
+                  <a:srgbClr val="385723"/>
+                </a:solidFill>
+                <a:latin typeface="Calibri"/>
+              </a:rPr>
+              <a:t> materials</a:t>
+            </a:r>
+            <a:r>
+              <a:rPr lang="en-US" sz="1100" dirty="0">
+                <a:solidFill>
+                  <a:srgbClr val="385723"/>
+                </a:solidFill>
+                <a:latin typeface="Calibri"/>
+              </a:rPr>
+              <a:t> </a:t>
+            </a:r>
+            <a:r>
+              <a:rPr sz="1100" dirty="0">
+                <a:solidFill>
+                  <a:srgbClr val="385723"/>
+                </a:solidFill>
+                <a:latin typeface="Calibri"/>
+              </a:rPr>
               <a:t>whose attenuations bracket its value</a:t>
             </a:r>
           </a:p>
@@ -3436,107 +3527,20 @@
       </p:sp>
       <p:sp>
         <p:nvSpPr>
-          <p:cNvPr id="8" name="Rounded Rectangle 7"/>
+          <p:cNvPr id="187" name="Rectangle 186">
+            <a:extLst>
+              <a:ext uri="{FF2B5EF4-FFF2-40B4-BE49-F238E27FC236}">
+                <a16:creationId xmlns:a16="http://schemas.microsoft.com/office/drawing/2014/main" id="{85FACF2A-BD9B-7ACD-1510-CB5D5DE9BE23}"/>
+              </a:ext>
+            </a:extLst>
+          </p:cNvPr>
           <p:cNvSpPr/>
           <p:nvPr/>
         </p:nvSpPr>
         <p:spPr>
           <a:xfrm>
-            <a:off x="8229600" y="914400"/>
-            <a:ext cx="3429000" cy="960120"/>
-          </a:xfrm>
-          <a:prstGeom prst="roundRect">
-            <a:avLst>
-              <a:gd name="adj" fmla="val 12000"/>
-            </a:avLst>
-          </a:prstGeom>
-          <a:solidFill>
-            <a:srgbClr val="F2F2F2"/>
-          </a:solidFill>
-          <a:ln w="15875">
-            <a:solidFill>
-              <a:srgbClr val="7F7F7F"/>
-            </a:solidFill>
-          </a:ln>
-          <a:effectLst/>
-        </p:spPr>
-        <p:style>
-          <a:lnRef idx="1">
-            <a:schemeClr val="accent1"/>
-          </a:lnRef>
-          <a:fillRef idx="3">
-            <a:schemeClr val="accent1"/>
-          </a:fillRef>
-          <a:effectRef idx="2">
-            <a:schemeClr val="accent1"/>
-          </a:effectRef>
-          <a:fontRef idx="minor">
-            <a:schemeClr val="lt1"/>
-          </a:fontRef>
-        </p:style>
-        <p:txBody>
-          <a:bodyPr rtlCol="0" anchor="ctr" wrap="square" lIns="54864" rIns="54864" tIns="27432" bIns="27432"/>
-          <a:lstStyle/>
-          <a:p>
-            <a:pPr algn="ctr"/>
-            <a:r>
-              <a:rPr sz="900" b="1">
-                <a:solidFill>
-                  <a:srgbClr val="404040"/>
-                </a:solidFill>
-                <a:latin typeface="Calibri"/>
-              </a:rPr>
-              <a:t>Schedule</a:t>
-            </a:r>
-          </a:p>
-          <a:p>
-            <a:pPr algn="ctr"/>
-            <a:r>
-              <a:rPr sz="900" b="0">
-                <a:solidFill>
-                  <a:srgbClr val="404040"/>
-                </a:solidFill>
-                <a:latin typeface="Calibri"/>
-              </a:rPr>
-              <a:t>scatter step at every n-th outer iteration;</a:t>
-            </a:r>
-          </a:p>
-          <a:p>
-            <a:pPr algn="ctr"/>
-            <a:r>
-              <a:rPr sz="900" b="0">
-                <a:solidFill>
-                  <a:srgbClr val="404040"/>
-                </a:solidFill>
-                <a:latin typeface="Calibri"/>
-              </a:rPr>
-              <a:t>scatter on every m-th view, the others</a:t>
-            </a:r>
-          </a:p>
-          <a:p>
-            <a:pPr algn="ctr"/>
-            <a:r>
-              <a:rPr sz="900" b="0">
-                <a:solidFill>
-                  <a:srgbClr val="404040"/>
-                </a:solidFill>
-                <a:latin typeface="Calibri"/>
-              </a:rPr>
-              <a:t>interpolated in angle</a:t>
-            </a:r>
-          </a:p>
-        </p:txBody>
-      </p:sp>
-      <p:sp>
-        <p:nvSpPr>
-          <p:cNvPr id="9" name="Rectangle 8"/>
-          <p:cNvSpPr/>
-          <p:nvPr/>
-        </p:nvSpPr>
-        <p:spPr>
-          <a:xfrm>
-            <a:off x="3611880" y="2148840"/>
-            <a:ext cx="8138159" cy="2103120"/>
+            <a:off x="5484267" y="1584835"/>
+            <a:ext cx="7863839" cy="1735328"/>
           </a:xfrm>
           <a:prstGeom prst="rect">
             <a:avLst/>
@@ -3566,32 +3570,30 @@
           </a:fontRef>
         </p:style>
         <p:txBody>
-          <a:bodyPr rtlCol="0" anchor="ctr" wrap="square" lIns="54864" rIns="54864" tIns="27432" bIns="27432"/>
+          <a:bodyPr wrap="square" lIns="54865" tIns="27432" rIns="54865" bIns="27432" rtlCol="0" anchor="ctr"/>
           <a:lstStyle/>
           <a:p>
             <a:pPr algn="ctr"/>
-            <a:r>
-              <a:rPr sz="1100" b="1">
-                <a:solidFill>
-                  <a:srgbClr val="843C0C"/>
-                </a:solidFill>
-                <a:latin typeface="Calibri"/>
-              </a:rPr>
-              <a:t/>
-            </a:r>
-          </a:p>
-        </p:txBody>
-      </p:sp>
-      <p:sp>
-        <p:nvSpPr>
-          <p:cNvPr id="10" name="TextBox 9"/>
+            <a:endParaRPr/>
+          </a:p>
+        </p:txBody>
+      </p:sp>
+      <p:sp>
+        <p:nvSpPr>
+          <p:cNvPr id="188" name="TextBox 187">
+            <a:extLst>
+              <a:ext uri="{FF2B5EF4-FFF2-40B4-BE49-F238E27FC236}">
+                <a16:creationId xmlns:a16="http://schemas.microsoft.com/office/drawing/2014/main" id="{FC14AA77-A85D-0A93-9AEF-E428C79B02E0}"/>
+              </a:ext>
+            </a:extLst>
+          </p:cNvPr>
           <p:cNvSpPr txBox="1"/>
           <p:nvPr/>
         </p:nvSpPr>
         <p:spPr>
           <a:xfrm>
-            <a:off x="3703320" y="2176272"/>
-            <a:ext cx="7772400" cy="256032"/>
+            <a:off x="5483788" y="1612268"/>
+            <a:ext cx="7864319" cy="215444"/>
           </a:xfrm>
           <a:prstGeom prst="rect">
             <a:avLst/>
@@ -3599,34 +3601,55 @@
           <a:noFill/>
         </p:spPr>
         <p:txBody>
-          <a:bodyPr wrap="square" lIns="18288" rIns="18288" tIns="0" bIns="0">
+          <a:bodyPr wrap="square" lIns="18288" tIns="0" rIns="18288" bIns="0">
             <a:spAutoFit/>
           </a:bodyPr>
           <a:lstStyle/>
           <a:p>
-            <a:pPr algn="l"/>
-            <a:r>
-              <a:rPr sz="1000" b="1" i="0">
+            <a:pPr algn="ctr"/>
+            <a:r>
+              <a:rPr sz="1400" b="1" dirty="0">
                 <a:solidFill>
                   <a:srgbClr val="843C0C"/>
                 </a:solidFill>
                 <a:latin typeface="Calibri"/>
               </a:rPr>
-              <a:t>LBTE scatter solver, one step per view v (deterministic, multigroup, discrete ordinates)</a:t>
-            </a:r>
-          </a:p>
-        </p:txBody>
-      </p:sp>
-      <p:sp>
-        <p:nvSpPr>
-          <p:cNvPr id="11" name="Rounded Rectangle 10"/>
+              <a:t>LBTE scatter solve</a:t>
+            </a:r>
+            <a:r>
+              <a:rPr lang="en-US" sz="1400" b="1" dirty="0">
+                <a:solidFill>
+                  <a:srgbClr val="843C0C"/>
+                </a:solidFill>
+                <a:latin typeface="Calibri"/>
+              </a:rPr>
+              <a:t>r</a:t>
+            </a:r>
+            <a:endParaRPr sz="1400" b="1" dirty="0">
+              <a:solidFill>
+                <a:srgbClr val="843C0C"/>
+              </a:solidFill>
+              <a:latin typeface="Calibri"/>
+            </a:endParaRPr>
+          </a:p>
+        </p:txBody>
+      </p:sp>
+      <p:sp>
+        <p:nvSpPr>
+          <p:cNvPr id="189" name="Rounded Rectangle 10">
+            <a:extLst>
+              <a:ext uri="{FF2B5EF4-FFF2-40B4-BE49-F238E27FC236}">
+                <a16:creationId xmlns:a16="http://schemas.microsoft.com/office/drawing/2014/main" id="{BD6A9EC6-68A6-0B1C-3674-E1362F97DE7A}"/>
+              </a:ext>
+            </a:extLst>
+          </p:cNvPr>
           <p:cNvSpPr/>
           <p:nvPr/>
         </p:nvSpPr>
         <p:spPr>
           <a:xfrm>
-            <a:off x="3749039" y="2487168"/>
-            <a:ext cx="2514600" cy="1097280"/>
+            <a:off x="5621424" y="1923163"/>
+            <a:ext cx="2286000" cy="914400"/>
           </a:xfrm>
           <a:prstGeom prst="roundRect">
             <a:avLst>
@@ -3658,56 +3681,134 @@
           </a:fontRef>
         </p:style>
         <p:txBody>
-          <a:bodyPr rtlCol="0" anchor="ctr" wrap="square" lIns="54864" rIns="54864" tIns="27432" bIns="27432"/>
+          <a:bodyPr wrap="square" lIns="54865" tIns="27432" rIns="54865" bIns="27432" rtlCol="0" anchor="ctr"/>
           <a:lstStyle/>
           <a:p>
             <a:pPr algn="ctr"/>
             <a:r>
-              <a:rPr sz="1100" b="1">
+              <a:rPr lang="en-US" sz="1200" b="1" dirty="0">
                 <a:solidFill>
                   <a:srgbClr val="843C0C"/>
                 </a:solidFill>
                 <a:latin typeface="Calibri"/>
               </a:rPr>
-              <a:t>Uncollided fluence</a:t>
-            </a:r>
+              <a:t>First-order scatter source </a:t>
+            </a:r>
+            <a:r>
+              <a:rPr lang="el-GR" sz="1200" b="1" dirty="0">
+                <a:solidFill>
+                  <a:srgbClr val="843C0C"/>
+                </a:solidFill>
+              </a:rPr>
+              <a:t>φ</a:t>
+            </a:r>
+            <a:r>
+              <a:rPr lang="en-US" sz="1200" b="1" baseline="-25000" dirty="0">
+                <a:solidFill>
+                  <a:srgbClr val="843C0C"/>
+                </a:solidFill>
+              </a:rPr>
+              <a:t>1</a:t>
+            </a:r>
+            <a:r>
+              <a:rPr lang="en-US" sz="1200" b="1" baseline="30000" dirty="0">
+                <a:solidFill>
+                  <a:srgbClr val="843C0C"/>
+                </a:solidFill>
+              </a:rPr>
+              <a:t>(k)</a:t>
+            </a:r>
+            <a:r>
+              <a:rPr lang="en-US" sz="1200" b="1" dirty="0">
+                <a:solidFill>
+                  <a:srgbClr val="843C0C"/>
+                </a:solidFill>
+                <a:latin typeface="Calibri"/>
+              </a:rPr>
+              <a:t> </a:t>
+            </a:r>
+            <a:endParaRPr sz="1200" b="1" dirty="0">
+              <a:solidFill>
+                <a:srgbClr val="843C0C"/>
+              </a:solidFill>
+              <a:latin typeface="Calibri"/>
+            </a:endParaRPr>
           </a:p>
           <a:p>
             <a:pPr algn="ctr"/>
             <a:r>
-              <a:rPr sz="1100" b="0">
+              <a:rPr lang="en-US" sz="1100" dirty="0">
                 <a:solidFill>
                   <a:srgbClr val="843C0C"/>
                 </a:solidFill>
                 <a:latin typeface="Calibri"/>
               </a:rPr>
-              <a:t>and first-collision source</a:t>
-            </a:r>
-          </a:p>
-          <a:p>
-            <a:pPr algn="ctr"/>
-            <a:r>
-              <a:rPr sz="1100" b="0">
+              <a:t>Computed from </a:t>
+            </a:r>
+            <a:r>
+              <a:rPr sz="1100" dirty="0">
                 <a:solidFill>
                   <a:srgbClr val="843C0C"/>
                 </a:solidFill>
                 <a:latin typeface="Calibri"/>
               </a:rPr>
-              <a:t>φ₁⁽ᵏ⁾ of the densities ρ(Xₖ)</a:t>
-            </a:r>
-          </a:p>
-        </p:txBody>
-      </p:sp>
-      <p:sp>
-        <p:nvSpPr>
-          <p:cNvPr id="12" name="Rounded Rectangle 11"/>
+              <a:t>the </a:t>
+            </a:r>
+            <a:r>
+              <a:rPr lang="en-US" sz="1100" dirty="0">
+                <a:solidFill>
+                  <a:srgbClr val="843C0C"/>
+                </a:solidFill>
+                <a:latin typeface="Calibri"/>
+              </a:rPr>
+              <a:t>current iteration’s </a:t>
+            </a:r>
+            <a:r>
+              <a:rPr sz="1100" dirty="0">
+                <a:solidFill>
+                  <a:srgbClr val="843C0C"/>
+                </a:solidFill>
+                <a:latin typeface="Calibri"/>
+              </a:rPr>
+              <a:t>densities ρ(X</a:t>
+            </a:r>
+            <a:r>
+              <a:rPr lang="en-US" sz="1100" baseline="-25000" dirty="0">
+                <a:solidFill>
+                  <a:srgbClr val="843C0C"/>
+                </a:solidFill>
+                <a:latin typeface="Calibri"/>
+              </a:rPr>
+              <a:t>k</a:t>
+            </a:r>
+            <a:r>
+              <a:rPr sz="1100" dirty="0">
+                <a:solidFill>
+                  <a:srgbClr val="843C0C"/>
+                </a:solidFill>
+                <a:latin typeface="Calibri"/>
+              </a:rPr>
+              <a:t>)</a:t>
+            </a:r>
+          </a:p>
+        </p:txBody>
+      </p:sp>
+      <p:sp>
+        <p:nvSpPr>
+          <p:cNvPr id="190" name="Rounded Rectangle 12">
+            <a:extLst>
+              <a:ext uri="{FF2B5EF4-FFF2-40B4-BE49-F238E27FC236}">
+                <a16:creationId xmlns:a16="http://schemas.microsoft.com/office/drawing/2014/main" id="{82ECFF69-E2FC-9ED2-B01C-A4A8981ACE64}"/>
+              </a:ext>
+            </a:extLst>
+          </p:cNvPr>
           <p:cNvSpPr/>
           <p:nvPr/>
         </p:nvSpPr>
         <p:spPr>
           <a:xfrm>
-            <a:off x="6537960" y="2487168"/>
-            <a:ext cx="2697480" cy="1097280"/>
+            <a:off x="11154630" y="1920892"/>
+            <a:ext cx="2057400" cy="914400"/>
           </a:xfrm>
           <a:prstGeom prst="roundRect">
             <a:avLst>
@@ -3739,56 +3840,152 @@
           </a:fontRef>
         </p:style>
         <p:txBody>
-          <a:bodyPr rtlCol="0" anchor="ctr" wrap="square" lIns="54864" rIns="54864" tIns="27432" bIns="27432"/>
+          <a:bodyPr wrap="square" lIns="54865" tIns="27432" rIns="54865" bIns="27432" rtlCol="0" anchor="ctr"/>
           <a:lstStyle/>
           <a:p>
             <a:pPr algn="ctr"/>
             <a:r>
-              <a:rPr sz="1000" b="1">
+              <a:rPr sz="1100" b="1" dirty="0">
                 <a:solidFill>
                   <a:srgbClr val="843C0C"/>
                 </a:solidFill>
                 <a:latin typeface="Calibri"/>
               </a:rPr>
-              <a:t>One transport sweep Gₖ</a:t>
+              <a:t>Collapsed-cone projection</a:t>
             </a:r>
           </a:p>
           <a:p>
             <a:pPr algn="ctr"/>
             <a:r>
-              <a:rPr sz="1000" b="0">
+              <a:rPr sz="1100" dirty="0">
                 <a:solidFill>
                   <a:srgbClr val="843C0C"/>
                 </a:solidFill>
                 <a:latin typeface="Calibri"/>
               </a:rPr>
-              <a:t>over φ₁⁽ᵏ⁾ + the aged accumulator</a:t>
+              <a:t>of the scatter emission</a:t>
             </a:r>
           </a:p>
           <a:p>
             <a:pPr algn="ctr"/>
             <a:r>
-              <a:rPr sz="1000" b="0">
+              <a:rPr sz="1100" dirty="0">
                 <a:solidFill>
                   <a:srgbClr val="843C0C"/>
                 </a:solidFill>
                 <a:latin typeface="Calibri"/>
               </a:rPr>
-              <a:t>Φᵥ⁽ᵏ⁻¹⁾  →  Φᵥ⁽ᵏ⁾ (all collision orders)</a:t>
-            </a:r>
-          </a:p>
-        </p:txBody>
-      </p:sp>
-      <p:sp>
-        <p:nvSpPr>
-          <p:cNvPr id="13" name="Rounded Rectangle 12"/>
+              <a:t>to the panel → sᵥ</a:t>
+            </a:r>
+          </a:p>
+        </p:txBody>
+      </p:sp>
+      <p:cxnSp>
+        <p:nvCxnSpPr>
+          <p:cNvPr id="191" name="Connector 13">
+            <a:extLst>
+              <a:ext uri="{FF2B5EF4-FFF2-40B4-BE49-F238E27FC236}">
+                <a16:creationId xmlns:a16="http://schemas.microsoft.com/office/drawing/2014/main" id="{7EF8C806-5757-E7FD-9734-0A7442066896}"/>
+              </a:ext>
+            </a:extLst>
+          </p:cNvPr>
+          <p:cNvCxnSpPr>
+            <a:cxnSpLocks/>
+          </p:cNvCxnSpPr>
+          <p:nvPr/>
+        </p:nvCxnSpPr>
+        <p:spPr>
+          <a:xfrm flipV="1">
+            <a:off x="7907425" y="2283443"/>
+            <a:ext cx="365853" cy="3160"/>
+          </a:xfrm>
+          <a:prstGeom prst="line">
+            <a:avLst/>
+          </a:prstGeom>
+          <a:ln w="19050">
+            <a:solidFill>
+              <a:srgbClr val="C55A11"/>
+            </a:solidFill>
+            <a:tailEnd type="triangle" w="med" len="med"/>
+          </a:ln>
+        </p:spPr>
+        <p:style>
+          <a:lnRef idx="2">
+            <a:schemeClr val="accent1"/>
+          </a:lnRef>
+          <a:fillRef idx="0">
+            <a:schemeClr val="accent1"/>
+          </a:fillRef>
+          <a:effectRef idx="1">
+            <a:schemeClr val="accent1"/>
+          </a:effectRef>
+          <a:fontRef idx="minor">
+            <a:schemeClr val="tx1"/>
+          </a:fontRef>
+        </p:style>
+      </p:cxnSp>
+      <p:cxnSp>
+        <p:nvCxnSpPr>
+          <p:cNvPr id="192" name="Connector 14">
+            <a:extLst>
+              <a:ext uri="{FF2B5EF4-FFF2-40B4-BE49-F238E27FC236}">
+                <a16:creationId xmlns:a16="http://schemas.microsoft.com/office/drawing/2014/main" id="{EF004CC8-528B-0A8B-6FA0-8F2028A31DE5}"/>
+              </a:ext>
+            </a:extLst>
+          </p:cNvPr>
+          <p:cNvCxnSpPr>
+            <a:cxnSpLocks/>
+            <a:stCxn id="193" idx="3"/>
+            <a:endCxn id="190" idx="1"/>
+          </p:cNvCxnSpPr>
+          <p:nvPr/>
+        </p:nvCxnSpPr>
+        <p:spPr>
+          <a:xfrm>
+            <a:off x="10787877" y="2377205"/>
+            <a:ext cx="366754" cy="889"/>
+          </a:xfrm>
+          <a:prstGeom prst="line">
+            <a:avLst/>
+          </a:prstGeom>
+          <a:ln w="19050">
+            <a:solidFill>
+              <a:srgbClr val="C55A11"/>
+            </a:solidFill>
+            <a:tailEnd type="triangle" w="med" len="med"/>
+          </a:ln>
+        </p:spPr>
+        <p:style>
+          <a:lnRef idx="2">
+            <a:schemeClr val="accent1"/>
+          </a:lnRef>
+          <a:fillRef idx="0">
+            <a:schemeClr val="accent1"/>
+          </a:fillRef>
+          <a:effectRef idx="1">
+            <a:schemeClr val="accent1"/>
+          </a:effectRef>
+          <a:fontRef idx="minor">
+            <a:schemeClr val="tx1"/>
+          </a:fontRef>
+        </p:style>
+      </p:cxnSp>
+      <p:sp>
+        <p:nvSpPr>
+          <p:cNvPr id="193" name="Rounded Rectangle 11">
+            <a:extLst>
+              <a:ext uri="{FF2B5EF4-FFF2-40B4-BE49-F238E27FC236}">
+                <a16:creationId xmlns:a16="http://schemas.microsoft.com/office/drawing/2014/main" id="{C4A7FC6F-EAE7-A217-3A8F-230A40748967}"/>
+              </a:ext>
+            </a:extLst>
+          </p:cNvPr>
           <p:cNvSpPr/>
           <p:nvPr/>
         </p:nvSpPr>
         <p:spPr>
           <a:xfrm>
-            <a:off x="9509760" y="2487168"/>
-            <a:ext cx="2148840" cy="1097280"/>
+            <a:off x="8273276" y="1920003"/>
+            <a:ext cx="2514600" cy="914400"/>
           </a:xfrm>
           <a:prstGeom prst="roundRect">
             <a:avLst>
@@ -3820,65 +4017,248 @@
           </a:fontRef>
         </p:style>
         <p:txBody>
-          <a:bodyPr rtlCol="0" anchor="ctr" wrap="square" lIns="54864" rIns="54864" tIns="27432" bIns="27432"/>
+          <a:bodyPr wrap="square" lIns="54865" tIns="27432" rIns="54865" bIns="27432" rtlCol="0" anchor="ctr"/>
           <a:lstStyle/>
           <a:p>
             <a:pPr algn="ctr"/>
             <a:r>
-              <a:rPr sz="1000" b="1">
+              <a:rPr sz="1200" b="1" dirty="0">
                 <a:solidFill>
                   <a:srgbClr val="843C0C"/>
                 </a:solidFill>
                 <a:latin typeface="Calibri"/>
               </a:rPr>
-              <a:t>Collapsed-cone projection</a:t>
-            </a:r>
+              <a:t>One </a:t>
+            </a:r>
+            <a:r>
+              <a:rPr lang="en-US" sz="1200" b="1" dirty="0">
+                <a:solidFill>
+                  <a:srgbClr val="843C0C"/>
+                </a:solidFill>
+                <a:latin typeface="Calibri"/>
+              </a:rPr>
+              <a:t>scatter source iteration</a:t>
+            </a:r>
+            <a:endParaRPr sz="1200" b="1" dirty="0">
+              <a:solidFill>
+                <a:srgbClr val="843C0C"/>
+              </a:solidFill>
+              <a:latin typeface="Calibri"/>
+            </a:endParaRPr>
           </a:p>
           <a:p>
             <a:pPr algn="ctr"/>
             <a:r>
-              <a:rPr sz="1000" b="0">
+              <a:rPr sz="1100" dirty="0">
                 <a:solidFill>
                   <a:srgbClr val="843C0C"/>
                 </a:solidFill>
                 <a:latin typeface="Calibri"/>
               </a:rPr>
-              <a:t>of the scatter emission</a:t>
-            </a:r>
+              <a:t>over φ</a:t>
+            </a:r>
+            <a:r>
+              <a:rPr lang="en-US" sz="1100" baseline="-25000" dirty="0">
+                <a:solidFill>
+                  <a:srgbClr val="843C0C"/>
+                </a:solidFill>
+                <a:latin typeface="Calibri"/>
+              </a:rPr>
+              <a:t>1</a:t>
+            </a:r>
+            <a:r>
+              <a:rPr lang="en-US" sz="1100" baseline="30000" dirty="0">
+                <a:solidFill>
+                  <a:srgbClr val="843C0C"/>
+                </a:solidFill>
+                <a:latin typeface="Calibri"/>
+              </a:rPr>
+              <a:t>(k)</a:t>
+            </a:r>
+            <a:r>
+              <a:rPr sz="1100" dirty="0">
+                <a:solidFill>
+                  <a:srgbClr val="843C0C"/>
+                </a:solidFill>
+                <a:latin typeface="Calibri"/>
+              </a:rPr>
+              <a:t> + the </a:t>
+            </a:r>
+            <a:r>
+              <a:rPr lang="en-US" sz="1100" dirty="0">
+                <a:solidFill>
+                  <a:srgbClr val="843C0C"/>
+                </a:solidFill>
+                <a:latin typeface="Calibri"/>
+              </a:rPr>
+              <a:t>prior iteration’s higher-order scatter</a:t>
+            </a:r>
+            <a:endParaRPr sz="1100" dirty="0">
+              <a:solidFill>
+                <a:srgbClr val="843C0C"/>
+              </a:solidFill>
+              <a:latin typeface="Calibri"/>
+            </a:endParaRPr>
           </a:p>
           <a:p>
             <a:pPr algn="ctr"/>
             <a:r>
-              <a:rPr sz="1000" b="0">
+              <a:rPr lang="en-US" sz="1100" dirty="0">
                 <a:solidFill>
                   <a:srgbClr val="843C0C"/>
                 </a:solidFill>
+              </a:rPr>
+              <a:t>G</a:t>
+            </a:r>
+            <a:r>
+              <a:rPr lang="en-US" sz="1100" baseline="-25000" dirty="0">
+                <a:solidFill>
+                  <a:srgbClr val="843C0C"/>
+                </a:solidFill>
+              </a:rPr>
+              <a:t>k</a:t>
+            </a:r>
+            <a:r>
+              <a:rPr lang="en-US" sz="1100" dirty="0">
+                <a:solidFill>
+                  <a:srgbClr val="843C0C"/>
+                </a:solidFill>
+              </a:rPr>
+              <a:t>(</a:t>
+            </a:r>
+            <a:r>
+              <a:rPr lang="el-GR" sz="1100" dirty="0">
+                <a:solidFill>
+                  <a:srgbClr val="843C0C"/>
+                </a:solidFill>
+              </a:rPr>
+              <a:t>φ</a:t>
+            </a:r>
+            <a:r>
+              <a:rPr lang="en-US" sz="1100" baseline="-25000" dirty="0">
+                <a:solidFill>
+                  <a:srgbClr val="843C0C"/>
+                </a:solidFill>
+              </a:rPr>
+              <a:t>1</a:t>
+            </a:r>
+            <a:r>
+              <a:rPr lang="en-US" sz="1100" baseline="30000" dirty="0">
+                <a:solidFill>
+                  <a:srgbClr val="843C0C"/>
+                </a:solidFill>
+              </a:rPr>
+              <a:t>(k)</a:t>
+            </a:r>
+            <a:r>
+              <a:rPr lang="en-US" sz="1100" dirty="0">
+                <a:solidFill>
+                  <a:srgbClr val="843C0C"/>
+                </a:solidFill>
+              </a:rPr>
+              <a:t> + </a:t>
+            </a:r>
+            <a:r>
+              <a:rPr lang="el-GR" sz="1100" dirty="0">
+                <a:solidFill>
+                  <a:srgbClr val="843C0C"/>
+                </a:solidFill>
+              </a:rPr>
+              <a:t>φ</a:t>
+            </a:r>
+            <a:r>
+              <a:rPr lang="en-US" sz="1100" baseline="-25000" dirty="0">
+                <a:solidFill>
+                  <a:srgbClr val="843C0C"/>
+                </a:solidFill>
+              </a:rPr>
+              <a:t>&gt;1</a:t>
+            </a:r>
+            <a:r>
+              <a:rPr lang="en-US" sz="1100" baseline="30000" dirty="0">
+                <a:solidFill>
+                  <a:srgbClr val="843C0C"/>
+                </a:solidFill>
+              </a:rPr>
+              <a:t>(k-1)</a:t>
+            </a:r>
+            <a:r>
+              <a:rPr lang="en-US" sz="1100" dirty="0">
+                <a:solidFill>
+                  <a:srgbClr val="843C0C"/>
+                </a:solidFill>
                 <a:latin typeface="Calibri"/>
               </a:rPr>
-              <a:t>to the panel → sᵥ</a:t>
-            </a:r>
+              <a:t>)</a:t>
+            </a:r>
+            <a:r>
+              <a:rPr sz="1100" dirty="0">
+                <a:solidFill>
+                  <a:srgbClr val="843C0C"/>
+                </a:solidFill>
+                <a:latin typeface="Calibri"/>
+              </a:rPr>
+              <a:t> → </a:t>
+            </a:r>
+            <a:r>
+              <a:rPr lang="el-GR" sz="1100" dirty="0">
+                <a:solidFill>
+                  <a:srgbClr val="843C0C"/>
+                </a:solidFill>
+              </a:rPr>
+              <a:t>φ</a:t>
+            </a:r>
+            <a:r>
+              <a:rPr lang="en-US" sz="1100" baseline="-25000" dirty="0">
+                <a:solidFill>
+                  <a:srgbClr val="843C0C"/>
+                </a:solidFill>
+              </a:rPr>
+              <a:t>&gt;1</a:t>
+            </a:r>
+            <a:r>
+              <a:rPr lang="en-US" sz="1100" baseline="30000" dirty="0">
+                <a:solidFill>
+                  <a:srgbClr val="843C0C"/>
+                </a:solidFill>
+              </a:rPr>
+              <a:t>(k)</a:t>
+            </a:r>
+            <a:endParaRPr sz="1100" dirty="0">
+              <a:solidFill>
+                <a:srgbClr val="843C0C"/>
+              </a:solidFill>
+              <a:latin typeface="Calibri"/>
+            </a:endParaRPr>
           </a:p>
         </p:txBody>
       </p:sp>
       <p:cxnSp>
         <p:nvCxnSpPr>
-          <p:cNvPr id="14" name="Connector 13"/>
-          <p:cNvCxnSpPr/>
+          <p:cNvPr id="194" name="Connector 15">
+            <a:extLst>
+              <a:ext uri="{FF2B5EF4-FFF2-40B4-BE49-F238E27FC236}">
+                <a16:creationId xmlns:a16="http://schemas.microsoft.com/office/drawing/2014/main" id="{0408D842-82CC-805D-832E-C80300C4DE9A}"/>
+              </a:ext>
+            </a:extLst>
+          </p:cNvPr>
+          <p:cNvCxnSpPr>
+            <a:cxnSpLocks/>
+          </p:cNvCxnSpPr>
           <p:nvPr/>
         </p:nvCxnSpPr>
         <p:spPr>
           <a:xfrm>
-            <a:off x="6263639" y="3035808"/>
-            <a:ext cx="274321" cy="0"/>
+            <a:off x="10949405" y="2380364"/>
+            <a:ext cx="0" cy="736610"/>
           </a:xfrm>
           <a:prstGeom prst="line">
             <a:avLst/>
           </a:prstGeom>
           <a:ln w="19050">
             <a:solidFill>
-              <a:srgbClr val="595959"/>
+              <a:srgbClr val="C55A11"/>
             </a:solidFill>
-            <a:tailEnd type="triangle" w="med" len="med"/>
           </a:ln>
         </p:spPr>
         <p:style>
@@ -3898,23 +4278,30 @@
       </p:cxnSp>
       <p:cxnSp>
         <p:nvCxnSpPr>
-          <p:cNvPr id="15" name="Connector 14"/>
-          <p:cNvCxnSpPr/>
+          <p:cNvPr id="195" name="Connector 16">
+            <a:extLst>
+              <a:ext uri="{FF2B5EF4-FFF2-40B4-BE49-F238E27FC236}">
+                <a16:creationId xmlns:a16="http://schemas.microsoft.com/office/drawing/2014/main" id="{566F58FB-1FB7-F3BE-1021-B92AE2FEDD9D}"/>
+              </a:ext>
+            </a:extLst>
+          </p:cNvPr>
+          <p:cNvCxnSpPr>
+            <a:cxnSpLocks/>
+          </p:cNvCxnSpPr>
           <p:nvPr/>
         </p:nvCxnSpPr>
         <p:spPr>
-          <a:xfrm>
-            <a:off x="9235440" y="3035808"/>
-            <a:ext cx="274320" cy="0"/>
+          <a:xfrm flipH="1">
+            <a:off x="8070280" y="3116973"/>
+            <a:ext cx="2882204" cy="0"/>
           </a:xfrm>
           <a:prstGeom prst="line">
             <a:avLst/>
           </a:prstGeom>
           <a:ln w="19050">
             <a:solidFill>
-              <a:srgbClr val="595959"/>
+              <a:srgbClr val="C55A11"/>
             </a:solidFill>
-            <a:tailEnd type="triangle" w="med" len="med"/>
           </a:ln>
         </p:spPr>
         <p:style>
@@ -3932,122 +4319,22 @@
           </a:fontRef>
         </p:style>
       </p:cxnSp>
-      <p:cxnSp>
-        <p:nvCxnSpPr>
-          <p:cNvPr id="16" name="Connector 15"/>
-          <p:cNvCxnSpPr/>
-          <p:nvPr/>
-        </p:nvCxnSpPr>
-        <p:spPr>
-          <a:xfrm>
-            <a:off x="8983980" y="3584448"/>
-            <a:ext cx="0" cy="292608"/>
-          </a:xfrm>
-          <a:prstGeom prst="line">
-            <a:avLst/>
-          </a:prstGeom>
-          <a:ln w="38100">
-            <a:solidFill>
-              <a:srgbClr val="C55A11"/>
-            </a:solidFill>
-          </a:ln>
-        </p:spPr>
-        <p:style>
-          <a:lnRef idx="2">
-            <a:schemeClr val="accent1"/>
-          </a:lnRef>
-          <a:fillRef idx="0">
-            <a:schemeClr val="accent1"/>
-          </a:fillRef>
-          <a:effectRef idx="1">
-            <a:schemeClr val="accent1"/>
-          </a:effectRef>
-          <a:fontRef idx="minor">
-            <a:schemeClr val="tx1"/>
-          </a:fontRef>
-        </p:style>
-      </p:cxnSp>
-      <p:cxnSp>
-        <p:nvCxnSpPr>
-          <p:cNvPr id="17" name="Connector 16"/>
-          <p:cNvCxnSpPr/>
-          <p:nvPr/>
-        </p:nvCxnSpPr>
-        <p:spPr>
-          <a:xfrm flipH="1">
-            <a:off x="6789420" y="3877056"/>
-            <a:ext cx="2194560" cy="0"/>
-          </a:xfrm>
-          <a:prstGeom prst="line">
-            <a:avLst/>
-          </a:prstGeom>
-          <a:ln w="38100">
-            <a:solidFill>
-              <a:srgbClr val="C55A11"/>
-            </a:solidFill>
-          </a:ln>
-        </p:spPr>
-        <p:style>
-          <a:lnRef idx="2">
-            <a:schemeClr val="accent1"/>
-          </a:lnRef>
-          <a:fillRef idx="0">
-            <a:schemeClr val="accent1"/>
-          </a:fillRef>
-          <a:effectRef idx="1">
-            <a:schemeClr val="accent1"/>
-          </a:effectRef>
-          <a:fontRef idx="minor">
-            <a:schemeClr val="tx1"/>
-          </a:fontRef>
-        </p:style>
-      </p:cxnSp>
-      <p:cxnSp>
-        <p:nvCxnSpPr>
-          <p:cNvPr id="18" name="Connector 17"/>
-          <p:cNvCxnSpPr/>
-          <p:nvPr/>
-        </p:nvCxnSpPr>
-        <p:spPr>
-          <a:xfrm flipV="1">
-            <a:off x="6789420" y="3602736"/>
-            <a:ext cx="0" cy="274320"/>
-          </a:xfrm>
-          <a:prstGeom prst="line">
-            <a:avLst/>
-          </a:prstGeom>
-          <a:ln w="38100">
-            <a:solidFill>
-              <a:srgbClr val="C55A11"/>
-            </a:solidFill>
-            <a:tailEnd type="triangle" w="med" len="med"/>
-          </a:ln>
-        </p:spPr>
-        <p:style>
-          <a:lnRef idx="2">
-            <a:schemeClr val="accent1"/>
-          </a:lnRef>
-          <a:fillRef idx="0">
-            <a:schemeClr val="accent1"/>
-          </a:fillRef>
-          <a:effectRef idx="1">
-            <a:schemeClr val="accent1"/>
-          </a:effectRef>
-          <a:fontRef idx="minor">
-            <a:schemeClr val="tx1"/>
-          </a:fontRef>
-        </p:style>
-      </p:cxnSp>
-      <p:sp>
-        <p:nvSpPr>
-          <p:cNvPr id="19" name="TextBox 18"/>
+      <p:sp>
+        <p:nvSpPr>
+          <p:cNvPr id="196" name="TextBox 195">
+            <a:extLst>
+              <a:ext uri="{FF2B5EF4-FFF2-40B4-BE49-F238E27FC236}">
+                <a16:creationId xmlns:a16="http://schemas.microsoft.com/office/drawing/2014/main" id="{6D8D6E4C-EC31-34F9-3F92-6523CADE95E3}"/>
+              </a:ext>
+            </a:extLst>
+          </p:cNvPr>
           <p:cNvSpPr txBox="1"/>
           <p:nvPr/>
         </p:nvSpPr>
         <p:spPr>
           <a:xfrm>
-            <a:off x="3703320" y="3913632"/>
-            <a:ext cx="7863840" cy="274320"/>
+            <a:off x="10320580" y="2905213"/>
+            <a:ext cx="583105" cy="169277"/>
           </a:xfrm>
           <a:prstGeom prst="rect">
             <a:avLst/>
@@ -4055,34 +4342,64 @@
           <a:noFill/>
         </p:spPr>
         <p:txBody>
-          <a:bodyPr wrap="square" lIns="18288" rIns="18288" tIns="0" bIns="0">
+          <a:bodyPr wrap="square" lIns="18288" tIns="0" rIns="18288" bIns="0">
             <a:spAutoFit/>
           </a:bodyPr>
           <a:lstStyle/>
           <a:p>
-            <a:pPr algn="l"/>
-            <a:r>
-              <a:rPr sz="1050" b="1" i="0">
+            <a:pPr algn="r"/>
+            <a:r>
+              <a:rPr lang="el-GR" sz="1100" dirty="0">
                 <a:solidFill>
                   <a:srgbClr val="843C0C"/>
                 </a:solidFill>
+              </a:rPr>
+              <a:t>φ</a:t>
+            </a:r>
+            <a:r>
+              <a:rPr lang="en-US" sz="1100" baseline="-25000" dirty="0">
+                <a:solidFill>
+                  <a:srgbClr val="843C0C"/>
+                </a:solidFill>
+              </a:rPr>
+              <a:t>&gt;1</a:t>
+            </a:r>
+            <a:r>
+              <a:rPr lang="en-US" sz="1100" baseline="30000" dirty="0">
+                <a:solidFill>
+                  <a:srgbClr val="843C0C"/>
+                </a:solidFill>
+              </a:rPr>
+              <a:t>(k)</a:t>
+            </a:r>
+            <a:r>
+              <a:rPr sz="1100" dirty="0">
+                <a:solidFill>
+                  <a:srgbClr val="843C0C"/>
+                </a:solidFill>
                 <a:latin typeface="Calibri"/>
               </a:rPr>
-              <a:t>Age-ordered recursion:   Φᵥ⁽ᵏ⁾ = Gₖ φ₁⁽ᵏ⁾ + Gₖ Φᵥ⁽ᵏ⁻¹⁾      (Φᵥ kept per view across outer iterations)</a:t>
-            </a:r>
-          </a:p>
-        </p:txBody>
-      </p:sp>
-      <p:sp>
-        <p:nvSpPr>
-          <p:cNvPr id="20" name="TextBox 19"/>
+              <a:t> out</a:t>
+            </a:r>
+          </a:p>
+        </p:txBody>
+      </p:sp>
+      <p:sp>
+        <p:nvSpPr>
+          <p:cNvPr id="197" name="TextBox 196">
+            <a:extLst>
+              <a:ext uri="{FF2B5EF4-FFF2-40B4-BE49-F238E27FC236}">
+                <a16:creationId xmlns:a16="http://schemas.microsoft.com/office/drawing/2014/main" id="{62FCACCD-4CCF-631F-798D-50A56C42147C}"/>
+              </a:ext>
+            </a:extLst>
+          </p:cNvPr>
           <p:cNvSpPr txBox="1"/>
           <p:nvPr/>
         </p:nvSpPr>
         <p:spPr>
           <a:xfrm>
-            <a:off x="3703320" y="4133087"/>
-            <a:ext cx="7863840" cy="182880"/>
+            <a:off x="8112925" y="2905210"/>
+            <a:ext cx="583105" cy="169277"/>
           </a:xfrm>
           <a:prstGeom prst="rect">
             <a:avLst/>
@@ -4090,104 +4407,70 @@
           <a:noFill/>
         </p:spPr>
         <p:txBody>
-          <a:bodyPr wrap="square" lIns="18288" rIns="18288" tIns="0" bIns="0">
+          <a:bodyPr wrap="square" lIns="18288" tIns="0" rIns="18288" bIns="0">
             <a:spAutoFit/>
           </a:bodyPr>
           <a:lstStyle/>
           <a:p>
-            <a:pPr algn="l"/>
-            <a:r>
-              <a:rPr sz="900" b="0" i="1">
+            <a:r>
+              <a:rPr lang="el-GR" sz="1100" dirty="0">
                 <a:solidFill>
                   <a:srgbClr val="843C0C"/>
                 </a:solidFill>
-                <a:latin typeface="Calibri"/>
-              </a:rPr>
-              <a:t>= Gₖ φ₁⁽ᵏ⁾ + GₖGₖ₋₁ φ₁⁽ᵏ⁻¹⁾ + GₖGₖ₋₁Gₖ₋₂ φ₁⁽ᵏ⁻²⁾ + … :  2nd order from Xₖ, 3rd from Xₖ₋₁, …  (low orders refreshed first)</a:t>
-            </a:r>
-          </a:p>
-        </p:txBody>
-      </p:sp>
-      <p:sp>
-        <p:nvSpPr>
-          <p:cNvPr id="21" name="TextBox 20"/>
-          <p:cNvSpPr txBox="1"/>
-          <p:nvPr/>
-        </p:nvSpPr>
-        <p:spPr>
-          <a:xfrm>
-            <a:off x="9029700" y="3657600"/>
-            <a:ext cx="1463040" cy="182880"/>
-          </a:xfrm>
-          <a:prstGeom prst="rect">
-            <a:avLst/>
-          </a:prstGeom>
-          <a:noFill/>
-        </p:spPr>
-        <p:txBody>
-          <a:bodyPr wrap="square" lIns="18288" rIns="18288" tIns="0" bIns="0">
-            <a:spAutoFit/>
-          </a:bodyPr>
-          <a:lstStyle/>
-          <a:p>
-            <a:pPr algn="l"/>
-            <a:r>
-              <a:rPr sz="900" b="0" i="1">
+              </a:rPr>
+              <a:t>φ</a:t>
+            </a:r>
+            <a:r>
+              <a:rPr lang="el-GR" sz="1100" baseline="-25000" dirty="0">
                 <a:solidFill>
                   <a:srgbClr val="843C0C"/>
                 </a:solidFill>
-                <a:latin typeface="Calibri"/>
-              </a:rPr>
-              <a:t>Φᵥ⁽ᵏ⁾ out</a:t>
-            </a:r>
-          </a:p>
-        </p:txBody>
-      </p:sp>
-      <p:sp>
-        <p:nvSpPr>
-          <p:cNvPr id="22" name="TextBox 21"/>
-          <p:cNvSpPr txBox="1"/>
-          <p:nvPr/>
-        </p:nvSpPr>
-        <p:spPr>
-          <a:xfrm>
-            <a:off x="6012180" y="3657600"/>
-            <a:ext cx="731520" cy="182880"/>
-          </a:xfrm>
-          <a:prstGeom prst="rect">
-            <a:avLst/>
-          </a:prstGeom>
-          <a:noFill/>
-        </p:spPr>
-        <p:txBody>
-          <a:bodyPr wrap="square" lIns="18288" rIns="18288" tIns="0" bIns="0">
-            <a:spAutoFit/>
-          </a:bodyPr>
-          <a:lstStyle/>
-          <a:p>
-            <a:pPr algn="r"/>
-            <a:r>
-              <a:rPr sz="900" b="0" i="1">
+              </a:rPr>
+              <a:t>&gt;1</a:t>
+            </a:r>
+            <a:r>
+              <a:rPr lang="el-GR" sz="1100" baseline="30000" dirty="0">
                 <a:solidFill>
                   <a:srgbClr val="843C0C"/>
                 </a:solidFill>
-                <a:latin typeface="Calibri"/>
-              </a:rPr>
-              <a:t>Φᵥ⁽ᵏ⁻¹⁾ in</a:t>
-            </a:r>
-          </a:p>
-        </p:txBody>
-      </p:sp>
-      <p:sp>
-        <p:nvSpPr>
-          <p:cNvPr id="23" name="Rounded Rectangle 22"/>
+              </a:rPr>
+              <a:t>(</a:t>
+            </a:r>
+            <a:r>
+              <a:rPr lang="en-US" sz="1100" baseline="30000" dirty="0">
+                <a:solidFill>
+                  <a:srgbClr val="843C0C"/>
+                </a:solidFill>
+              </a:rPr>
+              <a:t>k-1)</a:t>
+            </a:r>
+            <a:r>
+              <a:rPr lang="en-US" sz="1100" dirty="0">
+                <a:solidFill>
+                  <a:srgbClr val="843C0C"/>
+                </a:solidFill>
+              </a:rPr>
+              <a:t> in</a:t>
+            </a:r>
+          </a:p>
+        </p:txBody>
+      </p:sp>
+      <p:sp>
+        <p:nvSpPr>
+          <p:cNvPr id="198" name="Rounded Rectangle 22">
+            <a:extLst>
+              <a:ext uri="{FF2B5EF4-FFF2-40B4-BE49-F238E27FC236}">
+                <a16:creationId xmlns:a16="http://schemas.microsoft.com/office/drawing/2014/main" id="{0703DCF6-B17F-43C9-6F28-940044FE8AD7}"/>
+              </a:ext>
+            </a:extLst>
+          </p:cNvPr>
           <p:cNvSpPr/>
           <p:nvPr/>
         </p:nvSpPr>
         <p:spPr>
           <a:xfrm>
-            <a:off x="3200400" y="4617720"/>
-            <a:ext cx="2103120" cy="960120"/>
+            <a:off x="4981345" y="3695902"/>
+            <a:ext cx="1828800" cy="914400"/>
           </a:xfrm>
           <a:prstGeom prst="roundRect">
             <a:avLst>
@@ -4219,56 +4502,77 @@
           </a:fontRef>
         </p:style>
         <p:txBody>
-          <a:bodyPr rtlCol="0" anchor="ctr" wrap="square" lIns="54864" rIns="54864" tIns="27432" bIns="27432"/>
+          <a:bodyPr wrap="square" lIns="54865" tIns="27432" rIns="54865" bIns="27432" rtlCol="0" anchor="ctr"/>
           <a:lstStyle/>
           <a:p>
             <a:pPr algn="ctr"/>
             <a:r>
-              <a:rPr sz="1000" b="1">
+              <a:rPr sz="1200" b="1" dirty="0">
                 <a:solidFill>
                   <a:srgbClr val="3F1F5E"/>
                 </a:solidFill>
                 <a:latin typeface="Calibri"/>
               </a:rPr>
-              <a:t>Primary pᵥ of every view</a:t>
+              <a:t>Primary</a:t>
+            </a:r>
+            <a:r>
+              <a:rPr lang="en-US" sz="1200" b="1" dirty="0">
+                <a:solidFill>
+                  <a:srgbClr val="3F1F5E"/>
+                </a:solidFill>
+                <a:latin typeface="Calibri"/>
+              </a:rPr>
+              <a:t> projections</a:t>
+            </a:r>
+            <a:r>
+              <a:rPr sz="1200" b="1" dirty="0">
+                <a:solidFill>
+                  <a:srgbClr val="3F1F5E"/>
+                </a:solidFill>
+                <a:latin typeface="Calibri"/>
+              </a:rPr>
+              <a:t> pᵥ</a:t>
             </a:r>
           </a:p>
           <a:p>
             <a:pPr algn="ctr"/>
             <a:r>
-              <a:rPr sz="1000" b="0">
+              <a:rPr lang="en-US" sz="1100" dirty="0">
                 <a:solidFill>
                   <a:srgbClr val="3F1F5E"/>
                 </a:solidFill>
                 <a:latin typeface="Calibri"/>
               </a:rPr>
-              <a:t>projection of the densities ρ(Xₖ)</a:t>
-            </a:r>
-          </a:p>
-          <a:p>
-            <a:pPr algn="ctr"/>
-            <a:r>
-              <a:rPr sz="1000" b="0">
+              <a:t>Through the material </a:t>
+            </a:r>
+            <a:r>
+              <a:rPr sz="1100" dirty="0">
                 <a:solidFill>
                   <a:srgbClr val="3F1F5E"/>
                 </a:solidFill>
                 <a:latin typeface="Calibri"/>
               </a:rPr>
-              <a:t>with the spectrum</a:t>
-            </a:r>
-          </a:p>
-        </p:txBody>
-      </p:sp>
-      <p:sp>
-        <p:nvSpPr>
-          <p:cNvPr id="24" name="Rounded Rectangle 23"/>
+              <a:t>densities ρ(Xₖ)</a:t>
+            </a:r>
+          </a:p>
+        </p:txBody>
+      </p:sp>
+      <p:sp>
+        <p:nvSpPr>
+          <p:cNvPr id="199" name="Rounded Rectangle 23">
+            <a:extLst>
+              <a:ext uri="{FF2B5EF4-FFF2-40B4-BE49-F238E27FC236}">
+                <a16:creationId xmlns:a16="http://schemas.microsoft.com/office/drawing/2014/main" id="{6098FCC5-D675-C69D-1ADE-147AFB934F9D}"/>
+              </a:ext>
+            </a:extLst>
+          </p:cNvPr>
           <p:cNvSpPr/>
           <p:nvPr/>
         </p:nvSpPr>
         <p:spPr>
           <a:xfrm>
-            <a:off x="5532120" y="4617720"/>
-            <a:ext cx="2011680" cy="960120"/>
+            <a:off x="7084465" y="3695902"/>
+            <a:ext cx="1828800" cy="914400"/>
           </a:xfrm>
           <a:prstGeom prst="roundRect">
             <a:avLst>
@@ -4300,12 +4604,12 @@
           </a:fontRef>
         </p:style>
         <p:txBody>
-          <a:bodyPr rtlCol="0" anchor="ctr" wrap="square" lIns="54864" rIns="54864" tIns="27432" bIns="27432"/>
+          <a:bodyPr wrap="square" lIns="54865" tIns="27432" rIns="54865" bIns="27432" rtlCol="0" anchor="ctr"/>
           <a:lstStyle/>
           <a:p>
             <a:pPr algn="ctr"/>
             <a:r>
-              <a:rPr sz="1000" b="1">
+              <a:rPr sz="1200" b="1" dirty="0">
                 <a:solidFill>
                   <a:srgbClr val="7F6000"/>
                 </a:solidFill>
@@ -4317,7 +4621,7 @@
           <a:p>
             <a:pPr algn="ctr"/>
             <a:r>
-              <a:rPr sz="1000" b="0">
+              <a:rPr sz="1100" dirty="0">
                 <a:solidFill>
                   <a:srgbClr val="7F6000"/>
                 </a:solidFill>
@@ -4330,14 +4634,20 @@
       </p:sp>
       <p:sp>
         <p:nvSpPr>
-          <p:cNvPr id="25" name="Rounded Rectangle 24"/>
+          <p:cNvPr id="200" name="Rounded Rectangle 24">
+            <a:extLst>
+              <a:ext uri="{FF2B5EF4-FFF2-40B4-BE49-F238E27FC236}">
+                <a16:creationId xmlns:a16="http://schemas.microsoft.com/office/drawing/2014/main" id="{CE0741F0-62A4-3156-E83D-64B9966358C3}"/>
+              </a:ext>
+            </a:extLst>
+          </p:cNvPr>
           <p:cNvSpPr/>
           <p:nvPr/>
         </p:nvSpPr>
         <p:spPr>
           <a:xfrm>
-            <a:off x="7772400" y="4617720"/>
-            <a:ext cx="1828800" cy="960120"/>
+            <a:off x="9187585" y="3695902"/>
+            <a:ext cx="1828800" cy="914400"/>
           </a:xfrm>
           <a:prstGeom prst="roundRect">
             <a:avLst>
@@ -4369,12 +4679,12 @@
           </a:fontRef>
         </p:style>
         <p:txBody>
-          <a:bodyPr rtlCol="0" anchor="ctr" wrap="square" lIns="54864" rIns="54864" tIns="27432" bIns="27432"/>
+          <a:bodyPr wrap="square" lIns="54865" tIns="27432" rIns="54865" bIns="27432" rtlCol="0" anchor="ctr"/>
           <a:lstStyle/>
           <a:p>
             <a:pPr algn="ctr"/>
             <a:r>
-              <a:rPr sz="1000" b="1">
+              <a:rPr sz="1200" b="1" dirty="0">
                 <a:solidFill>
                   <a:srgbClr val="7F6000"/>
                 </a:solidFill>
@@ -4386,7 +4696,7 @@
           <a:p>
             <a:pPr algn="ctr"/>
             <a:r>
-              <a:rPr sz="1000" b="0">
+              <a:rPr sz="1100" dirty="0">
                 <a:solidFill>
                   <a:srgbClr val="7F6000"/>
                 </a:solidFill>
@@ -4399,14 +4709,20 @@
       </p:sp>
       <p:sp>
         <p:nvSpPr>
-          <p:cNvPr id="26" name="Rounded Rectangle 25"/>
+          <p:cNvPr id="201" name="Rounded Rectangle 25">
+            <a:extLst>
+              <a:ext uri="{FF2B5EF4-FFF2-40B4-BE49-F238E27FC236}">
+                <a16:creationId xmlns:a16="http://schemas.microsoft.com/office/drawing/2014/main" id="{6DF8E2E0-9EE7-97B2-0B78-0147221EC6E1}"/>
+              </a:ext>
+            </a:extLst>
+          </p:cNvPr>
           <p:cNvSpPr/>
           <p:nvPr/>
         </p:nvSpPr>
         <p:spPr>
           <a:xfrm>
-            <a:off x="9829800" y="4617720"/>
-            <a:ext cx="1828800" cy="960120"/>
+            <a:off x="11290705" y="3695902"/>
+            <a:ext cx="2057400" cy="914400"/>
           </a:xfrm>
           <a:prstGeom prst="roundRect">
             <a:avLst>
@@ -4438,24 +4754,33 @@
           </a:fontRef>
         </p:style>
         <p:txBody>
-          <a:bodyPr rtlCol="0" anchor="ctr" wrap="square" lIns="54864" rIns="54864" tIns="27432" bIns="27432"/>
+          <a:bodyPr wrap="square" lIns="54865" tIns="27432" rIns="54865" bIns="27432" rtlCol="0" anchor="ctr"/>
           <a:lstStyle/>
           <a:p>
             <a:pPr algn="ctr"/>
             <a:r>
-              <a:rPr sz="1000" b="1">
+              <a:rPr lang="en-US" sz="1200" b="1" dirty="0">
                 <a:solidFill>
                   <a:srgbClr val="1F3864"/>
                 </a:solidFill>
                 <a:latin typeface="Calibri"/>
               </a:rPr>
-              <a:t>n MBIR iterations</a:t>
+              <a:t>One or more </a:t>
+            </a:r>
+            <a:r>
+              <a:rPr sz="1200" b="1" dirty="0">
+                <a:solidFill>
+                  <a:srgbClr val="1F3864"/>
+                </a:solidFill>
+                <a:latin typeface="Calibri"/>
+              </a:rPr>
+              <a:t>MBIR iterations</a:t>
             </a:r>
           </a:p>
           <a:p>
             <a:pPr algn="ctr"/>
             <a:r>
-              <a:rPr sz="1000" b="0">
+              <a:rPr sz="1100" dirty="0">
                 <a:solidFill>
                   <a:srgbClr val="1F3864"/>
                 </a:solidFill>
@@ -4467,7 +4792,7 @@
           <a:p>
             <a:pPr algn="ctr"/>
             <a:r>
-              <a:rPr sz="1000" b="0">
+              <a:rPr sz="1100" dirty="0">
                 <a:solidFill>
                   <a:srgbClr val="1F3864"/>
                 </a:solidFill>
@@ -4480,21 +4805,31 @@
       </p:sp>
       <p:cxnSp>
         <p:nvCxnSpPr>
-          <p:cNvPr id="27" name="Connector 26"/>
-          <p:cNvCxnSpPr/>
+          <p:cNvPr id="202" name="Connector 26">
+            <a:extLst>
+              <a:ext uri="{FF2B5EF4-FFF2-40B4-BE49-F238E27FC236}">
+                <a16:creationId xmlns:a16="http://schemas.microsoft.com/office/drawing/2014/main" id="{7DA12EAB-F4F9-0C17-83F2-E17C35675E07}"/>
+              </a:ext>
+            </a:extLst>
+          </p:cNvPr>
+          <p:cNvCxnSpPr>
+            <a:cxnSpLocks/>
+            <a:stCxn id="198" idx="3"/>
+            <a:endCxn id="199" idx="1"/>
+          </p:cNvCxnSpPr>
           <p:nvPr/>
         </p:nvCxnSpPr>
         <p:spPr>
           <a:xfrm>
-            <a:off x="5303520" y="5097780"/>
-            <a:ext cx="228600" cy="0"/>
+            <a:off x="6810145" y="4153102"/>
+            <a:ext cx="274320" cy="0"/>
           </a:xfrm>
           <a:prstGeom prst="line">
             <a:avLst/>
           </a:prstGeom>
           <a:ln w="19050">
             <a:solidFill>
-              <a:srgbClr val="595959"/>
+              <a:srgbClr val="7030A0"/>
             </a:solidFill>
             <a:tailEnd type="triangle" w="med" len="med"/>
           </a:ln>
@@ -4516,21 +4851,31 @@
       </p:cxnSp>
       <p:cxnSp>
         <p:nvCxnSpPr>
-          <p:cNvPr id="28" name="Connector 27"/>
-          <p:cNvCxnSpPr/>
+          <p:cNvPr id="203" name="Connector 27">
+            <a:extLst>
+              <a:ext uri="{FF2B5EF4-FFF2-40B4-BE49-F238E27FC236}">
+                <a16:creationId xmlns:a16="http://schemas.microsoft.com/office/drawing/2014/main" id="{5E4E0E02-655B-5727-619B-ECDCC8F269C1}"/>
+              </a:ext>
+            </a:extLst>
+          </p:cNvPr>
+          <p:cNvCxnSpPr>
+            <a:cxnSpLocks/>
+            <a:stCxn id="199" idx="3"/>
+            <a:endCxn id="200" idx="1"/>
+          </p:cNvCxnSpPr>
           <p:nvPr/>
         </p:nvCxnSpPr>
         <p:spPr>
           <a:xfrm>
-            <a:off x="7543800" y="5097780"/>
-            <a:ext cx="228600" cy="0"/>
+            <a:off x="8913265" y="4153102"/>
+            <a:ext cx="274320" cy="0"/>
           </a:xfrm>
           <a:prstGeom prst="line">
             <a:avLst/>
           </a:prstGeom>
           <a:ln w="19050">
             <a:solidFill>
-              <a:srgbClr val="595959"/>
+              <a:srgbClr val="BF9000"/>
             </a:solidFill>
             <a:tailEnd type="triangle" w="med" len="med"/>
           </a:ln>
@@ -4552,21 +4897,31 @@
       </p:cxnSp>
       <p:cxnSp>
         <p:nvCxnSpPr>
-          <p:cNvPr id="29" name="Connector 28"/>
-          <p:cNvCxnSpPr/>
+          <p:cNvPr id="204" name="Connector 28">
+            <a:extLst>
+              <a:ext uri="{FF2B5EF4-FFF2-40B4-BE49-F238E27FC236}">
+                <a16:creationId xmlns:a16="http://schemas.microsoft.com/office/drawing/2014/main" id="{D670384F-954D-13FD-84A0-FE90DAE856FA}"/>
+              </a:ext>
+            </a:extLst>
+          </p:cNvPr>
+          <p:cNvCxnSpPr>
+            <a:cxnSpLocks/>
+            <a:stCxn id="200" idx="3"/>
+            <a:endCxn id="201" idx="1"/>
+          </p:cNvCxnSpPr>
           <p:nvPr/>
         </p:nvCxnSpPr>
         <p:spPr>
           <a:xfrm>
-            <a:off x="9601200" y="5097780"/>
-            <a:ext cx="228600" cy="0"/>
+            <a:off x="11016385" y="4153102"/>
+            <a:ext cx="274320" cy="0"/>
           </a:xfrm>
           <a:prstGeom prst="line">
             <a:avLst/>
           </a:prstGeom>
           <a:ln w="19050">
             <a:solidFill>
-              <a:srgbClr val="595959"/>
+              <a:srgbClr val="BF9000"/>
             </a:solidFill>
             <a:tailEnd type="triangle" w="med" len="med"/>
           </a:ln>
@@ -4588,23 +4943,31 @@
       </p:cxnSp>
       <p:cxnSp>
         <p:nvCxnSpPr>
-          <p:cNvPr id="30" name="Connector 29"/>
-          <p:cNvCxnSpPr/>
+          <p:cNvPr id="205" name="Connector 39">
+            <a:extLst>
+              <a:ext uri="{FF2B5EF4-FFF2-40B4-BE49-F238E27FC236}">
+                <a16:creationId xmlns:a16="http://schemas.microsoft.com/office/drawing/2014/main" id="{F453A8E7-99E9-7DCF-1DCF-928484A9C839}"/>
+              </a:ext>
+            </a:extLst>
+          </p:cNvPr>
+          <p:cNvCxnSpPr>
+            <a:cxnSpLocks/>
+            <a:stCxn id="201" idx="3"/>
+          </p:cNvCxnSpPr>
           <p:nvPr/>
         </p:nvCxnSpPr>
         <p:spPr>
           <a:xfrm>
-            <a:off x="5006339" y="1874519"/>
-            <a:ext cx="0" cy="612649"/>
+            <a:off x="13348105" y="4153102"/>
+            <a:ext cx="274320" cy="0"/>
           </a:xfrm>
           <a:prstGeom prst="line">
             <a:avLst/>
           </a:prstGeom>
           <a:ln w="19050">
             <a:solidFill>
-              <a:srgbClr val="595959"/>
+              <a:srgbClr val="2F5597"/>
             </a:solidFill>
-            <a:tailEnd type="triangle" w="med" len="med"/>
           </a:ln>
         </p:spPr>
         <p:style>
@@ -4624,92 +4987,29 @@
       </p:cxnSp>
       <p:cxnSp>
         <p:nvCxnSpPr>
-          <p:cNvPr id="31" name="Connector 30"/>
-          <p:cNvCxnSpPr/>
+          <p:cNvPr id="206" name="Connector 40">
+            <a:extLst>
+              <a:ext uri="{FF2B5EF4-FFF2-40B4-BE49-F238E27FC236}">
+                <a16:creationId xmlns:a16="http://schemas.microsoft.com/office/drawing/2014/main" id="{49184B2B-C238-F4A3-F461-D791254CEE36}"/>
+              </a:ext>
+            </a:extLst>
+          </p:cNvPr>
+          <p:cNvCxnSpPr>
+            <a:cxnSpLocks/>
+          </p:cNvCxnSpPr>
           <p:nvPr/>
         </p:nvCxnSpPr>
         <p:spPr>
           <a:xfrm>
-            <a:off x="3383280" y="1874519"/>
-            <a:ext cx="0" cy="2743201"/>
-          </a:xfrm>
-          <a:prstGeom prst="line">
-            <a:avLst/>
-          </a:prstGeom>
-          <a:ln w="15875">
-            <a:solidFill>
-              <a:srgbClr val="548235"/>
-            </a:solidFill>
-            <a:tailEnd type="triangle" w="med" len="med"/>
-          </a:ln>
-        </p:spPr>
-        <p:style>
-          <a:lnRef idx="2">
-            <a:schemeClr val="accent1"/>
-          </a:lnRef>
-          <a:fillRef idx="0">
-            <a:schemeClr val="accent1"/>
-          </a:fillRef>
-          <a:effectRef idx="1">
-            <a:schemeClr val="accent1"/>
-          </a:effectRef>
-          <a:fontRef idx="minor">
-            <a:schemeClr val="tx1"/>
-          </a:fontRef>
-        </p:style>
-      </p:cxnSp>
-      <p:sp>
-        <p:nvSpPr>
-          <p:cNvPr id="32" name="TextBox 31"/>
-          <p:cNvSpPr txBox="1"/>
-          <p:nvPr/>
-        </p:nvSpPr>
-        <p:spPr>
-          <a:xfrm>
-            <a:off x="2980944" y="3108960"/>
-            <a:ext cx="457200" cy="182880"/>
-          </a:xfrm>
-          <a:prstGeom prst="rect">
-            <a:avLst/>
-          </a:prstGeom>
-          <a:noFill/>
-        </p:spPr>
-        <p:txBody>
-          <a:bodyPr wrap="square" lIns="18288" rIns="18288" tIns="0" bIns="0">
-            <a:spAutoFit/>
-          </a:bodyPr>
-          <a:lstStyle/>
-          <a:p>
-            <a:pPr algn="l"/>
-            <a:r>
-              <a:rPr sz="800" b="0" i="1">
-                <a:solidFill>
-                  <a:srgbClr val="385723"/>
-                </a:solidFill>
-                <a:latin typeface="Calibri"/>
-              </a:rPr>
-              <a:t>ρ(Xₖ)</a:t>
-            </a:r>
-          </a:p>
-        </p:txBody>
-      </p:sp>
-      <p:cxnSp>
-        <p:nvCxnSpPr>
-          <p:cNvPr id="33" name="Connector 32"/>
-          <p:cNvCxnSpPr/>
-          <p:nvPr/>
-        </p:nvCxnSpPr>
-        <p:spPr>
-          <a:xfrm>
-            <a:off x="10584180" y="3584448"/>
-            <a:ext cx="0" cy="850392"/>
+            <a:off x="13622425" y="4148554"/>
+            <a:ext cx="0" cy="656879"/>
           </a:xfrm>
           <a:prstGeom prst="line">
             <a:avLst/>
           </a:prstGeom>
           <a:ln w="19050">
             <a:solidFill>
-              <a:srgbClr val="595959"/>
+              <a:srgbClr val="2F5597"/>
             </a:solidFill>
           </a:ln>
         </p:spPr>
@@ -4730,21 +5030,29 @@
       </p:cxnSp>
       <p:cxnSp>
         <p:nvCxnSpPr>
-          <p:cNvPr id="34" name="Connector 33"/>
-          <p:cNvCxnSpPr/>
+          <p:cNvPr id="207" name="Connector 41">
+            <a:extLst>
+              <a:ext uri="{FF2B5EF4-FFF2-40B4-BE49-F238E27FC236}">
+                <a16:creationId xmlns:a16="http://schemas.microsoft.com/office/drawing/2014/main" id="{B3C48E48-0D11-5320-3DCF-288AC277B628}"/>
+              </a:ext>
+            </a:extLst>
+          </p:cNvPr>
+          <p:cNvCxnSpPr>
+            <a:cxnSpLocks/>
+          </p:cNvCxnSpPr>
           <p:nvPr/>
         </p:nvCxnSpPr>
         <p:spPr>
           <a:xfrm flipH="1">
-            <a:off x="6812280" y="4434840"/>
-            <a:ext cx="3771900" cy="0"/>
+            <a:off x="4714978" y="4805431"/>
+            <a:ext cx="8907449" cy="0"/>
           </a:xfrm>
           <a:prstGeom prst="line">
             <a:avLst/>
           </a:prstGeom>
           <a:ln w="19050">
             <a:solidFill>
-              <a:srgbClr val="595959"/>
+              <a:srgbClr val="2F5597"/>
             </a:solidFill>
           </a:ln>
         </p:spPr>
@@ -4765,92 +5073,29 @@
       </p:cxnSp>
       <p:cxnSp>
         <p:nvCxnSpPr>
-          <p:cNvPr id="35" name="Connector 34"/>
-          <p:cNvCxnSpPr/>
+          <p:cNvPr id="208" name="Connector 42">
+            <a:extLst>
+              <a:ext uri="{FF2B5EF4-FFF2-40B4-BE49-F238E27FC236}">
+                <a16:creationId xmlns:a16="http://schemas.microsoft.com/office/drawing/2014/main" id="{DF8863B9-9D3D-2D93-5107-D4B1C60712F3}"/>
+              </a:ext>
+            </a:extLst>
+          </p:cNvPr>
+          <p:cNvCxnSpPr>
+            <a:cxnSpLocks/>
+          </p:cNvCxnSpPr>
           <p:nvPr/>
         </p:nvCxnSpPr>
         <p:spPr>
-          <a:xfrm>
-            <a:off x="6812280" y="4434840"/>
-            <a:ext cx="0" cy="182880"/>
+          <a:xfrm flipV="1">
+            <a:off x="4709676" y="894143"/>
+            <a:ext cx="0" cy="3911288"/>
           </a:xfrm>
           <a:prstGeom prst="line">
             <a:avLst/>
           </a:prstGeom>
           <a:ln w="19050">
             <a:solidFill>
-              <a:srgbClr val="595959"/>
-            </a:solidFill>
-            <a:tailEnd type="triangle" w="med" len="med"/>
-          </a:ln>
-        </p:spPr>
-        <p:style>
-          <a:lnRef idx="2">
-            <a:schemeClr val="accent1"/>
-          </a:lnRef>
-          <a:fillRef idx="0">
-            <a:schemeClr val="accent1"/>
-          </a:fillRef>
-          <a:effectRef idx="1">
-            <a:schemeClr val="accent1"/>
-          </a:effectRef>
-          <a:fontRef idx="minor">
-            <a:schemeClr val="tx1"/>
-          </a:fontRef>
-        </p:style>
-      </p:cxnSp>
-      <p:sp>
-        <p:nvSpPr>
-          <p:cNvPr id="36" name="TextBox 35"/>
-          <p:cNvSpPr txBox="1"/>
-          <p:nvPr/>
-        </p:nvSpPr>
-        <p:spPr>
-          <a:xfrm>
-            <a:off x="6885432" y="4425696"/>
-            <a:ext cx="548640" cy="182880"/>
-          </a:xfrm>
-          <a:prstGeom prst="rect">
-            <a:avLst/>
-          </a:prstGeom>
-          <a:noFill/>
-        </p:spPr>
-        <p:txBody>
-          <a:bodyPr wrap="square" lIns="18288" rIns="18288" tIns="0" bIns="0">
-            <a:spAutoFit/>
-          </a:bodyPr>
-          <a:lstStyle/>
-          <a:p>
-            <a:pPr algn="l"/>
-            <a:r>
-              <a:rPr sz="900" b="0" i="1">
-                <a:solidFill>
-                  <a:srgbClr val="843C0C"/>
-                </a:solidFill>
-                <a:latin typeface="Calibri"/>
-              </a:rPr>
-              <a:t>sᵥ</a:t>
-            </a:r>
-          </a:p>
-        </p:txBody>
-      </p:sp>
-      <p:cxnSp>
-        <p:nvCxnSpPr>
-          <p:cNvPr id="37" name="Connector 36"/>
-          <p:cNvCxnSpPr/>
-          <p:nvPr/>
-        </p:nvCxnSpPr>
-        <p:spPr>
-          <a:xfrm>
-            <a:off x="2377440" y="3451860"/>
-            <a:ext cx="228600" cy="0"/>
-          </a:xfrm>
-          <a:prstGeom prst="line">
-            <a:avLst/>
-          </a:prstGeom>
-          <a:ln w="19050">
-            <a:solidFill>
-              <a:srgbClr val="595959"/>
+              <a:srgbClr val="2F5597"/>
             </a:solidFill>
           </a:ln>
         </p:spPr>
@@ -4871,225 +5116,20 @@
       </p:cxnSp>
       <p:cxnSp>
         <p:nvCxnSpPr>
-          <p:cNvPr id="38" name="Connector 37"/>
+          <p:cNvPr id="209" name="Connector 43">
+            <a:extLst>
+              <a:ext uri="{FF2B5EF4-FFF2-40B4-BE49-F238E27FC236}">
+                <a16:creationId xmlns:a16="http://schemas.microsoft.com/office/drawing/2014/main" id="{70CA0F9D-84D0-76F3-D1DB-2CFDA2A7A388}"/>
+              </a:ext>
+            </a:extLst>
+          </p:cNvPr>
           <p:cNvCxnSpPr/>
           <p:nvPr/>
         </p:nvCxnSpPr>
         <p:spPr>
-          <a:xfrm flipV="1">
-            <a:off x="2606040" y="1211580"/>
-            <a:ext cx="0" cy="2240280"/>
-          </a:xfrm>
-          <a:prstGeom prst="line">
-            <a:avLst/>
-          </a:prstGeom>
-          <a:ln w="19050">
-            <a:solidFill>
-              <a:srgbClr val="595959"/>
-            </a:solidFill>
-          </a:ln>
-        </p:spPr>
-        <p:style>
-          <a:lnRef idx="2">
-            <a:schemeClr val="accent1"/>
-          </a:lnRef>
-          <a:fillRef idx="0">
-            <a:schemeClr val="accent1"/>
-          </a:fillRef>
-          <a:effectRef idx="1">
-            <a:schemeClr val="accent1"/>
-          </a:effectRef>
-          <a:fontRef idx="minor">
-            <a:schemeClr val="tx1"/>
-          </a:fontRef>
-        </p:style>
-      </p:cxnSp>
-      <p:cxnSp>
-        <p:nvCxnSpPr>
-          <p:cNvPr id="39" name="Connector 38"/>
-          <p:cNvCxnSpPr/>
-          <p:nvPr/>
-        </p:nvCxnSpPr>
-        <p:spPr>
           <a:xfrm>
-            <a:off x="2606040" y="1211580"/>
-            <a:ext cx="594360" cy="0"/>
-          </a:xfrm>
-          <a:prstGeom prst="line">
-            <a:avLst/>
-          </a:prstGeom>
-          <a:ln w="19050">
-            <a:solidFill>
-              <a:srgbClr val="595959"/>
-            </a:solidFill>
-            <a:tailEnd type="triangle" w="med" len="med"/>
-          </a:ln>
-        </p:spPr>
-        <p:style>
-          <a:lnRef idx="2">
-            <a:schemeClr val="accent1"/>
-          </a:lnRef>
-          <a:fillRef idx="0">
-            <a:schemeClr val="accent1"/>
-          </a:fillRef>
-          <a:effectRef idx="1">
-            <a:schemeClr val="accent1"/>
-          </a:effectRef>
-          <a:fontRef idx="minor">
-            <a:schemeClr val="tx1"/>
-          </a:fontRef>
-        </p:style>
-      </p:cxnSp>
-      <p:cxnSp>
-        <p:nvCxnSpPr>
-          <p:cNvPr id="40" name="Connector 39"/>
-          <p:cNvCxnSpPr/>
-          <p:nvPr/>
-        </p:nvCxnSpPr>
-        <p:spPr>
-          <a:xfrm>
-            <a:off x="11658600" y="5097780"/>
-            <a:ext cx="137160" cy="0"/>
-          </a:xfrm>
-          <a:prstGeom prst="line">
-            <a:avLst/>
-          </a:prstGeom>
-          <a:ln w="19050">
-            <a:solidFill>
-              <a:srgbClr val="2F5597"/>
-            </a:solidFill>
-          </a:ln>
-        </p:spPr>
-        <p:style>
-          <a:lnRef idx="2">
-            <a:schemeClr val="accent1"/>
-          </a:lnRef>
-          <a:fillRef idx="0">
-            <a:schemeClr val="accent1"/>
-          </a:fillRef>
-          <a:effectRef idx="1">
-            <a:schemeClr val="accent1"/>
-          </a:effectRef>
-          <a:fontRef idx="minor">
-            <a:schemeClr val="tx1"/>
-          </a:fontRef>
-        </p:style>
-      </p:cxnSp>
-      <p:cxnSp>
-        <p:nvCxnSpPr>
-          <p:cNvPr id="41" name="Connector 40"/>
-          <p:cNvCxnSpPr/>
-          <p:nvPr/>
-        </p:nvCxnSpPr>
-        <p:spPr>
-          <a:xfrm>
-            <a:off x="11795760" y="5097780"/>
-            <a:ext cx="0" cy="681228"/>
-          </a:xfrm>
-          <a:prstGeom prst="line">
-            <a:avLst/>
-          </a:prstGeom>
-          <a:ln w="19050">
-            <a:solidFill>
-              <a:srgbClr val="2F5597"/>
-            </a:solidFill>
-          </a:ln>
-        </p:spPr>
-        <p:style>
-          <a:lnRef idx="2">
-            <a:schemeClr val="accent1"/>
-          </a:lnRef>
-          <a:fillRef idx="0">
-            <a:schemeClr val="accent1"/>
-          </a:fillRef>
-          <a:effectRef idx="1">
-            <a:schemeClr val="accent1"/>
-          </a:effectRef>
-          <a:fontRef idx="minor">
-            <a:schemeClr val="tx1"/>
-          </a:fontRef>
-        </p:style>
-      </p:cxnSp>
-      <p:cxnSp>
-        <p:nvCxnSpPr>
-          <p:cNvPr id="42" name="Connector 41"/>
-          <p:cNvCxnSpPr/>
-          <p:nvPr/>
-        </p:nvCxnSpPr>
-        <p:spPr>
-          <a:xfrm flipH="1">
-            <a:off x="2971800" y="5779008"/>
-            <a:ext cx="8823960" cy="0"/>
-          </a:xfrm>
-          <a:prstGeom prst="line">
-            <a:avLst/>
-          </a:prstGeom>
-          <a:ln w="19050">
-            <a:solidFill>
-              <a:srgbClr val="2F5597"/>
-            </a:solidFill>
-          </a:ln>
-        </p:spPr>
-        <p:style>
-          <a:lnRef idx="2">
-            <a:schemeClr val="accent1"/>
-          </a:lnRef>
-          <a:fillRef idx="0">
-            <a:schemeClr val="accent1"/>
-          </a:fillRef>
-          <a:effectRef idx="1">
-            <a:schemeClr val="accent1"/>
-          </a:effectRef>
-          <a:fontRef idx="minor">
-            <a:schemeClr val="tx1"/>
-          </a:fontRef>
-        </p:style>
-      </p:cxnSp>
-      <p:cxnSp>
-        <p:nvCxnSpPr>
-          <p:cNvPr id="43" name="Connector 42"/>
-          <p:cNvCxnSpPr/>
-          <p:nvPr/>
-        </p:nvCxnSpPr>
-        <p:spPr>
-          <a:xfrm flipV="1">
-            <a:off x="2971800" y="1577339"/>
-            <a:ext cx="0" cy="4201669"/>
-          </a:xfrm>
-          <a:prstGeom prst="line">
-            <a:avLst/>
-          </a:prstGeom>
-          <a:ln w="19050">
-            <a:solidFill>
-              <a:srgbClr val="2F5597"/>
-            </a:solidFill>
-          </a:ln>
-        </p:spPr>
-        <p:style>
-          <a:lnRef idx="2">
-            <a:schemeClr val="accent1"/>
-          </a:lnRef>
-          <a:fillRef idx="0">
-            <a:schemeClr val="accent1"/>
-          </a:fillRef>
-          <a:effectRef idx="1">
-            <a:schemeClr val="accent1"/>
-          </a:effectRef>
-          <a:fontRef idx="minor">
-            <a:schemeClr val="tx1"/>
-          </a:fontRef>
-        </p:style>
-      </p:cxnSp>
-      <p:cxnSp>
-        <p:nvCxnSpPr>
-          <p:cNvPr id="44" name="Connector 43"/>
-          <p:cNvCxnSpPr/>
-          <p:nvPr/>
-        </p:nvCxnSpPr>
-        <p:spPr>
-          <a:xfrm>
-            <a:off x="2971800" y="1577339"/>
-            <a:ext cx="228600" cy="0"/>
+            <a:off x="4709676" y="894142"/>
+            <a:ext cx="274320" cy="0"/>
           </a:xfrm>
           <a:prstGeom prst="line">
             <a:avLst/>
@@ -5118,49 +5158,20 @@
       </p:cxnSp>
       <p:sp>
         <p:nvSpPr>
-          <p:cNvPr id="45" name="TextBox 44"/>
-          <p:cNvSpPr txBox="1"/>
-          <p:nvPr/>
-        </p:nvSpPr>
-        <p:spPr>
-          <a:xfrm>
-            <a:off x="5943600" y="5596128"/>
-            <a:ext cx="3200400" cy="182880"/>
-          </a:xfrm>
-          <a:prstGeom prst="rect">
-            <a:avLst/>
-          </a:prstGeom>
-          <a:noFill/>
-        </p:spPr>
-        <p:txBody>
-          <a:bodyPr wrap="square" lIns="18288" rIns="18288" tIns="0" bIns="0">
-            <a:spAutoFit/>
-          </a:bodyPr>
-          <a:lstStyle/>
-          <a:p>
-            <a:pPr algn="ctr"/>
-            <a:r>
-              <a:rPr sz="900" b="0" i="1">
-                <a:solidFill>
-                  <a:srgbClr val="1F3864"/>
-                </a:solidFill>
-                <a:latin typeface="Calibri"/>
-              </a:rPr>
-              <a:t>Xₖ₊₁ → next outer iteration</a:t>
-            </a:r>
-          </a:p>
-        </p:txBody>
-      </p:sp>
-      <p:sp>
-        <p:nvSpPr>
-          <p:cNvPr id="46" name="Rounded Rectangle 45"/>
+          <p:cNvPr id="210" name="Rounded Rectangle 45">
+            <a:extLst>
+              <a:ext uri="{FF2B5EF4-FFF2-40B4-BE49-F238E27FC236}">
+                <a16:creationId xmlns:a16="http://schemas.microsoft.com/office/drawing/2014/main" id="{D0D2E99E-1681-3EBB-1B9D-EFEDD7BD8312}"/>
+              </a:ext>
+            </a:extLst>
+          </p:cNvPr>
           <p:cNvSpPr/>
           <p:nvPr/>
         </p:nvSpPr>
         <p:spPr>
           <a:xfrm>
-            <a:off x="9829800" y="6217920"/>
-            <a:ext cx="1828800" cy="502920"/>
+            <a:off x="14012037" y="3695943"/>
+            <a:ext cx="1828800" cy="914400"/>
           </a:xfrm>
           <a:prstGeom prst="roundRect">
             <a:avLst>
@@ -5192,12 +5203,12 @@
           </a:fontRef>
         </p:style>
         <p:txBody>
-          <a:bodyPr rtlCol="0" anchor="ctr" wrap="square" lIns="54864" rIns="54864" tIns="27432" bIns="27432"/>
+          <a:bodyPr wrap="square" lIns="54865" tIns="27432" rIns="54865" bIns="27432" rtlCol="0" anchor="ctr"/>
           <a:lstStyle/>
           <a:p>
             <a:pPr algn="ctr"/>
             <a:r>
-              <a:rPr sz="1000" b="1">
+              <a:rPr sz="1200" b="1" dirty="0">
                 <a:solidFill>
                   <a:srgbClr val="1F3864"/>
                 </a:solidFill>
@@ -5209,7 +5220,7 @@
           <a:p>
             <a:pPr algn="ctr"/>
             <a:r>
-              <a:rPr sz="1000" b="0">
+              <a:rPr sz="1200" b="1" dirty="0">
                 <a:solidFill>
                   <a:srgbClr val="1F3864"/>
                 </a:solidFill>
@@ -5222,23 +5233,34 @@
       </p:sp>
       <p:cxnSp>
         <p:nvCxnSpPr>
-          <p:cNvPr id="47" name="Connector 46"/>
-          <p:cNvCxnSpPr/>
+          <p:cNvPr id="211" name="Connector: Elbow 210">
+            <a:extLst>
+              <a:ext uri="{FF2B5EF4-FFF2-40B4-BE49-F238E27FC236}">
+                <a16:creationId xmlns:a16="http://schemas.microsoft.com/office/drawing/2014/main" id="{0C4EA69C-FDD5-438D-0931-59D3493FC0EF}"/>
+              </a:ext>
+            </a:extLst>
+          </p:cNvPr>
+          <p:cNvCxnSpPr>
+            <a:cxnSpLocks/>
+            <a:stCxn id="182" idx="3"/>
+          </p:cNvCxnSpPr>
           <p:nvPr/>
         </p:nvCxnSpPr>
         <p:spPr>
-          <a:xfrm>
-            <a:off x="10744200" y="5577840"/>
-            <a:ext cx="0" cy="640080"/>
-          </a:xfrm>
-          <a:prstGeom prst="line">
-            <a:avLst/>
+          <a:xfrm flipV="1">
+            <a:off x="4244657" y="685682"/>
+            <a:ext cx="736690" cy="121910"/>
+          </a:xfrm>
+          <a:prstGeom prst="bentConnector3">
+            <a:avLst>
+              <a:gd name="adj1" fmla="val 26615"/>
+            </a:avLst>
           </a:prstGeom>
           <a:ln w="19050">
             <a:solidFill>
-              <a:srgbClr val="595959"/>
+              <a:srgbClr val="2F5597"/>
             </a:solidFill>
-            <a:tailEnd type="triangle" w="med" len="med"/>
+            <a:tailEnd type="triangle"/>
           </a:ln>
         </p:spPr>
         <p:style>
@@ -5256,53 +5278,324 @@
           </a:fontRef>
         </p:style>
       </p:cxnSp>
-      <p:sp>
-        <p:nvSpPr>
-          <p:cNvPr id="48" name="TextBox 47"/>
-          <p:cNvSpPr txBox="1"/>
+      <p:cxnSp>
+        <p:nvCxnSpPr>
+          <p:cNvPr id="212" name="Connector: Elbow 211">
+            <a:extLst>
+              <a:ext uri="{FF2B5EF4-FFF2-40B4-BE49-F238E27FC236}">
+                <a16:creationId xmlns:a16="http://schemas.microsoft.com/office/drawing/2014/main" id="{6CB95064-09E3-2D2F-FB96-A7AF407D019D}"/>
+              </a:ext>
+            </a:extLst>
+          </p:cNvPr>
+          <p:cNvCxnSpPr>
+            <a:cxnSpLocks/>
+            <a:stCxn id="186" idx="2"/>
+            <a:endCxn id="189" idx="0"/>
+          </p:cNvCxnSpPr>
           <p:nvPr/>
-        </p:nvSpPr>
-        <p:spPr>
-          <a:xfrm>
-            <a:off x="320040" y="6172200"/>
-            <a:ext cx="8686800" cy="457200"/>
-          </a:xfrm>
-          <a:prstGeom prst="rect">
+        </p:nvCxnSpPr>
+        <p:spPr>
+          <a:xfrm rot="16200000" flipH="1">
+            <a:off x="6343801" y="1502539"/>
+            <a:ext cx="658370" cy="182879"/>
+          </a:xfrm>
+          <a:prstGeom prst="bentConnector3">
+            <a:avLst>
+              <a:gd name="adj1" fmla="val 23872"/>
+            </a:avLst>
+          </a:prstGeom>
+          <a:ln w="19050">
+            <a:solidFill>
+              <a:srgbClr val="548235"/>
+            </a:solidFill>
+            <a:tailEnd type="triangle"/>
+          </a:ln>
+        </p:spPr>
+        <p:style>
+          <a:lnRef idx="2">
+            <a:schemeClr val="accent1"/>
+          </a:lnRef>
+          <a:fillRef idx="0">
+            <a:schemeClr val="accent1"/>
+          </a:fillRef>
+          <a:effectRef idx="1">
+            <a:schemeClr val="accent1"/>
+          </a:effectRef>
+          <a:fontRef idx="minor">
+            <a:schemeClr val="tx1"/>
+          </a:fontRef>
+        </p:style>
+      </p:cxnSp>
+      <p:cxnSp>
+        <p:nvCxnSpPr>
+          <p:cNvPr id="213" name="Connector: Elbow 212">
+            <a:extLst>
+              <a:ext uri="{FF2B5EF4-FFF2-40B4-BE49-F238E27FC236}">
+                <a16:creationId xmlns:a16="http://schemas.microsoft.com/office/drawing/2014/main" id="{57BF8852-3BF9-7DAB-DB0B-F3F2BBDA78C7}"/>
+              </a:ext>
+            </a:extLst>
+          </p:cNvPr>
+          <p:cNvCxnSpPr>
+            <a:cxnSpLocks/>
+            <a:endCxn id="198" idx="0"/>
+          </p:cNvCxnSpPr>
+          <p:nvPr/>
+        </p:nvCxnSpPr>
+        <p:spPr>
+          <a:xfrm rot="16200000" flipH="1">
+            <a:off x="4451064" y="2251221"/>
+            <a:ext cx="2272775" cy="616587"/>
+          </a:xfrm>
+          <a:prstGeom prst="bentConnector3">
+            <a:avLst>
+              <a:gd name="adj1" fmla="val 90757"/>
+            </a:avLst>
+          </a:prstGeom>
+          <a:ln w="19050">
+            <a:solidFill>
+              <a:srgbClr val="548235"/>
+            </a:solidFill>
+            <a:tailEnd type="triangle"/>
+          </a:ln>
+        </p:spPr>
+        <p:style>
+          <a:lnRef idx="2">
+            <a:schemeClr val="accent1"/>
+          </a:lnRef>
+          <a:fillRef idx="0">
+            <a:schemeClr val="accent1"/>
+          </a:fillRef>
+          <a:effectRef idx="1">
+            <a:schemeClr val="accent1"/>
+          </a:effectRef>
+          <a:fontRef idx="minor">
+            <a:schemeClr val="tx1"/>
+          </a:fontRef>
+        </p:style>
+      </p:cxnSp>
+      <p:cxnSp>
+        <p:nvCxnSpPr>
+          <p:cNvPr id="214" name="Connector: Elbow 213">
+            <a:extLst>
+              <a:ext uri="{FF2B5EF4-FFF2-40B4-BE49-F238E27FC236}">
+                <a16:creationId xmlns:a16="http://schemas.microsoft.com/office/drawing/2014/main" id="{FD589FAB-0F27-2313-4C94-FF51CCAE3E7A}"/>
+              </a:ext>
+            </a:extLst>
+          </p:cNvPr>
+          <p:cNvCxnSpPr>
+            <a:cxnSpLocks/>
+            <a:stCxn id="190" idx="2"/>
+            <a:endCxn id="199" idx="0"/>
+          </p:cNvCxnSpPr>
+          <p:nvPr/>
+        </p:nvCxnSpPr>
+        <p:spPr>
+          <a:xfrm rot="5400000">
+            <a:off x="9660793" y="1173365"/>
+            <a:ext cx="860610" cy="4184465"/>
+          </a:xfrm>
+          <a:prstGeom prst="bentConnector3">
+            <a:avLst>
+              <a:gd name="adj1" fmla="val 76299"/>
+            </a:avLst>
+          </a:prstGeom>
+          <a:ln w="19050">
+            <a:solidFill>
+              <a:srgbClr val="C55A11"/>
+            </a:solidFill>
+            <a:tailEnd type="triangle"/>
+          </a:ln>
+        </p:spPr>
+        <p:style>
+          <a:lnRef idx="2">
+            <a:schemeClr val="accent1"/>
+          </a:lnRef>
+          <a:fillRef idx="0">
+            <a:schemeClr val="accent1"/>
+          </a:fillRef>
+          <a:effectRef idx="1">
+            <a:schemeClr val="accent1"/>
+          </a:effectRef>
+          <a:fontRef idx="minor">
+            <a:schemeClr val="tx1"/>
+          </a:fontRef>
+        </p:style>
+      </p:cxnSp>
+      <p:cxnSp>
+        <p:nvCxnSpPr>
+          <p:cNvPr id="215" name="Connector 41">
+            <a:extLst>
+              <a:ext uri="{FF2B5EF4-FFF2-40B4-BE49-F238E27FC236}">
+                <a16:creationId xmlns:a16="http://schemas.microsoft.com/office/drawing/2014/main" id="{EE1629FA-33F2-86FF-79C1-F44D4C88F257}"/>
+              </a:ext>
+            </a:extLst>
+          </p:cNvPr>
+          <p:cNvCxnSpPr>
+            <a:cxnSpLocks/>
+          </p:cNvCxnSpPr>
+          <p:nvPr/>
+        </p:nvCxnSpPr>
+        <p:spPr>
+          <a:xfrm flipH="1">
+            <a:off x="5272757" y="1423125"/>
+            <a:ext cx="1308791" cy="1"/>
+          </a:xfrm>
+          <a:prstGeom prst="line">
             <a:avLst/>
           </a:prstGeom>
-          <a:noFill/>
-        </p:spPr>
-        <p:txBody>
-          <a:bodyPr wrap="square" lIns="18288" rIns="18288" tIns="0" bIns="0">
-            <a:spAutoFit/>
-          </a:bodyPr>
-          <a:lstStyle/>
-          <a:p>
-            <a:pPr algn="l"/>
-            <a:r>
-              <a:rPr sz="900" b="0" i="1">
-                <a:solidFill>
-                  <a:srgbClr val="404040"/>
-                </a:solidFill>
-                <a:latin typeface="Calibri"/>
-              </a:rPr>
-              <a:t>CITRUS: Coupled Iterative Tomographic reconstruction and Recursively-Updated Scatter.  With X held fixed, N outer iterations reproduce N source</a:t>
-            </a:r>
-          </a:p>
-          <a:p>
-            <a:pPr algn="l"/>
-            <a:r>
-              <a:rPr sz="900" b="0" i="1">
-                <a:solidFill>
-                  <a:srgbClr val="404040"/>
-                </a:solidFill>
-                <a:latin typeface="Calibri"/>
-              </a:rPr>
-              <a:t>iterations of the transport solver, so the scatter estimate converges together with the reconstruction for one sweep per view per outer iteration.</a:t>
-            </a:r>
-          </a:p>
-        </p:txBody>
-      </p:sp>
+          <a:ln w="19050">
+            <a:solidFill>
+              <a:srgbClr val="548235"/>
+            </a:solidFill>
+          </a:ln>
+        </p:spPr>
+        <p:style>
+          <a:lnRef idx="2">
+            <a:schemeClr val="accent1"/>
+          </a:lnRef>
+          <a:fillRef idx="0">
+            <a:schemeClr val="accent1"/>
+          </a:fillRef>
+          <a:effectRef idx="1">
+            <a:schemeClr val="accent1"/>
+          </a:effectRef>
+          <a:fontRef idx="minor">
+            <a:schemeClr val="tx1"/>
+          </a:fontRef>
+        </p:style>
+      </p:cxnSp>
+      <p:cxnSp>
+        <p:nvCxnSpPr>
+          <p:cNvPr id="216" name="Connector 15">
+            <a:extLst>
+              <a:ext uri="{FF2B5EF4-FFF2-40B4-BE49-F238E27FC236}">
+                <a16:creationId xmlns:a16="http://schemas.microsoft.com/office/drawing/2014/main" id="{B9417673-D440-D697-51C3-5ECA7E38C614}"/>
+              </a:ext>
+            </a:extLst>
+          </p:cNvPr>
+          <p:cNvCxnSpPr>
+            <a:cxnSpLocks/>
+          </p:cNvCxnSpPr>
+          <p:nvPr/>
+        </p:nvCxnSpPr>
+        <p:spPr>
+          <a:xfrm flipH="1">
+            <a:off x="8065983" y="2502446"/>
+            <a:ext cx="1219" cy="623684"/>
+          </a:xfrm>
+          <a:prstGeom prst="line">
+            <a:avLst/>
+          </a:prstGeom>
+          <a:ln w="19050">
+            <a:solidFill>
+              <a:srgbClr val="C55A11"/>
+            </a:solidFill>
+          </a:ln>
+        </p:spPr>
+        <p:style>
+          <a:lnRef idx="2">
+            <a:schemeClr val="accent1"/>
+          </a:lnRef>
+          <a:fillRef idx="0">
+            <a:schemeClr val="accent1"/>
+          </a:fillRef>
+          <a:effectRef idx="1">
+            <a:schemeClr val="accent1"/>
+          </a:effectRef>
+          <a:fontRef idx="minor">
+            <a:schemeClr val="tx1"/>
+          </a:fontRef>
+        </p:style>
+      </p:cxnSp>
+      <p:cxnSp>
+        <p:nvCxnSpPr>
+          <p:cNvPr id="217" name="Connector 13">
+            <a:extLst>
+              <a:ext uri="{FF2B5EF4-FFF2-40B4-BE49-F238E27FC236}">
+                <a16:creationId xmlns:a16="http://schemas.microsoft.com/office/drawing/2014/main" id="{F644E277-C7BC-48DF-4F60-2892512FB4C6}"/>
+              </a:ext>
+            </a:extLst>
+          </p:cNvPr>
+          <p:cNvCxnSpPr>
+            <a:cxnSpLocks/>
+          </p:cNvCxnSpPr>
+          <p:nvPr/>
+        </p:nvCxnSpPr>
+        <p:spPr>
+          <a:xfrm flipV="1">
+            <a:off x="8057104" y="2499155"/>
+            <a:ext cx="213453" cy="3292"/>
+          </a:xfrm>
+          <a:prstGeom prst="line">
+            <a:avLst/>
+          </a:prstGeom>
+          <a:ln w="19050">
+            <a:solidFill>
+              <a:srgbClr val="C55A11"/>
+            </a:solidFill>
+            <a:tailEnd type="triangle" w="med" len="med"/>
+          </a:ln>
+        </p:spPr>
+        <p:style>
+          <a:lnRef idx="2">
+            <a:schemeClr val="accent1"/>
+          </a:lnRef>
+          <a:fillRef idx="0">
+            <a:schemeClr val="accent1"/>
+          </a:fillRef>
+          <a:effectRef idx="1">
+            <a:schemeClr val="accent1"/>
+          </a:effectRef>
+          <a:fontRef idx="minor">
+            <a:schemeClr val="tx1"/>
+          </a:fontRef>
+        </p:style>
+      </p:cxnSp>
+      <p:cxnSp>
+        <p:nvCxnSpPr>
+          <p:cNvPr id="218" name="Connector 3">
+            <a:extLst>
+              <a:ext uri="{FF2B5EF4-FFF2-40B4-BE49-F238E27FC236}">
+                <a16:creationId xmlns:a16="http://schemas.microsoft.com/office/drawing/2014/main" id="{60350AA4-8497-718D-FC4F-E17866DF123E}"/>
+              </a:ext>
+            </a:extLst>
+          </p:cNvPr>
+          <p:cNvCxnSpPr>
+            <a:cxnSpLocks/>
+            <a:endCxn id="210" idx="1"/>
+          </p:cNvCxnSpPr>
+          <p:nvPr/>
+        </p:nvCxnSpPr>
+        <p:spPr>
+          <a:xfrm flipV="1">
+            <a:off x="13625078" y="4153143"/>
+            <a:ext cx="386960" cy="0"/>
+          </a:xfrm>
+          <a:prstGeom prst="line">
+            <a:avLst/>
+          </a:prstGeom>
+          <a:ln w="19050">
+            <a:solidFill>
+              <a:srgbClr val="2F5597"/>
+            </a:solidFill>
+            <a:tailEnd type="triangle" w="med" len="med"/>
+          </a:ln>
+        </p:spPr>
+        <p:style>
+          <a:lnRef idx="2">
+            <a:schemeClr val="accent1"/>
+          </a:lnRef>
+          <a:fillRef idx="0">
+            <a:schemeClr val="accent1"/>
+          </a:fillRef>
+          <a:effectRef idx="1">
+            <a:schemeClr val="accent1"/>
+          </a:effectRef>
+          <a:fontRef idx="minor">
+            <a:schemeClr val="tx1"/>
+          </a:fontRef>
+        </p:style>
+      </p:cxnSp>
     </p:spTree>
   </p:cSld>
   <p:clrMapOvr>

</xml_diff>

<commit_message>
Docs: CITRUS logo (sidebar, favicon, README header); flowchart re-exported from the updated slide
Co-Authored-By: Claude Fable 5.1 <noreply@anthropic.com>
</commit_message>
<xml_diff>
--- a/docs/figures/citrus_pipeline.pptx
+++ b/docs/figures/citrus_pipeline.pptx
@@ -7,7 +7,7 @@
   <p:sldIdLst>
     <p:sldId id="256" r:id="rId2"/>
   </p:sldIdLst>
-  <p:sldSz cx="15849600" cy="5029200"/>
+  <p:sldSz cx="16002000" cy="5029200"/>
   <p:notesSz cx="6858000" cy="9144000"/>
   <p:defaultTextStyle>
     <a:defPPr>
@@ -112,7 +112,7 @@
             <a:srgbClr val="A4A3A4"/>
           </p15:clr>
         </p15:guide>
-        <p15:guide id="2" pos="3744" userDrawn="1">
+        <p15:guide id="2" pos="3780" userDrawn="1">
           <p15:clr>
             <a:srgbClr val="A4A3A4"/>
           </p15:clr>
@@ -152,8 +152,8 @@
         </p:nvSpPr>
         <p:spPr>
           <a:xfrm>
-            <a:off x="891540" y="1562312"/>
-            <a:ext cx="10104120" cy="1078018"/>
+            <a:off x="900114" y="1562312"/>
+            <a:ext cx="10201275" cy="1078018"/>
           </a:xfrm>
         </p:spPr>
         <p:txBody>
@@ -179,8 +179,8 @@
         </p:nvSpPr>
         <p:spPr>
           <a:xfrm>
-            <a:off x="1783080" y="2849880"/>
-            <a:ext cx="8321040" cy="1285240"/>
+            <a:off x="1800225" y="2849880"/>
+            <a:ext cx="8401050" cy="1285240"/>
           </a:xfrm>
         </p:spPr>
         <p:txBody>
@@ -196,7 +196,7 @@
                 </a:solidFill>
               </a:defRPr>
             </a:lvl1pPr>
-            <a:lvl2pPr marL="335228" indent="0" algn="ctr">
+            <a:lvl2pPr marL="338449" indent="0" algn="ctr">
               <a:buNone/>
               <a:defRPr>
                 <a:solidFill>
@@ -206,7 +206,7 @@
                 </a:solidFill>
               </a:defRPr>
             </a:lvl2pPr>
-            <a:lvl3pPr marL="670454" indent="0" algn="ctr">
+            <a:lvl3pPr marL="676896" indent="0" algn="ctr">
               <a:buNone/>
               <a:defRPr>
                 <a:solidFill>
@@ -216,7 +216,7 @@
                 </a:solidFill>
               </a:defRPr>
             </a:lvl3pPr>
-            <a:lvl4pPr marL="1005681" indent="0" algn="ctr">
+            <a:lvl4pPr marL="1015345" indent="0" algn="ctr">
               <a:buNone/>
               <a:defRPr>
                 <a:solidFill>
@@ -226,7 +226,7 @@
                 </a:solidFill>
               </a:defRPr>
             </a:lvl4pPr>
-            <a:lvl5pPr marL="1340909" indent="0" algn="ctr">
+            <a:lvl5pPr marL="1353794" indent="0" algn="ctr">
               <a:buNone/>
               <a:defRPr>
                 <a:solidFill>
@@ -236,7 +236,7 @@
                 </a:solidFill>
               </a:defRPr>
             </a:lvl5pPr>
-            <a:lvl6pPr marL="1676136" indent="0" algn="ctr">
+            <a:lvl6pPr marL="1692242" indent="0" algn="ctr">
               <a:buNone/>
               <a:defRPr>
                 <a:solidFill>
@@ -246,7 +246,7 @@
                 </a:solidFill>
               </a:defRPr>
             </a:lvl6pPr>
-            <a:lvl7pPr marL="2011363" indent="0" algn="ctr">
+            <a:lvl7pPr marL="2030690" indent="0" algn="ctr">
               <a:buNone/>
               <a:defRPr>
                 <a:solidFill>
@@ -256,7 +256,7 @@
                 </a:solidFill>
               </a:defRPr>
             </a:lvl7pPr>
-            <a:lvl8pPr marL="2346590" indent="0" algn="ctr">
+            <a:lvl8pPr marL="2369137" indent="0" algn="ctr">
               <a:buNone/>
               <a:defRPr>
                 <a:solidFill>
@@ -266,7 +266,7 @@
                 </a:solidFill>
               </a:defRPr>
             </a:lvl8pPr>
-            <a:lvl9pPr marL="2681817" indent="0" algn="ctr">
+            <a:lvl9pPr marL="2707586" indent="0" algn="ctr">
               <a:buNone/>
               <a:defRPr>
                 <a:solidFill>
@@ -560,8 +560,8 @@
         </p:nvSpPr>
         <p:spPr>
           <a:xfrm>
-            <a:off x="8618220" y="201402"/>
-            <a:ext cx="2674620" cy="4291118"/>
+            <a:off x="8701087" y="201402"/>
+            <a:ext cx="2700338" cy="4291118"/>
           </a:xfrm>
         </p:spPr>
         <p:txBody>
@@ -587,8 +587,8 @@
         </p:nvSpPr>
         <p:spPr>
           <a:xfrm>
-            <a:off x="594360" y="201402"/>
-            <a:ext cx="7825740" cy="4291118"/>
+            <a:off x="600075" y="201402"/>
+            <a:ext cx="7900988" cy="4291118"/>
           </a:xfrm>
         </p:spPr>
         <p:txBody>
@@ -906,15 +906,15 @@
         </p:nvSpPr>
         <p:spPr>
           <a:xfrm>
-            <a:off x="939007" y="3231729"/>
-            <a:ext cx="10104120" cy="998855"/>
+            <a:off x="948037" y="3231732"/>
+            <a:ext cx="10201275" cy="998855"/>
           </a:xfrm>
         </p:spPr>
         <p:txBody>
           <a:bodyPr anchor="t"/>
           <a:lstStyle>
             <a:lvl1pPr algn="l">
-              <a:defRPr sz="2932" b="1" cap="all"/>
+              <a:defRPr sz="2960" b="1" cap="all"/>
             </a:lvl1pPr>
           </a:lstStyle>
           <a:p>
@@ -937,8 +937,8 @@
         </p:nvSpPr>
         <p:spPr>
           <a:xfrm>
-            <a:off x="939007" y="2131592"/>
-            <a:ext cx="10104120" cy="1100137"/>
+            <a:off x="948037" y="2131595"/>
+            <a:ext cx="10201275" cy="1100137"/>
           </a:xfrm>
         </p:spPr>
         <p:txBody>
@@ -946,7 +946,7 @@
           <a:lstStyle>
             <a:lvl1pPr marL="0" indent="0">
               <a:buNone/>
-              <a:defRPr sz="1467">
+              <a:defRPr sz="1481">
                 <a:solidFill>
                   <a:schemeClr val="tx1">
                     <a:tint val="75000"/>
@@ -954,9 +954,9 @@
                 </a:solidFill>
               </a:defRPr>
             </a:lvl1pPr>
-            <a:lvl2pPr marL="335228" indent="0">
-              <a:buNone/>
-              <a:defRPr sz="1320">
+            <a:lvl2pPr marL="338449" indent="0">
+              <a:buNone/>
+              <a:defRPr sz="1333">
                 <a:solidFill>
                   <a:schemeClr val="tx1">
                     <a:tint val="75000"/>
@@ -964,9 +964,9 @@
                 </a:solidFill>
               </a:defRPr>
             </a:lvl2pPr>
-            <a:lvl3pPr marL="670454" indent="0">
-              <a:buNone/>
-              <a:defRPr sz="1173">
+            <a:lvl3pPr marL="676896" indent="0">
+              <a:buNone/>
+              <a:defRPr sz="1184">
                 <a:solidFill>
                   <a:schemeClr val="tx1">
                     <a:tint val="75000"/>
@@ -974,9 +974,9 @@
                 </a:solidFill>
               </a:defRPr>
             </a:lvl3pPr>
-            <a:lvl4pPr marL="1005681" indent="0">
-              <a:buNone/>
-              <a:defRPr sz="1027">
+            <a:lvl4pPr marL="1015345" indent="0">
+              <a:buNone/>
+              <a:defRPr sz="1037">
                 <a:solidFill>
                   <a:schemeClr val="tx1">
                     <a:tint val="75000"/>
@@ -984,9 +984,9 @@
                 </a:solidFill>
               </a:defRPr>
             </a:lvl4pPr>
-            <a:lvl5pPr marL="1340909" indent="0">
-              <a:buNone/>
-              <a:defRPr sz="1027">
+            <a:lvl5pPr marL="1353794" indent="0">
+              <a:buNone/>
+              <a:defRPr sz="1037">
                 <a:solidFill>
                   <a:schemeClr val="tx1">
                     <a:tint val="75000"/>
@@ -994,9 +994,9 @@
                 </a:solidFill>
               </a:defRPr>
             </a:lvl5pPr>
-            <a:lvl6pPr marL="1676136" indent="0">
-              <a:buNone/>
-              <a:defRPr sz="1027">
+            <a:lvl6pPr marL="1692242" indent="0">
+              <a:buNone/>
+              <a:defRPr sz="1037">
                 <a:solidFill>
                   <a:schemeClr val="tx1">
                     <a:tint val="75000"/>
@@ -1004,9 +1004,9 @@
                 </a:solidFill>
               </a:defRPr>
             </a:lvl6pPr>
-            <a:lvl7pPr marL="2011363" indent="0">
-              <a:buNone/>
-              <a:defRPr sz="1027">
+            <a:lvl7pPr marL="2030690" indent="0">
+              <a:buNone/>
+              <a:defRPr sz="1037">
                 <a:solidFill>
                   <a:schemeClr val="tx1">
                     <a:tint val="75000"/>
@@ -1014,9 +1014,9 @@
                 </a:solidFill>
               </a:defRPr>
             </a:lvl7pPr>
-            <a:lvl8pPr marL="2346590" indent="0">
-              <a:buNone/>
-              <a:defRPr sz="1027">
+            <a:lvl8pPr marL="2369137" indent="0">
+              <a:buNone/>
+              <a:defRPr sz="1037">
                 <a:solidFill>
                   <a:schemeClr val="tx1">
                     <a:tint val="75000"/>
@@ -1024,9 +1024,9 @@
                 </a:solidFill>
               </a:defRPr>
             </a:lvl8pPr>
-            <a:lvl9pPr marL="2681817" indent="0">
-              <a:buNone/>
-              <a:defRPr sz="1027">
+            <a:lvl9pPr marL="2707586" indent="0">
+              <a:buNone/>
+              <a:defRPr sz="1037">
                 <a:solidFill>
                   <a:schemeClr val="tx1">
                     <a:tint val="75000"/>
@@ -1173,39 +1173,39 @@
         </p:nvSpPr>
         <p:spPr>
           <a:xfrm>
-            <a:off x="594360" y="1173480"/>
-            <a:ext cx="5250180" cy="3319040"/>
+            <a:off x="600076" y="1173480"/>
+            <a:ext cx="5300663" cy="3319040"/>
           </a:xfrm>
         </p:spPr>
         <p:txBody>
           <a:bodyPr/>
           <a:lstStyle>
             <a:lvl1pPr>
-              <a:defRPr sz="2053"/>
+              <a:defRPr sz="2073"/>
             </a:lvl1pPr>
             <a:lvl2pPr>
-              <a:defRPr sz="1760"/>
+              <a:defRPr sz="1777"/>
             </a:lvl2pPr>
             <a:lvl3pPr>
-              <a:defRPr sz="1467"/>
+              <a:defRPr sz="1481"/>
             </a:lvl3pPr>
             <a:lvl4pPr>
-              <a:defRPr sz="1320"/>
+              <a:defRPr sz="1333"/>
             </a:lvl4pPr>
             <a:lvl5pPr>
-              <a:defRPr sz="1320"/>
+              <a:defRPr sz="1333"/>
             </a:lvl5pPr>
             <a:lvl6pPr>
-              <a:defRPr sz="1320"/>
+              <a:defRPr sz="1333"/>
             </a:lvl6pPr>
             <a:lvl7pPr>
-              <a:defRPr sz="1320"/>
+              <a:defRPr sz="1333"/>
             </a:lvl7pPr>
             <a:lvl8pPr>
-              <a:defRPr sz="1320"/>
+              <a:defRPr sz="1333"/>
             </a:lvl8pPr>
             <a:lvl9pPr>
-              <a:defRPr sz="1320"/>
+              <a:defRPr sz="1333"/>
             </a:lvl9pPr>
           </a:lstStyle>
           <a:p>
@@ -1257,39 +1257,39 @@
         </p:nvSpPr>
         <p:spPr>
           <a:xfrm>
-            <a:off x="6042660" y="1173480"/>
-            <a:ext cx="5250180" cy="3319040"/>
+            <a:off x="6100762" y="1173480"/>
+            <a:ext cx="5300663" cy="3319040"/>
           </a:xfrm>
         </p:spPr>
         <p:txBody>
           <a:bodyPr/>
           <a:lstStyle>
             <a:lvl1pPr>
-              <a:defRPr sz="2053"/>
+              <a:defRPr sz="2073"/>
             </a:lvl1pPr>
             <a:lvl2pPr>
-              <a:defRPr sz="1760"/>
+              <a:defRPr sz="1777"/>
             </a:lvl2pPr>
             <a:lvl3pPr>
-              <a:defRPr sz="1467"/>
+              <a:defRPr sz="1481"/>
             </a:lvl3pPr>
             <a:lvl4pPr>
-              <a:defRPr sz="1320"/>
+              <a:defRPr sz="1333"/>
             </a:lvl4pPr>
             <a:lvl5pPr>
-              <a:defRPr sz="1320"/>
+              <a:defRPr sz="1333"/>
             </a:lvl5pPr>
             <a:lvl6pPr>
-              <a:defRPr sz="1320"/>
+              <a:defRPr sz="1333"/>
             </a:lvl6pPr>
             <a:lvl7pPr>
-              <a:defRPr sz="1320"/>
+              <a:defRPr sz="1333"/>
             </a:lvl7pPr>
             <a:lvl8pPr>
-              <a:defRPr sz="1320"/>
+              <a:defRPr sz="1333"/>
             </a:lvl8pPr>
             <a:lvl9pPr>
-              <a:defRPr sz="1320"/>
+              <a:defRPr sz="1333"/>
             </a:lvl9pPr>
           </a:lstStyle>
           <a:p>
@@ -1462,8 +1462,8 @@
         </p:nvSpPr>
         <p:spPr>
           <a:xfrm>
-            <a:off x="594360" y="1125749"/>
-            <a:ext cx="5252244" cy="469159"/>
+            <a:off x="600075" y="1125752"/>
+            <a:ext cx="5302746" cy="469159"/>
           </a:xfrm>
         </p:spPr>
         <p:txBody>
@@ -1471,39 +1471,39 @@
           <a:lstStyle>
             <a:lvl1pPr marL="0" indent="0">
               <a:buNone/>
-              <a:defRPr sz="1760" b="1"/>
+              <a:defRPr sz="1777" b="1"/>
             </a:lvl1pPr>
-            <a:lvl2pPr marL="335228" indent="0">
-              <a:buNone/>
-              <a:defRPr sz="1467" b="1"/>
+            <a:lvl2pPr marL="338449" indent="0">
+              <a:buNone/>
+              <a:defRPr sz="1481" b="1"/>
             </a:lvl2pPr>
-            <a:lvl3pPr marL="670454" indent="0">
-              <a:buNone/>
-              <a:defRPr sz="1320" b="1"/>
+            <a:lvl3pPr marL="676896" indent="0">
+              <a:buNone/>
+              <a:defRPr sz="1333" b="1"/>
             </a:lvl3pPr>
-            <a:lvl4pPr marL="1005681" indent="0">
-              <a:buNone/>
-              <a:defRPr sz="1173" b="1"/>
+            <a:lvl4pPr marL="1015345" indent="0">
+              <a:buNone/>
+              <a:defRPr sz="1184" b="1"/>
             </a:lvl4pPr>
-            <a:lvl5pPr marL="1340909" indent="0">
-              <a:buNone/>
-              <a:defRPr sz="1173" b="1"/>
+            <a:lvl5pPr marL="1353794" indent="0">
+              <a:buNone/>
+              <a:defRPr sz="1184" b="1"/>
             </a:lvl5pPr>
-            <a:lvl6pPr marL="1676136" indent="0">
-              <a:buNone/>
-              <a:defRPr sz="1173" b="1"/>
+            <a:lvl6pPr marL="1692242" indent="0">
+              <a:buNone/>
+              <a:defRPr sz="1184" b="1"/>
             </a:lvl6pPr>
-            <a:lvl7pPr marL="2011363" indent="0">
-              <a:buNone/>
-              <a:defRPr sz="1173" b="1"/>
+            <a:lvl7pPr marL="2030690" indent="0">
+              <a:buNone/>
+              <a:defRPr sz="1184" b="1"/>
             </a:lvl7pPr>
-            <a:lvl8pPr marL="2346590" indent="0">
-              <a:buNone/>
-              <a:defRPr sz="1173" b="1"/>
+            <a:lvl8pPr marL="2369137" indent="0">
+              <a:buNone/>
+              <a:defRPr sz="1184" b="1"/>
             </a:lvl8pPr>
-            <a:lvl9pPr marL="2681817" indent="0">
-              <a:buNone/>
-              <a:defRPr sz="1173" b="1"/>
+            <a:lvl9pPr marL="2707586" indent="0">
+              <a:buNone/>
+              <a:defRPr sz="1184" b="1"/>
             </a:lvl9pPr>
           </a:lstStyle>
           <a:p>
@@ -1527,39 +1527,39 @@
         </p:nvSpPr>
         <p:spPr>
           <a:xfrm>
-            <a:off x="594360" y="1594908"/>
-            <a:ext cx="5252244" cy="2897611"/>
+            <a:off x="600075" y="1594911"/>
+            <a:ext cx="5302746" cy="2897611"/>
           </a:xfrm>
         </p:spPr>
         <p:txBody>
           <a:bodyPr/>
           <a:lstStyle>
             <a:lvl1pPr>
-              <a:defRPr sz="1760"/>
+              <a:defRPr sz="1777"/>
             </a:lvl1pPr>
             <a:lvl2pPr>
-              <a:defRPr sz="1467"/>
+              <a:defRPr sz="1481"/>
             </a:lvl2pPr>
             <a:lvl3pPr>
-              <a:defRPr sz="1320"/>
+              <a:defRPr sz="1333"/>
             </a:lvl3pPr>
             <a:lvl4pPr>
-              <a:defRPr sz="1173"/>
+              <a:defRPr sz="1184"/>
             </a:lvl4pPr>
             <a:lvl5pPr>
-              <a:defRPr sz="1173"/>
+              <a:defRPr sz="1184"/>
             </a:lvl5pPr>
             <a:lvl6pPr>
-              <a:defRPr sz="1173"/>
+              <a:defRPr sz="1184"/>
             </a:lvl6pPr>
             <a:lvl7pPr>
-              <a:defRPr sz="1173"/>
+              <a:defRPr sz="1184"/>
             </a:lvl7pPr>
             <a:lvl8pPr>
-              <a:defRPr sz="1173"/>
+              <a:defRPr sz="1184"/>
             </a:lvl8pPr>
             <a:lvl9pPr>
-              <a:defRPr sz="1173"/>
+              <a:defRPr sz="1184"/>
             </a:lvl9pPr>
           </a:lstStyle>
           <a:p>
@@ -1611,8 +1611,8 @@
         </p:nvSpPr>
         <p:spPr>
           <a:xfrm>
-            <a:off x="6038534" y="1125749"/>
-            <a:ext cx="5254308" cy="469159"/>
+            <a:off x="6096597" y="1125752"/>
+            <a:ext cx="5304830" cy="469159"/>
           </a:xfrm>
         </p:spPr>
         <p:txBody>
@@ -1620,39 +1620,39 @@
           <a:lstStyle>
             <a:lvl1pPr marL="0" indent="0">
               <a:buNone/>
-              <a:defRPr sz="1760" b="1"/>
+              <a:defRPr sz="1777" b="1"/>
             </a:lvl1pPr>
-            <a:lvl2pPr marL="335228" indent="0">
-              <a:buNone/>
-              <a:defRPr sz="1467" b="1"/>
+            <a:lvl2pPr marL="338449" indent="0">
+              <a:buNone/>
+              <a:defRPr sz="1481" b="1"/>
             </a:lvl2pPr>
-            <a:lvl3pPr marL="670454" indent="0">
-              <a:buNone/>
-              <a:defRPr sz="1320" b="1"/>
+            <a:lvl3pPr marL="676896" indent="0">
+              <a:buNone/>
+              <a:defRPr sz="1333" b="1"/>
             </a:lvl3pPr>
-            <a:lvl4pPr marL="1005681" indent="0">
-              <a:buNone/>
-              <a:defRPr sz="1173" b="1"/>
+            <a:lvl4pPr marL="1015345" indent="0">
+              <a:buNone/>
+              <a:defRPr sz="1184" b="1"/>
             </a:lvl4pPr>
-            <a:lvl5pPr marL="1340909" indent="0">
-              <a:buNone/>
-              <a:defRPr sz="1173" b="1"/>
+            <a:lvl5pPr marL="1353794" indent="0">
+              <a:buNone/>
+              <a:defRPr sz="1184" b="1"/>
             </a:lvl5pPr>
-            <a:lvl6pPr marL="1676136" indent="0">
-              <a:buNone/>
-              <a:defRPr sz="1173" b="1"/>
+            <a:lvl6pPr marL="1692242" indent="0">
+              <a:buNone/>
+              <a:defRPr sz="1184" b="1"/>
             </a:lvl6pPr>
-            <a:lvl7pPr marL="2011363" indent="0">
-              <a:buNone/>
-              <a:defRPr sz="1173" b="1"/>
+            <a:lvl7pPr marL="2030690" indent="0">
+              <a:buNone/>
+              <a:defRPr sz="1184" b="1"/>
             </a:lvl7pPr>
-            <a:lvl8pPr marL="2346590" indent="0">
-              <a:buNone/>
-              <a:defRPr sz="1173" b="1"/>
+            <a:lvl8pPr marL="2369137" indent="0">
+              <a:buNone/>
+              <a:defRPr sz="1184" b="1"/>
             </a:lvl8pPr>
-            <a:lvl9pPr marL="2681817" indent="0">
-              <a:buNone/>
-              <a:defRPr sz="1173" b="1"/>
+            <a:lvl9pPr marL="2707586" indent="0">
+              <a:buNone/>
+              <a:defRPr sz="1184" b="1"/>
             </a:lvl9pPr>
           </a:lstStyle>
           <a:p>
@@ -1676,39 +1676,39 @@
         </p:nvSpPr>
         <p:spPr>
           <a:xfrm>
-            <a:off x="6038534" y="1594908"/>
-            <a:ext cx="5254308" cy="2897611"/>
+            <a:off x="6096597" y="1594911"/>
+            <a:ext cx="5304830" cy="2897611"/>
           </a:xfrm>
         </p:spPr>
         <p:txBody>
           <a:bodyPr/>
           <a:lstStyle>
             <a:lvl1pPr>
-              <a:defRPr sz="1760"/>
+              <a:defRPr sz="1777"/>
             </a:lvl1pPr>
             <a:lvl2pPr>
-              <a:defRPr sz="1467"/>
+              <a:defRPr sz="1481"/>
             </a:lvl2pPr>
             <a:lvl3pPr>
-              <a:defRPr sz="1320"/>
+              <a:defRPr sz="1333"/>
             </a:lvl3pPr>
             <a:lvl4pPr>
-              <a:defRPr sz="1173"/>
+              <a:defRPr sz="1184"/>
             </a:lvl4pPr>
             <a:lvl5pPr>
-              <a:defRPr sz="1173"/>
+              <a:defRPr sz="1184"/>
             </a:lvl5pPr>
             <a:lvl6pPr>
-              <a:defRPr sz="1173"/>
+              <a:defRPr sz="1184"/>
             </a:lvl6pPr>
             <a:lvl7pPr>
-              <a:defRPr sz="1173"/>
+              <a:defRPr sz="1184"/>
             </a:lvl7pPr>
             <a:lvl8pPr>
-              <a:defRPr sz="1173"/>
+              <a:defRPr sz="1184"/>
             </a:lvl8pPr>
             <a:lvl9pPr>
-              <a:defRPr sz="1173"/>
+              <a:defRPr sz="1184"/>
             </a:lvl9pPr>
           </a:lstStyle>
           <a:p>
@@ -2067,15 +2067,15 @@
         </p:nvSpPr>
         <p:spPr>
           <a:xfrm>
-            <a:off x="594363" y="200237"/>
-            <a:ext cx="3910807" cy="852170"/>
+            <a:off x="600080" y="200237"/>
+            <a:ext cx="3948411" cy="852170"/>
           </a:xfrm>
         </p:spPr>
         <p:txBody>
           <a:bodyPr anchor="b"/>
           <a:lstStyle>
             <a:lvl1pPr algn="l">
-              <a:defRPr sz="1467" b="1"/>
+              <a:defRPr sz="1481" b="1"/>
             </a:lvl1pPr>
           </a:lstStyle>
           <a:p>
@@ -2098,39 +2098,39 @@
         </p:nvSpPr>
         <p:spPr>
           <a:xfrm>
-            <a:off x="4647565" y="200239"/>
-            <a:ext cx="6645275" cy="4292283"/>
+            <a:off x="4692255" y="200242"/>
+            <a:ext cx="6709172" cy="4292283"/>
           </a:xfrm>
         </p:spPr>
         <p:txBody>
           <a:bodyPr/>
           <a:lstStyle>
             <a:lvl1pPr>
-              <a:defRPr sz="2347"/>
+              <a:defRPr sz="2370"/>
             </a:lvl1pPr>
             <a:lvl2pPr>
-              <a:defRPr sz="2053"/>
+              <a:defRPr sz="2073"/>
             </a:lvl2pPr>
             <a:lvl3pPr>
-              <a:defRPr sz="1760"/>
+              <a:defRPr sz="1777"/>
             </a:lvl3pPr>
             <a:lvl4pPr>
-              <a:defRPr sz="1467"/>
+              <a:defRPr sz="1481"/>
             </a:lvl4pPr>
             <a:lvl5pPr>
-              <a:defRPr sz="1467"/>
+              <a:defRPr sz="1481"/>
             </a:lvl5pPr>
             <a:lvl6pPr>
-              <a:defRPr sz="1467"/>
+              <a:defRPr sz="1481"/>
             </a:lvl6pPr>
             <a:lvl7pPr>
-              <a:defRPr sz="1467"/>
+              <a:defRPr sz="1481"/>
             </a:lvl7pPr>
             <a:lvl8pPr>
-              <a:defRPr sz="1467"/>
+              <a:defRPr sz="1481"/>
             </a:lvl8pPr>
             <a:lvl9pPr>
-              <a:defRPr sz="1467"/>
+              <a:defRPr sz="1481"/>
             </a:lvl9pPr>
           </a:lstStyle>
           <a:p>
@@ -2182,8 +2182,8 @@
         </p:nvSpPr>
         <p:spPr>
           <a:xfrm>
-            <a:off x="594363" y="1052409"/>
-            <a:ext cx="3910807" cy="3440113"/>
+            <a:off x="600080" y="1052412"/>
+            <a:ext cx="3948411" cy="3440113"/>
           </a:xfrm>
         </p:spPr>
         <p:txBody>
@@ -2191,39 +2191,39 @@
           <a:lstStyle>
             <a:lvl1pPr marL="0" indent="0">
               <a:buNone/>
-              <a:defRPr sz="1027"/>
+              <a:defRPr sz="1037"/>
             </a:lvl1pPr>
-            <a:lvl2pPr marL="335228" indent="0">
-              <a:buNone/>
-              <a:defRPr sz="880"/>
+            <a:lvl2pPr marL="338449" indent="0">
+              <a:buNone/>
+              <a:defRPr sz="888"/>
             </a:lvl2pPr>
-            <a:lvl3pPr marL="670454" indent="0">
-              <a:buNone/>
-              <a:defRPr sz="733"/>
+            <a:lvl3pPr marL="676896" indent="0">
+              <a:buNone/>
+              <a:defRPr sz="740"/>
             </a:lvl3pPr>
-            <a:lvl4pPr marL="1005681" indent="0">
-              <a:buNone/>
-              <a:defRPr sz="660"/>
+            <a:lvl4pPr marL="1015345" indent="0">
+              <a:buNone/>
+              <a:defRPr sz="666"/>
             </a:lvl4pPr>
-            <a:lvl5pPr marL="1340909" indent="0">
-              <a:buNone/>
-              <a:defRPr sz="660"/>
+            <a:lvl5pPr marL="1353794" indent="0">
+              <a:buNone/>
+              <a:defRPr sz="666"/>
             </a:lvl5pPr>
-            <a:lvl6pPr marL="1676136" indent="0">
-              <a:buNone/>
-              <a:defRPr sz="660"/>
+            <a:lvl6pPr marL="1692242" indent="0">
+              <a:buNone/>
+              <a:defRPr sz="666"/>
             </a:lvl6pPr>
-            <a:lvl7pPr marL="2011363" indent="0">
-              <a:buNone/>
-              <a:defRPr sz="660"/>
+            <a:lvl7pPr marL="2030690" indent="0">
+              <a:buNone/>
+              <a:defRPr sz="666"/>
             </a:lvl7pPr>
-            <a:lvl8pPr marL="2346590" indent="0">
-              <a:buNone/>
-              <a:defRPr sz="660"/>
+            <a:lvl8pPr marL="2369137" indent="0">
+              <a:buNone/>
+              <a:defRPr sz="666"/>
             </a:lvl8pPr>
-            <a:lvl9pPr marL="2681817" indent="0">
-              <a:buNone/>
-              <a:defRPr sz="660"/>
+            <a:lvl9pPr marL="2707586" indent="0">
+              <a:buNone/>
+              <a:defRPr sz="666"/>
             </a:lvl9pPr>
           </a:lstStyle>
           <a:p>
@@ -2342,15 +2342,15 @@
         </p:nvSpPr>
         <p:spPr>
           <a:xfrm>
-            <a:off x="2329974" y="3520440"/>
-            <a:ext cx="7132320" cy="415608"/>
+            <a:off x="2352378" y="3520440"/>
+            <a:ext cx="7200900" cy="415608"/>
           </a:xfrm>
         </p:spPr>
         <p:txBody>
           <a:bodyPr anchor="b"/>
           <a:lstStyle>
             <a:lvl1pPr algn="l">
-              <a:defRPr sz="1467" b="1"/>
+              <a:defRPr sz="1481" b="1"/>
             </a:lvl1pPr>
           </a:lstStyle>
           <a:p>
@@ -2373,8 +2373,8 @@
         </p:nvSpPr>
         <p:spPr>
           <a:xfrm>
-            <a:off x="2329974" y="449368"/>
-            <a:ext cx="7132320" cy="3017520"/>
+            <a:off x="2352378" y="449368"/>
+            <a:ext cx="7200900" cy="3017520"/>
           </a:xfrm>
         </p:spPr>
         <p:txBody>
@@ -2382,39 +2382,39 @@
           <a:lstStyle>
             <a:lvl1pPr marL="0" indent="0">
               <a:buNone/>
-              <a:defRPr sz="2347"/>
+              <a:defRPr sz="2370"/>
             </a:lvl1pPr>
-            <a:lvl2pPr marL="335228" indent="0">
-              <a:buNone/>
-              <a:defRPr sz="2053"/>
+            <a:lvl2pPr marL="338449" indent="0">
+              <a:buNone/>
+              <a:defRPr sz="2073"/>
             </a:lvl2pPr>
-            <a:lvl3pPr marL="670454" indent="0">
-              <a:buNone/>
-              <a:defRPr sz="1760"/>
+            <a:lvl3pPr marL="676896" indent="0">
+              <a:buNone/>
+              <a:defRPr sz="1777"/>
             </a:lvl3pPr>
-            <a:lvl4pPr marL="1005681" indent="0">
-              <a:buNone/>
-              <a:defRPr sz="1467"/>
+            <a:lvl4pPr marL="1015345" indent="0">
+              <a:buNone/>
+              <a:defRPr sz="1481"/>
             </a:lvl4pPr>
-            <a:lvl5pPr marL="1340909" indent="0">
-              <a:buNone/>
-              <a:defRPr sz="1467"/>
+            <a:lvl5pPr marL="1353794" indent="0">
+              <a:buNone/>
+              <a:defRPr sz="1481"/>
             </a:lvl5pPr>
-            <a:lvl6pPr marL="1676136" indent="0">
-              <a:buNone/>
-              <a:defRPr sz="1467"/>
+            <a:lvl6pPr marL="1692242" indent="0">
+              <a:buNone/>
+              <a:defRPr sz="1481"/>
             </a:lvl6pPr>
-            <a:lvl7pPr marL="2011363" indent="0">
-              <a:buNone/>
-              <a:defRPr sz="1467"/>
+            <a:lvl7pPr marL="2030690" indent="0">
+              <a:buNone/>
+              <a:defRPr sz="1481"/>
             </a:lvl7pPr>
-            <a:lvl8pPr marL="2346590" indent="0">
-              <a:buNone/>
-              <a:defRPr sz="1467"/>
+            <a:lvl8pPr marL="2369137" indent="0">
+              <a:buNone/>
+              <a:defRPr sz="1481"/>
             </a:lvl8pPr>
-            <a:lvl9pPr marL="2681817" indent="0">
-              <a:buNone/>
-              <a:defRPr sz="1467"/>
+            <a:lvl9pPr marL="2707586" indent="0">
+              <a:buNone/>
+              <a:defRPr sz="1481"/>
             </a:lvl9pPr>
           </a:lstStyle>
           <a:p>
@@ -2434,8 +2434,8 @@
         </p:nvSpPr>
         <p:spPr>
           <a:xfrm>
-            <a:off x="2329974" y="3936048"/>
-            <a:ext cx="7132320" cy="590232"/>
+            <a:off x="2352378" y="3936048"/>
+            <a:ext cx="7200900" cy="590232"/>
           </a:xfrm>
         </p:spPr>
         <p:txBody>
@@ -2443,39 +2443,39 @@
           <a:lstStyle>
             <a:lvl1pPr marL="0" indent="0">
               <a:buNone/>
-              <a:defRPr sz="1027"/>
+              <a:defRPr sz="1037"/>
             </a:lvl1pPr>
-            <a:lvl2pPr marL="335228" indent="0">
-              <a:buNone/>
-              <a:defRPr sz="880"/>
+            <a:lvl2pPr marL="338449" indent="0">
+              <a:buNone/>
+              <a:defRPr sz="888"/>
             </a:lvl2pPr>
-            <a:lvl3pPr marL="670454" indent="0">
-              <a:buNone/>
-              <a:defRPr sz="733"/>
+            <a:lvl3pPr marL="676896" indent="0">
+              <a:buNone/>
+              <a:defRPr sz="740"/>
             </a:lvl3pPr>
-            <a:lvl4pPr marL="1005681" indent="0">
-              <a:buNone/>
-              <a:defRPr sz="660"/>
+            <a:lvl4pPr marL="1015345" indent="0">
+              <a:buNone/>
+              <a:defRPr sz="666"/>
             </a:lvl4pPr>
-            <a:lvl5pPr marL="1340909" indent="0">
-              <a:buNone/>
-              <a:defRPr sz="660"/>
+            <a:lvl5pPr marL="1353794" indent="0">
+              <a:buNone/>
+              <a:defRPr sz="666"/>
             </a:lvl5pPr>
-            <a:lvl6pPr marL="1676136" indent="0">
-              <a:buNone/>
-              <a:defRPr sz="660"/>
+            <a:lvl6pPr marL="1692242" indent="0">
+              <a:buNone/>
+              <a:defRPr sz="666"/>
             </a:lvl6pPr>
-            <a:lvl7pPr marL="2011363" indent="0">
-              <a:buNone/>
-              <a:defRPr sz="660"/>
+            <a:lvl7pPr marL="2030690" indent="0">
+              <a:buNone/>
+              <a:defRPr sz="666"/>
             </a:lvl7pPr>
-            <a:lvl8pPr marL="2346590" indent="0">
-              <a:buNone/>
-              <a:defRPr sz="660"/>
+            <a:lvl8pPr marL="2369137" indent="0">
+              <a:buNone/>
+              <a:defRPr sz="666"/>
             </a:lvl8pPr>
-            <a:lvl9pPr marL="2681817" indent="0">
-              <a:buNone/>
-              <a:defRPr sz="660"/>
+            <a:lvl9pPr marL="2707586" indent="0">
+              <a:buNone/>
+              <a:defRPr sz="666"/>
             </a:lvl9pPr>
           </a:lstStyle>
           <a:p>
@@ -2599,8 +2599,8 @@
         </p:nvSpPr>
         <p:spPr>
           <a:xfrm>
-            <a:off x="594360" y="201401"/>
-            <a:ext cx="10698480" cy="838200"/>
+            <a:off x="600075" y="201401"/>
+            <a:ext cx="10801350" cy="838200"/>
           </a:xfrm>
           <a:prstGeom prst="rect">
             <a:avLst/>
@@ -2631,8 +2631,8 @@
         </p:nvSpPr>
         <p:spPr>
           <a:xfrm>
-            <a:off x="594360" y="1173480"/>
-            <a:ext cx="10698480" cy="3319040"/>
+            <a:off x="600075" y="1173480"/>
+            <a:ext cx="10801350" cy="3319040"/>
           </a:xfrm>
           <a:prstGeom prst="rect">
             <a:avLst/>
@@ -2692,8 +2692,8 @@
         </p:nvSpPr>
         <p:spPr>
           <a:xfrm>
-            <a:off x="594360" y="4661325"/>
-            <a:ext cx="2773680" cy="267758"/>
+            <a:off x="600075" y="4661325"/>
+            <a:ext cx="2800350" cy="267758"/>
           </a:xfrm>
           <a:prstGeom prst="rect">
             <a:avLst/>
@@ -2703,7 +2703,7 @@
           <a:bodyPr vert="horz" lIns="91440" tIns="45720" rIns="91440" bIns="45720" rtlCol="0" anchor="ctr"/>
           <a:lstStyle>
             <a:lvl1pPr algn="l">
-              <a:defRPr sz="880">
+              <a:defRPr sz="888">
                 <a:solidFill>
                   <a:schemeClr val="tx1">
                     <a:tint val="75000"/>
@@ -2733,8 +2733,8 @@
         </p:nvSpPr>
         <p:spPr>
           <a:xfrm>
-            <a:off x="4061460" y="4661325"/>
-            <a:ext cx="3764280" cy="267758"/>
+            <a:off x="4100514" y="4661325"/>
+            <a:ext cx="3800475" cy="267758"/>
           </a:xfrm>
           <a:prstGeom prst="rect">
             <a:avLst/>
@@ -2744,7 +2744,7 @@
           <a:bodyPr vert="horz" lIns="91440" tIns="45720" rIns="91440" bIns="45720" rtlCol="0" anchor="ctr"/>
           <a:lstStyle>
             <a:lvl1pPr algn="ctr">
-              <a:defRPr sz="880">
+              <a:defRPr sz="888">
                 <a:solidFill>
                   <a:schemeClr val="tx1">
                     <a:tint val="75000"/>
@@ -2770,8 +2770,8 @@
         </p:nvSpPr>
         <p:spPr>
           <a:xfrm>
-            <a:off x="8519160" y="4661325"/>
-            <a:ext cx="2773680" cy="267758"/>
+            <a:off x="8601075" y="4661325"/>
+            <a:ext cx="2800350" cy="267758"/>
           </a:xfrm>
           <a:prstGeom prst="rect">
             <a:avLst/>
@@ -2781,7 +2781,7 @@
           <a:bodyPr vert="horz" lIns="91440" tIns="45720" rIns="91440" bIns="45720" rtlCol="0" anchor="ctr"/>
           <a:lstStyle>
             <a:lvl1pPr algn="r">
-              <a:defRPr sz="880">
+              <a:defRPr sz="888">
                 <a:solidFill>
                   <a:schemeClr val="tx1">
                     <a:tint val="75000"/>
@@ -2822,12 +2822,12 @@
   </p:sldLayoutIdLst>
   <p:txStyles>
     <p:titleStyle>
-      <a:lvl1pPr algn="ctr" defTabSz="335228" rtl="0" eaLnBrk="1" latinLnBrk="0" hangingPunct="1">
+      <a:lvl1pPr algn="ctr" defTabSz="338449" rtl="0" eaLnBrk="1" latinLnBrk="0" hangingPunct="1">
         <a:spcBef>
           <a:spcPct val="0"/>
         </a:spcBef>
         <a:buNone/>
-        <a:defRPr sz="3227" kern="1200">
+        <a:defRPr sz="3258" kern="1200">
           <a:solidFill>
             <a:schemeClr val="tx1"/>
           </a:solidFill>
@@ -2838,13 +2838,13 @@
       </a:lvl1pPr>
     </p:titleStyle>
     <p:bodyStyle>
-      <a:lvl1pPr marL="251420" indent="-251420" algn="l" defTabSz="335228" rtl="0" eaLnBrk="1" latinLnBrk="0" hangingPunct="1">
+      <a:lvl1pPr marL="253837" indent="-253837" algn="l" defTabSz="338449" rtl="0" eaLnBrk="1" latinLnBrk="0" hangingPunct="1">
         <a:spcBef>
           <a:spcPct val="20000"/>
         </a:spcBef>
         <a:buFont typeface="Arial"/>
         <a:buChar char="•"/>
-        <a:defRPr sz="2347" kern="1200">
+        <a:defRPr sz="2370" kern="1200">
           <a:solidFill>
             <a:schemeClr val="tx1"/>
           </a:solidFill>
@@ -2853,13 +2853,13 @@
           <a:cs typeface="+mn-cs"/>
         </a:defRPr>
       </a:lvl1pPr>
-      <a:lvl2pPr marL="544744" indent="-209517" algn="l" defTabSz="335228" rtl="0" eaLnBrk="1" latinLnBrk="0" hangingPunct="1">
+      <a:lvl2pPr marL="549979" indent="-211529" algn="l" defTabSz="338449" rtl="0" eaLnBrk="1" latinLnBrk="0" hangingPunct="1">
         <a:spcBef>
           <a:spcPct val="20000"/>
         </a:spcBef>
         <a:buFont typeface="Arial"/>
         <a:buChar char="–"/>
-        <a:defRPr sz="2053" kern="1200">
+        <a:defRPr sz="2073" kern="1200">
           <a:solidFill>
             <a:schemeClr val="tx1"/>
           </a:solidFill>
@@ -2868,13 +2868,13 @@
           <a:cs typeface="+mn-cs"/>
         </a:defRPr>
       </a:lvl2pPr>
-      <a:lvl3pPr marL="838067" indent="-167614" algn="l" defTabSz="335228" rtl="0" eaLnBrk="1" latinLnBrk="0" hangingPunct="1">
+      <a:lvl3pPr marL="846120" indent="-169224" algn="l" defTabSz="338449" rtl="0" eaLnBrk="1" latinLnBrk="0" hangingPunct="1">
         <a:spcBef>
           <a:spcPct val="20000"/>
         </a:spcBef>
         <a:buFont typeface="Arial"/>
         <a:buChar char="•"/>
-        <a:defRPr sz="1760" kern="1200">
+        <a:defRPr sz="1777" kern="1200">
           <a:solidFill>
             <a:schemeClr val="tx1"/>
           </a:solidFill>
@@ -2883,13 +2883,13 @@
           <a:cs typeface="+mn-cs"/>
         </a:defRPr>
       </a:lvl3pPr>
-      <a:lvl4pPr marL="1173295" indent="-167614" algn="l" defTabSz="335228" rtl="0" eaLnBrk="1" latinLnBrk="0" hangingPunct="1">
+      <a:lvl4pPr marL="1184570" indent="-169224" algn="l" defTabSz="338449" rtl="0" eaLnBrk="1" latinLnBrk="0" hangingPunct="1">
         <a:spcBef>
           <a:spcPct val="20000"/>
         </a:spcBef>
         <a:buFont typeface="Arial"/>
         <a:buChar char="–"/>
-        <a:defRPr sz="1467" kern="1200">
+        <a:defRPr sz="1481" kern="1200">
           <a:solidFill>
             <a:schemeClr val="tx1"/>
           </a:solidFill>
@@ -2898,13 +2898,13 @@
           <a:cs typeface="+mn-cs"/>
         </a:defRPr>
       </a:lvl4pPr>
-      <a:lvl5pPr marL="1508522" indent="-167614" algn="l" defTabSz="335228" rtl="0" eaLnBrk="1" latinLnBrk="0" hangingPunct="1">
+      <a:lvl5pPr marL="1523017" indent="-169224" algn="l" defTabSz="338449" rtl="0" eaLnBrk="1" latinLnBrk="0" hangingPunct="1">
         <a:spcBef>
           <a:spcPct val="20000"/>
         </a:spcBef>
         <a:buFont typeface="Arial"/>
         <a:buChar char="»"/>
-        <a:defRPr sz="1467" kern="1200">
+        <a:defRPr sz="1481" kern="1200">
           <a:solidFill>
             <a:schemeClr val="tx1"/>
           </a:solidFill>
@@ -2913,13 +2913,13 @@
           <a:cs typeface="+mn-cs"/>
         </a:defRPr>
       </a:lvl5pPr>
-      <a:lvl6pPr marL="1843749" indent="-167614" algn="l" defTabSz="335228" rtl="0" eaLnBrk="1" latinLnBrk="0" hangingPunct="1">
+      <a:lvl6pPr marL="1861465" indent="-169224" algn="l" defTabSz="338449" rtl="0" eaLnBrk="1" latinLnBrk="0" hangingPunct="1">
         <a:spcBef>
           <a:spcPct val="20000"/>
         </a:spcBef>
         <a:buFont typeface="Arial"/>
         <a:buChar char="•"/>
-        <a:defRPr sz="1467" kern="1200">
+        <a:defRPr sz="1481" kern="1200">
           <a:solidFill>
             <a:schemeClr val="tx1"/>
           </a:solidFill>
@@ -2928,13 +2928,13 @@
           <a:cs typeface="+mn-cs"/>
         </a:defRPr>
       </a:lvl6pPr>
-      <a:lvl7pPr marL="2178977" indent="-167614" algn="l" defTabSz="335228" rtl="0" eaLnBrk="1" latinLnBrk="0" hangingPunct="1">
+      <a:lvl7pPr marL="2199914" indent="-169224" algn="l" defTabSz="338449" rtl="0" eaLnBrk="1" latinLnBrk="0" hangingPunct="1">
         <a:spcBef>
           <a:spcPct val="20000"/>
         </a:spcBef>
         <a:buFont typeface="Arial"/>
         <a:buChar char="•"/>
-        <a:defRPr sz="1467" kern="1200">
+        <a:defRPr sz="1481" kern="1200">
           <a:solidFill>
             <a:schemeClr val="tx1"/>
           </a:solidFill>
@@ -2943,13 +2943,13 @@
           <a:cs typeface="+mn-cs"/>
         </a:defRPr>
       </a:lvl7pPr>
-      <a:lvl8pPr marL="2514203" indent="-167614" algn="l" defTabSz="335228" rtl="0" eaLnBrk="1" latinLnBrk="0" hangingPunct="1">
+      <a:lvl8pPr marL="2538362" indent="-169224" algn="l" defTabSz="338449" rtl="0" eaLnBrk="1" latinLnBrk="0" hangingPunct="1">
         <a:spcBef>
           <a:spcPct val="20000"/>
         </a:spcBef>
         <a:buFont typeface="Arial"/>
         <a:buChar char="•"/>
-        <a:defRPr sz="1467" kern="1200">
+        <a:defRPr sz="1481" kern="1200">
           <a:solidFill>
             <a:schemeClr val="tx1"/>
           </a:solidFill>
@@ -2958,13 +2958,13 @@
           <a:cs typeface="+mn-cs"/>
         </a:defRPr>
       </a:lvl8pPr>
-      <a:lvl9pPr marL="2849431" indent="-167614" algn="l" defTabSz="335228" rtl="0" eaLnBrk="1" latinLnBrk="0" hangingPunct="1">
+      <a:lvl9pPr marL="2876812" indent="-169224" algn="l" defTabSz="338449" rtl="0" eaLnBrk="1" latinLnBrk="0" hangingPunct="1">
         <a:spcBef>
           <a:spcPct val="20000"/>
         </a:spcBef>
         <a:buFont typeface="Arial"/>
         <a:buChar char="•"/>
-        <a:defRPr sz="1467" kern="1200">
+        <a:defRPr sz="1481" kern="1200">
           <a:solidFill>
             <a:schemeClr val="tx1"/>
           </a:solidFill>
@@ -2978,8 +2978,8 @@
       <a:defPPr>
         <a:defRPr lang="en-US"/>
       </a:defPPr>
-      <a:lvl1pPr marL="0" algn="l" defTabSz="335228" rtl="0" eaLnBrk="1" latinLnBrk="0" hangingPunct="1">
-        <a:defRPr sz="1320" kern="1200">
+      <a:lvl1pPr marL="0" algn="l" defTabSz="338449" rtl="0" eaLnBrk="1" latinLnBrk="0" hangingPunct="1">
+        <a:defRPr sz="1333" kern="1200">
           <a:solidFill>
             <a:schemeClr val="tx1"/>
           </a:solidFill>
@@ -2988,8 +2988,8 @@
           <a:cs typeface="+mn-cs"/>
         </a:defRPr>
       </a:lvl1pPr>
-      <a:lvl2pPr marL="335228" algn="l" defTabSz="335228" rtl="0" eaLnBrk="1" latinLnBrk="0" hangingPunct="1">
-        <a:defRPr sz="1320" kern="1200">
+      <a:lvl2pPr marL="338449" algn="l" defTabSz="338449" rtl="0" eaLnBrk="1" latinLnBrk="0" hangingPunct="1">
+        <a:defRPr sz="1333" kern="1200">
           <a:solidFill>
             <a:schemeClr val="tx1"/>
           </a:solidFill>
@@ -2998,8 +2998,8 @@
           <a:cs typeface="+mn-cs"/>
         </a:defRPr>
       </a:lvl2pPr>
-      <a:lvl3pPr marL="670454" algn="l" defTabSz="335228" rtl="0" eaLnBrk="1" latinLnBrk="0" hangingPunct="1">
-        <a:defRPr sz="1320" kern="1200">
+      <a:lvl3pPr marL="676896" algn="l" defTabSz="338449" rtl="0" eaLnBrk="1" latinLnBrk="0" hangingPunct="1">
+        <a:defRPr sz="1333" kern="1200">
           <a:solidFill>
             <a:schemeClr val="tx1"/>
           </a:solidFill>
@@ -3008,8 +3008,8 @@
           <a:cs typeface="+mn-cs"/>
         </a:defRPr>
       </a:lvl3pPr>
-      <a:lvl4pPr marL="1005681" algn="l" defTabSz="335228" rtl="0" eaLnBrk="1" latinLnBrk="0" hangingPunct="1">
-        <a:defRPr sz="1320" kern="1200">
+      <a:lvl4pPr marL="1015345" algn="l" defTabSz="338449" rtl="0" eaLnBrk="1" latinLnBrk="0" hangingPunct="1">
+        <a:defRPr sz="1333" kern="1200">
           <a:solidFill>
             <a:schemeClr val="tx1"/>
           </a:solidFill>
@@ -3018,8 +3018,8 @@
           <a:cs typeface="+mn-cs"/>
         </a:defRPr>
       </a:lvl4pPr>
-      <a:lvl5pPr marL="1340909" algn="l" defTabSz="335228" rtl="0" eaLnBrk="1" latinLnBrk="0" hangingPunct="1">
-        <a:defRPr sz="1320" kern="1200">
+      <a:lvl5pPr marL="1353794" algn="l" defTabSz="338449" rtl="0" eaLnBrk="1" latinLnBrk="0" hangingPunct="1">
+        <a:defRPr sz="1333" kern="1200">
           <a:solidFill>
             <a:schemeClr val="tx1"/>
           </a:solidFill>
@@ -3028,8 +3028,8 @@
           <a:cs typeface="+mn-cs"/>
         </a:defRPr>
       </a:lvl5pPr>
-      <a:lvl6pPr marL="1676136" algn="l" defTabSz="335228" rtl="0" eaLnBrk="1" latinLnBrk="0" hangingPunct="1">
-        <a:defRPr sz="1320" kern="1200">
+      <a:lvl6pPr marL="1692242" algn="l" defTabSz="338449" rtl="0" eaLnBrk="1" latinLnBrk="0" hangingPunct="1">
+        <a:defRPr sz="1333" kern="1200">
           <a:solidFill>
             <a:schemeClr val="tx1"/>
           </a:solidFill>
@@ -3038,8 +3038,8 @@
           <a:cs typeface="+mn-cs"/>
         </a:defRPr>
       </a:lvl6pPr>
-      <a:lvl7pPr marL="2011363" algn="l" defTabSz="335228" rtl="0" eaLnBrk="1" latinLnBrk="0" hangingPunct="1">
-        <a:defRPr sz="1320" kern="1200">
+      <a:lvl7pPr marL="2030690" algn="l" defTabSz="338449" rtl="0" eaLnBrk="1" latinLnBrk="0" hangingPunct="1">
+        <a:defRPr sz="1333" kern="1200">
           <a:solidFill>
             <a:schemeClr val="tx1"/>
           </a:solidFill>
@@ -3048,8 +3048,8 @@
           <a:cs typeface="+mn-cs"/>
         </a:defRPr>
       </a:lvl7pPr>
-      <a:lvl8pPr marL="2346590" algn="l" defTabSz="335228" rtl="0" eaLnBrk="1" latinLnBrk="0" hangingPunct="1">
-        <a:defRPr sz="1320" kern="1200">
+      <a:lvl8pPr marL="2369137" algn="l" defTabSz="338449" rtl="0" eaLnBrk="1" latinLnBrk="0" hangingPunct="1">
+        <a:defRPr sz="1333" kern="1200">
           <a:solidFill>
             <a:schemeClr val="tx1"/>
           </a:solidFill>
@@ -3058,8 +3058,8 @@
           <a:cs typeface="+mn-cs"/>
         </a:defRPr>
       </a:lvl8pPr>
-      <a:lvl9pPr marL="2681817" algn="l" defTabSz="335228" rtl="0" eaLnBrk="1" latinLnBrk="0" hangingPunct="1">
-        <a:defRPr sz="1320" kern="1200">
+      <a:lvl9pPr marL="2707586" algn="l" defTabSz="338449" rtl="0" eaLnBrk="1" latinLnBrk="0" hangingPunct="1">
+        <a:defRPr sz="1333" kern="1200">
           <a:solidFill>
             <a:schemeClr val="tx1"/>
           </a:solidFill>
@@ -3092,10 +3092,10 @@
       </p:grpSpPr>
       <p:sp>
         <p:nvSpPr>
-          <p:cNvPr id="181" name="Rounded Rectangle 1">
+          <p:cNvPr id="2" name="Rounded Rectangle 1">
             <a:extLst>
               <a:ext uri="{FF2B5EF4-FFF2-40B4-BE49-F238E27FC236}">
-                <a16:creationId xmlns:a16="http://schemas.microsoft.com/office/drawing/2014/main" id="{00CB0606-CB25-9820-417C-2296C47E5578}"/>
+                <a16:creationId xmlns:a16="http://schemas.microsoft.com/office/drawing/2014/main" id="{7ED0B813-2DDD-A2CF-5F80-3B7DEA375B29}"/>
               </a:ext>
             </a:extLst>
           </p:cNvPr>
@@ -3104,7 +3104,7 @@
         </p:nvSpPr>
         <p:spPr>
           <a:xfrm>
-            <a:off x="-8960" y="347894"/>
+            <a:off x="60711" y="347894"/>
             <a:ext cx="1828800" cy="914400"/>
           </a:xfrm>
           <a:prstGeom prst="roundRect">
@@ -3173,10 +3173,10 @@
       </p:sp>
       <p:sp>
         <p:nvSpPr>
-          <p:cNvPr id="182" name="Rounded Rectangle 2">
+          <p:cNvPr id="3" name="Rounded Rectangle 2">
             <a:extLst>
               <a:ext uri="{FF2B5EF4-FFF2-40B4-BE49-F238E27FC236}">
-                <a16:creationId xmlns:a16="http://schemas.microsoft.com/office/drawing/2014/main" id="{E8F3EBA8-0DE3-6182-FD1E-F40F0F262D61}"/>
+                <a16:creationId xmlns:a16="http://schemas.microsoft.com/office/drawing/2014/main" id="{63D0A335-8CB1-81F3-D9FE-F7FA714054D0}"/>
               </a:ext>
             </a:extLst>
           </p:cNvPr>
@@ -3185,7 +3185,7 @@
         </p:nvSpPr>
         <p:spPr>
           <a:xfrm>
-            <a:off x="2187255" y="350391"/>
+            <a:off x="2256926" y="350391"/>
             <a:ext cx="2057400" cy="914400"/>
           </a:xfrm>
           <a:prstGeom prst="roundRect">
@@ -3248,23 +3248,23 @@
       </p:sp>
       <p:cxnSp>
         <p:nvCxnSpPr>
-          <p:cNvPr id="183" name="Connector 3">
+          <p:cNvPr id="4" name="Connector 3">
             <a:extLst>
               <a:ext uri="{FF2B5EF4-FFF2-40B4-BE49-F238E27FC236}">
-                <a16:creationId xmlns:a16="http://schemas.microsoft.com/office/drawing/2014/main" id="{018F8213-E94E-0E31-54C1-CAE9C314B719}"/>
+                <a16:creationId xmlns:a16="http://schemas.microsoft.com/office/drawing/2014/main" id="{3979C167-4356-4B0D-E519-3543D0732354}"/>
               </a:ext>
             </a:extLst>
           </p:cNvPr>
           <p:cNvCxnSpPr>
             <a:cxnSpLocks/>
-            <a:stCxn id="181" idx="3"/>
-            <a:endCxn id="182" idx="1"/>
+            <a:stCxn id="2" idx="3"/>
+            <a:endCxn id="3" idx="1"/>
           </p:cNvCxnSpPr>
           <p:nvPr/>
         </p:nvCxnSpPr>
         <p:spPr>
           <a:xfrm>
-            <a:off x="1819840" y="805095"/>
+            <a:off x="1889512" y="805096"/>
             <a:ext cx="367415" cy="2497"/>
           </a:xfrm>
           <a:prstGeom prst="line">
@@ -3294,10 +3294,10 @@
       </p:cxnSp>
       <p:sp>
         <p:nvSpPr>
-          <p:cNvPr id="184" name="Rounded Rectangle 4">
+          <p:cNvPr id="5" name="Rounded Rectangle 4">
             <a:extLst>
               <a:ext uri="{FF2B5EF4-FFF2-40B4-BE49-F238E27FC236}">
-                <a16:creationId xmlns:a16="http://schemas.microsoft.com/office/drawing/2014/main" id="{8C705704-A0AC-DD60-E07D-F379A2BAD4B6}"/>
+                <a16:creationId xmlns:a16="http://schemas.microsoft.com/office/drawing/2014/main" id="{22A5A8EE-7142-3E24-A565-37D8621696DB}"/>
               </a:ext>
             </a:extLst>
           </p:cNvPr>
@@ -3306,7 +3306,7 @@
         </p:nvSpPr>
         <p:spPr>
           <a:xfrm>
-            <a:off x="4581296" y="34283"/>
+            <a:off x="4650967" y="34284"/>
             <a:ext cx="9156421" cy="4957966"/>
           </a:xfrm>
           <a:prstGeom prst="roundRect">
@@ -3348,10 +3348,10 @@
       </p:sp>
       <p:sp>
         <p:nvSpPr>
-          <p:cNvPr id="185" name="TextBox 184">
+          <p:cNvPr id="6" name="TextBox 5">
             <a:extLst>
               <a:ext uri="{FF2B5EF4-FFF2-40B4-BE49-F238E27FC236}">
-                <a16:creationId xmlns:a16="http://schemas.microsoft.com/office/drawing/2014/main" id="{57458EDD-3903-675B-FA2C-0661ACA86968}"/>
+                <a16:creationId xmlns:a16="http://schemas.microsoft.com/office/drawing/2014/main" id="{56155C70-B8E2-027C-4226-1C89CE065E24}"/>
               </a:ext>
             </a:extLst>
           </p:cNvPr>
@@ -3360,7 +3360,7 @@
         </p:nvSpPr>
         <p:spPr>
           <a:xfrm>
-            <a:off x="5044706" y="68153"/>
+            <a:off x="5114378" y="68153"/>
             <a:ext cx="8229600" cy="215444"/>
           </a:xfrm>
           <a:prstGeom prst="rect">
@@ -3398,10 +3398,10 @@
       </p:sp>
       <p:sp>
         <p:nvSpPr>
-          <p:cNvPr id="186" name="Rounded Rectangle 6">
+          <p:cNvPr id="7" name="Rounded Rectangle 6">
             <a:extLst>
               <a:ext uri="{FF2B5EF4-FFF2-40B4-BE49-F238E27FC236}">
-                <a16:creationId xmlns:a16="http://schemas.microsoft.com/office/drawing/2014/main" id="{92D72720-168C-8B3D-27DF-E89861548A38}"/>
+                <a16:creationId xmlns:a16="http://schemas.microsoft.com/office/drawing/2014/main" id="{511DE164-900E-74B3-C098-E6F37ADF4698}"/>
               </a:ext>
             </a:extLst>
           </p:cNvPr>
@@ -3410,7 +3410,7 @@
         </p:nvSpPr>
         <p:spPr>
           <a:xfrm>
-            <a:off x="4981346" y="350392"/>
+            <a:off x="5051018" y="350392"/>
             <a:ext cx="3200400" cy="914400"/>
           </a:xfrm>
           <a:prstGeom prst="roundRect">
@@ -3527,10 +3527,10 @@
       </p:sp>
       <p:sp>
         <p:nvSpPr>
-          <p:cNvPr id="187" name="Rectangle 186">
+          <p:cNvPr id="8" name="Rectangle 7">
             <a:extLst>
               <a:ext uri="{FF2B5EF4-FFF2-40B4-BE49-F238E27FC236}">
-                <a16:creationId xmlns:a16="http://schemas.microsoft.com/office/drawing/2014/main" id="{85FACF2A-BD9B-7ACD-1510-CB5D5DE9BE23}"/>
+                <a16:creationId xmlns:a16="http://schemas.microsoft.com/office/drawing/2014/main" id="{C61BCD64-4305-B479-9B35-7D88082CF865}"/>
               </a:ext>
             </a:extLst>
           </p:cNvPr>
@@ -3539,7 +3539,7 @@
         </p:nvSpPr>
         <p:spPr>
           <a:xfrm>
-            <a:off x="5484267" y="1584835"/>
+            <a:off x="5553939" y="1584835"/>
             <a:ext cx="7863839" cy="1735328"/>
           </a:xfrm>
           <a:prstGeom prst="rect">
@@ -3580,10 +3580,10 @@
       </p:sp>
       <p:sp>
         <p:nvSpPr>
-          <p:cNvPr id="188" name="TextBox 187">
+          <p:cNvPr id="9" name="TextBox 8">
             <a:extLst>
               <a:ext uri="{FF2B5EF4-FFF2-40B4-BE49-F238E27FC236}">
-                <a16:creationId xmlns:a16="http://schemas.microsoft.com/office/drawing/2014/main" id="{FC14AA77-A85D-0A93-9AEF-E428C79B02E0}"/>
+                <a16:creationId xmlns:a16="http://schemas.microsoft.com/office/drawing/2014/main" id="{05B78C48-514F-D9E9-9614-A97411718BB8}"/>
               </a:ext>
             </a:extLst>
           </p:cNvPr>
@@ -3592,7 +3592,7 @@
         </p:nvSpPr>
         <p:spPr>
           <a:xfrm>
-            <a:off x="5483788" y="1612268"/>
+            <a:off x="5553460" y="1612268"/>
             <a:ext cx="7864319" cy="215444"/>
           </a:xfrm>
           <a:prstGeom prst="rect">
@@ -3636,10 +3636,10 @@
       </p:sp>
       <p:sp>
         <p:nvSpPr>
-          <p:cNvPr id="189" name="Rounded Rectangle 10">
+          <p:cNvPr id="10" name="Rounded Rectangle 10">
             <a:extLst>
               <a:ext uri="{FF2B5EF4-FFF2-40B4-BE49-F238E27FC236}">
-                <a16:creationId xmlns:a16="http://schemas.microsoft.com/office/drawing/2014/main" id="{BD6A9EC6-68A6-0B1C-3674-E1362F97DE7A}"/>
+                <a16:creationId xmlns:a16="http://schemas.microsoft.com/office/drawing/2014/main" id="{7302C8C5-66D2-DCEA-6BAB-A81690E9EEF9}"/>
               </a:ext>
             </a:extLst>
           </p:cNvPr>
@@ -3648,7 +3648,7 @@
         </p:nvSpPr>
         <p:spPr>
           <a:xfrm>
-            <a:off x="5621424" y="1923163"/>
+            <a:off x="5691095" y="1923163"/>
             <a:ext cx="2286000" cy="914400"/>
           </a:xfrm>
           <a:prstGeom prst="roundRect">
@@ -3743,7 +3743,7 @@
                 </a:solidFill>
                 <a:latin typeface="Calibri"/>
               </a:rPr>
-              <a:t>Computed from </a:t>
+              <a:t>computed from </a:t>
             </a:r>
             <a:r>
               <a:rPr sz="1100" dirty="0">
@@ -3795,10 +3795,10 @@
       </p:sp>
       <p:sp>
         <p:nvSpPr>
-          <p:cNvPr id="190" name="Rounded Rectangle 12">
+          <p:cNvPr id="11" name="Rounded Rectangle 12">
             <a:extLst>
               <a:ext uri="{FF2B5EF4-FFF2-40B4-BE49-F238E27FC236}">
-                <a16:creationId xmlns:a16="http://schemas.microsoft.com/office/drawing/2014/main" id="{82ECFF69-E2FC-9ED2-B01C-A4A8981ACE64}"/>
+                <a16:creationId xmlns:a16="http://schemas.microsoft.com/office/drawing/2014/main" id="{255AECA5-1A50-FDF1-34D4-2FF1C48D9EA9}"/>
               </a:ext>
             </a:extLst>
           </p:cNvPr>
@@ -3807,7 +3807,7 @@
         </p:nvSpPr>
         <p:spPr>
           <a:xfrm>
-            <a:off x="11154630" y="1920892"/>
+            <a:off x="11224302" y="1920892"/>
             <a:ext cx="2057400" cy="914400"/>
           </a:xfrm>
           <a:prstGeom prst="roundRect">
@@ -3845,14 +3845,46 @@
           <a:p>
             <a:pPr algn="ctr"/>
             <a:r>
-              <a:rPr sz="1100" b="1" dirty="0">
+              <a:rPr lang="en-US" sz="1200" b="1" dirty="0">
                 <a:solidFill>
                   <a:srgbClr val="843C0C"/>
                 </a:solidFill>
                 <a:latin typeface="Calibri"/>
               </a:rPr>
-              <a:t>Collapsed-cone projection</a:t>
-            </a:r>
+              <a:t>Scatter</a:t>
+            </a:r>
+            <a:r>
+              <a:rPr sz="1200" b="1" dirty="0">
+                <a:solidFill>
+                  <a:srgbClr val="843C0C"/>
+                </a:solidFill>
+                <a:latin typeface="Calibri"/>
+              </a:rPr>
+              <a:t> projection</a:t>
+            </a:r>
+            <a:r>
+              <a:rPr lang="en-US" sz="1200" b="1" dirty="0">
+                <a:solidFill>
+                  <a:srgbClr val="843C0C"/>
+                </a:solidFill>
+                <a:latin typeface="Calibri"/>
+              </a:rPr>
+              <a:t> </a:t>
+            </a:r>
+            <a:r>
+              <a:rPr lang="en-US" sz="1200" b="1" dirty="0">
+                <a:solidFill>
+                  <a:srgbClr val="843C0C"/>
+                </a:solidFill>
+              </a:rPr>
+              <a:t>sᵥ</a:t>
+            </a:r>
+            <a:endParaRPr sz="1200" b="1" dirty="0">
+              <a:solidFill>
+                <a:srgbClr val="843C0C"/>
+              </a:solidFill>
+              <a:latin typeface="Calibri"/>
+            </a:endParaRPr>
           </a:p>
           <a:p>
             <a:pPr algn="ctr"/>
@@ -3863,29 +3895,97 @@
                 </a:solidFill>
                 <a:latin typeface="Calibri"/>
               </a:rPr>
-              <a:t>of the scatter emission</a:t>
-            </a:r>
-          </a:p>
-          <a:p>
-            <a:pPr algn="ctr"/>
-            <a:r>
-              <a:rPr sz="1100" dirty="0">
+              <a:t>of</a:t>
+            </a:r>
+            <a:r>
+              <a:rPr lang="en-US" sz="1100" dirty="0">
                 <a:solidFill>
                   <a:srgbClr val="843C0C"/>
                 </a:solidFill>
                 <a:latin typeface="Calibri"/>
               </a:rPr>
-              <a:t>to the panel → sᵥ</a:t>
-            </a:r>
+              <a:t> </a:t>
+            </a:r>
+            <a:r>
+              <a:rPr lang="el-GR" sz="1100" dirty="0">
+                <a:solidFill>
+                  <a:srgbClr val="843C0C"/>
+                </a:solidFill>
+              </a:rPr>
+              <a:t>φ</a:t>
+            </a:r>
+            <a:r>
+              <a:rPr lang="en-US" sz="1100" baseline="-25000" dirty="0">
+                <a:solidFill>
+                  <a:srgbClr val="843C0C"/>
+                </a:solidFill>
+              </a:rPr>
+              <a:t>1</a:t>
+            </a:r>
+            <a:r>
+              <a:rPr lang="en-US" sz="1100" baseline="30000" dirty="0">
+                <a:solidFill>
+                  <a:srgbClr val="843C0C"/>
+                </a:solidFill>
+              </a:rPr>
+              <a:t>(k)</a:t>
+            </a:r>
+            <a:r>
+              <a:rPr lang="en-US" sz="1100" dirty="0">
+                <a:solidFill>
+                  <a:srgbClr val="843C0C"/>
+                </a:solidFill>
+              </a:rPr>
+              <a:t> + </a:t>
+            </a:r>
+            <a:r>
+              <a:rPr lang="el-GR" sz="1100" dirty="0">
+                <a:solidFill>
+                  <a:srgbClr val="843C0C"/>
+                </a:solidFill>
+              </a:rPr>
+              <a:t>φ</a:t>
+            </a:r>
+            <a:r>
+              <a:rPr lang="en-US" sz="1100" baseline="-25000" dirty="0">
+                <a:solidFill>
+                  <a:srgbClr val="843C0C"/>
+                </a:solidFill>
+              </a:rPr>
+              <a:t>&gt;1</a:t>
+            </a:r>
+            <a:r>
+              <a:rPr lang="en-US" sz="1100" baseline="30000" dirty="0">
+                <a:solidFill>
+                  <a:srgbClr val="843C0C"/>
+                </a:solidFill>
+              </a:rPr>
+              <a:t>(k)</a:t>
+            </a:r>
+            <a:r>
+              <a:rPr lang="en-US" sz="1100" dirty="0">
+                <a:solidFill>
+                  <a:srgbClr val="843C0C"/>
+                </a:solidFill>
+                <a:latin typeface="Calibri"/>
+              </a:rPr>
+              <a:t> </a:t>
+            </a:r>
+            <a:endParaRPr sz="1100" dirty="0">
+              <a:solidFill>
+                <a:srgbClr val="843C0C"/>
+              </a:solidFill>
+              <a:latin typeface="Calibri"/>
+            </a:endParaRPr>
           </a:p>
         </p:txBody>
       </p:sp>
       <p:cxnSp>
         <p:nvCxnSpPr>
-          <p:cNvPr id="191" name="Connector 13">
+          <p:cNvPr id="12" name="Connector 13">
             <a:extLst>
               <a:ext uri="{FF2B5EF4-FFF2-40B4-BE49-F238E27FC236}">
-                <a16:creationId xmlns:a16="http://schemas.microsoft.com/office/drawing/2014/main" id="{7EF8C806-5757-E7FD-9734-0A7442066896}"/>
+                <a16:creationId xmlns:a16="http://schemas.microsoft.com/office/drawing/2014/main" id="{7C98516E-4B20-3E7C-9FC2-1F8AB829FDF7}"/>
               </a:ext>
             </a:extLst>
           </p:cNvPr>
@@ -3896,7 +3996,7 @@
         </p:nvCxnSpPr>
         <p:spPr>
           <a:xfrm flipV="1">
-            <a:off x="7907425" y="2283443"/>
+            <a:off x="7977097" y="2283443"/>
             <a:ext cx="365853" cy="3160"/>
           </a:xfrm>
           <a:prstGeom prst="line">
@@ -3926,23 +4026,23 @@
       </p:cxnSp>
       <p:cxnSp>
         <p:nvCxnSpPr>
-          <p:cNvPr id="192" name="Connector 14">
+          <p:cNvPr id="13" name="Connector 14">
             <a:extLst>
               <a:ext uri="{FF2B5EF4-FFF2-40B4-BE49-F238E27FC236}">
-                <a16:creationId xmlns:a16="http://schemas.microsoft.com/office/drawing/2014/main" id="{EF004CC8-528B-0A8B-6FA0-8F2028A31DE5}"/>
+                <a16:creationId xmlns:a16="http://schemas.microsoft.com/office/drawing/2014/main" id="{5447864F-6197-E9F3-5223-E9D0D32055FD}"/>
               </a:ext>
             </a:extLst>
           </p:cNvPr>
           <p:cNvCxnSpPr>
             <a:cxnSpLocks/>
-            <a:stCxn id="193" idx="3"/>
-            <a:endCxn id="190" idx="1"/>
+            <a:stCxn id="14" idx="3"/>
+            <a:endCxn id="11" idx="1"/>
           </p:cNvCxnSpPr>
           <p:nvPr/>
         </p:nvCxnSpPr>
         <p:spPr>
           <a:xfrm>
-            <a:off x="10787877" y="2377205"/>
+            <a:off x="10857548" y="2377205"/>
             <a:ext cx="366754" cy="889"/>
           </a:xfrm>
           <a:prstGeom prst="line">
@@ -3972,10 +4072,10 @@
       </p:cxnSp>
       <p:sp>
         <p:nvSpPr>
-          <p:cNvPr id="193" name="Rounded Rectangle 11">
+          <p:cNvPr id="14" name="Rounded Rectangle 11">
             <a:extLst>
               <a:ext uri="{FF2B5EF4-FFF2-40B4-BE49-F238E27FC236}">
-                <a16:creationId xmlns:a16="http://schemas.microsoft.com/office/drawing/2014/main" id="{C4A7FC6F-EAE7-A217-3A8F-230A40748967}"/>
+                <a16:creationId xmlns:a16="http://schemas.microsoft.com/office/drawing/2014/main" id="{C377D2EA-B045-C82E-5A88-A72DE7328748}"/>
               </a:ext>
             </a:extLst>
           </p:cNvPr>
@@ -3984,7 +4084,7 @@
         </p:nvSpPr>
         <p:spPr>
           <a:xfrm>
-            <a:off x="8273276" y="1920003"/>
+            <a:off x="8342948" y="1920003"/>
             <a:ext cx="2514600" cy="914400"/>
           </a:xfrm>
           <a:prstGeom prst="roundRect">
@@ -4235,10 +4335,10 @@
       </p:sp>
       <p:cxnSp>
         <p:nvCxnSpPr>
-          <p:cNvPr id="194" name="Connector 15">
+          <p:cNvPr id="15" name="Connector 15">
             <a:extLst>
               <a:ext uri="{FF2B5EF4-FFF2-40B4-BE49-F238E27FC236}">
-                <a16:creationId xmlns:a16="http://schemas.microsoft.com/office/drawing/2014/main" id="{0408D842-82CC-805D-832E-C80300C4DE9A}"/>
+                <a16:creationId xmlns:a16="http://schemas.microsoft.com/office/drawing/2014/main" id="{5FE0800F-EB87-5333-4AA8-E729D1565ECA}"/>
               </a:ext>
             </a:extLst>
           </p:cNvPr>
@@ -4249,7 +4349,7 @@
         </p:nvCxnSpPr>
         <p:spPr>
           <a:xfrm>
-            <a:off x="10949405" y="2380364"/>
+            <a:off x="11019076" y="2380364"/>
             <a:ext cx="0" cy="736610"/>
           </a:xfrm>
           <a:prstGeom prst="line">
@@ -4278,10 +4378,10 @@
       </p:cxnSp>
       <p:cxnSp>
         <p:nvCxnSpPr>
-          <p:cNvPr id="195" name="Connector 16">
+          <p:cNvPr id="16" name="Connector 16">
             <a:extLst>
               <a:ext uri="{FF2B5EF4-FFF2-40B4-BE49-F238E27FC236}">
-                <a16:creationId xmlns:a16="http://schemas.microsoft.com/office/drawing/2014/main" id="{566F58FB-1FB7-F3BE-1021-B92AE2FEDD9D}"/>
+                <a16:creationId xmlns:a16="http://schemas.microsoft.com/office/drawing/2014/main" id="{B9F927DD-19AE-04E5-2677-E721ADCDF8E6}"/>
               </a:ext>
             </a:extLst>
           </p:cNvPr>
@@ -4292,7 +4392,7 @@
         </p:nvCxnSpPr>
         <p:spPr>
           <a:xfrm flipH="1">
-            <a:off x="8070280" y="3116973"/>
+            <a:off x="8139951" y="3116973"/>
             <a:ext cx="2882204" cy="0"/>
           </a:xfrm>
           <a:prstGeom prst="line">
@@ -4321,10 +4421,10 @@
       </p:cxnSp>
       <p:sp>
         <p:nvSpPr>
-          <p:cNvPr id="196" name="TextBox 195">
+          <p:cNvPr id="17" name="TextBox 16">
             <a:extLst>
               <a:ext uri="{FF2B5EF4-FFF2-40B4-BE49-F238E27FC236}">
-                <a16:creationId xmlns:a16="http://schemas.microsoft.com/office/drawing/2014/main" id="{6D8D6E4C-EC31-34F9-3F92-6523CADE95E3}"/>
+                <a16:creationId xmlns:a16="http://schemas.microsoft.com/office/drawing/2014/main" id="{7ED34FFF-896E-5890-B5CB-C88B1AA55C4A}"/>
               </a:ext>
             </a:extLst>
           </p:cNvPr>
@@ -4333,8 +4433,8 @@
         </p:nvSpPr>
         <p:spPr>
           <a:xfrm>
-            <a:off x="10320580" y="2905213"/>
-            <a:ext cx="583105" cy="169277"/>
+            <a:off x="10390252" y="2905213"/>
+            <a:ext cx="583105" cy="170944"/>
           </a:xfrm>
           <a:prstGeom prst="rect">
             <a:avLst/>
@@ -4386,10 +4486,10 @@
       </p:sp>
       <p:sp>
         <p:nvSpPr>
-          <p:cNvPr id="197" name="TextBox 196">
+          <p:cNvPr id="18" name="TextBox 17">
             <a:extLst>
               <a:ext uri="{FF2B5EF4-FFF2-40B4-BE49-F238E27FC236}">
-                <a16:creationId xmlns:a16="http://schemas.microsoft.com/office/drawing/2014/main" id="{62FCACCD-4CCF-631F-798D-50A56C42147C}"/>
+                <a16:creationId xmlns:a16="http://schemas.microsoft.com/office/drawing/2014/main" id="{75D8E104-888E-0EA4-3BB7-E07A1B562617}"/>
               </a:ext>
             </a:extLst>
           </p:cNvPr>
@@ -4398,8 +4498,8 @@
         </p:nvSpPr>
         <p:spPr>
           <a:xfrm>
-            <a:off x="8112925" y="2905210"/>
-            <a:ext cx="583105" cy="169277"/>
+            <a:off x="8182596" y="2905210"/>
+            <a:ext cx="583105" cy="170944"/>
           </a:xfrm>
           <a:prstGeom prst="rect">
             <a:avLst/>
@@ -4457,10 +4557,10 @@
       </p:sp>
       <p:sp>
         <p:nvSpPr>
-          <p:cNvPr id="198" name="Rounded Rectangle 22">
+          <p:cNvPr id="19" name="Rounded Rectangle 22">
             <a:extLst>
               <a:ext uri="{FF2B5EF4-FFF2-40B4-BE49-F238E27FC236}">
-                <a16:creationId xmlns:a16="http://schemas.microsoft.com/office/drawing/2014/main" id="{0703DCF6-B17F-43C9-6F28-940044FE8AD7}"/>
+                <a16:creationId xmlns:a16="http://schemas.microsoft.com/office/drawing/2014/main" id="{2FF562A5-D1D8-04AB-5618-BB510FF63319}"/>
               </a:ext>
             </a:extLst>
           </p:cNvPr>
@@ -4469,7 +4569,7 @@
         </p:nvSpPr>
         <p:spPr>
           <a:xfrm>
-            <a:off x="4981345" y="3695902"/>
+            <a:off x="5051016" y="3695902"/>
             <a:ext cx="1828800" cy="914400"/>
           </a:xfrm>
           <a:prstGeom prst="roundRect">
@@ -4543,7 +4643,7 @@
                 </a:solidFill>
                 <a:latin typeface="Calibri"/>
               </a:rPr>
-              <a:t>Through the material </a:t>
+              <a:t>through the material </a:t>
             </a:r>
             <a:r>
               <a:rPr sz="1100" dirty="0">
@@ -4559,10 +4659,10 @@
       </p:sp>
       <p:sp>
         <p:nvSpPr>
-          <p:cNvPr id="199" name="Rounded Rectangle 23">
+          <p:cNvPr id="20" name="Rounded Rectangle 23">
             <a:extLst>
               <a:ext uri="{FF2B5EF4-FFF2-40B4-BE49-F238E27FC236}">
-                <a16:creationId xmlns:a16="http://schemas.microsoft.com/office/drawing/2014/main" id="{6098FCC5-D675-C69D-1ADE-147AFB934F9D}"/>
+                <a16:creationId xmlns:a16="http://schemas.microsoft.com/office/drawing/2014/main" id="{D535A419-E7FC-EFF9-1A94-ECFCBDB7CA10}"/>
               </a:ext>
             </a:extLst>
           </p:cNvPr>
@@ -4571,7 +4671,7 @@
         </p:nvSpPr>
         <p:spPr>
           <a:xfrm>
-            <a:off x="7084465" y="3695902"/>
+            <a:off x="7154137" y="3695902"/>
             <a:ext cx="1828800" cy="914400"/>
           </a:xfrm>
           <a:prstGeom prst="roundRect">
@@ -4634,10 +4734,10 @@
       </p:sp>
       <p:sp>
         <p:nvSpPr>
-          <p:cNvPr id="200" name="Rounded Rectangle 24">
+          <p:cNvPr id="21" name="Rounded Rectangle 24">
             <a:extLst>
               <a:ext uri="{FF2B5EF4-FFF2-40B4-BE49-F238E27FC236}">
-                <a16:creationId xmlns:a16="http://schemas.microsoft.com/office/drawing/2014/main" id="{CE0741F0-62A4-3156-E83D-64B9966358C3}"/>
+                <a16:creationId xmlns:a16="http://schemas.microsoft.com/office/drawing/2014/main" id="{F07A4507-1EA2-02FC-CAC0-A5C7B8BDC211}"/>
               </a:ext>
             </a:extLst>
           </p:cNvPr>
@@ -4646,7 +4746,7 @@
         </p:nvSpPr>
         <p:spPr>
           <a:xfrm>
-            <a:off x="9187585" y="3695902"/>
+            <a:off x="9257257" y="3695902"/>
             <a:ext cx="1828800" cy="914400"/>
           </a:xfrm>
           <a:prstGeom prst="roundRect">
@@ -4709,10 +4809,10 @@
       </p:sp>
       <p:sp>
         <p:nvSpPr>
-          <p:cNvPr id="201" name="Rounded Rectangle 25">
+          <p:cNvPr id="22" name="Rounded Rectangle 25">
             <a:extLst>
               <a:ext uri="{FF2B5EF4-FFF2-40B4-BE49-F238E27FC236}">
-                <a16:creationId xmlns:a16="http://schemas.microsoft.com/office/drawing/2014/main" id="{6DF8E2E0-9EE7-97B2-0B78-0147221EC6E1}"/>
+                <a16:creationId xmlns:a16="http://schemas.microsoft.com/office/drawing/2014/main" id="{DBF5B9B2-44DC-F285-AFD5-7D9071D72AE4}"/>
               </a:ext>
             </a:extLst>
           </p:cNvPr>
@@ -4721,7 +4821,7 @@
         </p:nvSpPr>
         <p:spPr>
           <a:xfrm>
-            <a:off x="11290705" y="3695902"/>
+            <a:off x="11360376" y="3695902"/>
             <a:ext cx="2057400" cy="914400"/>
           </a:xfrm>
           <a:prstGeom prst="roundRect">
@@ -4805,23 +4905,23 @@
       </p:sp>
       <p:cxnSp>
         <p:nvCxnSpPr>
-          <p:cNvPr id="202" name="Connector 26">
+          <p:cNvPr id="23" name="Connector 26">
             <a:extLst>
               <a:ext uri="{FF2B5EF4-FFF2-40B4-BE49-F238E27FC236}">
-                <a16:creationId xmlns:a16="http://schemas.microsoft.com/office/drawing/2014/main" id="{7DA12EAB-F4F9-0C17-83F2-E17C35675E07}"/>
+                <a16:creationId xmlns:a16="http://schemas.microsoft.com/office/drawing/2014/main" id="{90AD685F-CC62-F8F0-656F-E064A0D96717}"/>
               </a:ext>
             </a:extLst>
           </p:cNvPr>
           <p:cNvCxnSpPr>
             <a:cxnSpLocks/>
-            <a:stCxn id="198" idx="3"/>
-            <a:endCxn id="199" idx="1"/>
+            <a:stCxn id="19" idx="3"/>
+            <a:endCxn id="20" idx="1"/>
           </p:cNvCxnSpPr>
           <p:nvPr/>
         </p:nvCxnSpPr>
         <p:spPr>
           <a:xfrm>
-            <a:off x="6810145" y="4153102"/>
+            <a:off x="6879816" y="4153102"/>
             <a:ext cx="274320" cy="0"/>
           </a:xfrm>
           <a:prstGeom prst="line">
@@ -4851,23 +4951,23 @@
       </p:cxnSp>
       <p:cxnSp>
         <p:nvCxnSpPr>
-          <p:cNvPr id="203" name="Connector 27">
+          <p:cNvPr id="24" name="Connector 27">
             <a:extLst>
               <a:ext uri="{FF2B5EF4-FFF2-40B4-BE49-F238E27FC236}">
-                <a16:creationId xmlns:a16="http://schemas.microsoft.com/office/drawing/2014/main" id="{5E4E0E02-655B-5727-619B-ECDCC8F269C1}"/>
+                <a16:creationId xmlns:a16="http://schemas.microsoft.com/office/drawing/2014/main" id="{C2D28982-7B38-81D2-472D-40EEEDD609A1}"/>
               </a:ext>
             </a:extLst>
           </p:cNvPr>
           <p:cNvCxnSpPr>
             <a:cxnSpLocks/>
-            <a:stCxn id="199" idx="3"/>
-            <a:endCxn id="200" idx="1"/>
+            <a:stCxn id="20" idx="3"/>
+            <a:endCxn id="21" idx="1"/>
           </p:cNvCxnSpPr>
           <p:nvPr/>
         </p:nvCxnSpPr>
         <p:spPr>
           <a:xfrm>
-            <a:off x="8913265" y="4153102"/>
+            <a:off x="8982936" y="4153102"/>
             <a:ext cx="274320" cy="0"/>
           </a:xfrm>
           <a:prstGeom prst="line">
@@ -4897,23 +4997,23 @@
       </p:cxnSp>
       <p:cxnSp>
         <p:nvCxnSpPr>
-          <p:cNvPr id="204" name="Connector 28">
+          <p:cNvPr id="25" name="Connector 28">
             <a:extLst>
               <a:ext uri="{FF2B5EF4-FFF2-40B4-BE49-F238E27FC236}">
-                <a16:creationId xmlns:a16="http://schemas.microsoft.com/office/drawing/2014/main" id="{D670384F-954D-13FD-84A0-FE90DAE856FA}"/>
+                <a16:creationId xmlns:a16="http://schemas.microsoft.com/office/drawing/2014/main" id="{8C8918E4-7470-1511-49BD-73C593899A30}"/>
               </a:ext>
             </a:extLst>
           </p:cNvPr>
           <p:cNvCxnSpPr>
             <a:cxnSpLocks/>
-            <a:stCxn id="200" idx="3"/>
-            <a:endCxn id="201" idx="1"/>
+            <a:stCxn id="21" idx="3"/>
+            <a:endCxn id="22" idx="1"/>
           </p:cNvCxnSpPr>
           <p:nvPr/>
         </p:nvCxnSpPr>
         <p:spPr>
           <a:xfrm>
-            <a:off x="11016385" y="4153102"/>
+            <a:off x="11086056" y="4153102"/>
             <a:ext cx="274320" cy="0"/>
           </a:xfrm>
           <a:prstGeom prst="line">
@@ -4943,22 +5043,22 @@
       </p:cxnSp>
       <p:cxnSp>
         <p:nvCxnSpPr>
-          <p:cNvPr id="205" name="Connector 39">
+          <p:cNvPr id="26" name="Connector 39">
             <a:extLst>
               <a:ext uri="{FF2B5EF4-FFF2-40B4-BE49-F238E27FC236}">
-                <a16:creationId xmlns:a16="http://schemas.microsoft.com/office/drawing/2014/main" id="{F453A8E7-99E9-7DCF-1DCF-928484A9C839}"/>
+                <a16:creationId xmlns:a16="http://schemas.microsoft.com/office/drawing/2014/main" id="{3544C87C-ABA4-B6E3-DAB1-F928CB70B66A}"/>
               </a:ext>
             </a:extLst>
           </p:cNvPr>
           <p:cNvCxnSpPr>
             <a:cxnSpLocks/>
-            <a:stCxn id="201" idx="3"/>
+            <a:stCxn id="22" idx="3"/>
           </p:cNvCxnSpPr>
           <p:nvPr/>
         </p:nvCxnSpPr>
         <p:spPr>
           <a:xfrm>
-            <a:off x="13348105" y="4153102"/>
+            <a:off x="13417776" y="4153102"/>
             <a:ext cx="274320" cy="0"/>
           </a:xfrm>
           <a:prstGeom prst="line">
@@ -4987,10 +5087,10 @@
       </p:cxnSp>
       <p:cxnSp>
         <p:nvCxnSpPr>
-          <p:cNvPr id="206" name="Connector 40">
+          <p:cNvPr id="27" name="Connector 40">
             <a:extLst>
               <a:ext uri="{FF2B5EF4-FFF2-40B4-BE49-F238E27FC236}">
-                <a16:creationId xmlns:a16="http://schemas.microsoft.com/office/drawing/2014/main" id="{49184B2B-C238-F4A3-F461-D791254CEE36}"/>
+                <a16:creationId xmlns:a16="http://schemas.microsoft.com/office/drawing/2014/main" id="{18ACB701-1DBF-5541-57F7-D11CD00A23DC}"/>
               </a:ext>
             </a:extLst>
           </p:cNvPr>
@@ -5001,7 +5101,7 @@
         </p:nvCxnSpPr>
         <p:spPr>
           <a:xfrm>
-            <a:off x="13622425" y="4148554"/>
+            <a:off x="13692096" y="4148555"/>
             <a:ext cx="0" cy="656879"/>
           </a:xfrm>
           <a:prstGeom prst="line">
@@ -5030,10 +5130,10 @@
       </p:cxnSp>
       <p:cxnSp>
         <p:nvCxnSpPr>
-          <p:cNvPr id="207" name="Connector 41">
+          <p:cNvPr id="28" name="Connector 41">
             <a:extLst>
               <a:ext uri="{FF2B5EF4-FFF2-40B4-BE49-F238E27FC236}">
-                <a16:creationId xmlns:a16="http://schemas.microsoft.com/office/drawing/2014/main" id="{B3C48E48-0D11-5320-3DCF-288AC277B628}"/>
+                <a16:creationId xmlns:a16="http://schemas.microsoft.com/office/drawing/2014/main" id="{88740F43-30B5-92E3-21FF-11C5F5D73CB3}"/>
               </a:ext>
             </a:extLst>
           </p:cNvPr>
@@ -5044,7 +5144,7 @@
         </p:nvCxnSpPr>
         <p:spPr>
           <a:xfrm flipH="1">
-            <a:off x="4714978" y="4805431"/>
+            <a:off x="4784650" y="4805431"/>
             <a:ext cx="8907449" cy="0"/>
           </a:xfrm>
           <a:prstGeom prst="line">
@@ -5073,10 +5173,10 @@
       </p:cxnSp>
       <p:cxnSp>
         <p:nvCxnSpPr>
-          <p:cNvPr id="208" name="Connector 42">
+          <p:cNvPr id="29" name="Connector 42">
             <a:extLst>
               <a:ext uri="{FF2B5EF4-FFF2-40B4-BE49-F238E27FC236}">
-                <a16:creationId xmlns:a16="http://schemas.microsoft.com/office/drawing/2014/main" id="{DF8863B9-9D3D-2D93-5107-D4B1C60712F3}"/>
+                <a16:creationId xmlns:a16="http://schemas.microsoft.com/office/drawing/2014/main" id="{5CAFA40E-D8E6-8C6E-C640-7BCC286D1E33}"/>
               </a:ext>
             </a:extLst>
           </p:cNvPr>
@@ -5087,7 +5187,7 @@
         </p:nvCxnSpPr>
         <p:spPr>
           <a:xfrm flipV="1">
-            <a:off x="4709676" y="894143"/>
+            <a:off x="4779347" y="894143"/>
             <a:ext cx="0" cy="3911288"/>
           </a:xfrm>
           <a:prstGeom prst="line">
@@ -5116,10 +5216,10 @@
       </p:cxnSp>
       <p:cxnSp>
         <p:nvCxnSpPr>
-          <p:cNvPr id="209" name="Connector 43">
+          <p:cNvPr id="30" name="Connector 43">
             <a:extLst>
               <a:ext uri="{FF2B5EF4-FFF2-40B4-BE49-F238E27FC236}">
-                <a16:creationId xmlns:a16="http://schemas.microsoft.com/office/drawing/2014/main" id="{70CA0F9D-84D0-76F3-D1DB-2CFDA2A7A388}"/>
+                <a16:creationId xmlns:a16="http://schemas.microsoft.com/office/drawing/2014/main" id="{E6659425-013D-9359-787B-2C6E079055E1}"/>
               </a:ext>
             </a:extLst>
           </p:cNvPr>
@@ -5128,7 +5228,7 @@
         </p:nvCxnSpPr>
         <p:spPr>
           <a:xfrm>
-            <a:off x="4709676" y="894142"/>
+            <a:off x="4779347" y="894142"/>
             <a:ext cx="274320" cy="0"/>
           </a:xfrm>
           <a:prstGeom prst="line">
@@ -5158,10 +5258,10 @@
       </p:cxnSp>
       <p:sp>
         <p:nvSpPr>
-          <p:cNvPr id="210" name="Rounded Rectangle 45">
+          <p:cNvPr id="31" name="Rounded Rectangle 45">
             <a:extLst>
               <a:ext uri="{FF2B5EF4-FFF2-40B4-BE49-F238E27FC236}">
-                <a16:creationId xmlns:a16="http://schemas.microsoft.com/office/drawing/2014/main" id="{D0D2E99E-1681-3EBB-1B9D-EFEDD7BD8312}"/>
+                <a16:creationId xmlns:a16="http://schemas.microsoft.com/office/drawing/2014/main" id="{A802D969-F421-AEB9-4FB3-F320BFAB80C0}"/>
               </a:ext>
             </a:extLst>
           </p:cNvPr>
@@ -5170,7 +5270,7 @@
         </p:nvSpPr>
         <p:spPr>
           <a:xfrm>
-            <a:off x="14012037" y="3695943"/>
+            <a:off x="14081709" y="3695943"/>
             <a:ext cx="1828800" cy="914400"/>
           </a:xfrm>
           <a:prstGeom prst="roundRect">
@@ -5233,22 +5333,22 @@
       </p:sp>
       <p:cxnSp>
         <p:nvCxnSpPr>
-          <p:cNvPr id="211" name="Connector: Elbow 210">
+          <p:cNvPr id="32" name="Connector: Elbow 31">
             <a:extLst>
               <a:ext uri="{FF2B5EF4-FFF2-40B4-BE49-F238E27FC236}">
-                <a16:creationId xmlns:a16="http://schemas.microsoft.com/office/drawing/2014/main" id="{0C4EA69C-FDD5-438D-0931-59D3493FC0EF}"/>
+                <a16:creationId xmlns:a16="http://schemas.microsoft.com/office/drawing/2014/main" id="{AC0DA71D-952E-4A6F-C56F-9D91BA6AB5CB}"/>
               </a:ext>
             </a:extLst>
           </p:cNvPr>
           <p:cNvCxnSpPr>
             <a:cxnSpLocks/>
-            <a:stCxn id="182" idx="3"/>
+            <a:stCxn id="3" idx="3"/>
           </p:cNvCxnSpPr>
           <p:nvPr/>
         </p:nvCxnSpPr>
         <p:spPr>
           <a:xfrm flipV="1">
-            <a:off x="4244657" y="685682"/>
+            <a:off x="4314328" y="685682"/>
             <a:ext cx="736690" cy="121910"/>
           </a:xfrm>
           <a:prstGeom prst="bentConnector3">
@@ -5280,23 +5380,23 @@
       </p:cxnSp>
       <p:cxnSp>
         <p:nvCxnSpPr>
-          <p:cNvPr id="212" name="Connector: Elbow 211">
+          <p:cNvPr id="33" name="Connector: Elbow 32">
             <a:extLst>
               <a:ext uri="{FF2B5EF4-FFF2-40B4-BE49-F238E27FC236}">
-                <a16:creationId xmlns:a16="http://schemas.microsoft.com/office/drawing/2014/main" id="{6CB95064-09E3-2D2F-FB96-A7AF407D019D}"/>
+                <a16:creationId xmlns:a16="http://schemas.microsoft.com/office/drawing/2014/main" id="{8D3D0BA7-2682-68DE-04E6-48A0C8E0E112}"/>
               </a:ext>
             </a:extLst>
           </p:cNvPr>
           <p:cNvCxnSpPr>
             <a:cxnSpLocks/>
-            <a:stCxn id="186" idx="2"/>
-            <a:endCxn id="189" idx="0"/>
+            <a:stCxn id="7" idx="2"/>
+            <a:endCxn id="10" idx="0"/>
           </p:cNvCxnSpPr>
           <p:nvPr/>
         </p:nvCxnSpPr>
         <p:spPr>
           <a:xfrm rot="16200000" flipH="1">
-            <a:off x="6343801" y="1502539"/>
+            <a:off x="6413472" y="1502540"/>
             <a:ext cx="658370" cy="182879"/>
           </a:xfrm>
           <a:prstGeom prst="bentConnector3">
@@ -5328,22 +5428,22 @@
       </p:cxnSp>
       <p:cxnSp>
         <p:nvCxnSpPr>
-          <p:cNvPr id="213" name="Connector: Elbow 212">
+          <p:cNvPr id="34" name="Connector: Elbow 33">
             <a:extLst>
               <a:ext uri="{FF2B5EF4-FFF2-40B4-BE49-F238E27FC236}">
-                <a16:creationId xmlns:a16="http://schemas.microsoft.com/office/drawing/2014/main" id="{57BF8852-3BF9-7DAB-DB0B-F3F2BBDA78C7}"/>
+                <a16:creationId xmlns:a16="http://schemas.microsoft.com/office/drawing/2014/main" id="{F95CD050-454F-AA79-747E-4B37AB6AD3C5}"/>
               </a:ext>
             </a:extLst>
           </p:cNvPr>
           <p:cNvCxnSpPr>
             <a:cxnSpLocks/>
-            <a:endCxn id="198" idx="0"/>
+            <a:endCxn id="19" idx="0"/>
           </p:cNvCxnSpPr>
           <p:nvPr/>
         </p:nvCxnSpPr>
         <p:spPr>
           <a:xfrm rot="16200000" flipH="1">
-            <a:off x="4451064" y="2251221"/>
+            <a:off x="4520736" y="2251222"/>
             <a:ext cx="2272775" cy="616587"/>
           </a:xfrm>
           <a:prstGeom prst="bentConnector3">
@@ -5375,23 +5475,23 @@
       </p:cxnSp>
       <p:cxnSp>
         <p:nvCxnSpPr>
-          <p:cNvPr id="214" name="Connector: Elbow 213">
+          <p:cNvPr id="35" name="Connector: Elbow 34">
             <a:extLst>
               <a:ext uri="{FF2B5EF4-FFF2-40B4-BE49-F238E27FC236}">
-                <a16:creationId xmlns:a16="http://schemas.microsoft.com/office/drawing/2014/main" id="{FD589FAB-0F27-2313-4C94-FF51CCAE3E7A}"/>
+                <a16:creationId xmlns:a16="http://schemas.microsoft.com/office/drawing/2014/main" id="{D89AEA0E-6600-5574-BA89-03FF755DC377}"/>
               </a:ext>
             </a:extLst>
           </p:cNvPr>
           <p:cNvCxnSpPr>
             <a:cxnSpLocks/>
-            <a:stCxn id="190" idx="2"/>
-            <a:endCxn id="199" idx="0"/>
+            <a:stCxn id="11" idx="2"/>
+            <a:endCxn id="20" idx="0"/>
           </p:cNvCxnSpPr>
           <p:nvPr/>
         </p:nvCxnSpPr>
         <p:spPr>
           <a:xfrm rot="5400000">
-            <a:off x="9660793" y="1173365"/>
+            <a:off x="9730464" y="1173365"/>
             <a:ext cx="860610" cy="4184465"/>
           </a:xfrm>
           <a:prstGeom prst="bentConnector3">
@@ -5423,10 +5523,10 @@
       </p:cxnSp>
       <p:cxnSp>
         <p:nvCxnSpPr>
-          <p:cNvPr id="215" name="Connector 41">
+          <p:cNvPr id="36" name="Connector 41">
             <a:extLst>
               <a:ext uri="{FF2B5EF4-FFF2-40B4-BE49-F238E27FC236}">
-                <a16:creationId xmlns:a16="http://schemas.microsoft.com/office/drawing/2014/main" id="{EE1629FA-33F2-86FF-79C1-F44D4C88F257}"/>
+                <a16:creationId xmlns:a16="http://schemas.microsoft.com/office/drawing/2014/main" id="{ECB2AEA0-2F00-4838-1860-8E336AD066F6}"/>
               </a:ext>
             </a:extLst>
           </p:cNvPr>
@@ -5437,7 +5537,7 @@
         </p:nvCxnSpPr>
         <p:spPr>
           <a:xfrm flipH="1">
-            <a:off x="5272757" y="1423125"/>
+            <a:off x="5342429" y="1423126"/>
             <a:ext cx="1308791" cy="1"/>
           </a:xfrm>
           <a:prstGeom prst="line">
@@ -5466,10 +5566,10 @@
       </p:cxnSp>
       <p:cxnSp>
         <p:nvCxnSpPr>
-          <p:cNvPr id="216" name="Connector 15">
+          <p:cNvPr id="37" name="Connector 15">
             <a:extLst>
               <a:ext uri="{FF2B5EF4-FFF2-40B4-BE49-F238E27FC236}">
-                <a16:creationId xmlns:a16="http://schemas.microsoft.com/office/drawing/2014/main" id="{B9417673-D440-D697-51C3-5ECA7E38C614}"/>
+                <a16:creationId xmlns:a16="http://schemas.microsoft.com/office/drawing/2014/main" id="{A1F60737-1252-826E-9746-43A47D3A970C}"/>
               </a:ext>
             </a:extLst>
           </p:cNvPr>
@@ -5480,7 +5580,7 @@
         </p:nvCxnSpPr>
         <p:spPr>
           <a:xfrm flipH="1">
-            <a:off x="8065983" y="2502446"/>
+            <a:off x="8135655" y="2502446"/>
             <a:ext cx="1219" cy="623684"/>
           </a:xfrm>
           <a:prstGeom prst="line">
@@ -5509,10 +5609,10 @@
       </p:cxnSp>
       <p:cxnSp>
         <p:nvCxnSpPr>
-          <p:cNvPr id="217" name="Connector 13">
+          <p:cNvPr id="38" name="Connector 13">
             <a:extLst>
               <a:ext uri="{FF2B5EF4-FFF2-40B4-BE49-F238E27FC236}">
-                <a16:creationId xmlns:a16="http://schemas.microsoft.com/office/drawing/2014/main" id="{F644E277-C7BC-48DF-4F60-2892512FB4C6}"/>
+                <a16:creationId xmlns:a16="http://schemas.microsoft.com/office/drawing/2014/main" id="{99536874-9D2E-2B82-3379-A47B705592E4}"/>
               </a:ext>
             </a:extLst>
           </p:cNvPr>
@@ -5523,7 +5623,7 @@
         </p:nvCxnSpPr>
         <p:spPr>
           <a:xfrm flipV="1">
-            <a:off x="8057104" y="2499155"/>
+            <a:off x="8126776" y="2499155"/>
             <a:ext cx="213453" cy="3292"/>
           </a:xfrm>
           <a:prstGeom prst="line">
@@ -5553,22 +5653,22 @@
       </p:cxnSp>
       <p:cxnSp>
         <p:nvCxnSpPr>
-          <p:cNvPr id="218" name="Connector 3">
+          <p:cNvPr id="39" name="Connector 3">
             <a:extLst>
               <a:ext uri="{FF2B5EF4-FFF2-40B4-BE49-F238E27FC236}">
-                <a16:creationId xmlns:a16="http://schemas.microsoft.com/office/drawing/2014/main" id="{60350AA4-8497-718D-FC4F-E17866DF123E}"/>
+                <a16:creationId xmlns:a16="http://schemas.microsoft.com/office/drawing/2014/main" id="{1BCEA982-8A4E-4C4B-CB5F-8941A910CCE6}"/>
               </a:ext>
             </a:extLst>
           </p:cNvPr>
           <p:cNvCxnSpPr>
             <a:cxnSpLocks/>
-            <a:endCxn id="210" idx="1"/>
+            <a:endCxn id="31" idx="1"/>
           </p:cNvCxnSpPr>
           <p:nvPr/>
         </p:nvCxnSpPr>
         <p:spPr>
           <a:xfrm flipV="1">
-            <a:off x="13625078" y="4153143"/>
+            <a:off x="13694749" y="4153143"/>
             <a:ext cx="386960" cy="0"/>
           </a:xfrm>
           <a:prstGeom prst="line">

</xml_diff>